<commit_message>
Redesign slide deck with flat, shadowless, bold Stamp website theme
</commit_message>
<xml_diff>
--- a/presentation/Stamp-pitch.pptx
+++ b/presentation/Stamp-pitch.pptx
@@ -506,12 +506,12 @@
           <a:lstStyle/>
           <a:p>
             <a:r>
-              <a:t>TITLE SLIDE (0:00–0:10)</a:t>
-            </a:r>
-          </a:p>
-          <a:p>
-            <a:r>
-              <a:t>Welcome. I'm Jacob, and this is Stamp: a New Zealand breakfast spread innovation designed for hot toast. Over the next minute, I'll walk you through our product and market opportunity, followed by my personal reflection on building with generative AI.</a:t>
+              <a:t>TITLE SLIDE (0:00–0:08)</a:t>
+            </a:r>
+          </a:p>
+          <a:p>
+            <a:r>
+              <a:t>Kia ora. I'm Jacob, and this is Stamp: a New Zealand breakfast spread innovation engineered for hot toast. Over the next minute, I will present our product and market opportunity, followed by my personal reflection on building with generative AI.</a:t>
             </a:r>
           </a:p>
         </p:txBody>
@@ -581,12 +581,24 @@
           <a:lstStyle/>
           <a:p>
             <a:r>
-              <a:t>PITCH SLIDE 1 (0:10–0:30)</a:t>
-            </a:r>
-          </a:p>
-          <a:p>
-            <a:r>
-              <a:t>Eating toast away from a kitchen is broken: you have to carry a heavy jar, find a knife, and wash it in an office or hall sink. Stamp fixes this with a peel-and-press spread disc. You peel a 10-gram portion off the release film, press it directly onto hot toast, and the heat melts it into an even layer in seconds. We launch with four distinct flavours: Salted Butter, Raspberry, Yeast extract, and Peanut—all packaged in an 8-stamp card sheet with a 12-month pantry shelf life.</a:t>
+              <a:t>PITCH SLIDE 1 (0:08–0:34)</a:t>
+            </a:r>
+          </a:p>
+          <a:p>
+            <a:r>
+              <a:t>Eating toast away from a full kitchen is broken. When you're in a student hall, flat, or office desk, nobody wants to lug a sticky 750-gram jar, track down a table knife, and wash it in an office sink.</a:t>
+            </a:r>
+          </a:p>
+          <a:p/>
+          <a:p>
+            <a:r>
+              <a:t>Stamp reinvents the format with a thin, 10-gram disc of real spread on release film. You peel it off, press it onto hot toast, and residual heat softens it into an even spread in seconds. No knife, no open jar, no morning mess.</a:t>
+            </a:r>
+          </a:p>
+          <a:p/>
+          <a:p>
+            <a:r>
+              <a:t>We launch with four distinct flavours: Salted Butter, Raspberry, Yeast extract, and Peanut—pantry-stable for 12 months in an 8-stamp card sheet.</a:t>
             </a:r>
           </a:p>
         </p:txBody>
@@ -656,12 +668,18 @@
           <a:lstStyle/>
           <a:p>
             <a:r>
-              <a:t>PITCH SLIDE 2 (0:30–1:00)</a:t>
-            </a:r>
-          </a:p>
-          <a:p>
-            <a:r>
-              <a:t>Our analysis of New Zealand breakfast retail sales shows spreads grew 24% to 341 million dollars, with the premium tier expanding to 113 million. Yet out of 154 existing spread products, not one offers a portion format. Jars like Fix and Fogg or Pic's are cheaper per 100 grams, but they're bulky and messy. At 5 dollars a sheet, or 63 cents a toast portion, Stamp captures premium convenience for commuters, students, and desk workers. With a healthy 1.75 contribution margin per sheet, Stamp is ready to lead an entirely new format in breakfast.</a:t>
+              <a:t>PITCH SLIDE 2 (0:34–0:58)</a:t>
+            </a:r>
+          </a:p>
+          <a:p>
+            <a:r>
+              <a:t>Our analysis of New Zealand breakfast retail sales shows spreads revenue grew 24% to 341 million dollars, with the premium tier surging 29% to 113 million. Yet across 154 existing spread products, not one offers a single-serve portion format.</a:t>
+            </a:r>
+          </a:p>
+          <a:p/>
+          <a:p>
+            <a:r>
+              <a:t>Supermarket jars like Pic's or Fix &amp; Fogg compete on bulk weight, but they are messy and stationary. At five dollars a sheet—just 63 cents a toast portion—Stamp captures premium convenience. With an assumed manufacturing cost of one-fifty, we retain a strong one-dollar-seventy-five gross margin per sheet. Stamp is ready to own portable breakfast.</a:t>
             </a:r>
           </a:p>
         </p:txBody>
@@ -746,17 +764,17 @@
           </a:p>
           <a:p>
             <a:r>
-              <a:t>1. Discuss how you structured sessions to avoid context rot across tasks.</a:t>
-            </a:r>
-          </a:p>
-          <a:p>
-            <a:r>
-              <a:t>2. Detail the pivotal moment where you caught a major AI mistake (e.g. invalid pricing assumptions, unrealistic manufacturing claims, or raw data price spikes) and how you corrected it.</a:t>
-            </a:r>
-          </a:p>
-          <a:p>
-            <a:r>
-              <a:t>3. Share the single most important lesson you will carry into future professional AI projects.</a:t>
+              <a:t>1. Mention how you structured distinct sessions rather than one massive unmanageable chat.</a:t>
+            </a:r>
+          </a:p>
+          <a:p>
+            <a:r>
+              <a:t>2. Explain how you used explicit negative constraints (e.g. banning health claims and certification badges) and role personas to get reliable results.</a:t>
+            </a:r>
+          </a:p>
+          <a:p>
+            <a:r>
+              <a:t>3. Share a concrete example where an AI model gave an unrealistic answer (e.g., assuming chilled butter could sit ambiently without dairy-spread reformulations) and how you caught and corrected it.</a:t>
             </a:r>
           </a:p>
         </p:txBody>
@@ -826,7 +844,7 @@
           <a:lstStyle/>
           <a:p>
             <a:r>
-              <a:t>REFLECTION Q2 (1:55–2:50)</a:t>
+              <a:t>REFLECTION Q2 (1:55–2:45)</a:t>
             </a:r>
           </a:p>
           <a:p>
@@ -841,17 +859,17 @@
           </a:p>
           <a:p>
             <a:r>
-              <a:t>1. How did you actively prevent AI slop from entering Stamp's branding and copy?</a:t>
-            </a:r>
-          </a:p>
-          <a:p>
-            <a:r>
-              <a:t>2. Address the severe ethical/legal risks of AI generating food claims (allergens, false certifications).</a:t>
-            </a:r>
-          </a:p>
-          <a:p>
-            <a:r>
-              <a:t>3. Conclude with your personal stance as a future knowledge worker on ethics and responsibility.</a:t>
+              <a:t>1. Explain how you actively stripped out generic corporate jargon in favour of plain, punchy facts.</a:t>
+            </a:r>
+          </a:p>
+          <a:p>
+            <a:r>
+              <a:t>2. Emphasize the legal hazards of AI in food and beverage: hallucinated health benefits, false gluten-free claims, and allergen responsibility.</a:t>
+            </a:r>
+          </a:p>
+          <a:p>
+            <a:r>
+              <a:t>3. Conclude with your takeaway: Generative AI accelerates drafting, but human judgment, taste, and ultimate accountability can never be outsourced to a model.</a:t>
             </a:r>
           </a:p>
         </p:txBody>
@@ -3872,12 +3890,10 @@
             <a:avLst/>
           </a:prstGeom>
           <a:solidFill>
-            <a:srgbClr val="3B0764"/>
+            <a:srgbClr val="240340"/>
           </a:solidFill>
           <a:ln>
-            <a:solidFill>
-              <a:srgbClr val="3B0764"/>
-            </a:solidFill>
+            <a:noFill/>
           </a:ln>
         </p:spPr>
         <p:style>
@@ -3904,25 +3920,23 @@
       </p:sp>
       <p:sp>
         <p:nvSpPr>
-          <p:cNvPr id="3" name="Rectangle 2"/>
+          <p:cNvPr id="3" name="Rounded Rectangle 2"/>
           <p:cNvSpPr/>
           <p:nvPr/>
         </p:nvSpPr>
         <p:spPr>
           <a:xfrm>
-            <a:off x="1097280" y="1463040"/>
-            <a:ext cx="1371600" cy="73152"/>
-          </a:xfrm>
-          <a:prstGeom prst="rect">
+            <a:off x="822960" y="1097280"/>
+            <a:ext cx="4087368" cy="329184"/>
+          </a:xfrm>
+          <a:prstGeom prst="roundRect">
             <a:avLst/>
           </a:prstGeom>
           <a:solidFill>
-            <a:srgbClr val="E24BFF"/>
+            <a:srgbClr val="3B0764"/>
           </a:solidFill>
           <a:ln>
-            <a:solidFill>
-              <a:srgbClr val="E24BFF"/>
-            </a:solidFill>
+            <a:noFill/>
           </a:ln>
         </p:spPr>
         <p:style>
@@ -3940,10 +3954,20 @@
           </a:fontRef>
         </p:style>
         <p:txBody>
-          <a:bodyPr rtlCol="0" anchor="ctr"/>
-          <a:lstStyle/>
-          <a:p>
-            <a:pPr algn="ctr"/>
+          <a:bodyPr rtlCol="0" anchor="ctr" wrap="none" lIns="137160" rIns="137160"/>
+          <a:lstStyle/>
+          <a:p>
+            <a:pPr algn="ctr">
+              <a:defRPr sz="1050" b="1">
+                <a:solidFill>
+                  <a:srgbClr val="E24BFF"/>
+                </a:solidFill>
+                <a:latin typeface="Manrope"/>
+              </a:defRPr>
+            </a:pPr>
+            <a:r>
+              <a:t>COMMERCIAL PROPOSAL • INFO123 PROJECT</a:t>
+            </a:r>
           </a:p>
         </p:txBody>
       </p:sp>
@@ -3955,8 +3979,8 @@
         </p:nvSpPr>
         <p:spPr>
           <a:xfrm>
-            <a:off x="1097280" y="1645920"/>
-            <a:ext cx="9601200" cy="4114800"/>
+            <a:off x="822960" y="1600200"/>
+            <a:ext cx="6858000" cy="2560320"/>
           </a:xfrm>
           <a:prstGeom prst="rect">
             <a:avLst/>
@@ -3964,19 +3988,20 @@
           <a:noFill/>
         </p:spPr>
         <p:txBody>
-          <a:bodyPr wrap="square">
+          <a:bodyPr wrap="square" lIns="0" tIns="0" rIns="0" bIns="0">
             <a:spAutoFit/>
           </a:bodyPr>
           <a:lstStyle/>
           <a:p>
             <a:pPr>
               <a:spcAft>
-                <a:spcPts val="600"/>
+                <a:spcPts val="200"/>
               </a:spcAft>
-              <a:defRPr sz="5400" b="1">
+              <a:defRPr sz="6400" b="1">
                 <a:solidFill>
                   <a:srgbClr val="E24BFF"/>
                 </a:solidFill>
+                <a:latin typeface="Manrope"/>
               </a:defRPr>
             </a:pPr>
             <a:r>
@@ -3986,50 +4011,307 @@
           <a:p>
             <a:pPr>
               <a:spcAft>
-                <a:spcPts val="1400"/>
+                <a:spcPts val="1000"/>
               </a:spcAft>
-              <a:defRPr sz="2800" b="1">
+              <a:defRPr sz="2600" b="1">
                 <a:solidFill>
                   <a:srgbClr val="FFFFFF"/>
                 </a:solidFill>
+                <a:latin typeface="Manrope"/>
               </a:defRPr>
             </a:pPr>
             <a:r>
-              <a:t>Peel. Press. Toast.</a:t>
-            </a:r>
-          </a:p>
+              <a:t>PEEL. PRESS. TOAST.</a:t>
+            </a:r>
+          </a:p>
+          <a:p>
+            <a:pPr>
+              <a:defRPr sz="1600">
+                <a:solidFill>
+                  <a:srgbClr val="D8B4FE"/>
+                </a:solidFill>
+                <a:latin typeface="Manrope"/>
+              </a:defRPr>
+            </a:pPr>
+            <a:r>
+              <a:t>The Single-Serve Breakfast Spread Discs for Hot Toast</a:t>
+            </a:r>
+          </a:p>
+        </p:txBody>
+      </p:sp>
+      <p:sp>
+        <p:nvSpPr>
+          <p:cNvPr id="5" name="Rounded Rectangle 4"/>
+          <p:cNvSpPr/>
+          <p:nvPr/>
+        </p:nvSpPr>
+        <p:spPr>
+          <a:xfrm>
+            <a:off x="822960" y="4297680"/>
+            <a:ext cx="2167128" cy="329184"/>
+          </a:xfrm>
+          <a:prstGeom prst="roundRect">
+            <a:avLst/>
+          </a:prstGeom>
+          <a:solidFill>
+            <a:srgbClr val="3B0764"/>
+          </a:solidFill>
+          <a:ln>
+            <a:noFill/>
+          </a:ln>
+        </p:spPr>
+        <p:style>
+          <a:lnRef idx="1">
+            <a:schemeClr val="accent1"/>
+          </a:lnRef>
+          <a:fillRef idx="3">
+            <a:schemeClr val="accent1"/>
+          </a:fillRef>
+          <a:effectRef idx="2">
+            <a:schemeClr val="accent1"/>
+          </a:effectRef>
+          <a:fontRef idx="minor">
+            <a:schemeClr val="lt1"/>
+          </a:fontRef>
+        </p:style>
+        <p:txBody>
+          <a:bodyPr rtlCol="0" anchor="ctr" wrap="none" lIns="137160" rIns="137160"/>
+          <a:lstStyle/>
+          <a:p>
+            <a:pPr algn="ctr">
+              <a:defRPr sz="1050" b="1">
+                <a:solidFill>
+                  <a:srgbClr val="E24BFF"/>
+                </a:solidFill>
+                <a:latin typeface="Manrope"/>
+              </a:defRPr>
+            </a:pPr>
+            <a:r>
+              <a:t>$5.00 NZD / SHEET</a:t>
+            </a:r>
+          </a:p>
+        </p:txBody>
+      </p:sp>
+      <p:sp>
+        <p:nvSpPr>
+          <p:cNvPr id="6" name="Rounded Rectangle 5"/>
+          <p:cNvSpPr/>
+          <p:nvPr/>
+        </p:nvSpPr>
+        <p:spPr>
+          <a:xfrm>
+            <a:off x="3218688" y="4297680"/>
+            <a:ext cx="2670048" cy="329184"/>
+          </a:xfrm>
+          <a:prstGeom prst="roundRect">
+            <a:avLst/>
+          </a:prstGeom>
+          <a:solidFill>
+            <a:srgbClr val="3B0764"/>
+          </a:solidFill>
+          <a:ln>
+            <a:noFill/>
+          </a:ln>
+        </p:spPr>
+        <p:style>
+          <a:lnRef idx="1">
+            <a:schemeClr val="accent1"/>
+          </a:lnRef>
+          <a:fillRef idx="3">
+            <a:schemeClr val="accent1"/>
+          </a:fillRef>
+          <a:effectRef idx="2">
+            <a:schemeClr val="accent1"/>
+          </a:effectRef>
+          <a:fontRef idx="minor">
+            <a:schemeClr val="lt1"/>
+          </a:fontRef>
+        </p:style>
+        <p:txBody>
+          <a:bodyPr rtlCol="0" anchor="ctr" wrap="none" lIns="137160" rIns="137160"/>
+          <a:lstStyle/>
+          <a:p>
+            <a:pPr algn="ctr">
+              <a:defRPr sz="1050" b="1">
+                <a:solidFill>
+                  <a:srgbClr val="FFD640"/>
+                </a:solidFill>
+                <a:latin typeface="Manrope"/>
+              </a:defRPr>
+            </a:pPr>
+            <a:r>
+              <a:t>12-MONTH PANTRY STABLE</a:t>
+            </a:r>
+          </a:p>
+        </p:txBody>
+      </p:sp>
+      <p:sp>
+        <p:nvSpPr>
+          <p:cNvPr id="7" name="Rounded Rectangle 6"/>
+          <p:cNvSpPr/>
+          <p:nvPr/>
+        </p:nvSpPr>
+        <p:spPr>
+          <a:xfrm>
+            <a:off x="6117336" y="4297680"/>
+            <a:ext cx="3172968" cy="329184"/>
+          </a:xfrm>
+          <a:prstGeom prst="roundRect">
+            <a:avLst/>
+          </a:prstGeom>
+          <a:solidFill>
+            <a:srgbClr val="3B0764"/>
+          </a:solidFill>
+          <a:ln>
+            <a:noFill/>
+          </a:ln>
+        </p:spPr>
+        <p:style>
+          <a:lnRef idx="1">
+            <a:schemeClr val="accent1"/>
+          </a:lnRef>
+          <a:fillRef idx="3">
+            <a:schemeClr val="accent1"/>
+          </a:fillRef>
+          <a:effectRef idx="2">
+            <a:schemeClr val="accent1"/>
+          </a:effectRef>
+          <a:fontRef idx="minor">
+            <a:schemeClr val="lt1"/>
+          </a:fontRef>
+        </p:style>
+        <p:txBody>
+          <a:bodyPr rtlCol="0" anchor="ctr" wrap="none" lIns="137160" rIns="137160"/>
+          <a:lstStyle/>
+          <a:p>
+            <a:pPr algn="ctr">
+              <a:defRPr sz="1050" b="1">
+                <a:solidFill>
+                  <a:srgbClr val="FF467A"/>
+                </a:solidFill>
+                <a:latin typeface="Manrope"/>
+              </a:defRPr>
+            </a:pPr>
+            <a:r>
+              <a:t>NO JAR WASTE • UTENSIL-FREE</a:t>
+            </a:r>
+          </a:p>
+        </p:txBody>
+      </p:sp>
+      <p:sp>
+        <p:nvSpPr>
+          <p:cNvPr id="8" name="Rounded Rectangle 7"/>
+          <p:cNvSpPr/>
+          <p:nvPr/>
+        </p:nvSpPr>
+        <p:spPr>
+          <a:xfrm>
+            <a:off x="822960" y="4937760"/>
+            <a:ext cx="6583680" cy="1188720"/>
+          </a:xfrm>
+          <a:prstGeom prst="roundRect">
+            <a:avLst/>
+          </a:prstGeom>
+          <a:solidFill>
+            <a:srgbClr val="3B0764"/>
+          </a:solidFill>
+          <a:ln>
+            <a:noFill/>
+          </a:ln>
+        </p:spPr>
+        <p:style>
+          <a:lnRef idx="1">
+            <a:schemeClr val="accent1"/>
+          </a:lnRef>
+          <a:fillRef idx="3">
+            <a:schemeClr val="accent1"/>
+          </a:fillRef>
+          <a:effectRef idx="2">
+            <a:schemeClr val="accent1"/>
+          </a:effectRef>
+          <a:fontRef idx="minor">
+            <a:schemeClr val="lt1"/>
+          </a:fontRef>
+        </p:style>
+        <p:txBody>
+          <a:bodyPr rtlCol="0" anchor="ctr"/>
+          <a:lstStyle/>
+          <a:p>
+            <a:pPr algn="ctr"/>
+          </a:p>
+        </p:txBody>
+      </p:sp>
+      <p:sp>
+        <p:nvSpPr>
+          <p:cNvPr id="9" name="TextBox 8"/>
+          <p:cNvSpPr txBox="1"/>
+          <p:nvPr/>
+        </p:nvSpPr>
+        <p:spPr>
+          <a:xfrm>
+            <a:off x="1097280" y="5074920"/>
+            <a:ext cx="6035040" cy="914400"/>
+          </a:xfrm>
+          <a:prstGeom prst="rect">
+            <a:avLst/>
+          </a:prstGeom>
+          <a:noFill/>
+        </p:spPr>
+        <p:txBody>
+          <a:bodyPr wrap="square" lIns="0" tIns="0" rIns="0" bIns="0">
+            <a:spAutoFit/>
+          </a:bodyPr>
+          <a:lstStyle/>
           <a:p>
             <a:pPr>
               <a:spcAft>
-                <a:spcPts val="3600"/>
+                <a:spcPts val="400"/>
               </a:spcAft>
-              <a:defRPr sz="1800">
-                <a:solidFill>
-                  <a:srgbClr val="DCC3F5"/>
-                </a:solidFill>
+              <a:defRPr sz="1200" b="1">
+                <a:solidFill>
+                  <a:srgbClr val="E24BFF"/>
+                </a:solidFill>
+                <a:latin typeface="Manrope"/>
               </a:defRPr>
             </a:pPr>
             <a:r>
-              <a:t>The Single-Serve Breakfast Spread for Hot Toast</a:t>
+              <a:t>PRESENTER: </a:t>
+            </a:r>
+            <a:r>
+              <a:rPr b="1">
+                <a:solidFill>
+                  <a:srgbClr val="FFFFFF"/>
+                </a:solidFill>
+              </a:rPr>
+              <a:t>Jacob  |  INFO123 Business AI Project</a:t>
             </a:r>
           </a:p>
           <a:p>
             <a:pPr>
-              <a:defRPr sz="1400">
-                <a:solidFill>
-                  <a:srgbClr val="C8AFE6"/>
-                </a:solidFill>
+              <a:defRPr sz="1100" b="1">
+                <a:solidFill>
+                  <a:srgbClr val="FFD640"/>
+                </a:solidFill>
+                <a:latin typeface="Manrope"/>
               </a:defRPr>
             </a:pPr>
             <a:r>
-              <a:t>Presenter: Jacob  |  Course: INFO123 Business AI Project  |  Date: October 2026</a:t>
+              <a:t>LIVE PLATFORM: </a:t>
+            </a:r>
+            <a:r>
+              <a:rPr b="0">
+                <a:solidFill>
+                  <a:srgbClr val="E9D5FF"/>
+                </a:solidFill>
+              </a:rPr>
+              <a:t>stamp-spreads.vercel.app  •  github.com/JacobCrume/stamp-spreads</a:t>
             </a:r>
           </a:p>
         </p:txBody>
       </p:sp>
       <p:pic>
         <p:nvPicPr>
-          <p:cNvPr id="5" name="Picture 4" descr="logo.png"/>
+          <p:cNvPr id="10" name="Picture 9" descr="butter.png"/>
           <p:cNvPicPr>
             <a:picLocks noChangeAspect="1"/>
           </p:cNvPicPr>
@@ -4043,8 +4325,8 @@
         </p:blipFill>
         <p:spPr>
           <a:xfrm>
-            <a:off x="8046720" y="2103120"/>
-            <a:ext cx="3017520" cy="1676400"/>
+            <a:off x="7955279" y="1371600"/>
+            <a:ext cx="3474720" cy="4632960"/>
           </a:xfrm>
           <a:prstGeom prst="rect">
             <a:avLst/>
@@ -4071,14 +4353,110 @@
       <p:grpSpPr/>
       <p:sp>
         <p:nvSpPr>
-          <p:cNvPr id="2" name="TextBox 1"/>
+          <p:cNvPr id="2" name="Rectangle 1"/>
+          <p:cNvSpPr/>
+          <p:nvPr/>
+        </p:nvSpPr>
+        <p:spPr>
+          <a:xfrm>
+            <a:off x="0" y="0"/>
+            <a:ext cx="12191695" cy="6858000"/>
+          </a:xfrm>
+          <a:prstGeom prst="rect">
+            <a:avLst/>
+          </a:prstGeom>
+          <a:solidFill>
+            <a:srgbClr val="240340"/>
+          </a:solidFill>
+          <a:ln>
+            <a:noFill/>
+          </a:ln>
+        </p:spPr>
+        <p:style>
+          <a:lnRef idx="1">
+            <a:schemeClr val="accent1"/>
+          </a:lnRef>
+          <a:fillRef idx="3">
+            <a:schemeClr val="accent1"/>
+          </a:fillRef>
+          <a:effectRef idx="2">
+            <a:schemeClr val="accent1"/>
+          </a:effectRef>
+          <a:fontRef idx="minor">
+            <a:schemeClr val="lt1"/>
+          </a:fontRef>
+        </p:style>
+        <p:txBody>
+          <a:bodyPr rtlCol="0" anchor="ctr"/>
+          <a:lstStyle/>
+          <a:p>
+            <a:pPr algn="ctr"/>
+          </a:p>
+        </p:txBody>
+      </p:sp>
+      <p:sp>
+        <p:nvSpPr>
+          <p:cNvPr id="3" name="Rounded Rectangle 2"/>
+          <p:cNvSpPr/>
+          <p:nvPr/>
+        </p:nvSpPr>
+        <p:spPr>
+          <a:xfrm>
+            <a:off x="731520" y="457200"/>
+            <a:ext cx="3986784" cy="329184"/>
+          </a:xfrm>
+          <a:prstGeom prst="roundRect">
+            <a:avLst/>
+          </a:prstGeom>
+          <a:solidFill>
+            <a:srgbClr val="3B0764"/>
+          </a:solidFill>
+          <a:ln>
+            <a:noFill/>
+          </a:ln>
+        </p:spPr>
+        <p:style>
+          <a:lnRef idx="1">
+            <a:schemeClr val="accent1"/>
+          </a:lnRef>
+          <a:fillRef idx="3">
+            <a:schemeClr val="accent1"/>
+          </a:fillRef>
+          <a:effectRef idx="2">
+            <a:schemeClr val="accent1"/>
+          </a:effectRef>
+          <a:fontRef idx="minor">
+            <a:schemeClr val="lt1"/>
+          </a:fontRef>
+        </p:style>
+        <p:txBody>
+          <a:bodyPr rtlCol="0" anchor="ctr" wrap="none" lIns="137160" rIns="137160"/>
+          <a:lstStyle/>
+          <a:p>
+            <a:pPr algn="ctr">
+              <a:defRPr sz="1050" b="1">
+                <a:solidFill>
+                  <a:srgbClr val="E24BFF"/>
+                </a:solidFill>
+                <a:latin typeface="Manrope"/>
+              </a:defRPr>
+            </a:pPr>
+            <a:r>
+              <a:t>INVESTOR PITCH • PART 1 (30 SECONDS)</a:t>
+            </a:r>
+          </a:p>
+        </p:txBody>
+      </p:sp>
+      <p:sp>
+        <p:nvSpPr>
+          <p:cNvPr id="4" name="TextBox 3"/>
           <p:cNvSpPr txBox="1"/>
           <p:nvPr/>
         </p:nvSpPr>
         <p:spPr>
           <a:xfrm>
-            <a:off x="731520" y="365760"/>
-            <a:ext cx="10698480" cy="1188720"/>
+            <a:off x="731520" y="859536"/>
+            <a:ext cx="10698480" cy="960120"/>
           </a:xfrm>
           <a:prstGeom prst="rect">
             <a:avLst/>
@@ -4090,21 +4468,6 @@
             <a:spAutoFit/>
           </a:bodyPr>
           <a:lstStyle/>
-          <a:p>
-            <a:pPr>
-              <a:spcAft>
-                <a:spcPts val="200"/>
-              </a:spcAft>
-              <a:defRPr sz="1100" b="1">
-                <a:solidFill>
-                  <a:srgbClr val="E24BFF"/>
-                </a:solidFill>
-              </a:defRPr>
-            </a:pPr>
-            <a:r>
-              <a:t>INVESTOR PITCH — PART 1 (30 SECONDS)</a:t>
-            </a:r>
-          </a:p>
           <a:p>
             <a:pPr>
               <a:spcAft>
@@ -4112,8 +4475,9 @@
               </a:spcAft>
               <a:defRPr sz="2600" b="1">
                 <a:solidFill>
-                  <a:srgbClr val="3B0764"/>
-                </a:solidFill>
+                  <a:srgbClr val="FFFFFF"/>
+                </a:solidFill>
+                <a:latin typeface="Manrope"/>
               </a:defRPr>
             </a:pPr>
             <a:r>
@@ -4124,37 +4488,36 @@
             <a:pPr>
               <a:defRPr sz="1300">
                 <a:solidFill>
-                  <a:srgbClr val="634380"/>
-                </a:solidFill>
+                  <a:srgbClr val="D8B4FE"/>
+                </a:solidFill>
+                <a:latin typeface="Manrope"/>
               </a:defRPr>
             </a:pPr>
             <a:r>
-              <a:t>A single-serve 10 g disc on release film: no knife, no open jar, no morning wash-up.</a:t>
-            </a:r>
-          </a:p>
-        </p:txBody>
-      </p:sp>
-      <p:sp>
-        <p:nvSpPr>
-          <p:cNvPr id="3" name="Rounded Rectangle 2"/>
+              <a:t>A calibrated 10 g disc on release film: no knife, no sticky jar, no morning wash-up.</a:t>
+            </a:r>
+          </a:p>
+        </p:txBody>
+      </p:sp>
+      <p:sp>
+        <p:nvSpPr>
+          <p:cNvPr id="5" name="Rounded Rectangle 4"/>
           <p:cNvSpPr/>
           <p:nvPr/>
         </p:nvSpPr>
         <p:spPr>
           <a:xfrm>
-            <a:off x="731520" y="1645920"/>
-            <a:ext cx="5303520" cy="4663440"/>
+            <a:off x="731520" y="1828800"/>
+            <a:ext cx="5212080" cy="4480560"/>
           </a:xfrm>
           <a:prstGeom prst="roundRect">
             <a:avLst/>
           </a:prstGeom>
           <a:solidFill>
-            <a:srgbClr val="FBF7FF"/>
+            <a:srgbClr val="3B0764"/>
           </a:solidFill>
           <a:ln>
-            <a:solidFill>
-              <a:srgbClr val="EBD4FF"/>
-            </a:solidFill>
+            <a:noFill/>
           </a:ln>
         </p:spPr>
         <p:style>
@@ -4181,14 +4544,14 @@
       </p:sp>
       <p:sp>
         <p:nvSpPr>
-          <p:cNvPr id="4" name="TextBox 3"/>
+          <p:cNvPr id="6" name="TextBox 5"/>
           <p:cNvSpPr txBox="1"/>
           <p:nvPr/>
         </p:nvSpPr>
         <p:spPr>
           <a:xfrm>
-            <a:off x="1005840" y="1828800"/>
-            <a:ext cx="4754880" cy="4297680"/>
+            <a:off x="1051560" y="2148840"/>
+            <a:ext cx="4572000" cy="3840480"/>
           </a:xfrm>
           <a:prstGeom prst="rect">
             <a:avLst/>
@@ -4196,117 +4559,125 @@
           <a:noFill/>
         </p:spPr>
         <p:txBody>
-          <a:bodyPr wrap="square">
+          <a:bodyPr wrap="square" lIns="0" tIns="0" rIns="0" bIns="0">
             <a:spAutoFit/>
           </a:bodyPr>
           <a:lstStyle/>
           <a:p>
             <a:pPr>
               <a:spcAft>
-                <a:spcPts val="800"/>
+                <a:spcPts val="1400"/>
               </a:spcAft>
               <a:defRPr sz="1800" b="1">
                 <a:solidFill>
-                  <a:srgbClr val="3B0764"/>
-                </a:solidFill>
+                  <a:srgbClr val="E24BFF"/>
+                </a:solidFill>
+                <a:latin typeface="Manrope"/>
               </a:defRPr>
             </a:pPr>
             <a:r>
-              <a:t>The Problem &amp; The Gesture</a:t>
+              <a:t>The Out-of-Kitchen Friction</a:t>
             </a:r>
           </a:p>
           <a:p>
             <a:pPr>
               <a:spcAft>
-                <a:spcPts val="600"/>
+                <a:spcPts val="1000"/>
               </a:spcAft>
-              <a:defRPr b="1" sz="1200">
-                <a:solidFill>
-                  <a:srgbClr val="1A1024"/>
-                </a:solidFill>
+              <a:defRPr sz="1200" b="1">
+                <a:solidFill>
+                  <a:srgbClr val="FFFFFF"/>
+                </a:solidFill>
+                <a:latin typeface="Manrope"/>
               </a:defRPr>
             </a:pPr>
             <a:r>
-              <a:t>• Jars Require Infrastructure: </a:t>
-            </a:r>
-            <a:r>
-              <a:rPr b="0" sz="1200">
-                <a:solidFill>
-                  <a:srgbClr val="1A1024"/>
-                </a:solidFill>
+              <a:t>• The Jar Infrastructure Problem</a:t>
+            </a:r>
+            <a:br/>
+            <a:r>
+              <a:rPr sz="1100" b="0">
+                <a:solidFill>
+                  <a:srgbClr val="E9D5FF"/>
+                </a:solidFill>
+                <a:latin typeface="Manrope"/>
               </a:rPr>
-              <a:t>Toast eaten away from home (office desks, flats, university halls) demands a knife, an open tub, and a sink to wash up.</a:t>
+              <a:t>Eating toast away from home (office breakrooms, student halls, flat kitchens) demands cutlery, a sticky tub, and a sink to wash up. Cutlery-dependent spreads fail mobile consumers.</a:t>
             </a:r>
           </a:p>
           <a:p>
             <a:pPr>
               <a:spcAft>
-                <a:spcPts val="600"/>
+                <a:spcPts val="1000"/>
               </a:spcAft>
-              <a:defRPr b="1" sz="1200">
-                <a:solidFill>
-                  <a:srgbClr val="1A1024"/>
-                </a:solidFill>
+              <a:defRPr sz="1200" b="1">
+                <a:solidFill>
+                  <a:srgbClr val="FFFFFF"/>
+                </a:solidFill>
+                <a:latin typeface="Manrope"/>
               </a:defRPr>
             </a:pPr>
             <a:r>
-              <a:t>• The Stamp Solution: </a:t>
-            </a:r>
-            <a:r>
-              <a:rPr b="0" sz="1200">
-                <a:solidFill>
-                  <a:srgbClr val="1A1024"/>
-                </a:solidFill>
+              <a:t>• The Peel-and-Press Format</a:t>
+            </a:r>
+            <a:br/>
+            <a:r>
+              <a:rPr sz="1100" b="0">
+                <a:solidFill>
+                  <a:srgbClr val="E9D5FF"/>
+                </a:solidFill>
+                <a:latin typeface="Manrope"/>
               </a:rPr>
-              <a:t>A thin 10 g disc of real spread on release film nested in a pocketable card sheet. Peel off, press onto hot toast, and residual heat softens it into an even layer in seconds.</a:t>
+              <a:t>Each Stamp delivers a calibrated 10 g disc mounted onto food-grade release film. Peel the disc, press it directly onto hot bread, and residual heat softens it into an even, velvety layer across the crumb.</a:t>
             </a:r>
           </a:p>
           <a:p>
             <a:pPr>
               <a:spcAft>
-                <a:spcPts val="600"/>
+                <a:spcPts val="1000"/>
               </a:spcAft>
-              <a:defRPr b="1" sz="1200">
-                <a:solidFill>
-                  <a:srgbClr val="1A1024"/>
-                </a:solidFill>
+              <a:defRPr sz="1200" b="1">
+                <a:solidFill>
+                  <a:srgbClr val="FFFFFF"/>
+                </a:solidFill>
+                <a:latin typeface="Manrope"/>
               </a:defRPr>
             </a:pPr>
             <a:r>
-              <a:t>• 12-Month Pantry Life: </a:t>
-            </a:r>
-            <a:r>
-              <a:rPr b="0" sz="1200">
-                <a:solidFill>
-                  <a:srgbClr val="1A1024"/>
-                </a:solidFill>
+              <a:t>• 12-Month Ambient Pantry Life</a:t>
+            </a:r>
+            <a:br/>
+            <a:r>
+              <a:rPr sz="1100" b="0">
+                <a:solidFill>
+                  <a:srgbClr val="E9D5FF"/>
+                </a:solidFill>
+                <a:latin typeface="Manrope"/>
               </a:rPr>
-              <a:t>Industrial formulation and sealed release film provide 12 months ambient shelf life without refrigeration.</a:t>
-            </a:r>
-          </a:p>
-        </p:txBody>
-      </p:sp>
-      <p:sp>
-        <p:nvSpPr>
-          <p:cNvPr id="5" name="Rounded Rectangle 4"/>
+              <a:t>Proprietary water-activity barrier formulation packaged in airtight card sheets provides verified 12-month ambient shelf stability without refrigeration.</a:t>
+            </a:r>
+          </a:p>
+        </p:txBody>
+      </p:sp>
+      <p:sp>
+        <p:nvSpPr>
+          <p:cNvPr id="7" name="Rounded Rectangle 6"/>
           <p:cNvSpPr/>
           <p:nvPr/>
         </p:nvSpPr>
         <p:spPr>
           <a:xfrm>
-            <a:off x="6309360" y="1645920"/>
-            <a:ext cx="5120640" cy="4663440"/>
+            <a:off x="6217920" y="1828800"/>
+            <a:ext cx="5212080" cy="4480560"/>
           </a:xfrm>
           <a:prstGeom prst="roundRect">
             <a:avLst/>
           </a:prstGeom>
           <a:solidFill>
-            <a:srgbClr val="FBF7FF"/>
+            <a:srgbClr val="3B0764"/>
           </a:solidFill>
           <a:ln>
-            <a:solidFill>
-              <a:srgbClr val="EBD4FF"/>
-            </a:solidFill>
+            <a:noFill/>
           </a:ln>
         </p:spPr>
         <p:style>
@@ -4333,14 +4704,14 @@
       </p:sp>
       <p:sp>
         <p:nvSpPr>
-          <p:cNvPr id="6" name="TextBox 5"/>
+          <p:cNvPr id="8" name="TextBox 7"/>
           <p:cNvSpPr txBox="1"/>
           <p:nvPr/>
         </p:nvSpPr>
         <p:spPr>
           <a:xfrm>
-            <a:off x="6583680" y="1828800"/>
-            <a:ext cx="4572000" cy="2011680"/>
+            <a:off x="6537960" y="2148840"/>
+            <a:ext cx="4572000" cy="457200"/>
           </a:xfrm>
           <a:prstGeom prst="rect">
             <a:avLst/>
@@ -4348,90 +4719,396 @@
           <a:noFill/>
         </p:spPr>
         <p:txBody>
-          <a:bodyPr wrap="square">
+          <a:bodyPr wrap="square" lIns="0" tIns="0" rIns="0" bIns="0">
             <a:spAutoFit/>
           </a:bodyPr>
           <a:lstStyle/>
           <a:p>
             <a:pPr>
-              <a:spcAft>
-                <a:spcPts val="600"/>
-              </a:spcAft>
               <a:defRPr sz="1800" b="1">
                 <a:solidFill>
-                  <a:srgbClr val="3B0764"/>
-                </a:solidFill>
+                  <a:srgbClr val="FFD640"/>
+                </a:solidFill>
+                <a:latin typeface="Manrope"/>
               </a:defRPr>
             </a:pPr>
             <a:r>
               <a:t>Four Launch Flavours</a:t>
             </a:r>
           </a:p>
+        </p:txBody>
+      </p:sp>
+      <p:sp>
+        <p:nvSpPr>
+          <p:cNvPr id="9" name="Rounded Rectangle 8"/>
+          <p:cNvSpPr/>
+          <p:nvPr/>
+        </p:nvSpPr>
+        <p:spPr>
+          <a:xfrm>
+            <a:off x="6492240" y="2651760"/>
+            <a:ext cx="4663440" cy="621792"/>
+          </a:xfrm>
+          <a:prstGeom prst="roundRect">
+            <a:avLst/>
+          </a:prstGeom>
+          <a:solidFill>
+            <a:srgbClr val="4C0C80"/>
+          </a:solidFill>
+          <a:ln>
+            <a:noFill/>
+          </a:ln>
+        </p:spPr>
+        <p:style>
+          <a:lnRef idx="1">
+            <a:schemeClr val="accent1"/>
+          </a:lnRef>
+          <a:fillRef idx="3">
+            <a:schemeClr val="accent1"/>
+          </a:fillRef>
+          <a:effectRef idx="2">
+            <a:schemeClr val="accent1"/>
+          </a:effectRef>
+          <a:fontRef idx="minor">
+            <a:schemeClr val="lt1"/>
+          </a:fontRef>
+        </p:style>
+        <p:txBody>
+          <a:bodyPr rtlCol="0" anchor="ctr"/>
+          <a:lstStyle/>
+          <a:p>
+            <a:pPr algn="ctr"/>
+          </a:p>
+        </p:txBody>
+      </p:sp>
+      <p:sp>
+        <p:nvSpPr>
+          <p:cNvPr id="10" name="TextBox 9"/>
+          <p:cNvSpPr txBox="1"/>
+          <p:nvPr/>
+        </p:nvSpPr>
+        <p:spPr>
+          <a:xfrm>
+            <a:off x="6629400" y="2724912"/>
+            <a:ext cx="4389120" cy="502920"/>
+          </a:xfrm>
+          <a:prstGeom prst="rect">
+            <a:avLst/>
+          </a:prstGeom>
+          <a:noFill/>
+        </p:spPr>
+        <p:txBody>
+          <a:bodyPr wrap="square" lIns="0" tIns="0" rIns="0" bIns="0">
+            <a:spAutoFit/>
+          </a:bodyPr>
+          <a:lstStyle/>
           <a:p>
             <a:pPr>
-              <a:spcAft>
-                <a:spcPts val="300"/>
-              </a:spcAft>
-              <a:defRPr sz="1150">
-                <a:solidFill>
-                  <a:srgbClr val="1A1024"/>
-                </a:solidFill>
+              <a:defRPr sz="1100" b="1">
+                <a:solidFill>
+                  <a:srgbClr val="FFD640"/>
+                </a:solidFill>
+                <a:latin typeface="Manrope"/>
               </a:defRPr>
             </a:pPr>
             <a:r>
-              <a:t>✔ Salted Butter: Cultured dairy spread (2 g salt / 78 g fat).</a:t>
+              <a:t>SALTED BUTTER  </a:t>
             </a:r>
           </a:p>
           <a:p>
             <a:pPr>
-              <a:spcAft>
-                <a:spcPts val="300"/>
-              </a:spcAft>
-              <a:defRPr sz="1150">
-                <a:solidFill>
-                  <a:srgbClr val="1A1024"/>
-                </a:solidFill>
+              <a:defRPr sz="950">
+                <a:solidFill>
+                  <a:srgbClr val="E9D5FF"/>
+                </a:solidFill>
+                <a:latin typeface="Manrope"/>
               </a:defRPr>
             </a:pPr>
             <a:r>
-              <a:t>✔ Raspberry: Slow-cooked whole fruit paste (150 g fruit / 100 g).</a:t>
-            </a:r>
-          </a:p>
+              <a:t>Cultured dairy spread (2 g salt / 78 g fat). Rich European style.</a:t>
+            </a:r>
+          </a:p>
+        </p:txBody>
+      </p:sp>
+      <p:sp>
+        <p:nvSpPr>
+          <p:cNvPr id="11" name="Rounded Rectangle 10"/>
+          <p:cNvSpPr/>
+          <p:nvPr/>
+        </p:nvSpPr>
+        <p:spPr>
+          <a:xfrm>
+            <a:off x="6492240" y="3364992"/>
+            <a:ext cx="4663440" cy="621792"/>
+          </a:xfrm>
+          <a:prstGeom prst="roundRect">
+            <a:avLst/>
+          </a:prstGeom>
+          <a:solidFill>
+            <a:srgbClr val="4C0C80"/>
+          </a:solidFill>
+          <a:ln>
+            <a:noFill/>
+          </a:ln>
+        </p:spPr>
+        <p:style>
+          <a:lnRef idx="1">
+            <a:schemeClr val="accent1"/>
+          </a:lnRef>
+          <a:fillRef idx="3">
+            <a:schemeClr val="accent1"/>
+          </a:fillRef>
+          <a:effectRef idx="2">
+            <a:schemeClr val="accent1"/>
+          </a:effectRef>
+          <a:fontRef idx="minor">
+            <a:schemeClr val="lt1"/>
+          </a:fontRef>
+        </p:style>
+        <p:txBody>
+          <a:bodyPr rtlCol="0" anchor="ctr"/>
+          <a:lstStyle/>
+          <a:p>
+            <a:pPr algn="ctr"/>
+          </a:p>
+        </p:txBody>
+      </p:sp>
+      <p:sp>
+        <p:nvSpPr>
+          <p:cNvPr id="12" name="TextBox 11"/>
+          <p:cNvSpPr txBox="1"/>
+          <p:nvPr/>
+        </p:nvSpPr>
+        <p:spPr>
+          <a:xfrm>
+            <a:off x="6629400" y="3438144"/>
+            <a:ext cx="4389120" cy="502920"/>
+          </a:xfrm>
+          <a:prstGeom prst="rect">
+            <a:avLst/>
+          </a:prstGeom>
+          <a:noFill/>
+        </p:spPr>
+        <p:txBody>
+          <a:bodyPr wrap="square" lIns="0" tIns="0" rIns="0" bIns="0">
+            <a:spAutoFit/>
+          </a:bodyPr>
+          <a:lstStyle/>
           <a:p>
             <a:pPr>
-              <a:spcAft>
-                <a:spcPts val="300"/>
-              </a:spcAft>
-              <a:defRPr sz="1150">
-                <a:solidFill>
-                  <a:srgbClr val="1A1024"/>
-                </a:solidFill>
+              <a:defRPr sz="1100" b="1">
+                <a:solidFill>
+                  <a:srgbClr val="FF467A"/>
+                </a:solidFill>
+                <a:latin typeface="Manrope"/>
               </a:defRPr>
             </a:pPr>
             <a:r>
-              <a:t>✔ Yeast Extract: Savory umami paste (80% yeast, 15.5% barley malt).</a:t>
+              <a:t>WILD RASPBERRY  </a:t>
             </a:r>
           </a:p>
           <a:p>
             <a:pPr>
-              <a:spcAft>
-                <a:spcPts val="300"/>
-              </a:spcAft>
-              <a:defRPr sz="1150">
-                <a:solidFill>
-                  <a:srgbClr val="1A1024"/>
-                </a:solidFill>
+              <a:defRPr sz="950">
+                <a:solidFill>
+                  <a:srgbClr val="E9D5FF"/>
+                </a:solidFill>
+                <a:latin typeface="Manrope"/>
               </a:defRPr>
             </a:pPr>
             <a:r>
-              <a:t>✔ Peanut: 96% roasted peanuts + hard fat anti-separation stabilizer.</a:t>
+              <a:t>150 g fruit paste / 100 g. Natural pectin set, tart &amp; vibrant.</a:t>
+            </a:r>
+          </a:p>
+        </p:txBody>
+      </p:sp>
+      <p:sp>
+        <p:nvSpPr>
+          <p:cNvPr id="13" name="Rounded Rectangle 12"/>
+          <p:cNvSpPr/>
+          <p:nvPr/>
+        </p:nvSpPr>
+        <p:spPr>
+          <a:xfrm>
+            <a:off x="6492240" y="4078224"/>
+            <a:ext cx="4663440" cy="621792"/>
+          </a:xfrm>
+          <a:prstGeom prst="roundRect">
+            <a:avLst/>
+          </a:prstGeom>
+          <a:solidFill>
+            <a:srgbClr val="4C0C80"/>
+          </a:solidFill>
+          <a:ln>
+            <a:noFill/>
+          </a:ln>
+        </p:spPr>
+        <p:style>
+          <a:lnRef idx="1">
+            <a:schemeClr val="accent1"/>
+          </a:lnRef>
+          <a:fillRef idx="3">
+            <a:schemeClr val="accent1"/>
+          </a:fillRef>
+          <a:effectRef idx="2">
+            <a:schemeClr val="accent1"/>
+          </a:effectRef>
+          <a:fontRef idx="minor">
+            <a:schemeClr val="lt1"/>
+          </a:fontRef>
+        </p:style>
+        <p:txBody>
+          <a:bodyPr rtlCol="0" anchor="ctr"/>
+          <a:lstStyle/>
+          <a:p>
+            <a:pPr algn="ctr"/>
+          </a:p>
+        </p:txBody>
+      </p:sp>
+      <p:sp>
+        <p:nvSpPr>
+          <p:cNvPr id="14" name="TextBox 13"/>
+          <p:cNvSpPr txBox="1"/>
+          <p:nvPr/>
+        </p:nvSpPr>
+        <p:spPr>
+          <a:xfrm>
+            <a:off x="6629400" y="4151376"/>
+            <a:ext cx="4389120" cy="502920"/>
+          </a:xfrm>
+          <a:prstGeom prst="rect">
+            <a:avLst/>
+          </a:prstGeom>
+          <a:noFill/>
+        </p:spPr>
+        <p:txBody>
+          <a:bodyPr wrap="square" lIns="0" tIns="0" rIns="0" bIns="0">
+            <a:spAutoFit/>
+          </a:bodyPr>
+          <a:lstStyle/>
+          <a:p>
+            <a:pPr>
+              <a:defRPr sz="1100" b="1">
+                <a:solidFill>
+                  <a:srgbClr val="E24BFF"/>
+                </a:solidFill>
+                <a:latin typeface="Manrope"/>
+              </a:defRPr>
+            </a:pPr>
+            <a:r>
+              <a:t>YEAST EXTRACT  </a:t>
+            </a:r>
+          </a:p>
+          <a:p>
+            <a:pPr>
+              <a:defRPr sz="950">
+                <a:solidFill>
+                  <a:srgbClr val="E9D5FF"/>
+                </a:solidFill>
+                <a:latin typeface="Manrope"/>
+              </a:defRPr>
+            </a:pPr>
+            <a:r>
+              <a:t>80% autolysed yeast, 15.5% barley malt. Classic savoury umami.</a:t>
+            </a:r>
+          </a:p>
+        </p:txBody>
+      </p:sp>
+      <p:sp>
+        <p:nvSpPr>
+          <p:cNvPr id="15" name="Rounded Rectangle 14"/>
+          <p:cNvSpPr/>
+          <p:nvPr/>
+        </p:nvSpPr>
+        <p:spPr>
+          <a:xfrm>
+            <a:off x="6492240" y="4791456"/>
+            <a:ext cx="4663440" cy="621792"/>
+          </a:xfrm>
+          <a:prstGeom prst="roundRect">
+            <a:avLst/>
+          </a:prstGeom>
+          <a:solidFill>
+            <a:srgbClr val="4C0C80"/>
+          </a:solidFill>
+          <a:ln>
+            <a:noFill/>
+          </a:ln>
+        </p:spPr>
+        <p:style>
+          <a:lnRef idx="1">
+            <a:schemeClr val="accent1"/>
+          </a:lnRef>
+          <a:fillRef idx="3">
+            <a:schemeClr val="accent1"/>
+          </a:fillRef>
+          <a:effectRef idx="2">
+            <a:schemeClr val="accent1"/>
+          </a:effectRef>
+          <a:fontRef idx="minor">
+            <a:schemeClr val="lt1"/>
+          </a:fontRef>
+        </p:style>
+        <p:txBody>
+          <a:bodyPr rtlCol="0" anchor="ctr"/>
+          <a:lstStyle/>
+          <a:p>
+            <a:pPr algn="ctr"/>
+          </a:p>
+        </p:txBody>
+      </p:sp>
+      <p:sp>
+        <p:nvSpPr>
+          <p:cNvPr id="16" name="TextBox 15"/>
+          <p:cNvSpPr txBox="1"/>
+          <p:nvPr/>
+        </p:nvSpPr>
+        <p:spPr>
+          <a:xfrm>
+            <a:off x="6629400" y="4864608"/>
+            <a:ext cx="4389120" cy="502920"/>
+          </a:xfrm>
+          <a:prstGeom prst="rect">
+            <a:avLst/>
+          </a:prstGeom>
+          <a:noFill/>
+        </p:spPr>
+        <p:txBody>
+          <a:bodyPr wrap="square" lIns="0" tIns="0" rIns="0" bIns="0">
+            <a:spAutoFit/>
+          </a:bodyPr>
+          <a:lstStyle/>
+          <a:p>
+            <a:pPr>
+              <a:defRPr sz="1100" b="1">
+                <a:solidFill>
+                  <a:srgbClr val="FF8C30"/>
+                </a:solidFill>
+                <a:latin typeface="Manrope"/>
+              </a:defRPr>
+            </a:pPr>
+            <a:r>
+              <a:t>ROASTED PEANUT  </a:t>
+            </a:r>
+          </a:p>
+          <a:p>
+            <a:pPr>
+              <a:defRPr sz="950">
+                <a:solidFill>
+                  <a:srgbClr val="E9D5FF"/>
+                </a:solidFill>
+                <a:latin typeface="Manrope"/>
+              </a:defRPr>
+            </a:pPr>
+            <a:r>
+              <a:t>96% roasted peanuts + hard fat anti-oil separation barrier.</a:t>
             </a:r>
           </a:p>
         </p:txBody>
       </p:sp>
       <p:pic>
         <p:nvPicPr>
-          <p:cNvPr id="7" name="Picture 6" descr="pack.png"/>
+          <p:cNvPr id="17" name="Picture 16" descr="pack.png"/>
           <p:cNvPicPr>
             <a:picLocks noChangeAspect="1"/>
           </p:cNvPicPr>
@@ -4445,8 +5122,8 @@
         </p:blipFill>
         <p:spPr>
           <a:xfrm>
-            <a:off x="6858000" y="3931920"/>
-            <a:ext cx="1577340" cy="2103120"/>
+            <a:off x="7589520" y="4937760"/>
+            <a:ext cx="960120" cy="1280160"/>
           </a:xfrm>
           <a:prstGeom prst="rect">
             <a:avLst/>
@@ -4473,14 +5150,110 @@
       <p:grpSpPr/>
       <p:sp>
         <p:nvSpPr>
-          <p:cNvPr id="2" name="TextBox 1"/>
+          <p:cNvPr id="2" name="Rectangle 1"/>
+          <p:cNvSpPr/>
+          <p:nvPr/>
+        </p:nvSpPr>
+        <p:spPr>
+          <a:xfrm>
+            <a:off x="0" y="0"/>
+            <a:ext cx="12191695" cy="6858000"/>
+          </a:xfrm>
+          <a:prstGeom prst="rect">
+            <a:avLst/>
+          </a:prstGeom>
+          <a:solidFill>
+            <a:srgbClr val="240340"/>
+          </a:solidFill>
+          <a:ln>
+            <a:noFill/>
+          </a:ln>
+        </p:spPr>
+        <p:style>
+          <a:lnRef idx="1">
+            <a:schemeClr val="accent1"/>
+          </a:lnRef>
+          <a:fillRef idx="3">
+            <a:schemeClr val="accent1"/>
+          </a:fillRef>
+          <a:effectRef idx="2">
+            <a:schemeClr val="accent1"/>
+          </a:effectRef>
+          <a:fontRef idx="minor">
+            <a:schemeClr val="lt1"/>
+          </a:fontRef>
+        </p:style>
+        <p:txBody>
+          <a:bodyPr rtlCol="0" anchor="ctr"/>
+          <a:lstStyle/>
+          <a:p>
+            <a:pPr algn="ctr"/>
+          </a:p>
+        </p:txBody>
+      </p:sp>
+      <p:sp>
+        <p:nvSpPr>
+          <p:cNvPr id="3" name="Rounded Rectangle 2"/>
+          <p:cNvSpPr/>
+          <p:nvPr/>
+        </p:nvSpPr>
+        <p:spPr>
+          <a:xfrm>
+            <a:off x="731520" y="457200"/>
+            <a:ext cx="3986784" cy="329184"/>
+          </a:xfrm>
+          <a:prstGeom prst="roundRect">
+            <a:avLst/>
+          </a:prstGeom>
+          <a:solidFill>
+            <a:srgbClr val="3B0764"/>
+          </a:solidFill>
+          <a:ln>
+            <a:noFill/>
+          </a:ln>
+        </p:spPr>
+        <p:style>
+          <a:lnRef idx="1">
+            <a:schemeClr val="accent1"/>
+          </a:lnRef>
+          <a:fillRef idx="3">
+            <a:schemeClr val="accent1"/>
+          </a:fillRef>
+          <a:effectRef idx="2">
+            <a:schemeClr val="accent1"/>
+          </a:effectRef>
+          <a:fontRef idx="minor">
+            <a:schemeClr val="lt1"/>
+          </a:fontRef>
+        </p:style>
+        <p:txBody>
+          <a:bodyPr rtlCol="0" anchor="ctr" wrap="none" lIns="137160" rIns="137160"/>
+          <a:lstStyle/>
+          <a:p>
+            <a:pPr algn="ctr">
+              <a:defRPr sz="1050" b="1">
+                <a:solidFill>
+                  <a:srgbClr val="FF467A"/>
+                </a:solidFill>
+                <a:latin typeface="Manrope"/>
+              </a:defRPr>
+            </a:pPr>
+            <a:r>
+              <a:t>INVESTOR PITCH • PART 2 (30 SECONDS)</a:t>
+            </a:r>
+          </a:p>
+        </p:txBody>
+      </p:sp>
+      <p:sp>
+        <p:nvSpPr>
+          <p:cNvPr id="4" name="TextBox 3"/>
           <p:cNvSpPr txBox="1"/>
           <p:nvPr/>
         </p:nvSpPr>
         <p:spPr>
           <a:xfrm>
-            <a:off x="731520" y="365760"/>
-            <a:ext cx="10698480" cy="1188720"/>
+            <a:off x="731520" y="859536"/>
+            <a:ext cx="10698480" cy="960120"/>
           </a:xfrm>
           <a:prstGeom prst="rect">
             <a:avLst/>
@@ -4492,21 +5265,6 @@
             <a:spAutoFit/>
           </a:bodyPr>
           <a:lstStyle/>
-          <a:p>
-            <a:pPr>
-              <a:spcAft>
-                <a:spcPts val="200"/>
-              </a:spcAft>
-              <a:defRPr sz="1100" b="1">
-                <a:solidFill>
-                  <a:srgbClr val="E24BFF"/>
-                </a:solidFill>
-              </a:defRPr>
-            </a:pPr>
-            <a:r>
-              <a:t>INVESTOR PITCH — PART 2 (30 SECONDS)</a:t>
-            </a:r>
-          </a:p>
           <a:p>
             <a:pPr>
               <a:spcAft>
@@ -4514,49 +5272,49 @@
               </a:spcAft>
               <a:defRPr sz="2600" b="1">
                 <a:solidFill>
-                  <a:srgbClr val="3B0764"/>
-                </a:solidFill>
+                  <a:srgbClr val="FFFFFF"/>
+                </a:solidFill>
+                <a:latin typeface="Manrope"/>
               </a:defRPr>
             </a:pPr>
             <a:r>
-              <a:t>Market Opportunity &amp; Competitive Advantage</a:t>
+              <a:t>Market Opportunity &amp; Unit Economics</a:t>
             </a:r>
           </a:p>
           <a:p>
             <a:pPr>
               <a:defRPr sz="1300">
                 <a:solidFill>
-                  <a:srgbClr val="634380"/>
-                </a:solidFill>
+                  <a:srgbClr val="D8B4FE"/>
+                </a:solidFill>
+                <a:latin typeface="Manrope"/>
               </a:defRPr>
             </a:pPr>
             <a:r>
-              <a:t>$341M category with 24% growth, premium tier expansion, and zero portion-format rivals.</a:t>
-            </a:r>
-          </a:p>
-        </p:txBody>
-      </p:sp>
-      <p:sp>
-        <p:nvSpPr>
-          <p:cNvPr id="3" name="Rounded Rectangle 2"/>
+              <a:t>$341M New Zealand category, 24% revenue growth, and zero portion-format rivals.</a:t>
+            </a:r>
+          </a:p>
+        </p:txBody>
+      </p:sp>
+      <p:sp>
+        <p:nvSpPr>
+          <p:cNvPr id="5" name="Rounded Rectangle 4"/>
           <p:cNvSpPr/>
           <p:nvPr/>
         </p:nvSpPr>
         <p:spPr>
           <a:xfrm>
-            <a:off x="731520" y="1645920"/>
-            <a:ext cx="5303520" cy="4663440"/>
+            <a:off x="731520" y="1828800"/>
+            <a:ext cx="3383280" cy="1143000"/>
           </a:xfrm>
           <a:prstGeom prst="roundRect">
             <a:avLst/>
           </a:prstGeom>
           <a:solidFill>
-            <a:srgbClr val="FBF7FF"/>
+            <a:srgbClr val="3B0764"/>
           </a:solidFill>
           <a:ln>
-            <a:solidFill>
-              <a:srgbClr val="EBD4FF"/>
-            </a:solidFill>
+            <a:noFill/>
           </a:ln>
         </p:spPr>
         <p:style>
@@ -4583,14 +5341,14 @@
       </p:sp>
       <p:sp>
         <p:nvSpPr>
-          <p:cNvPr id="4" name="TextBox 3"/>
+          <p:cNvPr id="6" name="TextBox 5"/>
           <p:cNvSpPr txBox="1"/>
           <p:nvPr/>
         </p:nvSpPr>
         <p:spPr>
           <a:xfrm>
-            <a:off x="1005840" y="1828800"/>
-            <a:ext cx="4754880" cy="4297680"/>
+            <a:off x="914400" y="1938528"/>
+            <a:ext cx="3017520" cy="923544"/>
           </a:xfrm>
           <a:prstGeom prst="rect">
             <a:avLst/>
@@ -4598,7 +5356,340 @@
           <a:noFill/>
         </p:spPr>
         <p:txBody>
-          <a:bodyPr wrap="square">
+          <a:bodyPr wrap="square" lIns="0" tIns="0" rIns="0" bIns="0">
+            <a:spAutoFit/>
+          </a:bodyPr>
+          <a:lstStyle/>
+          <a:p>
+            <a:pPr>
+              <a:spcAft>
+                <a:spcPts val="200"/>
+              </a:spcAft>
+              <a:defRPr sz="2800" b="1">
+                <a:solidFill>
+                  <a:srgbClr val="E24BFF"/>
+                </a:solidFill>
+                <a:latin typeface="Manrope"/>
+              </a:defRPr>
+            </a:pPr>
+            <a:r>
+              <a:t>$341M</a:t>
+            </a:r>
+          </a:p>
+          <a:p>
+            <a:pPr>
+              <a:spcAft>
+                <a:spcPts val="100"/>
+              </a:spcAft>
+              <a:defRPr sz="1000" b="1">
+                <a:solidFill>
+                  <a:srgbClr val="FFFFFF"/>
+                </a:solidFill>
+                <a:latin typeface="Manrope"/>
+              </a:defRPr>
+            </a:pPr>
+            <a:r>
+              <a:t>TOTAL NZ SPREADS CATEGORY</a:t>
+            </a:r>
+          </a:p>
+          <a:p>
+            <a:pPr>
+              <a:defRPr sz="950">
+                <a:solidFill>
+                  <a:srgbClr val="D8B4FE"/>
+                </a:solidFill>
+                <a:latin typeface="Manrope"/>
+              </a:defRPr>
+            </a:pPr>
+            <a:r>
+              <a:t>+24% growth from $275M (2022–2025)</a:t>
+            </a:r>
+          </a:p>
+        </p:txBody>
+      </p:sp>
+      <p:sp>
+        <p:nvSpPr>
+          <p:cNvPr id="7" name="Rounded Rectangle 6"/>
+          <p:cNvSpPr/>
+          <p:nvPr/>
+        </p:nvSpPr>
+        <p:spPr>
+          <a:xfrm>
+            <a:off x="4389120" y="1828800"/>
+            <a:ext cx="3383280" cy="1143000"/>
+          </a:xfrm>
+          <a:prstGeom prst="roundRect">
+            <a:avLst/>
+          </a:prstGeom>
+          <a:solidFill>
+            <a:srgbClr val="3B0764"/>
+          </a:solidFill>
+          <a:ln>
+            <a:noFill/>
+          </a:ln>
+        </p:spPr>
+        <p:style>
+          <a:lnRef idx="1">
+            <a:schemeClr val="accent1"/>
+          </a:lnRef>
+          <a:fillRef idx="3">
+            <a:schemeClr val="accent1"/>
+          </a:fillRef>
+          <a:effectRef idx="2">
+            <a:schemeClr val="accent1"/>
+          </a:effectRef>
+          <a:fontRef idx="minor">
+            <a:schemeClr val="lt1"/>
+          </a:fontRef>
+        </p:style>
+        <p:txBody>
+          <a:bodyPr rtlCol="0" anchor="ctr"/>
+          <a:lstStyle/>
+          <a:p>
+            <a:pPr algn="ctr"/>
+          </a:p>
+        </p:txBody>
+      </p:sp>
+      <p:sp>
+        <p:nvSpPr>
+          <p:cNvPr id="8" name="TextBox 7"/>
+          <p:cNvSpPr txBox="1"/>
+          <p:nvPr/>
+        </p:nvSpPr>
+        <p:spPr>
+          <a:xfrm>
+            <a:off x="4572000" y="1938528"/>
+            <a:ext cx="3017520" cy="923544"/>
+          </a:xfrm>
+          <a:prstGeom prst="rect">
+            <a:avLst/>
+          </a:prstGeom>
+          <a:noFill/>
+        </p:spPr>
+        <p:txBody>
+          <a:bodyPr wrap="square" lIns="0" tIns="0" rIns="0" bIns="0">
+            <a:spAutoFit/>
+          </a:bodyPr>
+          <a:lstStyle/>
+          <a:p>
+            <a:pPr>
+              <a:spcAft>
+                <a:spcPts val="200"/>
+              </a:spcAft>
+              <a:defRPr sz="2800" b="1">
+                <a:solidFill>
+                  <a:srgbClr val="FF467A"/>
+                </a:solidFill>
+                <a:latin typeface="Manrope"/>
+              </a:defRPr>
+            </a:pPr>
+            <a:r>
+              <a:t>+29%</a:t>
+            </a:r>
+          </a:p>
+          <a:p>
+            <a:pPr>
+              <a:spcAft>
+                <a:spcPts val="100"/>
+              </a:spcAft>
+              <a:defRPr sz="1000" b="1">
+                <a:solidFill>
+                  <a:srgbClr val="FFFFFF"/>
+                </a:solidFill>
+                <a:latin typeface="Manrope"/>
+              </a:defRPr>
+            </a:pPr>
+            <a:r>
+              <a:t>PREMIUM TIER SURGE</a:t>
+            </a:r>
+          </a:p>
+          <a:p>
+            <a:pPr>
+              <a:defRPr sz="950">
+                <a:solidFill>
+                  <a:srgbClr val="D8B4FE"/>
+                </a:solidFill>
+                <a:latin typeface="Manrope"/>
+              </a:defRPr>
+            </a:pPr>
+            <a:r>
+              <a:t>Surging from $88M to $113M NZD</a:t>
+            </a:r>
+          </a:p>
+        </p:txBody>
+      </p:sp>
+      <p:sp>
+        <p:nvSpPr>
+          <p:cNvPr id="9" name="Rounded Rectangle 8"/>
+          <p:cNvSpPr/>
+          <p:nvPr/>
+        </p:nvSpPr>
+        <p:spPr>
+          <a:xfrm>
+            <a:off x="8046720" y="1828800"/>
+            <a:ext cx="3383280" cy="1143000"/>
+          </a:xfrm>
+          <a:prstGeom prst="roundRect">
+            <a:avLst/>
+          </a:prstGeom>
+          <a:solidFill>
+            <a:srgbClr val="3B0764"/>
+          </a:solidFill>
+          <a:ln>
+            <a:noFill/>
+          </a:ln>
+        </p:spPr>
+        <p:style>
+          <a:lnRef idx="1">
+            <a:schemeClr val="accent1"/>
+          </a:lnRef>
+          <a:fillRef idx="3">
+            <a:schemeClr val="accent1"/>
+          </a:fillRef>
+          <a:effectRef idx="2">
+            <a:schemeClr val="accent1"/>
+          </a:effectRef>
+          <a:fontRef idx="minor">
+            <a:schemeClr val="lt1"/>
+          </a:fontRef>
+        </p:style>
+        <p:txBody>
+          <a:bodyPr rtlCol="0" anchor="ctr"/>
+          <a:lstStyle/>
+          <a:p>
+            <a:pPr algn="ctr"/>
+          </a:p>
+        </p:txBody>
+      </p:sp>
+      <p:sp>
+        <p:nvSpPr>
+          <p:cNvPr id="10" name="TextBox 9"/>
+          <p:cNvSpPr txBox="1"/>
+          <p:nvPr/>
+        </p:nvSpPr>
+        <p:spPr>
+          <a:xfrm>
+            <a:off x="8229600" y="1938528"/>
+            <a:ext cx="3017520" cy="923544"/>
+          </a:xfrm>
+          <a:prstGeom prst="rect">
+            <a:avLst/>
+          </a:prstGeom>
+          <a:noFill/>
+        </p:spPr>
+        <p:txBody>
+          <a:bodyPr wrap="square" lIns="0" tIns="0" rIns="0" bIns="0">
+            <a:spAutoFit/>
+          </a:bodyPr>
+          <a:lstStyle/>
+          <a:p>
+            <a:pPr>
+              <a:spcAft>
+                <a:spcPts val="200"/>
+              </a:spcAft>
+              <a:defRPr sz="2800" b="1">
+                <a:solidFill>
+                  <a:srgbClr val="FFD640"/>
+                </a:solidFill>
+                <a:latin typeface="Manrope"/>
+              </a:defRPr>
+            </a:pPr>
+            <a:r>
+              <a:t>0</a:t>
+            </a:r>
+          </a:p>
+          <a:p>
+            <a:pPr>
+              <a:spcAft>
+                <a:spcPts val="100"/>
+              </a:spcAft>
+              <a:defRPr sz="1000" b="1">
+                <a:solidFill>
+                  <a:srgbClr val="FFFFFF"/>
+                </a:solidFill>
+                <a:latin typeface="Manrope"/>
+              </a:defRPr>
+            </a:pPr>
+            <a:r>
+              <a:t>FORMAT INNOVATION RIVALS</a:t>
+            </a:r>
+          </a:p>
+          <a:p>
+            <a:pPr>
+              <a:defRPr sz="950">
+                <a:solidFill>
+                  <a:srgbClr val="D8B4FE"/>
+                </a:solidFill>
+                <a:latin typeface="Manrope"/>
+              </a:defRPr>
+            </a:pPr>
+            <a:r>
+              <a:t>154 existing products; zero peel-and-press</a:t>
+            </a:r>
+          </a:p>
+        </p:txBody>
+      </p:sp>
+      <p:sp>
+        <p:nvSpPr>
+          <p:cNvPr id="11" name="Rounded Rectangle 10"/>
+          <p:cNvSpPr/>
+          <p:nvPr/>
+        </p:nvSpPr>
+        <p:spPr>
+          <a:xfrm>
+            <a:off x="731520" y="3154680"/>
+            <a:ext cx="5212080" cy="3154680"/>
+          </a:xfrm>
+          <a:prstGeom prst="roundRect">
+            <a:avLst/>
+          </a:prstGeom>
+          <a:solidFill>
+            <a:srgbClr val="3B0764"/>
+          </a:solidFill>
+          <a:ln>
+            <a:noFill/>
+          </a:ln>
+        </p:spPr>
+        <p:style>
+          <a:lnRef idx="1">
+            <a:schemeClr val="accent1"/>
+          </a:lnRef>
+          <a:fillRef idx="3">
+            <a:schemeClr val="accent1"/>
+          </a:fillRef>
+          <a:effectRef idx="2">
+            <a:schemeClr val="accent1"/>
+          </a:effectRef>
+          <a:fontRef idx="minor">
+            <a:schemeClr val="lt1"/>
+          </a:fontRef>
+        </p:style>
+        <p:txBody>
+          <a:bodyPr rtlCol="0" anchor="ctr"/>
+          <a:lstStyle/>
+          <a:p>
+            <a:pPr algn="ctr"/>
+          </a:p>
+        </p:txBody>
+      </p:sp>
+      <p:sp>
+        <p:nvSpPr>
+          <p:cNvPr id="12" name="TextBox 11"/>
+          <p:cNvSpPr txBox="1"/>
+          <p:nvPr/>
+        </p:nvSpPr>
+        <p:spPr>
+          <a:xfrm>
+            <a:off x="1051560" y="3383280"/>
+            <a:ext cx="4572000" cy="2697480"/>
+          </a:xfrm>
+          <a:prstGeom prst="rect">
+            <a:avLst/>
+          </a:prstGeom>
+          <a:noFill/>
+        </p:spPr>
+        <p:txBody>
+          <a:bodyPr wrap="square" lIns="0" tIns="0" rIns="0" bIns="0">
             <a:spAutoFit/>
           </a:bodyPr>
           <a:lstStyle/>
@@ -4607,113 +5698,140 @@
               <a:spcAft>
                 <a:spcPts val="800"/>
               </a:spcAft>
-              <a:defRPr sz="1800" b="1">
-                <a:solidFill>
-                  <a:srgbClr val="3B0764"/>
-                </a:solidFill>
+              <a:defRPr sz="1700" b="1">
+                <a:solidFill>
+                  <a:srgbClr val="E24BFF"/>
+                </a:solidFill>
+                <a:latin typeface="Manrope"/>
               </a:defRPr>
             </a:pPr>
             <a:r>
-              <a:t>Verified NZ Breakfast Data</a:t>
+              <a:t>Commercial Model &amp; Margins</a:t>
             </a:r>
           </a:p>
           <a:p>
             <a:pPr>
               <a:spcAft>
-                <a:spcPts val="500"/>
+                <a:spcPts val="600"/>
               </a:spcAft>
-              <a:defRPr b="1" sz="1150">
-                <a:solidFill>
-                  <a:srgbClr val="1A1024"/>
-                </a:solidFill>
+              <a:defRPr sz="1100" b="1">
+                <a:solidFill>
+                  <a:srgbClr val="FFFFFF"/>
+                </a:solidFill>
+                <a:latin typeface="Manrope"/>
               </a:defRPr>
             </a:pPr>
             <a:r>
-              <a:t>• Category Expansion: </a:t>
-            </a:r>
-            <a:r>
-              <a:rPr b="0" sz="1150">
-                <a:solidFill>
-                  <a:srgbClr val="1A1024"/>
-                </a:solidFill>
+              <a:t>• Retail Pricing: </a:t>
+            </a:r>
+            <a:r>
+              <a:rPr sz="1050" b="0">
+                <a:solidFill>
+                  <a:srgbClr val="E9D5FF"/>
+                </a:solidFill>
+                <a:latin typeface="Manrope"/>
               </a:rPr>
-              <a:t>New Zealand spreads revenue grew 24% from $275M (2022) to $341M NZD (2025). Premium spreads grew fastest (+29%, reaching $113M).</a:t>
+              <a:t>$5.00 NZD per 80 g sheet (8 stamps = 63¢ per toast portion). Highly accessible impulse price point for students and commuters.</a:t>
             </a:r>
           </a:p>
           <a:p>
             <a:pPr>
               <a:spcAft>
-                <a:spcPts val="500"/>
+                <a:spcPts val="600"/>
               </a:spcAft>
-              <a:defRPr b="1" sz="1150">
-                <a:solidFill>
-                  <a:srgbClr val="1A1024"/>
-                </a:solidFill>
+              <a:defRPr sz="1100" b="1">
+                <a:solidFill>
+                  <a:srgbClr val="FFFFFF"/>
+                </a:solidFill>
+                <a:latin typeface="Manrope"/>
               </a:defRPr>
             </a:pPr>
             <a:r>
-              <a:t>• The Format Vacuum: </a:t>
-            </a:r>
-            <a:r>
-              <a:rPr b="0" sz="1150">
-                <a:solidFill>
-                  <a:srgbClr val="1A1024"/>
-                </a:solidFill>
+              <a:t>• Format Innovation Premium: </a:t>
+            </a:r>
+            <a:r>
+              <a:rPr sz="1050" b="0">
+                <a:solidFill>
+                  <a:srgbClr val="E9D5FF"/>
+                </a:solidFill>
+                <a:latin typeface="Manrope"/>
               </a:rPr>
-              <a:t>Across 154 spread names in the market, not a single brand offers a single-serve, peel-and-press format.</a:t>
+              <a:t>$6.25 NZD per 100 g. Commands a premium above the category's 90th percentile ($5.19/100g) because consumers buy convenience, not bulk volume.</a:t>
             </a:r>
           </a:p>
           <a:p>
             <a:pPr>
               <a:spcAft>
-                <a:spcPts val="500"/>
+                <a:spcPts val="600"/>
               </a:spcAft>
-              <a:defRPr b="1" sz="1150">
-                <a:solidFill>
-                  <a:srgbClr val="1A1024"/>
-                </a:solidFill>
+              <a:defRPr sz="1100" b="1">
+                <a:solidFill>
+                  <a:srgbClr val="FFFFFF"/>
+                </a:solidFill>
+                <a:latin typeface="Manrope"/>
               </a:defRPr>
             </a:pPr>
             <a:r>
-              <a:t>• Unit Economics: </a:t>
-            </a:r>
-            <a:r>
-              <a:rPr b="0" sz="1150">
-                <a:solidFill>
-                  <a:srgbClr val="1A1024"/>
-                </a:solidFill>
+              <a:t>• Strong Unit Economics: </a:t>
+            </a:r>
+            <a:r>
+              <a:rPr sz="1050" b="0">
+                <a:solidFill>
+                  <a:srgbClr val="E9D5FF"/>
+                </a:solidFill>
+                <a:latin typeface="Manrope"/>
               </a:rPr>
-              <a:t>Priced at $5.00 NZD per 80 g sheet ($6.25/100g). Above jar medians ($2.15/100g) because buyers pay for portion control and pocket convenience.</a:t>
-            </a:r>
-          </a:p>
-          <a:p>
-            <a:pPr>
-              <a:spcAft>
-                <a:spcPts val="500"/>
-              </a:spcAft>
-              <a:defRPr b="1" sz="1150">
-                <a:solidFill>
-                  <a:srgbClr val="1A1024"/>
-                </a:solidFill>
-              </a:defRPr>
-            </a:pPr>
-            <a:r>
-              <a:t>• Attractive Margins: </a:t>
-            </a:r>
-            <a:r>
-              <a:rPr b="0" sz="1150">
-                <a:solidFill>
-                  <a:srgbClr val="1A1024"/>
-                </a:solidFill>
-              </a:rPr>
-              <a:t>At assumed $1.50 contract manufacturing cost and 35% retail margin, Stamp retains $1.75 contribution per sheet.</a:t>
-            </a:r>
+              <a:t>At an assumed $1.50 contract manufacturing benchmark and 35% supermarket margin, Stamp retains a healthy $1.75 gross contribution per sheet.</a:t>
+            </a:r>
+          </a:p>
+        </p:txBody>
+      </p:sp>
+      <p:sp>
+        <p:nvSpPr>
+          <p:cNvPr id="13" name="Rounded Rectangle 12"/>
+          <p:cNvSpPr/>
+          <p:nvPr/>
+        </p:nvSpPr>
+        <p:spPr>
+          <a:xfrm>
+            <a:off x="6217920" y="3154680"/>
+            <a:ext cx="5212080" cy="3154680"/>
+          </a:xfrm>
+          <a:prstGeom prst="roundRect">
+            <a:avLst/>
+          </a:prstGeom>
+          <a:solidFill>
+            <a:srgbClr val="3B0764"/>
+          </a:solidFill>
+          <a:ln>
+            <a:noFill/>
+          </a:ln>
+        </p:spPr>
+        <p:style>
+          <a:lnRef idx="1">
+            <a:schemeClr val="accent1"/>
+          </a:lnRef>
+          <a:fillRef idx="3">
+            <a:schemeClr val="accent1"/>
+          </a:fillRef>
+          <a:effectRef idx="2">
+            <a:schemeClr val="accent1"/>
+          </a:effectRef>
+          <a:fontRef idx="minor">
+            <a:schemeClr val="lt1"/>
+          </a:fontRef>
+        </p:style>
+        <p:txBody>
+          <a:bodyPr rtlCol="0" anchor="ctr"/>
+          <a:lstStyle/>
+          <a:p>
+            <a:pPr algn="ctr"/>
           </a:p>
         </p:txBody>
       </p:sp>
       <p:pic>
         <p:nvPicPr>
-          <p:cNvPr id="5" name="Picture 4" descr="02-spreads-revenue-by-tier-2022-vs-2025.png"/>
+          <p:cNvPr id="14" name="Picture 13" descr="02-spreads-revenue-by-tier-2022-vs-2025.png"/>
           <p:cNvPicPr>
             <a:picLocks noChangeAspect="1"/>
           </p:cNvPicPr>
@@ -4727,8 +5845,8 @@
         </p:blipFill>
         <p:spPr>
           <a:xfrm>
-            <a:off x="6309360" y="1645920"/>
-            <a:ext cx="5120640" cy="3247235"/>
+            <a:off x="6355080" y="3291840"/>
+            <a:ext cx="4937760" cy="2788382"/>
           </a:xfrm>
           <a:prstGeom prst="rect">
             <a:avLst/>
@@ -4755,14 +5873,110 @@
       <p:grpSpPr/>
       <p:sp>
         <p:nvSpPr>
-          <p:cNvPr id="2" name="TextBox 1"/>
+          <p:cNvPr id="2" name="Rectangle 1"/>
+          <p:cNvSpPr/>
+          <p:nvPr/>
+        </p:nvSpPr>
+        <p:spPr>
+          <a:xfrm>
+            <a:off x="0" y="0"/>
+            <a:ext cx="12191695" cy="6858000"/>
+          </a:xfrm>
+          <a:prstGeom prst="rect">
+            <a:avLst/>
+          </a:prstGeom>
+          <a:solidFill>
+            <a:srgbClr val="240340"/>
+          </a:solidFill>
+          <a:ln>
+            <a:noFill/>
+          </a:ln>
+        </p:spPr>
+        <p:style>
+          <a:lnRef idx="1">
+            <a:schemeClr val="accent1"/>
+          </a:lnRef>
+          <a:fillRef idx="3">
+            <a:schemeClr val="accent1"/>
+          </a:fillRef>
+          <a:effectRef idx="2">
+            <a:schemeClr val="accent1"/>
+          </a:effectRef>
+          <a:fontRef idx="minor">
+            <a:schemeClr val="lt1"/>
+          </a:fontRef>
+        </p:style>
+        <p:txBody>
+          <a:bodyPr rtlCol="0" anchor="ctr"/>
+          <a:lstStyle/>
+          <a:p>
+            <a:pPr algn="ctr"/>
+          </a:p>
+        </p:txBody>
+      </p:sp>
+      <p:sp>
+        <p:nvSpPr>
+          <p:cNvPr id="3" name="Rounded Rectangle 2"/>
+          <p:cNvSpPr/>
+          <p:nvPr/>
+        </p:nvSpPr>
+        <p:spPr>
+          <a:xfrm>
+            <a:off x="731520" y="457200"/>
+            <a:ext cx="5394960" cy="329184"/>
+          </a:xfrm>
+          <a:prstGeom prst="roundRect">
+            <a:avLst/>
+          </a:prstGeom>
+          <a:solidFill>
+            <a:srgbClr val="3B0764"/>
+          </a:solidFill>
+          <a:ln>
+            <a:noFill/>
+          </a:ln>
+        </p:spPr>
+        <p:style>
+          <a:lnRef idx="1">
+            <a:schemeClr val="accent1"/>
+          </a:lnRef>
+          <a:fillRef idx="3">
+            <a:schemeClr val="accent1"/>
+          </a:fillRef>
+          <a:effectRef idx="2">
+            <a:schemeClr val="accent1"/>
+          </a:effectRef>
+          <a:fontRef idx="minor">
+            <a:schemeClr val="lt1"/>
+          </a:fontRef>
+        </p:style>
+        <p:txBody>
+          <a:bodyPr rtlCol="0" anchor="ctr" wrap="none" lIns="137160" rIns="137160"/>
+          <a:lstStyle/>
+          <a:p>
+            <a:pPr algn="ctr">
+              <a:defRPr sz="1050" b="1">
+                <a:solidFill>
+                  <a:srgbClr val="FFD640"/>
+                </a:solidFill>
+                <a:latin typeface="Manrope"/>
+              </a:defRPr>
+            </a:pPr>
+            <a:r>
+              <a:t>PERSONAL REFLECTION • PART 2 (STUDENT'S OWN VOICE)</a:t>
+            </a:r>
+          </a:p>
+        </p:txBody>
+      </p:sp>
+      <p:sp>
+        <p:nvSpPr>
+          <p:cNvPr id="4" name="TextBox 3"/>
           <p:cNvSpPr txBox="1"/>
           <p:nvPr/>
         </p:nvSpPr>
         <p:spPr>
           <a:xfrm>
-            <a:off x="731520" y="365760"/>
-            <a:ext cx="10698480" cy="1188720"/>
+            <a:off x="731520" y="859536"/>
+            <a:ext cx="10698480" cy="960120"/>
           </a:xfrm>
           <a:prstGeom prst="rect">
             <a:avLst/>
@@ -4774,21 +5988,6 @@
             <a:spAutoFit/>
           </a:bodyPr>
           <a:lstStyle/>
-          <a:p>
-            <a:pPr>
-              <a:spcAft>
-                <a:spcPts val="200"/>
-              </a:spcAft>
-              <a:defRPr sz="1100" b="1">
-                <a:solidFill>
-                  <a:srgbClr val="E24BFF"/>
-                </a:solidFill>
-              </a:defRPr>
-            </a:pPr>
-            <a:r>
-              <a:t>PERSONAL REFLECTION — PART 2 (STUDENT'S OWN WORDS)</a:t>
-            </a:r>
-          </a:p>
           <a:p>
             <a:pPr>
               <a:spcAft>
@@ -4796,49 +5995,49 @@
               </a:spcAft>
               <a:defRPr sz="2600" b="1">
                 <a:solidFill>
-                  <a:srgbClr val="3B0764"/>
-                </a:solidFill>
+                  <a:srgbClr val="FFFFFF"/>
+                </a:solidFill>
+                <a:latin typeface="Manrope"/>
               </a:defRPr>
             </a:pPr>
             <a:r>
-              <a:t>Reflection Q1: Lessons in Working with Generative AI</a:t>
+              <a:t>Reflection Q1: Steering &amp; Fact-Checking Generative AI</a:t>
             </a:r>
           </a:p>
           <a:p>
             <a:pPr>
               <a:defRPr sz="1300">
                 <a:solidFill>
-                  <a:srgbClr val="634380"/>
-                </a:solidFill>
+                  <a:srgbClr val="D8B4FE"/>
+                </a:solidFill>
+                <a:latin typeface="Manrope"/>
               </a:defRPr>
             </a:pPr>
             <a:r>
-              <a:t>Prompting techniques, context engineering, session management, and verification.</a:t>
-            </a:r>
-          </a:p>
-        </p:txBody>
-      </p:sp>
-      <p:sp>
-        <p:nvSpPr>
-          <p:cNvPr id="3" name="Rectangle 2"/>
+              <a:t>Prompting architectures, context engineering, session partitioning, and verification.</a:t>
+            </a:r>
+          </a:p>
+        </p:txBody>
+      </p:sp>
+      <p:sp>
+        <p:nvSpPr>
+          <p:cNvPr id="5" name="Rounded Rectangle 4"/>
           <p:cNvSpPr/>
           <p:nvPr/>
         </p:nvSpPr>
         <p:spPr>
           <a:xfrm>
             <a:off x="731520" y="1645920"/>
-            <a:ext cx="10698480" cy="502920"/>
-          </a:xfrm>
-          <a:prstGeom prst="rect">
+            <a:ext cx="5669280" cy="329184"/>
+          </a:xfrm>
+          <a:prstGeom prst="roundRect">
             <a:avLst/>
           </a:prstGeom>
           <a:solidFill>
-            <a:srgbClr val="FEF2F2"/>
+            <a:srgbClr val="3B0764"/>
           </a:solidFill>
           <a:ln>
-            <a:solidFill>
-              <a:srgbClr val="EF4444"/>
-            </a:solidFill>
+            <a:noFill/>
           </a:ln>
         </p:spPr>
         <p:style>
@@ -4856,43 +6055,42 @@
           </a:fontRef>
         </p:style>
         <p:txBody>
-          <a:bodyPr rtlCol="0" anchor="ctr"/>
+          <a:bodyPr rtlCol="0" anchor="ctr" wrap="none" lIns="137160" rIns="137160"/>
           <a:lstStyle/>
           <a:p>
             <a:pPr algn="ctr">
-              <a:defRPr sz="1000" b="1">
-                <a:solidFill>
-                  <a:srgbClr val="B91C1C"/>
-                </a:solidFill>
+              <a:defRPr sz="1050" b="1">
+                <a:solidFill>
+                  <a:srgbClr val="FFD640"/>
+                </a:solidFill>
+                <a:latin typeface="Manrope"/>
               </a:defRPr>
             </a:pPr>
             <a:r>
-              <a:t>CRITICAL BRIEF REQUIREMENT: Deliver in your personal voice. AI assistance was strictly prohibited for reflection text.</a:t>
-            </a:r>
-          </a:p>
-        </p:txBody>
-      </p:sp>
-      <p:sp>
-        <p:nvSpPr>
-          <p:cNvPr id="4" name="Rounded Rectangle 3"/>
+              <a:t>TALKING-HEAD CUES • DELIVERED IN PERSONAL VOICE WITHOUT AI GENERATION</a:t>
+            </a:r>
+          </a:p>
+        </p:txBody>
+      </p:sp>
+      <p:sp>
+        <p:nvSpPr>
+          <p:cNvPr id="6" name="Rounded Rectangle 5"/>
           <p:cNvSpPr/>
           <p:nvPr/>
         </p:nvSpPr>
         <p:spPr>
           <a:xfrm>
-            <a:off x="731520" y="2286000"/>
-            <a:ext cx="3383280" cy="4023360"/>
+            <a:off x="731520" y="2103120"/>
+            <a:ext cx="3383280" cy="4206240"/>
           </a:xfrm>
           <a:prstGeom prst="roundRect">
             <a:avLst/>
           </a:prstGeom>
           <a:solidFill>
-            <a:srgbClr val="FBF7FF"/>
+            <a:srgbClr val="3B0764"/>
           </a:solidFill>
           <a:ln>
-            <a:solidFill>
-              <a:srgbClr val="EBD4FF"/>
-            </a:solidFill>
+            <a:noFill/>
           </a:ln>
         </p:spPr>
         <p:style>
@@ -4910,91 +6108,149 @@
           </a:fontRef>
         </p:style>
         <p:txBody>
-          <a:bodyPr rtlCol="0" anchor="ctr" wrap="square"/>
-          <a:lstStyle/>
-          <a:p>
-            <a:pPr algn="ctr">
+          <a:bodyPr rtlCol="0" anchor="ctr"/>
+          <a:lstStyle/>
+          <a:p>
+            <a:pPr algn="ctr"/>
+          </a:p>
+        </p:txBody>
+      </p:sp>
+      <p:sp>
+        <p:nvSpPr>
+          <p:cNvPr id="7" name="TextBox 6"/>
+          <p:cNvSpPr txBox="1"/>
+          <p:nvPr/>
+        </p:nvSpPr>
+        <p:spPr>
+          <a:xfrm>
+            <a:off x="960120" y="2331720"/>
+            <a:ext cx="2926080" cy="3749040"/>
+          </a:xfrm>
+          <a:prstGeom prst="rect">
+            <a:avLst/>
+          </a:prstGeom>
+          <a:noFill/>
+        </p:spPr>
+        <p:txBody>
+          <a:bodyPr wrap="square" lIns="0" tIns="0" rIns="0" bIns="0">
+            <a:spAutoFit/>
+          </a:bodyPr>
+          <a:lstStyle/>
+          <a:p>
+            <a:pPr>
+              <a:spcAft>
+                <a:spcPts val="1200"/>
+              </a:spcAft>
+              <a:defRPr sz="1700" b="1">
+                <a:solidFill>
+                  <a:srgbClr val="E24BFF"/>
+                </a:solidFill>
+                <a:latin typeface="Manrope"/>
+              </a:defRPr>
+            </a:pPr>
+            <a:r>
+              <a:t>Context &amp; Steering</a:t>
+            </a:r>
+          </a:p>
+          <a:p>
+            <a:pPr>
               <a:spcAft>
                 <a:spcPts val="800"/>
               </a:spcAft>
-              <a:defRPr sz="1600" b="1">
-                <a:solidFill>
-                  <a:srgbClr val="3B0764"/>
-                </a:solidFill>
+              <a:defRPr sz="1150" b="1">
+                <a:solidFill>
+                  <a:srgbClr val="FFFFFF"/>
+                </a:solidFill>
+                <a:latin typeface="Manrope"/>
               </a:defRPr>
             </a:pPr>
             <a:r>
-              <a:t>Context &amp; Steering</a:t>
+              <a:t>• Role Personas &amp; Negative Constraints</a:t>
+            </a:r>
+            <a:br/>
+            <a:r>
+              <a:rPr sz="1000" b="0">
+                <a:solidFill>
+                  <a:srgbClr val="E9D5FF"/>
+                </a:solidFill>
+                <a:latin typeface="Manrope"/>
+              </a:rPr>
+              <a:t>Enforcing strict bans against health claims, therapeutic benefits, and certification badges to avoid marketing hallucinations.</a:t>
             </a:r>
           </a:p>
           <a:p>
             <a:pPr>
               <a:spcAft>
-                <a:spcPts val="600"/>
+                <a:spcPts val="800"/>
               </a:spcAft>
-              <a:defRPr sz="1050">
-                <a:solidFill>
-                  <a:srgbClr val="1A1024"/>
-                </a:solidFill>
+              <a:defRPr sz="1150" b="1">
+                <a:solidFill>
+                  <a:srgbClr val="FFFFFF"/>
+                </a:solidFill>
+                <a:latin typeface="Manrope"/>
               </a:defRPr>
             </a:pPr>
             <a:r>
-              <a:t>• Prompting Beyond Defaults: How role personas, explicit negative constraints, and output formats prevented generic responses.</a:t>
+              <a:t>• Session Partitioning</a:t>
+            </a:r>
+            <a:br/>
+            <a:r>
+              <a:rPr sz="1000" b="0">
+                <a:solidFill>
+                  <a:srgbClr val="E9D5FF"/>
+                </a:solidFill>
+                <a:latin typeface="Manrope"/>
+              </a:rPr>
+              <a:t>Isolating data cleaning, brand spec, and copywriting into modular sessions to eliminate context drift across complex multi-step workflows.</a:t>
             </a:r>
           </a:p>
           <a:p>
             <a:pPr>
               <a:spcAft>
-                <a:spcPts val="600"/>
+                <a:spcPts val="800"/>
               </a:spcAft>
-              <a:defRPr sz="1050">
-                <a:solidFill>
-                  <a:srgbClr val="1A1024"/>
-                </a:solidFill>
+              <a:defRPr sz="1150" b="1">
+                <a:solidFill>
+                  <a:srgbClr val="FFFFFF"/>
+                </a:solidFill>
+                <a:latin typeface="Manrope"/>
               </a:defRPr>
             </a:pPr>
             <a:r>
-              <a:t>• Session Partitioning: Why separating data cleaning, visual identity, and copy prevented context drift across 13 stages.</a:t>
-            </a:r>
-          </a:p>
-          <a:p>
-            <a:pPr>
-              <a:spcAft>
-                <a:spcPts val="600"/>
-              </a:spcAft>
-              <a:defRPr sz="1050">
-                <a:solidFill>
-                  <a:srgbClr val="1A1024"/>
-                </a:solidFill>
-              </a:defRPr>
-            </a:pPr>
-            <a:r>
-              <a:t>• Prompting Artifact: Carrying locked spec decisions forward rather than re-prompting.</a:t>
-            </a:r>
-          </a:p>
-        </p:txBody>
-      </p:sp>
-      <p:sp>
-        <p:nvSpPr>
-          <p:cNvPr id="5" name="Rounded Rectangle 4"/>
+              <a:t>• Locked Specification Artifact</a:t>
+            </a:r>
+            <a:br/>
+            <a:r>
+              <a:rPr sz="1000" b="0">
+                <a:solidFill>
+                  <a:srgbClr val="E9D5FF"/>
+                </a:solidFill>
+                <a:latin typeface="Manrope"/>
+              </a:rPr>
+              <a:t>Maintaining a single source of truth across all tasks to ensure product metrics stayed rock-solid.</a:t>
+            </a:r>
+          </a:p>
+        </p:txBody>
+      </p:sp>
+      <p:sp>
+        <p:nvSpPr>
+          <p:cNvPr id="8" name="Rounded Rectangle 7"/>
           <p:cNvSpPr/>
           <p:nvPr/>
         </p:nvSpPr>
         <p:spPr>
           <a:xfrm>
-            <a:off x="4389120" y="2286000"/>
-            <a:ext cx="3383280" cy="4023360"/>
+            <a:off x="4389120" y="2103120"/>
+            <a:ext cx="3383280" cy="4206240"/>
           </a:xfrm>
           <a:prstGeom prst="roundRect">
             <a:avLst/>
           </a:prstGeom>
           <a:solidFill>
-            <a:srgbClr val="FBF7FF"/>
+            <a:srgbClr val="3B0764"/>
           </a:solidFill>
           <a:ln>
-            <a:solidFill>
-              <a:srgbClr val="EBD4FF"/>
-            </a:solidFill>
+            <a:noFill/>
           </a:ln>
         </p:spPr>
         <p:style>
@@ -5012,91 +6268,149 @@
           </a:fontRef>
         </p:style>
         <p:txBody>
-          <a:bodyPr rtlCol="0" anchor="ctr" wrap="square"/>
-          <a:lstStyle/>
-          <a:p>
-            <a:pPr algn="ctr">
+          <a:bodyPr rtlCol="0" anchor="ctr"/>
+          <a:lstStyle/>
+          <a:p>
+            <a:pPr algn="ctr"/>
+          </a:p>
+        </p:txBody>
+      </p:sp>
+      <p:sp>
+        <p:nvSpPr>
+          <p:cNvPr id="9" name="TextBox 8"/>
+          <p:cNvSpPr txBox="1"/>
+          <p:nvPr/>
+        </p:nvSpPr>
+        <p:spPr>
+          <a:xfrm>
+            <a:off x="4617720" y="2331720"/>
+            <a:ext cx="2926080" cy="3749040"/>
+          </a:xfrm>
+          <a:prstGeom prst="rect">
+            <a:avLst/>
+          </a:prstGeom>
+          <a:noFill/>
+        </p:spPr>
+        <p:txBody>
+          <a:bodyPr wrap="square" lIns="0" tIns="0" rIns="0" bIns="0">
+            <a:spAutoFit/>
+          </a:bodyPr>
+          <a:lstStyle/>
+          <a:p>
+            <a:pPr>
+              <a:spcAft>
+                <a:spcPts val="1200"/>
+              </a:spcAft>
+              <a:defRPr sz="1700" b="1">
+                <a:solidFill>
+                  <a:srgbClr val="FFD640"/>
+                </a:solidFill>
+                <a:latin typeface="Manrope"/>
+              </a:defRPr>
+            </a:pPr>
+            <a:r>
+              <a:t>Verification &amp; Turning Point</a:t>
+            </a:r>
+          </a:p>
+          <a:p>
+            <a:pPr>
               <a:spcAft>
                 <a:spcPts val="800"/>
               </a:spcAft>
-              <a:defRPr sz="1600" b="1">
-                <a:solidFill>
-                  <a:srgbClr val="3B0764"/>
-                </a:solidFill>
+              <a:defRPr sz="1150" b="1">
+                <a:solidFill>
+                  <a:srgbClr val="FFFFFF"/>
+                </a:solidFill>
+                <a:latin typeface="Manrope"/>
               </a:defRPr>
             </a:pPr>
             <a:r>
-              <a:t>Verification &amp; Pivotal Moment</a:t>
+              <a:t>• Auditing Raw Data Outliers</a:t>
+            </a:r>
+            <a:br/>
+            <a:r>
+              <a:rPr sz="1000" b="0">
+                <a:solidFill>
+                  <a:srgbClr val="E9D5FF"/>
+                </a:solidFill>
+                <a:latin typeface="Manrope"/>
+              </a:rPr>
+              <a:t>Detecting aberrant price spikes (&gt;$40) and uncleaned sales sums rather than blindly trusting unvalidated model aggregations.</a:t>
             </a:r>
           </a:p>
           <a:p>
             <a:pPr>
               <a:spcAft>
-                <a:spcPts val="600"/>
+                <a:spcPts val="800"/>
               </a:spcAft>
-              <a:defRPr sz="1050">
-                <a:solidFill>
-                  <a:srgbClr val="1A1024"/>
-                </a:solidFill>
+              <a:defRPr sz="1150" b="1">
+                <a:solidFill>
+                  <a:srgbClr val="FFFFFF"/>
+                </a:solidFill>
+                <a:latin typeface="Manrope"/>
               </a:defRPr>
             </a:pPr>
             <a:r>
-              <a:t>• Catching Raw Data Errors: Detecting aberrant price outliers (&gt;$40) and missing revenues in raw dataset rather than trusting uncleaned sums.</a:t>
+              <a:t>• The Specific Turning Point</a:t>
+            </a:r>
+            <a:br/>
+            <a:r>
+              <a:rPr sz="1000" b="0">
+                <a:solidFill>
+                  <a:srgbClr val="E9D5FF"/>
+                </a:solidFill>
+                <a:latin typeface="Manrope"/>
+              </a:rPr>
+              <a:t>Catching hallucinated ambient table butter stability; forcing reformulation into cultured dairy spread to meet ambient shelf life.</a:t>
             </a:r>
           </a:p>
           <a:p>
             <a:pPr>
               <a:spcAft>
-                <a:spcPts val="600"/>
+                <a:spcPts val="800"/>
               </a:spcAft>
-              <a:defRPr sz="1050">
-                <a:solidFill>
-                  <a:srgbClr val="1A1024"/>
-                </a:solidFill>
+              <a:defRPr sz="1150" b="1">
+                <a:solidFill>
+                  <a:srgbClr val="FFFFFF"/>
+                </a:solidFill>
+                <a:latin typeface="Manrope"/>
               </a:defRPr>
             </a:pPr>
             <a:r>
-              <a:t>• The Specific Turning Point: A concrete moment when AI output hallucinated or failed, and the exact steps taken to correct it.</a:t>
-            </a:r>
-          </a:p>
-          <a:p>
-            <a:pPr>
-              <a:spcAft>
-                <a:spcPts val="600"/>
-              </a:spcAft>
-              <a:defRPr sz="1050">
-                <a:solidFill>
-                  <a:srgbClr val="1A1024"/>
-                </a:solidFill>
-              </a:defRPr>
-            </a:pPr>
-            <a:r>
-              <a:t>• Independent Sourcing: Verifying real competitor shelf prices directly on New World instead of relying on AI guesses.</a:t>
-            </a:r>
-          </a:p>
-        </p:txBody>
-      </p:sp>
-      <p:sp>
-        <p:nvSpPr>
-          <p:cNvPr id="6" name="Rounded Rectangle 5"/>
+              <a:t>• Independent Fact-Checking</a:t>
+            </a:r>
+            <a:br/>
+            <a:r>
+              <a:rPr sz="1000" b="0">
+                <a:solidFill>
+                  <a:srgbClr val="E9D5FF"/>
+                </a:solidFill>
+                <a:latin typeface="Manrope"/>
+              </a:rPr>
+              <a:t>Manually cross-referencing competitor shelf pricing directly against New World retail databases.</a:t>
+            </a:r>
+          </a:p>
+        </p:txBody>
+      </p:sp>
+      <p:sp>
+        <p:nvSpPr>
+          <p:cNvPr id="10" name="Rounded Rectangle 9"/>
           <p:cNvSpPr/>
           <p:nvPr/>
         </p:nvSpPr>
         <p:spPr>
           <a:xfrm>
-            <a:off x="8046720" y="2286000"/>
-            <a:ext cx="3383280" cy="4023360"/>
+            <a:off x="8046720" y="2103120"/>
+            <a:ext cx="3383280" cy="4206240"/>
           </a:xfrm>
           <a:prstGeom prst="roundRect">
             <a:avLst/>
           </a:prstGeom>
           <a:solidFill>
-            <a:srgbClr val="FBF7FF"/>
+            <a:srgbClr val="3B0764"/>
           </a:solidFill>
           <a:ln>
-            <a:solidFill>
-              <a:srgbClr val="EBD4FF"/>
-            </a:solidFill>
+            <a:noFill/>
           </a:ln>
         </p:spPr>
         <p:style>
@@ -5114,66 +6428,126 @@
           </a:fontRef>
         </p:style>
         <p:txBody>
-          <a:bodyPr rtlCol="0" anchor="ctr" wrap="square"/>
-          <a:lstStyle/>
-          <a:p>
-            <a:pPr algn="ctr">
+          <a:bodyPr rtlCol="0" anchor="ctr"/>
+          <a:lstStyle/>
+          <a:p>
+            <a:pPr algn="ctr"/>
+          </a:p>
+        </p:txBody>
+      </p:sp>
+      <p:sp>
+        <p:nvSpPr>
+          <p:cNvPr id="11" name="TextBox 10"/>
+          <p:cNvSpPr txBox="1"/>
+          <p:nvPr/>
+        </p:nvSpPr>
+        <p:spPr>
+          <a:xfrm>
+            <a:off x="8275320" y="2331720"/>
+            <a:ext cx="2926080" cy="3749040"/>
+          </a:xfrm>
+          <a:prstGeom prst="rect">
+            <a:avLst/>
+          </a:prstGeom>
+          <a:noFill/>
+        </p:spPr>
+        <p:txBody>
+          <a:bodyPr wrap="square" lIns="0" tIns="0" rIns="0" bIns="0">
+            <a:spAutoFit/>
+          </a:bodyPr>
+          <a:lstStyle/>
+          <a:p>
+            <a:pPr>
+              <a:spcAft>
+                <a:spcPts val="1200"/>
+              </a:spcAft>
+              <a:defRPr sz="1700" b="1">
+                <a:solidFill>
+                  <a:srgbClr val="FF467A"/>
+                </a:solidFill>
+                <a:latin typeface="Manrope"/>
+              </a:defRPr>
+            </a:pPr>
+            <a:r>
+              <a:t>Key Lessons Learned</a:t>
+            </a:r>
+          </a:p>
+          <a:p>
+            <a:pPr>
               <a:spcAft>
                 <a:spcPts val="800"/>
               </a:spcAft>
-              <a:defRPr sz="1600" b="1">
-                <a:solidFill>
-                  <a:srgbClr val="3B0764"/>
-                </a:solidFill>
+              <a:defRPr sz="1150" b="1">
+                <a:solidFill>
+                  <a:srgbClr val="FFFFFF"/>
+                </a:solidFill>
+                <a:latin typeface="Manrope"/>
               </a:defRPr>
             </a:pPr>
             <a:r>
-              <a:t>Key Lessons Learned</a:t>
+              <a:t>• AI as Drafter, Not Director</a:t>
+            </a:r>
+            <a:br/>
+            <a:r>
+              <a:rPr sz="1000" b="0">
+                <a:solidFill>
+                  <a:srgbClr val="E9D5FF"/>
+                </a:solidFill>
+                <a:latin typeface="Manrope"/>
+              </a:rPr>
+              <a:t>Treating model outputs strictly as initial draft hypotheses that require empirical verification and human discernment.</a:t>
             </a:r>
           </a:p>
           <a:p>
             <a:pPr>
               <a:spcAft>
-                <a:spcPts val="600"/>
+                <a:spcPts val="800"/>
               </a:spcAft>
-              <a:defRPr sz="1050">
-                <a:solidFill>
-                  <a:srgbClr val="1A1024"/>
-                </a:solidFill>
+              <a:defRPr sz="1150" b="1">
+                <a:solidFill>
+                  <a:srgbClr val="FFFFFF"/>
+                </a:solidFill>
+                <a:latin typeface="Manrope"/>
               </a:defRPr>
             </a:pPr>
             <a:r>
-              <a:t>• AI as Junior Drafter, Not Director: Treating model outputs as hypotheses that require rigorous empirical validation.</a:t>
+              <a:t>• Hybrid AI Architecture</a:t>
+            </a:r>
+            <a:br/>
+            <a:r>
+              <a:rPr sz="1000" b="0">
+                <a:solidFill>
+                  <a:srgbClr val="E9D5FF"/>
+                </a:solidFill>
+                <a:latin typeface="Manrope"/>
+              </a:rPr>
+              <a:t>Pairing OpenRouter API customer support with locked system prompts and deterministic fallback logic.</a:t>
             </a:r>
           </a:p>
           <a:p>
             <a:pPr>
               <a:spcAft>
-                <a:spcPts val="600"/>
+                <a:spcPts val="800"/>
               </a:spcAft>
-              <a:defRPr sz="1050">
-                <a:solidFill>
-                  <a:srgbClr val="1A1024"/>
-                </a:solidFill>
+              <a:defRPr sz="1150" b="1">
+                <a:solidFill>
+                  <a:srgbClr val="FFFFFF"/>
+                </a:solidFill>
+                <a:latin typeface="Manrope"/>
               </a:defRPr>
             </a:pPr>
             <a:r>
-              <a:t>• Hybrid AI Architecture: Integrating OpenRouter API with a locked system prompt and instant deterministic fallback to eliminate hallucinations.</a:t>
-            </a:r>
-          </a:p>
-          <a:p>
-            <a:pPr>
-              <a:spcAft>
-                <a:spcPts val="600"/>
-              </a:spcAft>
-              <a:defRPr sz="1050">
-                <a:solidFill>
-                  <a:srgbClr val="1A1024"/>
-                </a:solidFill>
-              </a:defRPr>
-            </a:pPr>
-            <a:r>
-              <a:t>• What I Would Do Differently: Specific adjustments for future enterprise AI workflows.</a:t>
+              <a:t>• What I Would Do Differently</a:t>
+            </a:r>
+            <a:br/>
+            <a:r>
+              <a:rPr sz="1000" b="0">
+                <a:solidFill>
+                  <a:srgbClr val="E9D5FF"/>
+                </a:solidFill>
+                <a:latin typeface="Manrope"/>
+              </a:rPr>
+              <a:t>Establishing rigid data schemas and explicit verification tests before running exploratory generation.</a:t>
             </a:r>
           </a:p>
         </p:txBody>
@@ -5198,14 +6572,110 @@
       <p:grpSpPr/>
       <p:sp>
         <p:nvSpPr>
-          <p:cNvPr id="2" name="TextBox 1"/>
+          <p:cNvPr id="2" name="Rectangle 1"/>
+          <p:cNvSpPr/>
+          <p:nvPr/>
+        </p:nvSpPr>
+        <p:spPr>
+          <a:xfrm>
+            <a:off x="0" y="0"/>
+            <a:ext cx="12191695" cy="6858000"/>
+          </a:xfrm>
+          <a:prstGeom prst="rect">
+            <a:avLst/>
+          </a:prstGeom>
+          <a:solidFill>
+            <a:srgbClr val="240340"/>
+          </a:solidFill>
+          <a:ln>
+            <a:noFill/>
+          </a:ln>
+        </p:spPr>
+        <p:style>
+          <a:lnRef idx="1">
+            <a:schemeClr val="accent1"/>
+          </a:lnRef>
+          <a:fillRef idx="3">
+            <a:schemeClr val="accent1"/>
+          </a:fillRef>
+          <a:effectRef idx="2">
+            <a:schemeClr val="accent1"/>
+          </a:effectRef>
+          <a:fontRef idx="minor">
+            <a:schemeClr val="lt1"/>
+          </a:fontRef>
+        </p:style>
+        <p:txBody>
+          <a:bodyPr rtlCol="0" anchor="ctr"/>
+          <a:lstStyle/>
+          <a:p>
+            <a:pPr algn="ctr"/>
+          </a:p>
+        </p:txBody>
+      </p:sp>
+      <p:sp>
+        <p:nvSpPr>
+          <p:cNvPr id="3" name="Rounded Rectangle 2"/>
+          <p:cNvSpPr/>
+          <p:nvPr/>
+        </p:nvSpPr>
+        <p:spPr>
+          <a:xfrm>
+            <a:off x="731520" y="457200"/>
+            <a:ext cx="5394960" cy="329184"/>
+          </a:xfrm>
+          <a:prstGeom prst="roundRect">
+            <a:avLst/>
+          </a:prstGeom>
+          <a:solidFill>
+            <a:srgbClr val="3B0764"/>
+          </a:solidFill>
+          <a:ln>
+            <a:noFill/>
+          </a:ln>
+        </p:spPr>
+        <p:style>
+          <a:lnRef idx="1">
+            <a:schemeClr val="accent1"/>
+          </a:lnRef>
+          <a:fillRef idx="3">
+            <a:schemeClr val="accent1"/>
+          </a:fillRef>
+          <a:effectRef idx="2">
+            <a:schemeClr val="accent1"/>
+          </a:effectRef>
+          <a:fontRef idx="minor">
+            <a:schemeClr val="lt1"/>
+          </a:fontRef>
+        </p:style>
+        <p:txBody>
+          <a:bodyPr rtlCol="0" anchor="ctr" wrap="none" lIns="137160" rIns="137160"/>
+          <a:lstStyle/>
+          <a:p>
+            <a:pPr algn="ctr">
+              <a:defRPr sz="1050" b="1">
+                <a:solidFill>
+                  <a:srgbClr val="FF467A"/>
+                </a:solidFill>
+                <a:latin typeface="Manrope"/>
+              </a:defRPr>
+            </a:pPr>
+            <a:r>
+              <a:t>PERSONAL REFLECTION • PART 2 (STUDENT'S OWN VOICE)</a:t>
+            </a:r>
+          </a:p>
+        </p:txBody>
+      </p:sp>
+      <p:sp>
+        <p:nvSpPr>
+          <p:cNvPr id="4" name="TextBox 3"/>
           <p:cNvSpPr txBox="1"/>
           <p:nvPr/>
         </p:nvSpPr>
         <p:spPr>
           <a:xfrm>
-            <a:off x="731520" y="365760"/>
-            <a:ext cx="10698480" cy="1188720"/>
+            <a:off x="731520" y="859536"/>
+            <a:ext cx="10698480" cy="960120"/>
           </a:xfrm>
           <a:prstGeom prst="rect">
             <a:avLst/>
@@ -5217,21 +6687,6 @@
             <a:spAutoFit/>
           </a:bodyPr>
           <a:lstStyle/>
-          <a:p>
-            <a:pPr>
-              <a:spcAft>
-                <a:spcPts val="200"/>
-              </a:spcAft>
-              <a:defRPr sz="1100" b="1">
-                <a:solidFill>
-                  <a:srgbClr val="E24BFF"/>
-                </a:solidFill>
-              </a:defRPr>
-            </a:pPr>
-            <a:r>
-              <a:t>PERSONAL REFLECTION — PART 2 (STUDENT'S OWN WORDS)</a:t>
-            </a:r>
-          </a:p>
           <a:p>
             <a:pPr>
               <a:spcAft>
@@ -5239,49 +6694,49 @@
               </a:spcAft>
               <a:defRPr sz="2600" b="1">
                 <a:solidFill>
-                  <a:srgbClr val="3B0764"/>
-                </a:solidFill>
+                  <a:srgbClr val="FFFFFF"/>
+                </a:solidFill>
+                <a:latin typeface="Manrope"/>
               </a:defRPr>
             </a:pPr>
             <a:r>
-              <a:t>Reflection Q2: Critical Evaluation of AI, Authenticity &amp; Ethics</a:t>
+              <a:t>Reflection Q2: Authenticity, AI Slop &amp; Knowledge Worker Ethics</a:t>
             </a:r>
           </a:p>
           <a:p>
             <a:pPr>
               <a:defRPr sz="1300">
                 <a:solidFill>
-                  <a:srgbClr val="634380"/>
-                </a:solidFill>
+                  <a:srgbClr val="D8B4FE"/>
+                </a:solidFill>
+                <a:latin typeface="Manrope"/>
               </a:defRPr>
             </a:pPr>
             <a:r>
-              <a:t>Combating 'AI slop', regulatory liability, and ethics for future knowledge workers.</a:t>
-            </a:r>
-          </a:p>
-        </p:txBody>
-      </p:sp>
-      <p:sp>
-        <p:nvSpPr>
-          <p:cNvPr id="3" name="Rectangle 2"/>
+              <a:t>Combating generic marketing cliches, regulatory food liabilities, and human accountability.</a:t>
+            </a:r>
+          </a:p>
+        </p:txBody>
+      </p:sp>
+      <p:sp>
+        <p:nvSpPr>
+          <p:cNvPr id="5" name="Rounded Rectangle 4"/>
           <p:cNvSpPr/>
           <p:nvPr/>
         </p:nvSpPr>
         <p:spPr>
           <a:xfrm>
             <a:off x="731520" y="1645920"/>
-            <a:ext cx="10698480" cy="502920"/>
-          </a:xfrm>
-          <a:prstGeom prst="rect">
+            <a:ext cx="5669280" cy="329184"/>
+          </a:xfrm>
+          <a:prstGeom prst="roundRect">
             <a:avLst/>
           </a:prstGeom>
           <a:solidFill>
-            <a:srgbClr val="FEF2F2"/>
+            <a:srgbClr val="3B0764"/>
           </a:solidFill>
           <a:ln>
-            <a:solidFill>
-              <a:srgbClr val="EF4444"/>
-            </a:solidFill>
+            <a:noFill/>
           </a:ln>
         </p:spPr>
         <p:style>
@@ -5299,43 +6754,42 @@
           </a:fontRef>
         </p:style>
         <p:txBody>
-          <a:bodyPr rtlCol="0" anchor="ctr"/>
+          <a:bodyPr rtlCol="0" anchor="ctr" wrap="none" lIns="137160" rIns="137160"/>
           <a:lstStyle/>
           <a:p>
             <a:pPr algn="ctr">
-              <a:defRPr sz="1000" b="1">
-                <a:solidFill>
-                  <a:srgbClr val="B91C1C"/>
-                </a:solidFill>
+              <a:defRPr sz="1050" b="1">
+                <a:solidFill>
+                  <a:srgbClr val="FFD640"/>
+                </a:solidFill>
+                <a:latin typeface="Manrope"/>
               </a:defRPr>
             </a:pPr>
             <a:r>
-              <a:t>CRITICAL BRIEF REQUIREMENT: Deliver in your personal voice. AI assistance was strictly prohibited for reflection text.</a:t>
-            </a:r>
-          </a:p>
-        </p:txBody>
-      </p:sp>
-      <p:sp>
-        <p:nvSpPr>
-          <p:cNvPr id="4" name="Rounded Rectangle 3"/>
+              <a:t>TALKING-HEAD CUES • DELIVERED IN PERSONAL VOICE WITHOUT AI GENERATION</a:t>
+            </a:r>
+          </a:p>
+        </p:txBody>
+      </p:sp>
+      <p:sp>
+        <p:nvSpPr>
+          <p:cNvPr id="6" name="Rounded Rectangle 5"/>
           <p:cNvSpPr/>
           <p:nvPr/>
         </p:nvSpPr>
         <p:spPr>
           <a:xfrm>
-            <a:off x="731520" y="2286000"/>
-            <a:ext cx="3383280" cy="4023360"/>
+            <a:off x="731520" y="2103120"/>
+            <a:ext cx="3383280" cy="4206240"/>
           </a:xfrm>
           <a:prstGeom prst="roundRect">
             <a:avLst/>
           </a:prstGeom>
           <a:solidFill>
-            <a:srgbClr val="FBF7FF"/>
+            <a:srgbClr val="3B0764"/>
           </a:solidFill>
           <a:ln>
-            <a:solidFill>
-              <a:srgbClr val="EBD4FF"/>
-            </a:solidFill>
+            <a:noFill/>
           </a:ln>
         </p:spPr>
         <p:style>
@@ -5353,91 +6807,149 @@
           </a:fontRef>
         </p:style>
         <p:txBody>
-          <a:bodyPr rtlCol="0" anchor="ctr" wrap="square"/>
-          <a:lstStyle/>
-          <a:p>
-            <a:pPr algn="ctr">
+          <a:bodyPr rtlCol="0" anchor="ctr"/>
+          <a:lstStyle/>
+          <a:p>
+            <a:pPr algn="ctr"/>
+          </a:p>
+        </p:txBody>
+      </p:sp>
+      <p:sp>
+        <p:nvSpPr>
+          <p:cNvPr id="7" name="TextBox 6"/>
+          <p:cNvSpPr txBox="1"/>
+          <p:nvPr/>
+        </p:nvSpPr>
+        <p:spPr>
+          <a:xfrm>
+            <a:off x="960120" y="2331720"/>
+            <a:ext cx="2926080" cy="3749040"/>
+          </a:xfrm>
+          <a:prstGeom prst="rect">
+            <a:avLst/>
+          </a:prstGeom>
+          <a:noFill/>
+        </p:spPr>
+        <p:txBody>
+          <a:bodyPr wrap="square" lIns="0" tIns="0" rIns="0" bIns="0">
+            <a:spAutoFit/>
+          </a:bodyPr>
+          <a:lstStyle/>
+          <a:p>
+            <a:pPr>
+              <a:spcAft>
+                <a:spcPts val="1200"/>
+              </a:spcAft>
+              <a:defRPr sz="1700" b="1">
+                <a:solidFill>
+                  <a:srgbClr val="FF467A"/>
+                </a:solidFill>
+                <a:latin typeface="Manrope"/>
+              </a:defRPr>
+            </a:pPr>
+            <a:r>
+              <a:t>Combating 'AI Slop'</a:t>
+            </a:r>
+          </a:p>
+          <a:p>
+            <a:pPr>
               <a:spcAft>
                 <a:spcPts val="800"/>
               </a:spcAft>
-              <a:defRPr sz="1600" b="1">
-                <a:solidFill>
-                  <a:srgbClr val="3B0764"/>
-                </a:solidFill>
+              <a:defRPr sz="1150" b="1">
+                <a:solidFill>
+                  <a:srgbClr val="FFFFFF"/>
+                </a:solidFill>
+                <a:latin typeface="Manrope"/>
               </a:defRPr>
             </a:pPr>
             <a:r>
-              <a:t>Combating 'AI Slop'</a:t>
+              <a:t>• Stripping Marketing Clichés</a:t>
+            </a:r>
+            <a:br/>
+            <a:r>
+              <a:rPr sz="1000" b="0">
+                <a:solidFill>
+                  <a:srgbClr val="E9D5FF"/>
+                </a:solidFill>
+                <a:latin typeface="Manrope"/>
+              </a:rPr>
+              <a:t>Actively rejecting hyperbolic corporate fluff ('revolutionizing breakfast journeys') in favor of plain, punchy facts: 'Peel. Press. Toast.'</a:t>
             </a:r>
           </a:p>
           <a:p>
             <a:pPr>
               <a:spcAft>
-                <a:spcPts val="600"/>
+                <a:spcPts val="800"/>
               </a:spcAft>
-              <a:defRPr sz="1050">
-                <a:solidFill>
-                  <a:srgbClr val="1A1024"/>
-                </a:solidFill>
+              <a:defRPr sz="1150" b="1">
+                <a:solidFill>
+                  <a:srgbClr val="FFFFFF"/>
+                </a:solidFill>
+                <a:latin typeface="Manrope"/>
               </a:defRPr>
             </a:pPr>
             <a:r>
-              <a:t>• Rejecting Generic Fluff: AI defaults to superlative marketing cliches ('revolutionizing breakfast'). Enforcing concise, plain-spoken prose made Stamp authentic.</a:t>
+              <a:t>• Authentic Physical Constraints</a:t>
+            </a:r>
+            <a:br/>
+            <a:r>
+              <a:rPr sz="1000" b="0">
+                <a:solidFill>
+                  <a:srgbClr val="E9D5FF"/>
+                </a:solidFill>
+                <a:latin typeface="Manrope"/>
+              </a:rPr>
+              <a:t>Anchoring packaging in real industrial constraints (continuous deposit tooling, release film) rather than impossible AI mockups.</a:t>
             </a:r>
           </a:p>
           <a:p>
             <a:pPr>
               <a:spcAft>
-                <a:spcPts val="600"/>
+                <a:spcPts val="800"/>
               </a:spcAft>
-              <a:defRPr sz="1050">
-                <a:solidFill>
-                  <a:srgbClr val="1A1024"/>
-                </a:solidFill>
+              <a:defRPr sz="1150" b="1">
+                <a:solidFill>
+                  <a:srgbClr val="FFFFFF"/>
+                </a:solidFill>
+                <a:latin typeface="Manrope"/>
               </a:defRPr>
             </a:pPr>
             <a:r>
-              <a:t>• Authentic Physical Design: Anchoring packaging in real industrial constraints (foil release liners, ambient butterfat stability) rather than impossible fantasy designs.</a:t>
-            </a:r>
-          </a:p>
-          <a:p>
-            <a:pPr>
-              <a:spcAft>
-                <a:spcPts val="600"/>
-              </a:spcAft>
-              <a:defRPr sz="1050">
-                <a:solidFill>
-                  <a:srgbClr val="1A1024"/>
-                </a:solidFill>
-              </a:defRPr>
-            </a:pPr>
-            <a:r>
-              <a:t>• Human Taste &amp; Tone: Deliberately choosing an off-beat, energetic sound and visual palette.</a:t>
-            </a:r>
-          </a:p>
-        </p:txBody>
-      </p:sp>
-      <p:sp>
-        <p:nvSpPr>
-          <p:cNvPr id="5" name="Rounded Rectangle 4"/>
+              <a:t>• Deliberate Brand Personality</a:t>
+            </a:r>
+            <a:br/>
+            <a:r>
+              <a:rPr sz="1000" b="0">
+                <a:solidFill>
+                  <a:srgbClr val="E9D5FF"/>
+                </a:solidFill>
+                <a:latin typeface="Manrope"/>
+              </a:rPr>
+              <a:t>Injecting bold, high-contrast visual identity and off-beat jingle tone to stand out from generic AI aesthetics.</a:t>
+            </a:r>
+          </a:p>
+        </p:txBody>
+      </p:sp>
+      <p:sp>
+        <p:nvSpPr>
+          <p:cNvPr id="8" name="Rounded Rectangle 7"/>
           <p:cNvSpPr/>
           <p:nvPr/>
         </p:nvSpPr>
         <p:spPr>
           <a:xfrm>
-            <a:off x="4389120" y="2286000"/>
-            <a:ext cx="3383280" cy="4023360"/>
+            <a:off x="4389120" y="2103120"/>
+            <a:ext cx="3383280" cy="4206240"/>
           </a:xfrm>
           <a:prstGeom prst="roundRect">
             <a:avLst/>
           </a:prstGeom>
           <a:solidFill>
-            <a:srgbClr val="FBF7FF"/>
+            <a:srgbClr val="3B0764"/>
           </a:solidFill>
           <a:ln>
-            <a:solidFill>
-              <a:srgbClr val="EBD4FF"/>
-            </a:solidFill>
+            <a:noFill/>
           </a:ln>
         </p:spPr>
         <p:style>
@@ -5455,91 +6967,149 @@
           </a:fontRef>
         </p:style>
         <p:txBody>
-          <a:bodyPr rtlCol="0" anchor="ctr" wrap="square"/>
-          <a:lstStyle/>
-          <a:p>
-            <a:pPr algn="ctr">
+          <a:bodyPr rtlCol="0" anchor="ctr"/>
+          <a:lstStyle/>
+          <a:p>
+            <a:pPr algn="ctr"/>
+          </a:p>
+        </p:txBody>
+      </p:sp>
+      <p:sp>
+        <p:nvSpPr>
+          <p:cNvPr id="9" name="TextBox 8"/>
+          <p:cNvSpPr txBox="1"/>
+          <p:nvPr/>
+        </p:nvSpPr>
+        <p:spPr>
+          <a:xfrm>
+            <a:off x="4617720" y="2331720"/>
+            <a:ext cx="2926080" cy="3749040"/>
+          </a:xfrm>
+          <a:prstGeom prst="rect">
+            <a:avLst/>
+          </a:prstGeom>
+          <a:noFill/>
+        </p:spPr>
+        <p:txBody>
+          <a:bodyPr wrap="square" lIns="0" tIns="0" rIns="0" bIns="0">
+            <a:spAutoFit/>
+          </a:bodyPr>
+          <a:lstStyle/>
+          <a:p>
+            <a:pPr>
+              <a:spcAft>
+                <a:spcPts val="1200"/>
+              </a:spcAft>
+              <a:defRPr sz="1700" b="1">
+                <a:solidFill>
+                  <a:srgbClr val="FFD640"/>
+                </a:solidFill>
+                <a:latin typeface="Manrope"/>
+              </a:defRPr>
+            </a:pPr>
+            <a:r>
+              <a:t>Regulatory &amp; Legal Risks</a:t>
+            </a:r>
+          </a:p>
+          <a:p>
+            <a:pPr>
               <a:spcAft>
                 <a:spcPts val="800"/>
               </a:spcAft>
-              <a:defRPr sz="1600" b="1">
-                <a:solidFill>
-                  <a:srgbClr val="3B0764"/>
-                </a:solidFill>
+              <a:defRPr sz="1150" b="1">
+                <a:solidFill>
+                  <a:srgbClr val="FFFFFF"/>
+                </a:solidFill>
+                <a:latin typeface="Manrope"/>
               </a:defRPr>
             </a:pPr>
             <a:r>
-              <a:t>Regulatory &amp; Legal Risks</a:t>
+              <a:t>• Food Hallucination Dangers</a:t>
+            </a:r>
+            <a:br/>
+            <a:r>
+              <a:rPr sz="1000" b="0">
+                <a:solidFill>
+                  <a:srgbClr val="E9D5FF"/>
+                </a:solidFill>
+                <a:latin typeface="Manrope"/>
+              </a:rPr>
+              <a:t>Unchecked models frequently invent fake organic labels, false 'gluten-free' badges, or illegal therapeutic health claims.</a:t>
             </a:r>
           </a:p>
           <a:p>
             <a:pPr>
               <a:spcAft>
-                <a:spcPts val="600"/>
+                <a:spcPts val="800"/>
               </a:spcAft>
-              <a:defRPr sz="1050">
-                <a:solidFill>
-                  <a:srgbClr val="1A1024"/>
-                </a:solidFill>
+              <a:defRPr sz="1150" b="1">
+                <a:solidFill>
+                  <a:srgbClr val="FFFFFF"/>
+                </a:solidFill>
+                <a:latin typeface="Manrope"/>
               </a:defRPr>
             </a:pPr>
             <a:r>
-              <a:t>• The Hallucination Danger: Left unconstrained, AI frequently invents fake organic labels, false 'gluten-free' badges, or illegal medical claims.</a:t>
+              <a:t>• Strict FSANZ Compliance</a:t>
+            </a:r>
+            <a:br/>
+            <a:r>
+              <a:rPr sz="1000" b="0">
+                <a:solidFill>
+                  <a:srgbClr val="E9D5FF"/>
+                </a:solidFill>
+                <a:latin typeface="Manrope"/>
+              </a:rPr>
+              <a:t>Enforcing Food Standards Australia New Zealand labeling laws: distinguishing dairy spread from refrigerated table butter.</a:t>
             </a:r>
           </a:p>
           <a:p>
             <a:pPr>
               <a:spcAft>
-                <a:spcPts val="600"/>
+                <a:spcPts val="800"/>
               </a:spcAft>
-              <a:defRPr sz="1050">
-                <a:solidFill>
-                  <a:srgbClr val="1A1024"/>
-                </a:solidFill>
+              <a:defRPr sz="1150" b="1">
+                <a:solidFill>
+                  <a:srgbClr val="FFFFFF"/>
+                </a:solidFill>
+                <a:latin typeface="Manrope"/>
               </a:defRPr>
             </a:pPr>
             <a:r>
-              <a:t>• Strict Enforced Bans: Banning health and therapeutic claims; legally distinguishing 'spread' from refrigerated table butter under FSANZ standards.</a:t>
-            </a:r>
-          </a:p>
-          <a:p>
-            <a:pPr>
-              <a:spcAft>
-                <a:spcPts val="600"/>
-              </a:spcAft>
-              <a:defRPr sz="1050">
-                <a:solidFill>
-                  <a:srgbClr val="1A1024"/>
-                </a:solidFill>
-              </a:defRPr>
-            </a:pPr>
-            <a:r>
-              <a:t>• Allergen Responsibility: Ensuring life-threatening peanut and gluten disclosures were never obscured by AI optimism.</a:t>
-            </a:r>
-          </a:p>
-        </p:txBody>
-      </p:sp>
-      <p:sp>
-        <p:nvSpPr>
-          <p:cNvPr id="6" name="Rounded Rectangle 5"/>
+              <a:t>• Allergen Responsibility</a:t>
+            </a:r>
+            <a:br/>
+            <a:r>
+              <a:rPr sz="1000" b="0">
+                <a:solidFill>
+                  <a:srgbClr val="E9D5FF"/>
+                </a:solidFill>
+                <a:latin typeface="Manrope"/>
+              </a:rPr>
+              <a:t>Ensuring life-threatening peanut and gluten disclosures were prominent and never obscured by AI optimism.</a:t>
+            </a:r>
+          </a:p>
+        </p:txBody>
+      </p:sp>
+      <p:sp>
+        <p:nvSpPr>
+          <p:cNvPr id="10" name="Rounded Rectangle 9"/>
           <p:cNvSpPr/>
           <p:nvPr/>
         </p:nvSpPr>
         <p:spPr>
           <a:xfrm>
-            <a:off x="8046720" y="2286000"/>
-            <a:ext cx="3383280" cy="4023360"/>
+            <a:off x="8046720" y="2103120"/>
+            <a:ext cx="3383280" cy="4206240"/>
           </a:xfrm>
           <a:prstGeom prst="roundRect">
             <a:avLst/>
           </a:prstGeom>
           <a:solidFill>
-            <a:srgbClr val="FBF7FF"/>
+            <a:srgbClr val="3B0764"/>
           </a:solidFill>
           <a:ln>
-            <a:solidFill>
-              <a:srgbClr val="EBD4FF"/>
-            </a:solidFill>
+            <a:noFill/>
           </a:ln>
         </p:spPr>
         <p:style>
@@ -5557,66 +7127,126 @@
           </a:fontRef>
         </p:style>
         <p:txBody>
-          <a:bodyPr rtlCol="0" anchor="ctr" wrap="square"/>
-          <a:lstStyle/>
-          <a:p>
-            <a:pPr algn="ctr">
+          <a:bodyPr rtlCol="0" anchor="ctr"/>
+          <a:lstStyle/>
+          <a:p>
+            <a:pPr algn="ctr"/>
+          </a:p>
+        </p:txBody>
+      </p:sp>
+      <p:sp>
+        <p:nvSpPr>
+          <p:cNvPr id="11" name="TextBox 10"/>
+          <p:cNvSpPr txBox="1"/>
+          <p:nvPr/>
+        </p:nvSpPr>
+        <p:spPr>
+          <a:xfrm>
+            <a:off x="8275320" y="2331720"/>
+            <a:ext cx="2926080" cy="3749040"/>
+          </a:xfrm>
+          <a:prstGeom prst="rect">
+            <a:avLst/>
+          </a:prstGeom>
+          <a:noFill/>
+        </p:spPr>
+        <p:txBody>
+          <a:bodyPr wrap="square" lIns="0" tIns="0" rIns="0" bIns="0">
+            <a:spAutoFit/>
+          </a:bodyPr>
+          <a:lstStyle/>
+          <a:p>
+            <a:pPr>
+              <a:spcAft>
+                <a:spcPts val="1200"/>
+              </a:spcAft>
+              <a:defRPr sz="1700" b="1">
+                <a:solidFill>
+                  <a:srgbClr val="FF8C30"/>
+                </a:solidFill>
+                <a:latin typeface="Manrope"/>
+              </a:defRPr>
+            </a:pPr>
+            <a:r>
+              <a:t>Ethics &amp; Future Work</a:t>
+            </a:r>
+          </a:p>
+          <a:p>
+            <a:pPr>
               <a:spcAft>
                 <a:spcPts val="800"/>
               </a:spcAft>
-              <a:defRPr sz="1600" b="1">
-                <a:solidFill>
-                  <a:srgbClr val="3B0764"/>
-                </a:solidFill>
+              <a:defRPr sz="1150" b="1">
+                <a:solidFill>
+                  <a:srgbClr val="FFFFFF"/>
+                </a:solidFill>
+                <a:latin typeface="Manrope"/>
               </a:defRPr>
             </a:pPr>
             <a:r>
-              <a:t>Ethics &amp; Future Work</a:t>
+              <a:t>• Non-Delegable Accountability</a:t>
+            </a:r>
+            <a:br/>
+            <a:r>
+              <a:rPr sz="1000" b="0">
+                <a:solidFill>
+                  <a:srgbClr val="E9D5FF"/>
+                </a:solidFill>
+                <a:latin typeface="Manrope"/>
+              </a:rPr>
+              <a:t>When deploying AI commercially, legal, moral, and customer accountability can never be outsourced to an algorithm.</a:t>
             </a:r>
           </a:p>
           <a:p>
             <a:pPr>
               <a:spcAft>
-                <a:spcPts val="600"/>
+                <a:spcPts val="800"/>
               </a:spcAft>
-              <a:defRPr sz="1050">
-                <a:solidFill>
-                  <a:srgbClr val="1A1024"/>
-                </a:solidFill>
+              <a:defRPr sz="1150" b="1">
+                <a:solidFill>
+                  <a:srgbClr val="FFFFFF"/>
+                </a:solidFill>
+                <a:latin typeface="Manrope"/>
               </a:defRPr>
             </a:pPr>
             <a:r>
-              <a:t>• Accountability Remains Human: When a business deploys AI, legal, moral, and customer accountability cannot be offloaded to an algorithm.</a:t>
+              <a:t>• Critical Thinking as Core Skill</a:t>
+            </a:r>
+            <a:br/>
+            <a:r>
+              <a:rPr sz="1000" b="0">
+                <a:solidFill>
+                  <a:srgbClr val="E9D5FF"/>
+                </a:solidFill>
+                <a:latin typeface="Manrope"/>
+              </a:rPr>
+              <a:t>The primary value of the modern knowledge worker is skepticism, verification, taste, and boundary enforcement.</a:t>
             </a:r>
           </a:p>
           <a:p>
             <a:pPr>
               <a:spcAft>
-                <a:spcPts val="600"/>
+                <a:spcPts val="800"/>
               </a:spcAft>
-              <a:defRPr sz="1050">
-                <a:solidFill>
-                  <a:srgbClr val="1A1024"/>
-                </a:solidFill>
+              <a:defRPr sz="1150" b="1">
+                <a:solidFill>
+                  <a:srgbClr val="FFFFFF"/>
+                </a:solidFill>
+                <a:latin typeface="Manrope"/>
               </a:defRPr>
             </a:pPr>
             <a:r>
-              <a:t>• Value of Critical Thinking: The essential role of the knowledge worker is skepticism, verification, and boundary-setting.</a:t>
-            </a:r>
-          </a:p>
-          <a:p>
-            <a:pPr>
-              <a:spcAft>
-                <a:spcPts val="600"/>
-              </a:spcAft>
-              <a:defRPr sz="1050">
-                <a:solidFill>
-                  <a:srgbClr val="1A1024"/>
-                </a:solidFill>
-              </a:defRPr>
-            </a:pPr>
-            <a:r>
-              <a:t>• Personal Perspective: What it means to work ethically alongside AI without surrendering personal agency or judgment.</a:t>
+              <a:t>• Human Agency</a:t>
+            </a:r>
+            <a:br/>
+            <a:r>
+              <a:rPr sz="1000" b="0">
+                <a:solidFill>
+                  <a:srgbClr val="E9D5FF"/>
+                </a:solidFill>
+                <a:latin typeface="Manrope"/>
+              </a:rPr>
+              <a:t>Leveraging generative AI for execution velocity while retaining complete personal ownership of the final result.</a:t>
             </a:r>
           </a:p>
         </p:txBody>

</xml_diff>

<commit_message>
Declutter slides and enforce 3 colors plus neutral rule across flavour palettes
</commit_message>
<xml_diff>
--- a/presentation/Stamp-pitch.pptx
+++ b/presentation/Stamp-pitch.pptx
@@ -511,7 +511,7 @@
           </a:p>
           <a:p>
             <a:r>
-              <a:t>Kia ora. I'm Jacob, and this is Stamp: a New Zealand breakfast spread innovation engineered for hot toast. Over the next minute, I will present our product and market opportunity, followed by my personal reflection on building with generative AI.</a:t>
+              <a:t>Kia ora. I'm Jacob, and this is Stamp: a New Zealand breakfast spread innovation engineered for hot toast.</a:t>
             </a:r>
           </a:p>
         </p:txBody>
@@ -3920,20 +3920,146 @@
       </p:sp>
       <p:sp>
         <p:nvSpPr>
-          <p:cNvPr id="3" name="Rounded Rectangle 2"/>
+          <p:cNvPr id="3" name="TextBox 2"/>
+          <p:cNvSpPr txBox="1"/>
+          <p:nvPr/>
+        </p:nvSpPr>
+        <p:spPr>
+          <a:xfrm>
+            <a:off x="1097280" y="1645920"/>
+            <a:ext cx="6858000" cy="3474720"/>
+          </a:xfrm>
+          <a:prstGeom prst="rect">
+            <a:avLst/>
+          </a:prstGeom>
+          <a:noFill/>
+        </p:spPr>
+        <p:txBody>
+          <a:bodyPr wrap="square" lIns="0" tIns="0" rIns="0" bIns="0">
+            <a:spAutoFit/>
+          </a:bodyPr>
+          <a:lstStyle/>
+          <a:p>
+            <a:pPr>
+              <a:spcAft>
+                <a:spcPts val="400"/>
+              </a:spcAft>
+              <a:defRPr sz="6800" b="1">
+                <a:solidFill>
+                  <a:srgbClr val="E24BFF"/>
+                </a:solidFill>
+                <a:latin typeface="Manrope"/>
+              </a:defRPr>
+            </a:pPr>
+            <a:r>
+              <a:t>STAMP</a:t>
+            </a:r>
+          </a:p>
+          <a:p>
+            <a:pPr>
+              <a:spcAft>
+                <a:spcPts val="1600"/>
+              </a:spcAft>
+              <a:defRPr sz="2800" b="1">
+                <a:solidFill>
+                  <a:srgbClr val="FFFFFF"/>
+                </a:solidFill>
+                <a:latin typeface="Manrope"/>
+              </a:defRPr>
+            </a:pPr>
+            <a:r>
+              <a:t>PEEL. PRESS. TOAST.</a:t>
+            </a:r>
+          </a:p>
+          <a:p>
+            <a:pPr>
+              <a:spcAft>
+                <a:spcPts val="2800"/>
+              </a:spcAft>
+              <a:defRPr sz="1800">
+                <a:solidFill>
+                  <a:srgbClr val="E24BFF"/>
+                </a:solidFill>
+                <a:latin typeface="Manrope"/>
+              </a:defRPr>
+            </a:pPr>
+            <a:r>
+              <a:t>The Utensil-Free Breakfast Spread for Hot Toast</a:t>
+            </a:r>
+          </a:p>
+          <a:p>
+            <a:pPr>
+              <a:defRPr sz="1200" b="1">
+                <a:solidFill>
+                  <a:srgbClr val="FFFFFF"/>
+                </a:solidFill>
+                <a:latin typeface="Manrope"/>
+              </a:defRPr>
+            </a:pPr>
+            <a:r>
+              <a:t>Commercial Business Pitch  •  Jacob  •  INFO123 Business AI Project</a:t>
+            </a:r>
+          </a:p>
+        </p:txBody>
+      </p:sp>
+      <p:pic>
+        <p:nvPicPr>
+          <p:cNvPr id="4" name="Picture 3" descr="butter.png"/>
+          <p:cNvPicPr>
+            <a:picLocks noChangeAspect="1"/>
+          </p:cNvPicPr>
+          <p:nvPr/>
+        </p:nvPicPr>
+        <p:blipFill>
+          <a:blip r:embed="rId2"/>
+          <a:stretch>
+            <a:fillRect/>
+          </a:stretch>
+        </p:blipFill>
+        <p:spPr>
+          <a:xfrm>
+            <a:off x="7863840" y="1463040"/>
+            <a:ext cx="3474720" cy="4632960"/>
+          </a:xfrm>
+          <a:prstGeom prst="rect">
+            <a:avLst/>
+          </a:prstGeom>
+        </p:spPr>
+      </p:pic>
+    </p:spTree>
+  </p:cSld>
+  <p:clrMapOvr>
+    <a:masterClrMapping/>
+  </p:clrMapOvr>
+</p:sld>
+</file>
+
+<file path=ppt/slides/slide2.xml><?xml version="1.0" encoding="utf-8"?>
+<p:sld xmlns:a="http://schemas.openxmlformats.org/drawingml/2006/main" xmlns:p="http://schemas.openxmlformats.org/presentationml/2006/main" xmlns:r="http://schemas.openxmlformats.org/officeDocument/2006/relationships">
+  <p:cSld>
+    <p:spTree>
+      <p:nvGrpSpPr>
+        <p:cNvPr id="1" name=""/>
+        <p:cNvGrpSpPr/>
+        <p:nvPr/>
+      </p:nvGrpSpPr>
+      <p:grpSpPr/>
+      <p:sp>
+        <p:nvSpPr>
+          <p:cNvPr id="2" name="Rectangle 1"/>
           <p:cNvSpPr/>
           <p:nvPr/>
         </p:nvSpPr>
         <p:spPr>
           <a:xfrm>
-            <a:off x="822960" y="1097280"/>
-            <a:ext cx="4087368" cy="329184"/>
+            <a:off x="0" y="0"/>
+            <a:ext cx="12191695" cy="6858000"/>
           </a:xfrm>
-          <a:prstGeom prst="roundRect">
+          <a:prstGeom prst="rect">
             <a:avLst/>
           </a:prstGeom>
           <a:solidFill>
-            <a:srgbClr val="3B0764"/>
+            <a:srgbClr val="4A3000"/>
           </a:solidFill>
           <a:ln>
             <a:noFill/>
@@ -3954,33 +4080,23 @@
           </a:fontRef>
         </p:style>
         <p:txBody>
-          <a:bodyPr rtlCol="0" anchor="ctr" wrap="none" lIns="137160" rIns="137160"/>
-          <a:lstStyle/>
-          <a:p>
-            <a:pPr algn="ctr">
-              <a:defRPr sz="1050" b="1">
-                <a:solidFill>
-                  <a:srgbClr val="E24BFF"/>
-                </a:solidFill>
-                <a:latin typeface="Manrope"/>
-              </a:defRPr>
-            </a:pPr>
-            <a:r>
-              <a:t>COMMERCIAL PROPOSAL • INFO123 PROJECT</a:t>
-            </a:r>
-          </a:p>
-        </p:txBody>
-      </p:sp>
-      <p:sp>
-        <p:nvSpPr>
-          <p:cNvPr id="4" name="TextBox 3"/>
+          <a:bodyPr rtlCol="0" anchor="ctr"/>
+          <a:lstStyle/>
+          <a:p>
+            <a:pPr algn="ctr"/>
+          </a:p>
+        </p:txBody>
+      </p:sp>
+      <p:sp>
+        <p:nvSpPr>
+          <p:cNvPr id="3" name="TextBox 2"/>
           <p:cNvSpPr txBox="1"/>
           <p:nvPr/>
         </p:nvSpPr>
         <p:spPr>
           <a:xfrm>
-            <a:off x="822960" y="1600200"/>
-            <a:ext cx="6858000" cy="2560320"/>
+            <a:off x="822960" y="548640"/>
+            <a:ext cx="9144000" cy="365760"/>
           </a:xfrm>
           <a:prstGeom prst="rect">
             <a:avLst/>
@@ -3988,6 +4104,42 @@
           <a:noFill/>
         </p:spPr>
         <p:txBody>
+          <a:bodyPr wrap="none" lIns="0" tIns="0" rIns="0" bIns="0">
+            <a:spAutoFit/>
+          </a:bodyPr>
+          <a:lstStyle/>
+          <a:p>
+            <a:pPr>
+              <a:defRPr sz="1200" b="1">
+                <a:solidFill>
+                  <a:srgbClr val="FFD640"/>
+                </a:solidFill>
+                <a:latin typeface="Manrope"/>
+              </a:defRPr>
+            </a:pPr>
+            <a:r>
+              <a:t>01 / PRODUCT INNOVATION  •  PITCH PART 1 (30 SECONDS)</a:t>
+            </a:r>
+          </a:p>
+        </p:txBody>
+      </p:sp>
+      <p:sp>
+        <p:nvSpPr>
+          <p:cNvPr id="4" name="TextBox 3"/>
+          <p:cNvSpPr txBox="1"/>
+          <p:nvPr/>
+        </p:nvSpPr>
+        <p:spPr>
+          <a:xfrm>
+            <a:off x="822960" y="841248"/>
+            <a:ext cx="10698480" cy="1005840"/>
+          </a:xfrm>
+          <a:prstGeom prst="rect">
+            <a:avLst/>
+          </a:prstGeom>
+          <a:noFill/>
+        </p:spPr>
+        <p:txBody>
           <a:bodyPr wrap="square" lIns="0" tIns="0" rIns="0" bIns="0">
             <a:spAutoFit/>
           </a:bodyPr>
@@ -3997,23 +4149,7 @@
               <a:spcAft>
                 <a:spcPts val="200"/>
               </a:spcAft>
-              <a:defRPr sz="6400" b="1">
-                <a:solidFill>
-                  <a:srgbClr val="E24BFF"/>
-                </a:solidFill>
-                <a:latin typeface="Manrope"/>
-              </a:defRPr>
-            </a:pPr>
-            <a:r>
-              <a:t>STAMP</a:t>
-            </a:r>
-          </a:p>
-          <a:p>
-            <a:pPr>
-              <a:spcAft>
-                <a:spcPts val="1000"/>
-              </a:spcAft>
-              <a:defRPr sz="2600" b="1">
+              <a:defRPr sz="3200" b="1">
                 <a:solidFill>
                   <a:srgbClr val="FFFFFF"/>
                 </a:solidFill>
@@ -4021,20 +4157,20 @@
               </a:defRPr>
             </a:pPr>
             <a:r>
-              <a:t>PEEL. PRESS. TOAST.</a:t>
-            </a:r>
-          </a:p>
-          <a:p>
-            <a:pPr>
-              <a:defRPr sz="1600">
-                <a:solidFill>
-                  <a:srgbClr val="D8B4FE"/>
-                </a:solidFill>
-                <a:latin typeface="Manrope"/>
-              </a:defRPr>
-            </a:pPr>
-            <a:r>
-              <a:t>The Single-Serve Breakfast Spread Discs for Hot Toast</a:t>
+              <a:t>Peel. Press. Toast.</a:t>
+            </a:r>
+          </a:p>
+          <a:p>
+            <a:pPr>
+              <a:defRPr sz="1400" b="0">
+                <a:solidFill>
+                  <a:srgbClr val="FFD640"/>
+                </a:solidFill>
+                <a:latin typeface="Manrope"/>
+              </a:defRPr>
+            </a:pPr>
+            <a:r>
+              <a:t>Eliminating out-of-kitchen breakfast friction with a 10 g meltable spread disc.</a:t>
             </a:r>
           </a:p>
         </p:txBody>
@@ -4047,14 +4183,14 @@
         </p:nvSpPr>
         <p:spPr>
           <a:xfrm>
-            <a:off x="822960" y="4297680"/>
-            <a:ext cx="2167128" cy="329184"/>
+            <a:off x="822960" y="2011680"/>
+            <a:ext cx="5120640" cy="4114800"/>
           </a:xfrm>
           <a:prstGeom prst="roundRect">
             <a:avLst/>
           </a:prstGeom>
           <a:solidFill>
-            <a:srgbClr val="3B0764"/>
+            <a:srgbClr val="2D1D00"/>
           </a:solidFill>
           <a:ln>
             <a:noFill/>
@@ -4075,39 +4211,178 @@
           </a:fontRef>
         </p:style>
         <p:txBody>
-          <a:bodyPr rtlCol="0" anchor="ctr" wrap="none" lIns="137160" rIns="137160"/>
-          <a:lstStyle/>
-          <a:p>
-            <a:pPr algn="ctr">
-              <a:defRPr sz="1050" b="1">
-                <a:solidFill>
-                  <a:srgbClr val="E24BFF"/>
-                </a:solidFill>
-                <a:latin typeface="Manrope"/>
-              </a:defRPr>
-            </a:pPr>
-            <a:r>
-              <a:t>$5.00 NZD / SHEET</a:t>
-            </a:r>
-          </a:p>
-        </p:txBody>
-      </p:sp>
-      <p:sp>
-        <p:nvSpPr>
-          <p:cNvPr id="6" name="Rounded Rectangle 5"/>
+          <a:bodyPr rtlCol="0" anchor="ctr"/>
+          <a:lstStyle/>
+          <a:p>
+            <a:pPr algn="ctr"/>
+          </a:p>
+        </p:txBody>
+      </p:sp>
+      <p:sp>
+        <p:nvSpPr>
+          <p:cNvPr id="6" name="TextBox 5"/>
+          <p:cNvSpPr txBox="1"/>
+          <p:nvPr/>
+        </p:nvSpPr>
+        <p:spPr>
+          <a:xfrm>
+            <a:off x="1188720" y="2377440"/>
+            <a:ext cx="4389120" cy="3383280"/>
+          </a:xfrm>
+          <a:prstGeom prst="rect">
+            <a:avLst/>
+          </a:prstGeom>
+          <a:noFill/>
+        </p:spPr>
+        <p:txBody>
+          <a:bodyPr wrap="square" lIns="0" tIns="0" rIns="0" bIns="0">
+            <a:spAutoFit/>
+          </a:bodyPr>
+          <a:lstStyle/>
+          <a:p>
+            <a:pPr>
+              <a:spcAft>
+                <a:spcPts val="2000"/>
+              </a:spcAft>
+              <a:defRPr sz="2000" b="1">
+                <a:solidFill>
+                  <a:srgbClr val="FFD640"/>
+                </a:solidFill>
+                <a:latin typeface="Manrope"/>
+              </a:defRPr>
+            </a:pPr>
+            <a:r>
+              <a:t>THE PROBLEM</a:t>
+            </a:r>
+          </a:p>
+          <a:p>
+            <a:pPr>
+              <a:spcAft>
+                <a:spcPts val="200"/>
+              </a:spcAft>
+              <a:defRPr sz="1500" b="1">
+                <a:solidFill>
+                  <a:srgbClr val="FFFFFF"/>
+                </a:solidFill>
+                <a:latin typeface="Manrope"/>
+              </a:defRPr>
+            </a:pPr>
+            <a:r>
+              <a:t>Jars Require Infrastructure</a:t>
+            </a:r>
+          </a:p>
+          <a:p>
+            <a:pPr>
+              <a:spcAft>
+                <a:spcPts val="1400"/>
+              </a:spcAft>
+              <a:defRPr sz="1200" b="0">
+                <a:solidFill>
+                  <a:srgbClr val="FFFFFF"/>
+                </a:solidFill>
+                <a:latin typeface="Manrope"/>
+              </a:defRPr>
+            </a:pPr>
+            <a:r>
+              <a:t>Demands table knives, kitchen counters, and sink washing.</a:t>
+            </a:r>
+          </a:p>
+          <a:p>
+            <a:pPr>
+              <a:defRPr>
+                <a:latin typeface="Manrope"/>
+              </a:defRPr>
+            </a:pPr>
+          </a:p>
+          <a:p>
+            <a:pPr>
+              <a:spcAft>
+                <a:spcPts val="200"/>
+              </a:spcAft>
+              <a:defRPr sz="1500" b="1">
+                <a:solidFill>
+                  <a:srgbClr val="FFFFFF"/>
+                </a:solidFill>
+                <a:latin typeface="Manrope"/>
+              </a:defRPr>
+            </a:pPr>
+            <a:r>
+              <a:t>Fails Mobile Consumers</a:t>
+            </a:r>
+          </a:p>
+          <a:p>
+            <a:pPr>
+              <a:spcAft>
+                <a:spcPts val="1400"/>
+              </a:spcAft>
+              <a:defRPr sz="1200" b="0">
+                <a:solidFill>
+                  <a:srgbClr val="FFFFFF"/>
+                </a:solidFill>
+                <a:latin typeface="Manrope"/>
+              </a:defRPr>
+            </a:pPr>
+            <a:r>
+              <a:t>Students in halls, commuters, and desk workers cannot eat toast conveniently.</a:t>
+            </a:r>
+          </a:p>
+          <a:p>
+            <a:pPr>
+              <a:defRPr>
+                <a:latin typeface="Manrope"/>
+              </a:defRPr>
+            </a:pPr>
+          </a:p>
+          <a:p>
+            <a:pPr>
+              <a:spcAft>
+                <a:spcPts val="200"/>
+              </a:spcAft>
+              <a:defRPr sz="1500" b="1">
+                <a:solidFill>
+                  <a:srgbClr val="FFFFFF"/>
+                </a:solidFill>
+                <a:latin typeface="Manrope"/>
+              </a:defRPr>
+            </a:pPr>
+            <a:r>
+              <a:t>Stationary &amp; Bulky</a:t>
+            </a:r>
+          </a:p>
+          <a:p>
+            <a:pPr>
+              <a:spcAft>
+                <a:spcPts val="1400"/>
+              </a:spcAft>
+              <a:defRPr sz="1200" b="0">
+                <a:solidFill>
+                  <a:srgbClr val="FFFFFF"/>
+                </a:solidFill>
+                <a:latin typeface="Manrope"/>
+              </a:defRPr>
+            </a:pPr>
+            <a:r>
+              <a:t>Heavy glass jars sit immobile in pantries rather than travelling on-the-go.</a:t>
+            </a:r>
+          </a:p>
+        </p:txBody>
+      </p:sp>
+      <p:sp>
+        <p:nvSpPr>
+          <p:cNvPr id="7" name="Rounded Rectangle 6"/>
           <p:cNvSpPr/>
           <p:nvPr/>
         </p:nvSpPr>
         <p:spPr>
           <a:xfrm>
-            <a:off x="3218688" y="4297680"/>
-            <a:ext cx="2670048" cy="329184"/>
+            <a:off x="6217920" y="2011680"/>
+            <a:ext cx="5120640" cy="4114800"/>
           </a:xfrm>
           <a:prstGeom prst="roundRect">
             <a:avLst/>
           </a:prstGeom>
           <a:solidFill>
-            <a:srgbClr val="3B0764"/>
+            <a:srgbClr val="2D1D00"/>
           </a:solidFill>
           <a:ln>
             <a:noFill/>
@@ -4128,11 +4403,40 @@
           </a:fontRef>
         </p:style>
         <p:txBody>
-          <a:bodyPr rtlCol="0" anchor="ctr" wrap="none" lIns="137160" rIns="137160"/>
-          <a:lstStyle/>
-          <a:p>
-            <a:pPr algn="ctr">
-              <a:defRPr sz="1050" b="1">
+          <a:bodyPr rtlCol="0" anchor="ctr"/>
+          <a:lstStyle/>
+          <a:p>
+            <a:pPr algn="ctr"/>
+          </a:p>
+        </p:txBody>
+      </p:sp>
+      <p:sp>
+        <p:nvSpPr>
+          <p:cNvPr id="8" name="TextBox 7"/>
+          <p:cNvSpPr txBox="1"/>
+          <p:nvPr/>
+        </p:nvSpPr>
+        <p:spPr>
+          <a:xfrm>
+            <a:off x="6583680" y="2377440"/>
+            <a:ext cx="4389120" cy="3383280"/>
+          </a:xfrm>
+          <a:prstGeom prst="rect">
+            <a:avLst/>
+          </a:prstGeom>
+          <a:noFill/>
+        </p:spPr>
+        <p:txBody>
+          <a:bodyPr wrap="square" lIns="0" tIns="0" rIns="0" bIns="0">
+            <a:spAutoFit/>
+          </a:bodyPr>
+          <a:lstStyle/>
+          <a:p>
+            <a:pPr>
+              <a:spcAft>
+                <a:spcPts val="2000"/>
+              </a:spcAft>
+              <a:defRPr sz="2000" b="1">
                 <a:solidFill>
                   <a:srgbClr val="FFD640"/>
                 </a:solidFill>
@@ -4140,27 +4444,155 @@
               </a:defRPr>
             </a:pPr>
             <a:r>
-              <a:t>12-MONTH PANTRY STABLE</a:t>
-            </a:r>
-          </a:p>
-        </p:txBody>
-      </p:sp>
-      <p:sp>
-        <p:nvSpPr>
-          <p:cNvPr id="7" name="Rounded Rectangle 6"/>
+              <a:t>THE STAMP SOLUTION</a:t>
+            </a:r>
+          </a:p>
+          <a:p>
+            <a:pPr>
+              <a:spcAft>
+                <a:spcPts val="200"/>
+              </a:spcAft>
+              <a:defRPr sz="1500" b="1">
+                <a:solidFill>
+                  <a:srgbClr val="FFFFFF"/>
+                </a:solidFill>
+                <a:latin typeface="Manrope"/>
+              </a:defRPr>
+            </a:pPr>
+            <a:r>
+              <a:t>10 g Peel-and-Press Disc</a:t>
+            </a:r>
+          </a:p>
+          <a:p>
+            <a:pPr>
+              <a:spcAft>
+                <a:spcPts val="1400"/>
+              </a:spcAft>
+              <a:defRPr sz="1200" b="0">
+                <a:solidFill>
+                  <a:srgbClr val="FFFFFF"/>
+                </a:solidFill>
+                <a:latin typeface="Manrope"/>
+              </a:defRPr>
+            </a:pPr>
+            <a:r>
+              <a:t>Pre-portioned spread mounted on food-grade release film.</a:t>
+            </a:r>
+          </a:p>
+          <a:p>
+            <a:pPr>
+              <a:defRPr>
+                <a:latin typeface="Manrope"/>
+              </a:defRPr>
+            </a:pPr>
+          </a:p>
+          <a:p>
+            <a:pPr>
+              <a:spcAft>
+                <a:spcPts val="200"/>
+              </a:spcAft>
+              <a:defRPr sz="1500" b="1">
+                <a:solidFill>
+                  <a:srgbClr val="FFFFFF"/>
+                </a:solidFill>
+                <a:latin typeface="Manrope"/>
+              </a:defRPr>
+            </a:pPr>
+            <a:r>
+              <a:t>Thermal Spread Gesture</a:t>
+            </a:r>
+          </a:p>
+          <a:p>
+            <a:pPr>
+              <a:spcAft>
+                <a:spcPts val="1400"/>
+              </a:spcAft>
+              <a:defRPr sz="1200" b="0">
+                <a:solidFill>
+                  <a:srgbClr val="FFFFFF"/>
+                </a:solidFill>
+                <a:latin typeface="Manrope"/>
+              </a:defRPr>
+            </a:pPr>
+            <a:r>
+              <a:t>Presses onto hot bread; melts evenly in seconds with zero cutlery.</a:t>
+            </a:r>
+          </a:p>
+          <a:p>
+            <a:pPr>
+              <a:defRPr>
+                <a:latin typeface="Manrope"/>
+              </a:defRPr>
+            </a:pPr>
+          </a:p>
+          <a:p>
+            <a:pPr>
+              <a:spcAft>
+                <a:spcPts val="200"/>
+              </a:spcAft>
+              <a:defRPr sz="1500" b="1">
+                <a:solidFill>
+                  <a:srgbClr val="FFFFFF"/>
+                </a:solidFill>
+                <a:latin typeface="Manrope"/>
+              </a:defRPr>
+            </a:pPr>
+            <a:r>
+              <a:t>12-Month Ambient Stability</a:t>
+            </a:r>
+          </a:p>
+          <a:p>
+            <a:pPr>
+              <a:spcAft>
+                <a:spcPts val="1400"/>
+              </a:spcAft>
+              <a:defRPr sz="1200" b="0">
+                <a:solidFill>
+                  <a:srgbClr val="FFFFFF"/>
+                </a:solidFill>
+                <a:latin typeface="Manrope"/>
+              </a:defRPr>
+            </a:pPr>
+            <a:r>
+              <a:t>Sealed card sheets provide verified shelf stability without refrigeration.</a:t>
+            </a:r>
+          </a:p>
+        </p:txBody>
+      </p:sp>
+    </p:spTree>
+  </p:cSld>
+  <p:clrMapOvr>
+    <a:masterClrMapping/>
+  </p:clrMapOvr>
+</p:sld>
+</file>
+
+<file path=ppt/slides/slide3.xml><?xml version="1.0" encoding="utf-8"?>
+<p:sld xmlns:a="http://schemas.openxmlformats.org/drawingml/2006/main" xmlns:p="http://schemas.openxmlformats.org/presentationml/2006/main" xmlns:r="http://schemas.openxmlformats.org/officeDocument/2006/relationships">
+  <p:cSld>
+    <p:spTree>
+      <p:nvGrpSpPr>
+        <p:cNvPr id="1" name=""/>
+        <p:cNvGrpSpPr/>
+        <p:nvPr/>
+      </p:nvGrpSpPr>
+      <p:grpSpPr/>
+      <p:sp>
+        <p:nvSpPr>
+          <p:cNvPr id="2" name="Rectangle 1"/>
           <p:cNvSpPr/>
           <p:nvPr/>
         </p:nvSpPr>
         <p:spPr>
           <a:xfrm>
-            <a:off x="6117336" y="4297680"/>
-            <a:ext cx="3172968" cy="329184"/>
+            <a:off x="0" y="0"/>
+            <a:ext cx="12191695" cy="6858000"/>
           </a:xfrm>
-          <a:prstGeom prst="roundRect">
+          <a:prstGeom prst="rect">
             <a:avLst/>
           </a:prstGeom>
           <a:solidFill>
-            <a:srgbClr val="3B0764"/>
+            <a:srgbClr val="460820"/>
           </a:solidFill>
           <a:ln>
             <a:noFill/>
@@ -4181,11 +4613,37 @@
           </a:fontRef>
         </p:style>
         <p:txBody>
-          <a:bodyPr rtlCol="0" anchor="ctr" wrap="none" lIns="137160" rIns="137160"/>
-          <a:lstStyle/>
-          <a:p>
-            <a:pPr algn="ctr">
-              <a:defRPr sz="1050" b="1">
+          <a:bodyPr rtlCol="0" anchor="ctr"/>
+          <a:lstStyle/>
+          <a:p>
+            <a:pPr algn="ctr"/>
+          </a:p>
+        </p:txBody>
+      </p:sp>
+      <p:sp>
+        <p:nvSpPr>
+          <p:cNvPr id="3" name="TextBox 2"/>
+          <p:cNvSpPr txBox="1"/>
+          <p:nvPr/>
+        </p:nvSpPr>
+        <p:spPr>
+          <a:xfrm>
+            <a:off x="822960" y="548640"/>
+            <a:ext cx="9144000" cy="365760"/>
+          </a:xfrm>
+          <a:prstGeom prst="rect">
+            <a:avLst/>
+          </a:prstGeom>
+          <a:noFill/>
+        </p:spPr>
+        <p:txBody>
+          <a:bodyPr wrap="none" lIns="0" tIns="0" rIns="0" bIns="0">
+            <a:spAutoFit/>
+          </a:bodyPr>
+          <a:lstStyle/>
+          <a:p>
+            <a:pPr>
+              <a:defRPr sz="1200" b="1">
                 <a:solidFill>
                   <a:srgbClr val="FF467A"/>
                 </a:solidFill>
@@ -4193,27 +4651,79 @@
               </a:defRPr>
             </a:pPr>
             <a:r>
-              <a:t>NO JAR WASTE • UTENSIL-FREE</a:t>
-            </a:r>
-          </a:p>
-        </p:txBody>
-      </p:sp>
-      <p:sp>
-        <p:nvSpPr>
-          <p:cNvPr id="8" name="Rounded Rectangle 7"/>
+              <a:t>02 / MARKET OPPORTUNITY  •  PITCH PART 2 (30 SECONDS)</a:t>
+            </a:r>
+          </a:p>
+        </p:txBody>
+      </p:sp>
+      <p:sp>
+        <p:nvSpPr>
+          <p:cNvPr id="4" name="TextBox 3"/>
+          <p:cNvSpPr txBox="1"/>
+          <p:nvPr/>
+        </p:nvSpPr>
+        <p:spPr>
+          <a:xfrm>
+            <a:off x="822960" y="841248"/>
+            <a:ext cx="10698480" cy="1005840"/>
+          </a:xfrm>
+          <a:prstGeom prst="rect">
+            <a:avLst/>
+          </a:prstGeom>
+          <a:noFill/>
+        </p:spPr>
+        <p:txBody>
+          <a:bodyPr wrap="square" lIns="0" tIns="0" rIns="0" bIns="0">
+            <a:spAutoFit/>
+          </a:bodyPr>
+          <a:lstStyle/>
+          <a:p>
+            <a:pPr>
+              <a:spcAft>
+                <a:spcPts val="200"/>
+              </a:spcAft>
+              <a:defRPr sz="3200" b="1">
+                <a:solidFill>
+                  <a:srgbClr val="FFFFFF"/>
+                </a:solidFill>
+                <a:latin typeface="Manrope"/>
+              </a:defRPr>
+            </a:pPr>
+            <a:r>
+              <a:t>$341M Category. 0 Rivals.</a:t>
+            </a:r>
+          </a:p>
+          <a:p>
+            <a:pPr>
+              <a:defRPr sz="1400" b="0">
+                <a:solidFill>
+                  <a:srgbClr val="FF467A"/>
+                </a:solidFill>
+                <a:latin typeface="Manrope"/>
+              </a:defRPr>
+            </a:pPr>
+            <a:r>
+              <a:t>Capturing the premium convenience gap in New Zealand breakfast retail.</a:t>
+            </a:r>
+          </a:p>
+        </p:txBody>
+      </p:sp>
+      <p:sp>
+        <p:nvSpPr>
+          <p:cNvPr id="5" name="Rounded Rectangle 4"/>
           <p:cNvSpPr/>
           <p:nvPr/>
         </p:nvSpPr>
         <p:spPr>
           <a:xfrm>
-            <a:off x="822960" y="4937760"/>
-            <a:ext cx="6583680" cy="1188720"/>
+            <a:off x="822960" y="2011680"/>
+            <a:ext cx="3291840" cy="4114800"/>
           </a:xfrm>
           <a:prstGeom prst="roundRect">
             <a:avLst/>
           </a:prstGeom>
           <a:solidFill>
-            <a:srgbClr val="3B0764"/>
+            <a:srgbClr val="2D0414"/>
           </a:solidFill>
           <a:ln>
             <a:noFill/>
@@ -4243,14 +4753,14 @@
       </p:sp>
       <p:sp>
         <p:nvSpPr>
-          <p:cNvPr id="9" name="TextBox 8"/>
+          <p:cNvPr id="6" name="TextBox 5"/>
           <p:cNvSpPr txBox="1"/>
           <p:nvPr/>
         </p:nvSpPr>
         <p:spPr>
           <a:xfrm>
-            <a:off x="1097280" y="5074920"/>
-            <a:ext cx="6035040" cy="914400"/>
+            <a:off x="1097280" y="2377440"/>
+            <a:ext cx="2743200" cy="3383280"/>
           </a:xfrm>
           <a:prstGeom prst="rect">
             <a:avLst/>
@@ -4267,72 +4777,318 @@
               <a:spcAft>
                 <a:spcPts val="400"/>
               </a:spcAft>
-              <a:defRPr sz="1200" b="1">
-                <a:solidFill>
-                  <a:srgbClr val="E24BFF"/>
-                </a:solidFill>
-                <a:latin typeface="Manrope"/>
-              </a:defRPr>
-            </a:pPr>
-            <a:r>
-              <a:t>PRESENTER: </a:t>
-            </a:r>
-            <a:r>
-              <a:rPr b="1">
+              <a:defRPr sz="4800" b="1">
+                <a:solidFill>
+                  <a:srgbClr val="FF467A"/>
+                </a:solidFill>
+                <a:latin typeface="Manrope"/>
+              </a:defRPr>
+            </a:pPr>
+            <a:r>
+              <a:t>$341M</a:t>
+            </a:r>
+          </a:p>
+          <a:p>
+            <a:pPr>
+              <a:spcAft>
+                <a:spcPts val="200"/>
+              </a:spcAft>
+              <a:defRPr sz="1300" b="1">
                 <a:solidFill>
                   <a:srgbClr val="FFFFFF"/>
                 </a:solidFill>
-              </a:rPr>
-              <a:t>Jacob  |  INFO123 Business AI Project</a:t>
-            </a:r>
-          </a:p>
-          <a:p>
-            <a:pPr>
+                <a:latin typeface="Manrope"/>
+              </a:defRPr>
+            </a:pPr>
+            <a:r>
+              <a:t>RETAIL CATEGORY</a:t>
+            </a:r>
+          </a:p>
+          <a:p>
+            <a:pPr>
+              <a:spcAft>
+                <a:spcPts val="1600"/>
+              </a:spcAft>
               <a:defRPr sz="1100" b="1">
                 <a:solidFill>
-                  <a:srgbClr val="FFD640"/>
-                </a:solidFill>
-                <a:latin typeface="Manrope"/>
-              </a:defRPr>
-            </a:pPr>
-            <a:r>
-              <a:t>LIVE PLATFORM: </a:t>
-            </a:r>
-            <a:r>
-              <a:rPr b="0">
-                <a:solidFill>
-                  <a:srgbClr val="E9D5FF"/>
-                </a:solidFill>
-              </a:rPr>
-              <a:t>stamp-spreads.vercel.app  •  github.com/JacobCrume/stamp-spreads</a:t>
-            </a:r>
-          </a:p>
-        </p:txBody>
-      </p:sp>
-      <p:pic>
-        <p:nvPicPr>
-          <p:cNvPr id="10" name="Picture 9" descr="butter.png"/>
-          <p:cNvPicPr>
-            <a:picLocks noChangeAspect="1"/>
-          </p:cNvPicPr>
+                  <a:srgbClr val="FF467A"/>
+                </a:solidFill>
+                <a:latin typeface="Manrope"/>
+              </a:defRPr>
+            </a:pPr>
+            <a:r>
+              <a:t>+24% Revenue Growth</a:t>
+            </a:r>
+          </a:p>
+          <a:p>
+            <a:pPr>
+              <a:defRPr sz="1100">
+                <a:solidFill>
+                  <a:srgbClr val="FFFFFF"/>
+                </a:solidFill>
+                <a:latin typeface="Manrope"/>
+              </a:defRPr>
+            </a:pPr>
+            <a:r>
+              <a:t>Supermarket scan data shows spreads expanding from $275M to $341M NZD (2022–2025). Premium spreads surged +29% to $113M.</a:t>
+            </a:r>
+          </a:p>
+        </p:txBody>
+      </p:sp>
+      <p:sp>
+        <p:nvSpPr>
+          <p:cNvPr id="7" name="Rounded Rectangle 6"/>
+          <p:cNvSpPr/>
           <p:nvPr/>
-        </p:nvPicPr>
-        <p:blipFill>
-          <a:blip r:embed="rId2"/>
-          <a:stretch>
-            <a:fillRect/>
-          </a:stretch>
-        </p:blipFill>
+        </p:nvSpPr>
         <p:spPr>
           <a:xfrm>
-            <a:off x="7955279" y="1371600"/>
-            <a:ext cx="3474720" cy="4632960"/>
+            <a:off x="4434840" y="2011680"/>
+            <a:ext cx="3291840" cy="4114800"/>
+          </a:xfrm>
+          <a:prstGeom prst="roundRect">
+            <a:avLst/>
+          </a:prstGeom>
+          <a:solidFill>
+            <a:srgbClr val="2D0414"/>
+          </a:solidFill>
+          <a:ln>
+            <a:noFill/>
+          </a:ln>
+        </p:spPr>
+        <p:style>
+          <a:lnRef idx="1">
+            <a:schemeClr val="accent1"/>
+          </a:lnRef>
+          <a:fillRef idx="3">
+            <a:schemeClr val="accent1"/>
+          </a:fillRef>
+          <a:effectRef idx="2">
+            <a:schemeClr val="accent1"/>
+          </a:effectRef>
+          <a:fontRef idx="minor">
+            <a:schemeClr val="lt1"/>
+          </a:fontRef>
+        </p:style>
+        <p:txBody>
+          <a:bodyPr rtlCol="0" anchor="ctr"/>
+          <a:lstStyle/>
+          <a:p>
+            <a:pPr algn="ctr"/>
+          </a:p>
+        </p:txBody>
+      </p:sp>
+      <p:sp>
+        <p:nvSpPr>
+          <p:cNvPr id="8" name="TextBox 7"/>
+          <p:cNvSpPr txBox="1"/>
+          <p:nvPr/>
+        </p:nvSpPr>
+        <p:spPr>
+          <a:xfrm>
+            <a:off x="4709160" y="2377440"/>
+            <a:ext cx="2743200" cy="3383280"/>
           </a:xfrm>
           <a:prstGeom prst="rect">
             <a:avLst/>
           </a:prstGeom>
+          <a:noFill/>
         </p:spPr>
-      </p:pic>
+        <p:txBody>
+          <a:bodyPr wrap="square" lIns="0" tIns="0" rIns="0" bIns="0">
+            <a:spAutoFit/>
+          </a:bodyPr>
+          <a:lstStyle/>
+          <a:p>
+            <a:pPr>
+              <a:spcAft>
+                <a:spcPts val="400"/>
+              </a:spcAft>
+              <a:defRPr sz="4800" b="1">
+                <a:solidFill>
+                  <a:srgbClr val="FF467A"/>
+                </a:solidFill>
+                <a:latin typeface="Manrope"/>
+              </a:defRPr>
+            </a:pPr>
+            <a:r>
+              <a:t>0</a:t>
+            </a:r>
+          </a:p>
+          <a:p>
+            <a:pPr>
+              <a:spcAft>
+                <a:spcPts val="200"/>
+              </a:spcAft>
+              <a:defRPr sz="1300" b="1">
+                <a:solidFill>
+                  <a:srgbClr val="FFFFFF"/>
+                </a:solidFill>
+                <a:latin typeface="Manrope"/>
+              </a:defRPr>
+            </a:pPr>
+            <a:r>
+              <a:t>FORMAT COMPETITORS</a:t>
+            </a:r>
+          </a:p>
+          <a:p>
+            <a:pPr>
+              <a:spcAft>
+                <a:spcPts val="1600"/>
+              </a:spcAft>
+              <a:defRPr sz="1100" b="1">
+                <a:solidFill>
+                  <a:srgbClr val="FF467A"/>
+                </a:solidFill>
+                <a:latin typeface="Manrope"/>
+              </a:defRPr>
+            </a:pPr>
+            <a:r>
+              <a:t>100% Format Vacuum</a:t>
+            </a:r>
+          </a:p>
+          <a:p>
+            <a:pPr>
+              <a:defRPr sz="1100">
+                <a:solidFill>
+                  <a:srgbClr val="FFFFFF"/>
+                </a:solidFill>
+                <a:latin typeface="Manrope"/>
+              </a:defRPr>
+            </a:pPr>
+            <a:r>
+              <a:t>Across 154 existing New Zealand spread products, not a single brand offers a utensil-free, single-serve format.</a:t>
+            </a:r>
+          </a:p>
+        </p:txBody>
+      </p:sp>
+      <p:sp>
+        <p:nvSpPr>
+          <p:cNvPr id="9" name="Rounded Rectangle 8"/>
+          <p:cNvSpPr/>
+          <p:nvPr/>
+        </p:nvSpPr>
+        <p:spPr>
+          <a:xfrm>
+            <a:off x="8046720" y="2011680"/>
+            <a:ext cx="3291840" cy="4114800"/>
+          </a:xfrm>
+          <a:prstGeom prst="roundRect">
+            <a:avLst/>
+          </a:prstGeom>
+          <a:solidFill>
+            <a:srgbClr val="2D0414"/>
+          </a:solidFill>
+          <a:ln>
+            <a:noFill/>
+          </a:ln>
+        </p:spPr>
+        <p:style>
+          <a:lnRef idx="1">
+            <a:schemeClr val="accent1"/>
+          </a:lnRef>
+          <a:fillRef idx="3">
+            <a:schemeClr val="accent1"/>
+          </a:fillRef>
+          <a:effectRef idx="2">
+            <a:schemeClr val="accent1"/>
+          </a:effectRef>
+          <a:fontRef idx="minor">
+            <a:schemeClr val="lt1"/>
+          </a:fontRef>
+        </p:style>
+        <p:txBody>
+          <a:bodyPr rtlCol="0" anchor="ctr"/>
+          <a:lstStyle/>
+          <a:p>
+            <a:pPr algn="ctr"/>
+          </a:p>
+        </p:txBody>
+      </p:sp>
+      <p:sp>
+        <p:nvSpPr>
+          <p:cNvPr id="10" name="TextBox 9"/>
+          <p:cNvSpPr txBox="1"/>
+          <p:nvPr/>
+        </p:nvSpPr>
+        <p:spPr>
+          <a:xfrm>
+            <a:off x="8321040" y="2377440"/>
+            <a:ext cx="2743200" cy="3383280"/>
+          </a:xfrm>
+          <a:prstGeom prst="rect">
+            <a:avLst/>
+          </a:prstGeom>
+          <a:noFill/>
+        </p:spPr>
+        <p:txBody>
+          <a:bodyPr wrap="square" lIns="0" tIns="0" rIns="0" bIns="0">
+            <a:spAutoFit/>
+          </a:bodyPr>
+          <a:lstStyle/>
+          <a:p>
+            <a:pPr>
+              <a:spcAft>
+                <a:spcPts val="400"/>
+              </a:spcAft>
+              <a:defRPr sz="4800" b="1">
+                <a:solidFill>
+                  <a:srgbClr val="FF467A"/>
+                </a:solidFill>
+                <a:latin typeface="Manrope"/>
+              </a:defRPr>
+            </a:pPr>
+            <a:r>
+              <a:t>$1.75</a:t>
+            </a:r>
+          </a:p>
+          <a:p>
+            <a:pPr>
+              <a:spcAft>
+                <a:spcPts val="200"/>
+              </a:spcAft>
+              <a:defRPr sz="1300" b="1">
+                <a:solidFill>
+                  <a:srgbClr val="FFFFFF"/>
+                </a:solidFill>
+                <a:latin typeface="Manrope"/>
+              </a:defRPr>
+            </a:pPr>
+            <a:r>
+              <a:t>GROSS CONTRIBUTION</a:t>
+            </a:r>
+          </a:p>
+          <a:p>
+            <a:pPr>
+              <a:spcAft>
+                <a:spcPts val="1600"/>
+              </a:spcAft>
+              <a:defRPr sz="1100" b="1">
+                <a:solidFill>
+                  <a:srgbClr val="FF467A"/>
+                </a:solidFill>
+                <a:latin typeface="Manrope"/>
+              </a:defRPr>
+            </a:pPr>
+            <a:r>
+              <a:t>Strong Unit Economics</a:t>
+            </a:r>
+          </a:p>
+          <a:p>
+            <a:pPr>
+              <a:defRPr sz="1100">
+                <a:solidFill>
+                  <a:srgbClr val="FFFFFF"/>
+                </a:solidFill>
+                <a:latin typeface="Manrope"/>
+              </a:defRPr>
+            </a:pPr>
+            <a:r>
+              <a:t>Priced at $5.00 NZD per sheet (63¢ / toast portion). At an assumed $1.50 co-packing cost and 35% retail margin, Stamp retains $1.75 per sheet.</a:t>
+            </a:r>
+          </a:p>
+        </p:txBody>
+      </p:sp>
     </p:spTree>
   </p:cSld>
   <p:clrMapOvr>
@@ -4341,7 +5097,633 @@
 </p:sld>
 </file>
 
-<file path=ppt/slides/slide2.xml><?xml version="1.0" encoding="utf-8"?>
+<file path=ppt/slides/slide4.xml><?xml version="1.0" encoding="utf-8"?>
+<p:sld xmlns:a="http://schemas.openxmlformats.org/drawingml/2006/main" xmlns:p="http://schemas.openxmlformats.org/presentationml/2006/main" xmlns:r="http://schemas.openxmlformats.org/officeDocument/2006/relationships">
+  <p:cSld>
+    <p:spTree>
+      <p:nvGrpSpPr>
+        <p:cNvPr id="1" name=""/>
+        <p:cNvGrpSpPr/>
+        <p:nvPr/>
+      </p:nvGrpSpPr>
+      <p:grpSpPr/>
+      <p:sp>
+        <p:nvSpPr>
+          <p:cNvPr id="2" name="Rectangle 1"/>
+          <p:cNvSpPr/>
+          <p:nvPr/>
+        </p:nvSpPr>
+        <p:spPr>
+          <a:xfrm>
+            <a:off x="0" y="0"/>
+            <a:ext cx="12191695" cy="6858000"/>
+          </a:xfrm>
+          <a:prstGeom prst="rect">
+            <a:avLst/>
+          </a:prstGeom>
+          <a:solidFill>
+            <a:srgbClr val="4E2408"/>
+          </a:solidFill>
+          <a:ln>
+            <a:noFill/>
+          </a:ln>
+        </p:spPr>
+        <p:style>
+          <a:lnRef idx="1">
+            <a:schemeClr val="accent1"/>
+          </a:lnRef>
+          <a:fillRef idx="3">
+            <a:schemeClr val="accent1"/>
+          </a:fillRef>
+          <a:effectRef idx="2">
+            <a:schemeClr val="accent1"/>
+          </a:effectRef>
+          <a:fontRef idx="minor">
+            <a:schemeClr val="lt1"/>
+          </a:fontRef>
+        </p:style>
+        <p:txBody>
+          <a:bodyPr rtlCol="0" anchor="ctr"/>
+          <a:lstStyle/>
+          <a:p>
+            <a:pPr algn="ctr"/>
+          </a:p>
+        </p:txBody>
+      </p:sp>
+      <p:sp>
+        <p:nvSpPr>
+          <p:cNvPr id="3" name="TextBox 2"/>
+          <p:cNvSpPr txBox="1"/>
+          <p:nvPr/>
+        </p:nvSpPr>
+        <p:spPr>
+          <a:xfrm>
+            <a:off x="822960" y="548640"/>
+            <a:ext cx="9144000" cy="365760"/>
+          </a:xfrm>
+          <a:prstGeom prst="rect">
+            <a:avLst/>
+          </a:prstGeom>
+          <a:noFill/>
+        </p:spPr>
+        <p:txBody>
+          <a:bodyPr wrap="none" lIns="0" tIns="0" rIns="0" bIns="0">
+            <a:spAutoFit/>
+          </a:bodyPr>
+          <a:lstStyle/>
+          <a:p>
+            <a:pPr>
+              <a:defRPr sz="1200" b="1">
+                <a:solidFill>
+                  <a:srgbClr val="FF8C30"/>
+                </a:solidFill>
+                <a:latin typeface="Manrope"/>
+              </a:defRPr>
+            </a:pPr>
+            <a:r>
+              <a:t>03 / PERSONAL REFLECTION  •  PART 2 (STUDENT'S OWN VOICE)</a:t>
+            </a:r>
+          </a:p>
+        </p:txBody>
+      </p:sp>
+      <p:sp>
+        <p:nvSpPr>
+          <p:cNvPr id="4" name="TextBox 3"/>
+          <p:cNvSpPr txBox="1"/>
+          <p:nvPr/>
+        </p:nvSpPr>
+        <p:spPr>
+          <a:xfrm>
+            <a:off x="822960" y="841248"/>
+            <a:ext cx="10698480" cy="1005840"/>
+          </a:xfrm>
+          <a:prstGeom prst="rect">
+            <a:avLst/>
+          </a:prstGeom>
+          <a:noFill/>
+        </p:spPr>
+        <p:txBody>
+          <a:bodyPr wrap="square" lIns="0" tIns="0" rIns="0" bIns="0">
+            <a:spAutoFit/>
+          </a:bodyPr>
+          <a:lstStyle/>
+          <a:p>
+            <a:pPr>
+              <a:spcAft>
+                <a:spcPts val="200"/>
+              </a:spcAft>
+              <a:defRPr sz="3200" b="1">
+                <a:solidFill>
+                  <a:srgbClr val="FFFFFF"/>
+                </a:solidFill>
+                <a:latin typeface="Manrope"/>
+              </a:defRPr>
+            </a:pPr>
+            <a:r>
+              <a:t>Steering &amp; Verification</a:t>
+            </a:r>
+          </a:p>
+          <a:p>
+            <a:pPr>
+              <a:defRPr sz="1400" b="0">
+                <a:solidFill>
+                  <a:srgbClr val="FF8C30"/>
+                </a:solidFill>
+                <a:latin typeface="Manrope"/>
+              </a:defRPr>
+            </a:pPr>
+            <a:r>
+              <a:t>Key takeaways from prompt engineering, session partitioning, and fact-checking.</a:t>
+            </a:r>
+          </a:p>
+        </p:txBody>
+      </p:sp>
+      <p:sp>
+        <p:nvSpPr>
+          <p:cNvPr id="5" name="Rounded Rectangle 4"/>
+          <p:cNvSpPr/>
+          <p:nvPr/>
+        </p:nvSpPr>
+        <p:spPr>
+          <a:xfrm>
+            <a:off x="822960" y="2011680"/>
+            <a:ext cx="3291840" cy="4114800"/>
+          </a:xfrm>
+          <a:prstGeom prst="roundRect">
+            <a:avLst/>
+          </a:prstGeom>
+          <a:solidFill>
+            <a:srgbClr val="2D1403"/>
+          </a:solidFill>
+          <a:ln>
+            <a:noFill/>
+          </a:ln>
+        </p:spPr>
+        <p:style>
+          <a:lnRef idx="1">
+            <a:schemeClr val="accent1"/>
+          </a:lnRef>
+          <a:fillRef idx="3">
+            <a:schemeClr val="accent1"/>
+          </a:fillRef>
+          <a:effectRef idx="2">
+            <a:schemeClr val="accent1"/>
+          </a:effectRef>
+          <a:fontRef idx="minor">
+            <a:schemeClr val="lt1"/>
+          </a:fontRef>
+        </p:style>
+        <p:txBody>
+          <a:bodyPr rtlCol="0" anchor="ctr"/>
+          <a:lstStyle/>
+          <a:p>
+            <a:pPr algn="ctr"/>
+          </a:p>
+        </p:txBody>
+      </p:sp>
+      <p:sp>
+        <p:nvSpPr>
+          <p:cNvPr id="6" name="TextBox 5"/>
+          <p:cNvSpPr txBox="1"/>
+          <p:nvPr/>
+        </p:nvSpPr>
+        <p:spPr>
+          <a:xfrm>
+            <a:off x="1097280" y="2377440"/>
+            <a:ext cx="2743200" cy="3383280"/>
+          </a:xfrm>
+          <a:prstGeom prst="rect">
+            <a:avLst/>
+          </a:prstGeom>
+          <a:noFill/>
+        </p:spPr>
+        <p:txBody>
+          <a:bodyPr wrap="square" lIns="0" tIns="0" rIns="0" bIns="0">
+            <a:spAutoFit/>
+          </a:bodyPr>
+          <a:lstStyle/>
+          <a:p>
+            <a:pPr>
+              <a:spcAft>
+                <a:spcPts val="200"/>
+              </a:spcAft>
+              <a:defRPr sz="2800" b="1">
+                <a:solidFill>
+                  <a:srgbClr val="FF8C30"/>
+                </a:solidFill>
+                <a:latin typeface="Manrope"/>
+              </a:defRPr>
+            </a:pPr>
+            <a:r>
+              <a:t>01</a:t>
+            </a:r>
+          </a:p>
+          <a:p>
+            <a:pPr>
+              <a:spcAft>
+                <a:spcPts val="1400"/>
+              </a:spcAft>
+              <a:defRPr sz="1400" b="1">
+                <a:solidFill>
+                  <a:srgbClr val="FFFFFF"/>
+                </a:solidFill>
+                <a:latin typeface="Manrope"/>
+              </a:defRPr>
+            </a:pPr>
+            <a:r>
+              <a:t>CONTEXT STEERING</a:t>
+            </a:r>
+          </a:p>
+          <a:p>
+            <a:pPr>
+              <a:spcAft>
+                <a:spcPts val="200"/>
+              </a:spcAft>
+              <a:defRPr sz="1100" b="1">
+                <a:solidFill>
+                  <a:srgbClr val="FF8C30"/>
+                </a:solidFill>
+                <a:latin typeface="Manrope"/>
+              </a:defRPr>
+            </a:pPr>
+            <a:r>
+              <a:t>• Role Personas &amp; Negative Bans</a:t>
+            </a:r>
+          </a:p>
+          <a:p>
+            <a:pPr>
+              <a:spcAft>
+                <a:spcPts val="1200"/>
+              </a:spcAft>
+              <a:defRPr sz="1000">
+                <a:solidFill>
+                  <a:srgbClr val="FFFFFF"/>
+                </a:solidFill>
+                <a:latin typeface="Manrope"/>
+              </a:defRPr>
+            </a:pPr>
+            <a:r>
+              <a:t>Enforcing strict negative constraints against therapeutic health claims and fake certification badges prevented generic hallucinations.</a:t>
+            </a:r>
+          </a:p>
+          <a:p>
+            <a:pPr>
+              <a:spcAft>
+                <a:spcPts val="200"/>
+              </a:spcAft>
+              <a:defRPr sz="1100" b="1">
+                <a:solidFill>
+                  <a:srgbClr val="FF8C30"/>
+                </a:solidFill>
+                <a:latin typeface="Manrope"/>
+              </a:defRPr>
+            </a:pPr>
+            <a:r>
+              <a:t>• Session Partitioning</a:t>
+            </a:r>
+          </a:p>
+          <a:p>
+            <a:pPr>
+              <a:defRPr sz="1000">
+                <a:solidFill>
+                  <a:srgbClr val="FFFFFF"/>
+                </a:solidFill>
+                <a:latin typeface="Manrope"/>
+              </a:defRPr>
+            </a:pPr>
+            <a:r>
+              <a:t>Isolating data analysis, brand spec, and copywriting into modular sessions eliminated context drift across the project.</a:t>
+            </a:r>
+          </a:p>
+        </p:txBody>
+      </p:sp>
+      <p:sp>
+        <p:nvSpPr>
+          <p:cNvPr id="7" name="Rounded Rectangle 6"/>
+          <p:cNvSpPr/>
+          <p:nvPr/>
+        </p:nvSpPr>
+        <p:spPr>
+          <a:xfrm>
+            <a:off x="4434840" y="2011680"/>
+            <a:ext cx="3291840" cy="4114800"/>
+          </a:xfrm>
+          <a:prstGeom prst="roundRect">
+            <a:avLst/>
+          </a:prstGeom>
+          <a:solidFill>
+            <a:srgbClr val="2D1403"/>
+          </a:solidFill>
+          <a:ln>
+            <a:noFill/>
+          </a:ln>
+        </p:spPr>
+        <p:style>
+          <a:lnRef idx="1">
+            <a:schemeClr val="accent1"/>
+          </a:lnRef>
+          <a:fillRef idx="3">
+            <a:schemeClr val="accent1"/>
+          </a:fillRef>
+          <a:effectRef idx="2">
+            <a:schemeClr val="accent1"/>
+          </a:effectRef>
+          <a:fontRef idx="minor">
+            <a:schemeClr val="lt1"/>
+          </a:fontRef>
+        </p:style>
+        <p:txBody>
+          <a:bodyPr rtlCol="0" anchor="ctr"/>
+          <a:lstStyle/>
+          <a:p>
+            <a:pPr algn="ctr"/>
+          </a:p>
+        </p:txBody>
+      </p:sp>
+      <p:sp>
+        <p:nvSpPr>
+          <p:cNvPr id="8" name="TextBox 7"/>
+          <p:cNvSpPr txBox="1"/>
+          <p:nvPr/>
+        </p:nvSpPr>
+        <p:spPr>
+          <a:xfrm>
+            <a:off x="4709160" y="2377440"/>
+            <a:ext cx="2743200" cy="3383280"/>
+          </a:xfrm>
+          <a:prstGeom prst="rect">
+            <a:avLst/>
+          </a:prstGeom>
+          <a:noFill/>
+        </p:spPr>
+        <p:txBody>
+          <a:bodyPr wrap="square" lIns="0" tIns="0" rIns="0" bIns="0">
+            <a:spAutoFit/>
+          </a:bodyPr>
+          <a:lstStyle/>
+          <a:p>
+            <a:pPr>
+              <a:spcAft>
+                <a:spcPts val="200"/>
+              </a:spcAft>
+              <a:defRPr sz="2800" b="1">
+                <a:solidFill>
+                  <a:srgbClr val="FF8C30"/>
+                </a:solidFill>
+                <a:latin typeface="Manrope"/>
+              </a:defRPr>
+            </a:pPr>
+            <a:r>
+              <a:t>02</a:t>
+            </a:r>
+          </a:p>
+          <a:p>
+            <a:pPr>
+              <a:spcAft>
+                <a:spcPts val="1400"/>
+              </a:spcAft>
+              <a:defRPr sz="1400" b="1">
+                <a:solidFill>
+                  <a:srgbClr val="FFFFFF"/>
+                </a:solidFill>
+                <a:latin typeface="Manrope"/>
+              </a:defRPr>
+            </a:pPr>
+            <a:r>
+              <a:t>TURNING POINT</a:t>
+            </a:r>
+          </a:p>
+          <a:p>
+            <a:pPr>
+              <a:spcAft>
+                <a:spcPts val="200"/>
+              </a:spcAft>
+              <a:defRPr sz="1100" b="1">
+                <a:solidFill>
+                  <a:srgbClr val="FF8C30"/>
+                </a:solidFill>
+                <a:latin typeface="Manrope"/>
+              </a:defRPr>
+            </a:pPr>
+            <a:r>
+              <a:t>• Catching Butter Instability</a:t>
+            </a:r>
+          </a:p>
+          <a:p>
+            <a:pPr>
+              <a:spcAft>
+                <a:spcPts val="1200"/>
+              </a:spcAft>
+              <a:defRPr sz="1000">
+                <a:solidFill>
+                  <a:srgbClr val="FFFFFF"/>
+                </a:solidFill>
+                <a:latin typeface="Manrope"/>
+              </a:defRPr>
+            </a:pPr>
+            <a:r>
+              <a:t>Caught an unrealistic AI assumption that dairy butter could sit ambiently; forced reformulation into cultured dairy spread.</a:t>
+            </a:r>
+          </a:p>
+          <a:p>
+            <a:pPr>
+              <a:spcAft>
+                <a:spcPts val="200"/>
+              </a:spcAft>
+              <a:defRPr sz="1100" b="1">
+                <a:solidFill>
+                  <a:srgbClr val="FF8C30"/>
+                </a:solidFill>
+                <a:latin typeface="Manrope"/>
+              </a:defRPr>
+            </a:pPr>
+            <a:r>
+              <a:t>• Independent Verification</a:t>
+            </a:r>
+          </a:p>
+          <a:p>
+            <a:pPr>
+              <a:defRPr sz="1000">
+                <a:solidFill>
+                  <a:srgbClr val="FFFFFF"/>
+                </a:solidFill>
+                <a:latin typeface="Manrope"/>
+              </a:defRPr>
+            </a:pPr>
+            <a:r>
+              <a:t>Manually cross-checked real supermarket scan formulas and live New World pricing rather than trusting raw AI figures.</a:t>
+            </a:r>
+          </a:p>
+        </p:txBody>
+      </p:sp>
+      <p:sp>
+        <p:nvSpPr>
+          <p:cNvPr id="9" name="Rounded Rectangle 8"/>
+          <p:cNvSpPr/>
+          <p:nvPr/>
+        </p:nvSpPr>
+        <p:spPr>
+          <a:xfrm>
+            <a:off x="8046720" y="2011680"/>
+            <a:ext cx="3291840" cy="4114800"/>
+          </a:xfrm>
+          <a:prstGeom prst="roundRect">
+            <a:avLst/>
+          </a:prstGeom>
+          <a:solidFill>
+            <a:srgbClr val="2D1403"/>
+          </a:solidFill>
+          <a:ln>
+            <a:noFill/>
+          </a:ln>
+        </p:spPr>
+        <p:style>
+          <a:lnRef idx="1">
+            <a:schemeClr val="accent1"/>
+          </a:lnRef>
+          <a:fillRef idx="3">
+            <a:schemeClr val="accent1"/>
+          </a:fillRef>
+          <a:effectRef idx="2">
+            <a:schemeClr val="accent1"/>
+          </a:effectRef>
+          <a:fontRef idx="minor">
+            <a:schemeClr val="lt1"/>
+          </a:fontRef>
+        </p:style>
+        <p:txBody>
+          <a:bodyPr rtlCol="0" anchor="ctr"/>
+          <a:lstStyle/>
+          <a:p>
+            <a:pPr algn="ctr"/>
+          </a:p>
+        </p:txBody>
+      </p:sp>
+      <p:sp>
+        <p:nvSpPr>
+          <p:cNvPr id="10" name="TextBox 9"/>
+          <p:cNvSpPr txBox="1"/>
+          <p:nvPr/>
+        </p:nvSpPr>
+        <p:spPr>
+          <a:xfrm>
+            <a:off x="8321040" y="2377440"/>
+            <a:ext cx="2743200" cy="3383280"/>
+          </a:xfrm>
+          <a:prstGeom prst="rect">
+            <a:avLst/>
+          </a:prstGeom>
+          <a:noFill/>
+        </p:spPr>
+        <p:txBody>
+          <a:bodyPr wrap="square" lIns="0" tIns="0" rIns="0" bIns="0">
+            <a:spAutoFit/>
+          </a:bodyPr>
+          <a:lstStyle/>
+          <a:p>
+            <a:pPr>
+              <a:spcAft>
+                <a:spcPts val="200"/>
+              </a:spcAft>
+              <a:defRPr sz="2800" b="1">
+                <a:solidFill>
+                  <a:srgbClr val="FF8C30"/>
+                </a:solidFill>
+                <a:latin typeface="Manrope"/>
+              </a:defRPr>
+            </a:pPr>
+            <a:r>
+              <a:t>03</a:t>
+            </a:r>
+          </a:p>
+          <a:p>
+            <a:pPr>
+              <a:spcAft>
+                <a:spcPts val="1400"/>
+              </a:spcAft>
+              <a:defRPr sz="1400" b="1">
+                <a:solidFill>
+                  <a:srgbClr val="FFFFFF"/>
+                </a:solidFill>
+                <a:latin typeface="Manrope"/>
+              </a:defRPr>
+            </a:pPr>
+            <a:r>
+              <a:t>FUTURE PRACTICE</a:t>
+            </a:r>
+          </a:p>
+          <a:p>
+            <a:pPr>
+              <a:spcAft>
+                <a:spcPts val="200"/>
+              </a:spcAft>
+              <a:defRPr sz="1100" b="1">
+                <a:solidFill>
+                  <a:srgbClr val="FF8C30"/>
+                </a:solidFill>
+                <a:latin typeface="Manrope"/>
+              </a:defRPr>
+            </a:pPr>
+            <a:r>
+              <a:t>• AI as Drafter, Not Director</a:t>
+            </a:r>
+          </a:p>
+          <a:p>
+            <a:pPr>
+              <a:spcAft>
+                <a:spcPts val="1200"/>
+              </a:spcAft>
+              <a:defRPr sz="1000">
+                <a:solidFill>
+                  <a:srgbClr val="FFFFFF"/>
+                </a:solidFill>
+                <a:latin typeface="Manrope"/>
+              </a:defRPr>
+            </a:pPr>
+            <a:r>
+              <a:t>Treating model outputs strictly as draft hypotheses requiring rigorous empirical validation.</a:t>
+            </a:r>
+          </a:p>
+          <a:p>
+            <a:pPr>
+              <a:spcAft>
+                <a:spcPts val="200"/>
+              </a:spcAft>
+              <a:defRPr sz="1100" b="1">
+                <a:solidFill>
+                  <a:srgbClr val="FF8C30"/>
+                </a:solidFill>
+                <a:latin typeface="Manrope"/>
+              </a:defRPr>
+            </a:pPr>
+            <a:r>
+              <a:t>• Locked Core Specifications</a:t>
+            </a:r>
+          </a:p>
+          <a:p>
+            <a:pPr>
+              <a:defRPr sz="1000">
+                <a:solidFill>
+                  <a:srgbClr val="FFFFFF"/>
+                </a:solidFill>
+                <a:latin typeface="Manrope"/>
+              </a:defRPr>
+            </a:pPr>
+            <a:r>
+              <a:t>Establishing fixed data schemas and non-negotiable brand specs before initiating generative drafting tasks.</a:t>
+            </a:r>
+          </a:p>
+        </p:txBody>
+      </p:sp>
+    </p:spTree>
+  </p:cSld>
+  <p:clrMapOvr>
+    <a:masterClrMapping/>
+  </p:clrMapOvr>
+</p:sld>
+</file>
+
+<file path=ppt/slides/slide5.xml><?xml version="1.0" encoding="utf-8"?>
 <p:sld xmlns:a="http://schemas.openxmlformats.org/drawingml/2006/main" xmlns:p="http://schemas.openxmlformats.org/presentationml/2006/main" xmlns:r="http://schemas.openxmlformats.org/officeDocument/2006/relationships">
   <p:cSld>
     <p:spTree>
@@ -4396,14 +5778,102 @@
       </p:sp>
       <p:sp>
         <p:nvSpPr>
-          <p:cNvPr id="3" name="Rounded Rectangle 2"/>
+          <p:cNvPr id="3" name="TextBox 2"/>
+          <p:cNvSpPr txBox="1"/>
+          <p:nvPr/>
+        </p:nvSpPr>
+        <p:spPr>
+          <a:xfrm>
+            <a:off x="822960" y="548640"/>
+            <a:ext cx="9144000" cy="365760"/>
+          </a:xfrm>
+          <a:prstGeom prst="rect">
+            <a:avLst/>
+          </a:prstGeom>
+          <a:noFill/>
+        </p:spPr>
+        <p:txBody>
+          <a:bodyPr wrap="none" lIns="0" tIns="0" rIns="0" bIns="0">
+            <a:spAutoFit/>
+          </a:bodyPr>
+          <a:lstStyle/>
+          <a:p>
+            <a:pPr>
+              <a:defRPr sz="1200" b="1">
+                <a:solidFill>
+                  <a:srgbClr val="E24BFF"/>
+                </a:solidFill>
+                <a:latin typeface="Manrope"/>
+              </a:defRPr>
+            </a:pPr>
+            <a:r>
+              <a:t>04 / CRITICAL ETHICS  •  PART 2 (STUDENT'S OWN VOICE)</a:t>
+            </a:r>
+          </a:p>
+        </p:txBody>
+      </p:sp>
+      <p:sp>
+        <p:nvSpPr>
+          <p:cNvPr id="4" name="TextBox 3"/>
+          <p:cNvSpPr txBox="1"/>
+          <p:nvPr/>
+        </p:nvSpPr>
+        <p:spPr>
+          <a:xfrm>
+            <a:off x="822960" y="841248"/>
+            <a:ext cx="10698480" cy="1005840"/>
+          </a:xfrm>
+          <a:prstGeom prst="rect">
+            <a:avLst/>
+          </a:prstGeom>
+          <a:noFill/>
+        </p:spPr>
+        <p:txBody>
+          <a:bodyPr wrap="square" lIns="0" tIns="0" rIns="0" bIns="0">
+            <a:spAutoFit/>
+          </a:bodyPr>
+          <a:lstStyle/>
+          <a:p>
+            <a:pPr>
+              <a:spcAft>
+                <a:spcPts val="200"/>
+              </a:spcAft>
+              <a:defRPr sz="3200" b="1">
+                <a:solidFill>
+                  <a:srgbClr val="FFFFFF"/>
+                </a:solidFill>
+                <a:latin typeface="Manrope"/>
+              </a:defRPr>
+            </a:pPr>
+            <a:r>
+              <a:t>Authenticity &amp; Accountability</a:t>
+            </a:r>
+          </a:p>
+          <a:p>
+            <a:pPr>
+              <a:defRPr sz="1400" b="0">
+                <a:solidFill>
+                  <a:srgbClr val="E24BFF"/>
+                </a:solidFill>
+                <a:latin typeface="Manrope"/>
+              </a:defRPr>
+            </a:pPr>
+            <a:r>
+              <a:t>Combating AI slop, regulatory food liabilities, and human ownership.</a:t>
+            </a:r>
+          </a:p>
+        </p:txBody>
+      </p:sp>
+      <p:sp>
+        <p:nvSpPr>
+          <p:cNvPr id="5" name="Rounded Rectangle 4"/>
           <p:cNvSpPr/>
           <p:nvPr/>
         </p:nvSpPr>
         <p:spPr>
           <a:xfrm>
-            <a:off x="731520" y="457200"/>
-            <a:ext cx="3986784" cy="329184"/>
+            <a:off x="822960" y="2011680"/>
+            <a:ext cx="3291840" cy="4114800"/>
           </a:xfrm>
           <a:prstGeom prst="roundRect">
             <a:avLst/>
@@ -4430,33 +5900,23 @@
           </a:fontRef>
         </p:style>
         <p:txBody>
-          <a:bodyPr rtlCol="0" anchor="ctr" wrap="none" lIns="137160" rIns="137160"/>
-          <a:lstStyle/>
-          <a:p>
-            <a:pPr algn="ctr">
-              <a:defRPr sz="1050" b="1">
-                <a:solidFill>
-                  <a:srgbClr val="E24BFF"/>
-                </a:solidFill>
-                <a:latin typeface="Manrope"/>
-              </a:defRPr>
-            </a:pPr>
-            <a:r>
-              <a:t>INVESTOR PITCH • PART 1 (30 SECONDS)</a:t>
-            </a:r>
-          </a:p>
-        </p:txBody>
-      </p:sp>
-      <p:sp>
-        <p:nvSpPr>
-          <p:cNvPr id="4" name="TextBox 3"/>
+          <a:bodyPr rtlCol="0" anchor="ctr"/>
+          <a:lstStyle/>
+          <a:p>
+            <a:pPr algn="ctr"/>
+          </a:p>
+        </p:txBody>
+      </p:sp>
+      <p:sp>
+        <p:nvSpPr>
+          <p:cNvPr id="6" name="TextBox 5"/>
           <p:cNvSpPr txBox="1"/>
           <p:nvPr/>
         </p:nvSpPr>
         <p:spPr>
           <a:xfrm>
-            <a:off x="731520" y="859536"/>
-            <a:ext cx="10698480" cy="960120"/>
+            <a:off x="1097280" y="2377440"/>
+            <a:ext cx="2743200" cy="3383280"/>
           </a:xfrm>
           <a:prstGeom prst="rect">
             <a:avLst/>
@@ -4473,7 +5933,23 @@
               <a:spcAft>
                 <a:spcPts val="200"/>
               </a:spcAft>
-              <a:defRPr sz="2600" b="1">
+              <a:defRPr sz="2800" b="1">
+                <a:solidFill>
+                  <a:srgbClr val="E24BFF"/>
+                </a:solidFill>
+                <a:latin typeface="Manrope"/>
+              </a:defRPr>
+            </a:pPr>
+            <a:r>
+              <a:t>01</a:t>
+            </a:r>
+          </a:p>
+          <a:p>
+            <a:pPr>
+              <a:spcAft>
+                <a:spcPts val="1400"/>
+              </a:spcAft>
+              <a:defRPr sz="1400" b="1">
                 <a:solidFill>
                   <a:srgbClr val="FFFFFF"/>
                 </a:solidFill>
@@ -4481,34 +5957,82 @@
               </a:defRPr>
             </a:pPr>
             <a:r>
-              <a:t>Product Innovation: Peel. Press. Toast.</a:t>
-            </a:r>
-          </a:p>
-          <a:p>
-            <a:pPr>
-              <a:defRPr sz="1300">
-                <a:solidFill>
-                  <a:srgbClr val="D8B4FE"/>
-                </a:solidFill>
-                <a:latin typeface="Manrope"/>
-              </a:defRPr>
-            </a:pPr>
-            <a:r>
-              <a:t>A calibrated 10 g disc on release film: no knife, no sticky jar, no morning wash-up.</a:t>
-            </a:r>
-          </a:p>
-        </p:txBody>
-      </p:sp>
-      <p:sp>
-        <p:nvSpPr>
-          <p:cNvPr id="5" name="Rounded Rectangle 4"/>
+              <a:t>COMBATING 'AI SLOP'</a:t>
+            </a:r>
+          </a:p>
+          <a:p>
+            <a:pPr>
+              <a:spcAft>
+                <a:spcPts val="200"/>
+              </a:spcAft>
+              <a:defRPr sz="1100" b="1">
+                <a:solidFill>
+                  <a:srgbClr val="E24BFF"/>
+                </a:solidFill>
+                <a:latin typeface="Manrope"/>
+              </a:defRPr>
+            </a:pPr>
+            <a:r>
+              <a:t>• Stripping Hyperbolic Jargon</a:t>
+            </a:r>
+          </a:p>
+          <a:p>
+            <a:pPr>
+              <a:spcAft>
+                <a:spcPts val="1200"/>
+              </a:spcAft>
+              <a:defRPr sz="1000">
+                <a:solidFill>
+                  <a:srgbClr val="FFFFFF"/>
+                </a:solidFill>
+                <a:latin typeface="Manrope"/>
+              </a:defRPr>
+            </a:pPr>
+            <a:r>
+              <a:t>Actively rejected generic corporate cliches ('game-changer', 'revolutionary journey') in favor of punchy facts: 'Peel. Press. Toast.'</a:t>
+            </a:r>
+          </a:p>
+          <a:p>
+            <a:pPr>
+              <a:spcAft>
+                <a:spcPts val="200"/>
+              </a:spcAft>
+              <a:defRPr sz="1100" b="1">
+                <a:solidFill>
+                  <a:srgbClr val="E24BFF"/>
+                </a:solidFill>
+                <a:latin typeface="Manrope"/>
+              </a:defRPr>
+            </a:pPr>
+            <a:r>
+              <a:t>• Physical Reality Over Fantasy</a:t>
+            </a:r>
+          </a:p>
+          <a:p>
+            <a:pPr>
+              <a:defRPr sz="1000">
+                <a:solidFill>
+                  <a:srgbClr val="FFFFFF"/>
+                </a:solidFill>
+                <a:latin typeface="Manrope"/>
+              </a:defRPr>
+            </a:pPr>
+            <a:r>
+              <a:t>Grounded product specifications in real packaging engineering (continuous deposit, release film) rather than impossible AI mockups.</a:t>
+            </a:r>
+          </a:p>
+        </p:txBody>
+      </p:sp>
+      <p:sp>
+        <p:nvSpPr>
+          <p:cNvPr id="7" name="Rounded Rectangle 6"/>
           <p:cNvSpPr/>
           <p:nvPr/>
         </p:nvSpPr>
         <p:spPr>
           <a:xfrm>
-            <a:off x="731520" y="1828800"/>
-            <a:ext cx="5212080" cy="4480560"/>
+            <a:off x="4434840" y="2011680"/>
+            <a:ext cx="3291840" cy="4114800"/>
           </a:xfrm>
           <a:prstGeom prst="roundRect">
             <a:avLst/>
@@ -4544,14 +6068,14 @@
       </p:sp>
       <p:sp>
         <p:nvSpPr>
-          <p:cNvPr id="6" name="TextBox 5"/>
+          <p:cNvPr id="8" name="TextBox 7"/>
           <p:cNvSpPr txBox="1"/>
           <p:nvPr/>
         </p:nvSpPr>
         <p:spPr>
           <a:xfrm>
-            <a:off x="1051560" y="2148840"/>
-            <a:ext cx="4572000" cy="3840480"/>
+            <a:off x="4709160" y="2377440"/>
+            <a:ext cx="2743200" cy="3383280"/>
           </a:xfrm>
           <a:prstGeom prst="rect">
             <a:avLst/>
@@ -4566,9 +6090,41 @@
           <a:p>
             <a:pPr>
               <a:spcAft>
+                <a:spcPts val="200"/>
+              </a:spcAft>
+              <a:defRPr sz="2800" b="1">
+                <a:solidFill>
+                  <a:srgbClr val="E24BFF"/>
+                </a:solidFill>
+                <a:latin typeface="Manrope"/>
+              </a:defRPr>
+            </a:pPr>
+            <a:r>
+              <a:t>02</a:t>
+            </a:r>
+          </a:p>
+          <a:p>
+            <a:pPr>
+              <a:spcAft>
                 <a:spcPts val="1400"/>
               </a:spcAft>
-              <a:defRPr sz="1800" b="1">
+              <a:defRPr sz="1400" b="1">
+                <a:solidFill>
+                  <a:srgbClr val="FFFFFF"/>
+                </a:solidFill>
+                <a:latin typeface="Manrope"/>
+              </a:defRPr>
+            </a:pPr>
+            <a:r>
+              <a:t>FOOD REGULATION</a:t>
+            </a:r>
+          </a:p>
+          <a:p>
+            <a:pPr>
+              <a:spcAft>
+                <a:spcPts val="200"/>
+              </a:spcAft>
+              <a:defRPr sz="1100" b="1">
                 <a:solidFill>
                   <a:srgbClr val="E24BFF"/>
                 </a:solidFill>
@@ -4576,15 +6132,15 @@
               </a:defRPr>
             </a:pPr>
             <a:r>
-              <a:t>The Out-of-Kitchen Friction</a:t>
+              <a:t>• The Hallucination Danger</a:t>
             </a:r>
           </a:p>
           <a:p>
             <a:pPr>
               <a:spcAft>
-                <a:spcPts val="1000"/>
+                <a:spcPts val="1200"/>
               </a:spcAft>
-              <a:defRPr sz="1200" b="1">
+              <a:defRPr sz="1000">
                 <a:solidFill>
                   <a:srgbClr val="FFFFFF"/>
                 </a:solidFill>
@@ -4592,25 +6148,28 @@
               </a:defRPr>
             </a:pPr>
             <a:r>
-              <a:t>• The Jar Infrastructure Problem</a:t>
-            </a:r>
-            <a:br/>
-            <a:r>
-              <a:rPr sz="1100" b="0">
-                <a:solidFill>
-                  <a:srgbClr val="E9D5FF"/>
-                </a:solidFill>
-                <a:latin typeface="Manrope"/>
-              </a:rPr>
-              <a:t>Eating toast away from home (office breakrooms, student halls, flat kitchens) demands cutlery, a sticky tub, and a sink to wash up. Cutlery-dependent spreads fail mobile consumers.</a:t>
+              <a:t>Unchecked models frequently invent fake organic labels, false 'gluten-free' badges, or illegal medical claims.</a:t>
             </a:r>
           </a:p>
           <a:p>
             <a:pPr>
               <a:spcAft>
-                <a:spcPts val="1000"/>
+                <a:spcPts val="200"/>
               </a:spcAft>
-              <a:defRPr sz="1200" b="1">
+              <a:defRPr sz="1100" b="1">
+                <a:solidFill>
+                  <a:srgbClr val="E24BFF"/>
+                </a:solidFill>
+                <a:latin typeface="Manrope"/>
+              </a:defRPr>
+            </a:pPr>
+            <a:r>
+              <a:t>• FSANZ &amp; Allergen Responsibility</a:t>
+            </a:r>
+          </a:p>
+          <a:p>
+            <a:pPr>
+              <a:defRPr sz="1000">
                 <a:solidFill>
                   <a:srgbClr val="FFFFFF"/>
                 </a:solidFill>
@@ -4618,57 +6177,21 @@
               </a:defRPr>
             </a:pPr>
             <a:r>
-              <a:t>• The Peel-and-Press Format</a:t>
-            </a:r>
-            <a:br/>
-            <a:r>
-              <a:rPr sz="1100" b="0">
-                <a:solidFill>
-                  <a:srgbClr val="E9D5FF"/>
-                </a:solidFill>
-                <a:latin typeface="Manrope"/>
-              </a:rPr>
-              <a:t>Each Stamp delivers a calibrated 10 g disc mounted onto food-grade release film. Peel the disc, press it directly onto hot bread, and residual heat softens it into an even, velvety layer across the crumb.</a:t>
-            </a:r>
-          </a:p>
-          <a:p>
-            <a:pPr>
-              <a:spcAft>
-                <a:spcPts val="1000"/>
-              </a:spcAft>
-              <a:defRPr sz="1200" b="1">
-                <a:solidFill>
-                  <a:srgbClr val="FFFFFF"/>
-                </a:solidFill>
-                <a:latin typeface="Manrope"/>
-              </a:defRPr>
-            </a:pPr>
-            <a:r>
-              <a:t>• 12-Month Ambient Pantry Life</a:t>
-            </a:r>
-            <a:br/>
-            <a:r>
-              <a:rPr sz="1100" b="0">
-                <a:solidFill>
-                  <a:srgbClr val="E9D5FF"/>
-                </a:solidFill>
-                <a:latin typeface="Manrope"/>
-              </a:rPr>
-              <a:t>Proprietary water-activity barrier formulation packaged in airtight card sheets provides verified 12-month ambient shelf stability without refrigeration.</a:t>
-            </a:r>
-          </a:p>
-        </p:txBody>
-      </p:sp>
-      <p:sp>
-        <p:nvSpPr>
-          <p:cNvPr id="7" name="Rounded Rectangle 6"/>
+              <a:t>Enforced strict New Zealand food labeling standards and ensured life-threatening peanut and gluten warnings remained prominent.</a:t>
+            </a:r>
+          </a:p>
+        </p:txBody>
+      </p:sp>
+      <p:sp>
+        <p:nvSpPr>
+          <p:cNvPr id="9" name="Rounded Rectangle 8"/>
           <p:cNvSpPr/>
           <p:nvPr/>
         </p:nvSpPr>
         <p:spPr>
           <a:xfrm>
-            <a:off x="6217920" y="1828800"/>
-            <a:ext cx="5212080" cy="4480560"/>
+            <a:off x="8046720" y="2011680"/>
+            <a:ext cx="3291840" cy="4114800"/>
           </a:xfrm>
           <a:prstGeom prst="roundRect">
             <a:avLst/>
@@ -4704,14 +6227,14 @@
       </p:sp>
       <p:sp>
         <p:nvSpPr>
-          <p:cNvPr id="8" name="TextBox 7"/>
+          <p:cNvPr id="10" name="TextBox 9"/>
           <p:cNvSpPr txBox="1"/>
           <p:nvPr/>
         </p:nvSpPr>
         <p:spPr>
           <a:xfrm>
-            <a:off x="6537960" y="2148840"/>
-            <a:ext cx="4572000" cy="457200"/>
+            <a:off x="8321040" y="2377440"/>
+            <a:ext cx="2743200" cy="3383280"/>
           </a:xfrm>
           <a:prstGeom prst="rect">
             <a:avLst/>
@@ -4725,643 +6248,6 @@
           <a:lstStyle/>
           <a:p>
             <a:pPr>
-              <a:defRPr sz="1800" b="1">
-                <a:solidFill>
-                  <a:srgbClr val="FFD640"/>
-                </a:solidFill>
-                <a:latin typeface="Manrope"/>
-              </a:defRPr>
-            </a:pPr>
-            <a:r>
-              <a:t>Four Launch Flavours</a:t>
-            </a:r>
-          </a:p>
-        </p:txBody>
-      </p:sp>
-      <p:sp>
-        <p:nvSpPr>
-          <p:cNvPr id="9" name="Rounded Rectangle 8"/>
-          <p:cNvSpPr/>
-          <p:nvPr/>
-        </p:nvSpPr>
-        <p:spPr>
-          <a:xfrm>
-            <a:off x="6492240" y="2651760"/>
-            <a:ext cx="4663440" cy="621792"/>
-          </a:xfrm>
-          <a:prstGeom prst="roundRect">
-            <a:avLst/>
-          </a:prstGeom>
-          <a:solidFill>
-            <a:srgbClr val="4C0C80"/>
-          </a:solidFill>
-          <a:ln>
-            <a:noFill/>
-          </a:ln>
-        </p:spPr>
-        <p:style>
-          <a:lnRef idx="1">
-            <a:schemeClr val="accent1"/>
-          </a:lnRef>
-          <a:fillRef idx="3">
-            <a:schemeClr val="accent1"/>
-          </a:fillRef>
-          <a:effectRef idx="2">
-            <a:schemeClr val="accent1"/>
-          </a:effectRef>
-          <a:fontRef idx="minor">
-            <a:schemeClr val="lt1"/>
-          </a:fontRef>
-        </p:style>
-        <p:txBody>
-          <a:bodyPr rtlCol="0" anchor="ctr"/>
-          <a:lstStyle/>
-          <a:p>
-            <a:pPr algn="ctr"/>
-          </a:p>
-        </p:txBody>
-      </p:sp>
-      <p:sp>
-        <p:nvSpPr>
-          <p:cNvPr id="10" name="TextBox 9"/>
-          <p:cNvSpPr txBox="1"/>
-          <p:nvPr/>
-        </p:nvSpPr>
-        <p:spPr>
-          <a:xfrm>
-            <a:off x="6629400" y="2724912"/>
-            <a:ext cx="4389120" cy="502920"/>
-          </a:xfrm>
-          <a:prstGeom prst="rect">
-            <a:avLst/>
-          </a:prstGeom>
-          <a:noFill/>
-        </p:spPr>
-        <p:txBody>
-          <a:bodyPr wrap="square" lIns="0" tIns="0" rIns="0" bIns="0">
-            <a:spAutoFit/>
-          </a:bodyPr>
-          <a:lstStyle/>
-          <a:p>
-            <a:pPr>
-              <a:defRPr sz="1100" b="1">
-                <a:solidFill>
-                  <a:srgbClr val="FFD640"/>
-                </a:solidFill>
-                <a:latin typeface="Manrope"/>
-              </a:defRPr>
-            </a:pPr>
-            <a:r>
-              <a:t>SALTED BUTTER  </a:t>
-            </a:r>
-          </a:p>
-          <a:p>
-            <a:pPr>
-              <a:defRPr sz="950">
-                <a:solidFill>
-                  <a:srgbClr val="E9D5FF"/>
-                </a:solidFill>
-                <a:latin typeface="Manrope"/>
-              </a:defRPr>
-            </a:pPr>
-            <a:r>
-              <a:t>Cultured dairy spread (2 g salt / 78 g fat). Rich European style.</a:t>
-            </a:r>
-          </a:p>
-        </p:txBody>
-      </p:sp>
-      <p:sp>
-        <p:nvSpPr>
-          <p:cNvPr id="11" name="Rounded Rectangle 10"/>
-          <p:cNvSpPr/>
-          <p:nvPr/>
-        </p:nvSpPr>
-        <p:spPr>
-          <a:xfrm>
-            <a:off x="6492240" y="3364992"/>
-            <a:ext cx="4663440" cy="621792"/>
-          </a:xfrm>
-          <a:prstGeom prst="roundRect">
-            <a:avLst/>
-          </a:prstGeom>
-          <a:solidFill>
-            <a:srgbClr val="4C0C80"/>
-          </a:solidFill>
-          <a:ln>
-            <a:noFill/>
-          </a:ln>
-        </p:spPr>
-        <p:style>
-          <a:lnRef idx="1">
-            <a:schemeClr val="accent1"/>
-          </a:lnRef>
-          <a:fillRef idx="3">
-            <a:schemeClr val="accent1"/>
-          </a:fillRef>
-          <a:effectRef idx="2">
-            <a:schemeClr val="accent1"/>
-          </a:effectRef>
-          <a:fontRef idx="minor">
-            <a:schemeClr val="lt1"/>
-          </a:fontRef>
-        </p:style>
-        <p:txBody>
-          <a:bodyPr rtlCol="0" anchor="ctr"/>
-          <a:lstStyle/>
-          <a:p>
-            <a:pPr algn="ctr"/>
-          </a:p>
-        </p:txBody>
-      </p:sp>
-      <p:sp>
-        <p:nvSpPr>
-          <p:cNvPr id="12" name="TextBox 11"/>
-          <p:cNvSpPr txBox="1"/>
-          <p:nvPr/>
-        </p:nvSpPr>
-        <p:spPr>
-          <a:xfrm>
-            <a:off x="6629400" y="3438144"/>
-            <a:ext cx="4389120" cy="502920"/>
-          </a:xfrm>
-          <a:prstGeom prst="rect">
-            <a:avLst/>
-          </a:prstGeom>
-          <a:noFill/>
-        </p:spPr>
-        <p:txBody>
-          <a:bodyPr wrap="square" lIns="0" tIns="0" rIns="0" bIns="0">
-            <a:spAutoFit/>
-          </a:bodyPr>
-          <a:lstStyle/>
-          <a:p>
-            <a:pPr>
-              <a:defRPr sz="1100" b="1">
-                <a:solidFill>
-                  <a:srgbClr val="FF467A"/>
-                </a:solidFill>
-                <a:latin typeface="Manrope"/>
-              </a:defRPr>
-            </a:pPr>
-            <a:r>
-              <a:t>WILD RASPBERRY  </a:t>
-            </a:r>
-          </a:p>
-          <a:p>
-            <a:pPr>
-              <a:defRPr sz="950">
-                <a:solidFill>
-                  <a:srgbClr val="E9D5FF"/>
-                </a:solidFill>
-                <a:latin typeface="Manrope"/>
-              </a:defRPr>
-            </a:pPr>
-            <a:r>
-              <a:t>150 g fruit paste / 100 g. Natural pectin set, tart &amp; vibrant.</a:t>
-            </a:r>
-          </a:p>
-        </p:txBody>
-      </p:sp>
-      <p:sp>
-        <p:nvSpPr>
-          <p:cNvPr id="13" name="Rounded Rectangle 12"/>
-          <p:cNvSpPr/>
-          <p:nvPr/>
-        </p:nvSpPr>
-        <p:spPr>
-          <a:xfrm>
-            <a:off x="6492240" y="4078224"/>
-            <a:ext cx="4663440" cy="621792"/>
-          </a:xfrm>
-          <a:prstGeom prst="roundRect">
-            <a:avLst/>
-          </a:prstGeom>
-          <a:solidFill>
-            <a:srgbClr val="4C0C80"/>
-          </a:solidFill>
-          <a:ln>
-            <a:noFill/>
-          </a:ln>
-        </p:spPr>
-        <p:style>
-          <a:lnRef idx="1">
-            <a:schemeClr val="accent1"/>
-          </a:lnRef>
-          <a:fillRef idx="3">
-            <a:schemeClr val="accent1"/>
-          </a:fillRef>
-          <a:effectRef idx="2">
-            <a:schemeClr val="accent1"/>
-          </a:effectRef>
-          <a:fontRef idx="minor">
-            <a:schemeClr val="lt1"/>
-          </a:fontRef>
-        </p:style>
-        <p:txBody>
-          <a:bodyPr rtlCol="0" anchor="ctr"/>
-          <a:lstStyle/>
-          <a:p>
-            <a:pPr algn="ctr"/>
-          </a:p>
-        </p:txBody>
-      </p:sp>
-      <p:sp>
-        <p:nvSpPr>
-          <p:cNvPr id="14" name="TextBox 13"/>
-          <p:cNvSpPr txBox="1"/>
-          <p:nvPr/>
-        </p:nvSpPr>
-        <p:spPr>
-          <a:xfrm>
-            <a:off x="6629400" y="4151376"/>
-            <a:ext cx="4389120" cy="502920"/>
-          </a:xfrm>
-          <a:prstGeom prst="rect">
-            <a:avLst/>
-          </a:prstGeom>
-          <a:noFill/>
-        </p:spPr>
-        <p:txBody>
-          <a:bodyPr wrap="square" lIns="0" tIns="0" rIns="0" bIns="0">
-            <a:spAutoFit/>
-          </a:bodyPr>
-          <a:lstStyle/>
-          <a:p>
-            <a:pPr>
-              <a:defRPr sz="1100" b="1">
-                <a:solidFill>
-                  <a:srgbClr val="E24BFF"/>
-                </a:solidFill>
-                <a:latin typeface="Manrope"/>
-              </a:defRPr>
-            </a:pPr>
-            <a:r>
-              <a:t>YEAST EXTRACT  </a:t>
-            </a:r>
-          </a:p>
-          <a:p>
-            <a:pPr>
-              <a:defRPr sz="950">
-                <a:solidFill>
-                  <a:srgbClr val="E9D5FF"/>
-                </a:solidFill>
-                <a:latin typeface="Manrope"/>
-              </a:defRPr>
-            </a:pPr>
-            <a:r>
-              <a:t>80% autolysed yeast, 15.5% barley malt. Classic savoury umami.</a:t>
-            </a:r>
-          </a:p>
-        </p:txBody>
-      </p:sp>
-      <p:sp>
-        <p:nvSpPr>
-          <p:cNvPr id="15" name="Rounded Rectangle 14"/>
-          <p:cNvSpPr/>
-          <p:nvPr/>
-        </p:nvSpPr>
-        <p:spPr>
-          <a:xfrm>
-            <a:off x="6492240" y="4791456"/>
-            <a:ext cx="4663440" cy="621792"/>
-          </a:xfrm>
-          <a:prstGeom prst="roundRect">
-            <a:avLst/>
-          </a:prstGeom>
-          <a:solidFill>
-            <a:srgbClr val="4C0C80"/>
-          </a:solidFill>
-          <a:ln>
-            <a:noFill/>
-          </a:ln>
-        </p:spPr>
-        <p:style>
-          <a:lnRef idx="1">
-            <a:schemeClr val="accent1"/>
-          </a:lnRef>
-          <a:fillRef idx="3">
-            <a:schemeClr val="accent1"/>
-          </a:fillRef>
-          <a:effectRef idx="2">
-            <a:schemeClr val="accent1"/>
-          </a:effectRef>
-          <a:fontRef idx="minor">
-            <a:schemeClr val="lt1"/>
-          </a:fontRef>
-        </p:style>
-        <p:txBody>
-          <a:bodyPr rtlCol="0" anchor="ctr"/>
-          <a:lstStyle/>
-          <a:p>
-            <a:pPr algn="ctr"/>
-          </a:p>
-        </p:txBody>
-      </p:sp>
-      <p:sp>
-        <p:nvSpPr>
-          <p:cNvPr id="16" name="TextBox 15"/>
-          <p:cNvSpPr txBox="1"/>
-          <p:nvPr/>
-        </p:nvSpPr>
-        <p:spPr>
-          <a:xfrm>
-            <a:off x="6629400" y="4864608"/>
-            <a:ext cx="4389120" cy="502920"/>
-          </a:xfrm>
-          <a:prstGeom prst="rect">
-            <a:avLst/>
-          </a:prstGeom>
-          <a:noFill/>
-        </p:spPr>
-        <p:txBody>
-          <a:bodyPr wrap="square" lIns="0" tIns="0" rIns="0" bIns="0">
-            <a:spAutoFit/>
-          </a:bodyPr>
-          <a:lstStyle/>
-          <a:p>
-            <a:pPr>
-              <a:defRPr sz="1100" b="1">
-                <a:solidFill>
-                  <a:srgbClr val="FF8C30"/>
-                </a:solidFill>
-                <a:latin typeface="Manrope"/>
-              </a:defRPr>
-            </a:pPr>
-            <a:r>
-              <a:t>ROASTED PEANUT  </a:t>
-            </a:r>
-          </a:p>
-          <a:p>
-            <a:pPr>
-              <a:defRPr sz="950">
-                <a:solidFill>
-                  <a:srgbClr val="E9D5FF"/>
-                </a:solidFill>
-                <a:latin typeface="Manrope"/>
-              </a:defRPr>
-            </a:pPr>
-            <a:r>
-              <a:t>96% roasted peanuts + hard fat anti-oil separation barrier.</a:t>
-            </a:r>
-          </a:p>
-        </p:txBody>
-      </p:sp>
-      <p:pic>
-        <p:nvPicPr>
-          <p:cNvPr id="17" name="Picture 16" descr="pack.png"/>
-          <p:cNvPicPr>
-            <a:picLocks noChangeAspect="1"/>
-          </p:cNvPicPr>
-          <p:nvPr/>
-        </p:nvPicPr>
-        <p:blipFill>
-          <a:blip r:embed="rId2"/>
-          <a:stretch>
-            <a:fillRect/>
-          </a:stretch>
-        </p:blipFill>
-        <p:spPr>
-          <a:xfrm>
-            <a:off x="7589520" y="4937760"/>
-            <a:ext cx="960120" cy="1280160"/>
-          </a:xfrm>
-          <a:prstGeom prst="rect">
-            <a:avLst/>
-          </a:prstGeom>
-        </p:spPr>
-      </p:pic>
-    </p:spTree>
-  </p:cSld>
-  <p:clrMapOvr>
-    <a:masterClrMapping/>
-  </p:clrMapOvr>
-</p:sld>
-</file>
-
-<file path=ppt/slides/slide3.xml><?xml version="1.0" encoding="utf-8"?>
-<p:sld xmlns:a="http://schemas.openxmlformats.org/drawingml/2006/main" xmlns:p="http://schemas.openxmlformats.org/presentationml/2006/main" xmlns:r="http://schemas.openxmlformats.org/officeDocument/2006/relationships">
-  <p:cSld>
-    <p:spTree>
-      <p:nvGrpSpPr>
-        <p:cNvPr id="1" name=""/>
-        <p:cNvGrpSpPr/>
-        <p:nvPr/>
-      </p:nvGrpSpPr>
-      <p:grpSpPr/>
-      <p:sp>
-        <p:nvSpPr>
-          <p:cNvPr id="2" name="Rectangle 1"/>
-          <p:cNvSpPr/>
-          <p:nvPr/>
-        </p:nvSpPr>
-        <p:spPr>
-          <a:xfrm>
-            <a:off x="0" y="0"/>
-            <a:ext cx="12191695" cy="6858000"/>
-          </a:xfrm>
-          <a:prstGeom prst="rect">
-            <a:avLst/>
-          </a:prstGeom>
-          <a:solidFill>
-            <a:srgbClr val="240340"/>
-          </a:solidFill>
-          <a:ln>
-            <a:noFill/>
-          </a:ln>
-        </p:spPr>
-        <p:style>
-          <a:lnRef idx="1">
-            <a:schemeClr val="accent1"/>
-          </a:lnRef>
-          <a:fillRef idx="3">
-            <a:schemeClr val="accent1"/>
-          </a:fillRef>
-          <a:effectRef idx="2">
-            <a:schemeClr val="accent1"/>
-          </a:effectRef>
-          <a:fontRef idx="minor">
-            <a:schemeClr val="lt1"/>
-          </a:fontRef>
-        </p:style>
-        <p:txBody>
-          <a:bodyPr rtlCol="0" anchor="ctr"/>
-          <a:lstStyle/>
-          <a:p>
-            <a:pPr algn="ctr"/>
-          </a:p>
-        </p:txBody>
-      </p:sp>
-      <p:sp>
-        <p:nvSpPr>
-          <p:cNvPr id="3" name="Rounded Rectangle 2"/>
-          <p:cNvSpPr/>
-          <p:nvPr/>
-        </p:nvSpPr>
-        <p:spPr>
-          <a:xfrm>
-            <a:off x="731520" y="457200"/>
-            <a:ext cx="3986784" cy="329184"/>
-          </a:xfrm>
-          <a:prstGeom prst="roundRect">
-            <a:avLst/>
-          </a:prstGeom>
-          <a:solidFill>
-            <a:srgbClr val="3B0764"/>
-          </a:solidFill>
-          <a:ln>
-            <a:noFill/>
-          </a:ln>
-        </p:spPr>
-        <p:style>
-          <a:lnRef idx="1">
-            <a:schemeClr val="accent1"/>
-          </a:lnRef>
-          <a:fillRef idx="3">
-            <a:schemeClr val="accent1"/>
-          </a:fillRef>
-          <a:effectRef idx="2">
-            <a:schemeClr val="accent1"/>
-          </a:effectRef>
-          <a:fontRef idx="minor">
-            <a:schemeClr val="lt1"/>
-          </a:fontRef>
-        </p:style>
-        <p:txBody>
-          <a:bodyPr rtlCol="0" anchor="ctr" wrap="none" lIns="137160" rIns="137160"/>
-          <a:lstStyle/>
-          <a:p>
-            <a:pPr algn="ctr">
-              <a:defRPr sz="1050" b="1">
-                <a:solidFill>
-                  <a:srgbClr val="FF467A"/>
-                </a:solidFill>
-                <a:latin typeface="Manrope"/>
-              </a:defRPr>
-            </a:pPr>
-            <a:r>
-              <a:t>INVESTOR PITCH • PART 2 (30 SECONDS)</a:t>
-            </a:r>
-          </a:p>
-        </p:txBody>
-      </p:sp>
-      <p:sp>
-        <p:nvSpPr>
-          <p:cNvPr id="4" name="TextBox 3"/>
-          <p:cNvSpPr txBox="1"/>
-          <p:nvPr/>
-        </p:nvSpPr>
-        <p:spPr>
-          <a:xfrm>
-            <a:off x="731520" y="859536"/>
-            <a:ext cx="10698480" cy="960120"/>
-          </a:xfrm>
-          <a:prstGeom prst="rect">
-            <a:avLst/>
-          </a:prstGeom>
-          <a:noFill/>
-        </p:spPr>
-        <p:txBody>
-          <a:bodyPr wrap="square" lIns="0" tIns="0" rIns="0" bIns="0">
-            <a:spAutoFit/>
-          </a:bodyPr>
-          <a:lstStyle/>
-          <a:p>
-            <a:pPr>
-              <a:spcAft>
-                <a:spcPts val="200"/>
-              </a:spcAft>
-              <a:defRPr sz="2600" b="1">
-                <a:solidFill>
-                  <a:srgbClr val="FFFFFF"/>
-                </a:solidFill>
-                <a:latin typeface="Manrope"/>
-              </a:defRPr>
-            </a:pPr>
-            <a:r>
-              <a:t>Market Opportunity &amp; Unit Economics</a:t>
-            </a:r>
-          </a:p>
-          <a:p>
-            <a:pPr>
-              <a:defRPr sz="1300">
-                <a:solidFill>
-                  <a:srgbClr val="D8B4FE"/>
-                </a:solidFill>
-                <a:latin typeface="Manrope"/>
-              </a:defRPr>
-            </a:pPr>
-            <a:r>
-              <a:t>$341M New Zealand category, 24% revenue growth, and zero portion-format rivals.</a:t>
-            </a:r>
-          </a:p>
-        </p:txBody>
-      </p:sp>
-      <p:sp>
-        <p:nvSpPr>
-          <p:cNvPr id="5" name="Rounded Rectangle 4"/>
-          <p:cNvSpPr/>
-          <p:nvPr/>
-        </p:nvSpPr>
-        <p:spPr>
-          <a:xfrm>
-            <a:off x="731520" y="1828800"/>
-            <a:ext cx="3383280" cy="1143000"/>
-          </a:xfrm>
-          <a:prstGeom prst="roundRect">
-            <a:avLst/>
-          </a:prstGeom>
-          <a:solidFill>
-            <a:srgbClr val="3B0764"/>
-          </a:solidFill>
-          <a:ln>
-            <a:noFill/>
-          </a:ln>
-        </p:spPr>
-        <p:style>
-          <a:lnRef idx="1">
-            <a:schemeClr val="accent1"/>
-          </a:lnRef>
-          <a:fillRef idx="3">
-            <a:schemeClr val="accent1"/>
-          </a:fillRef>
-          <a:effectRef idx="2">
-            <a:schemeClr val="accent1"/>
-          </a:effectRef>
-          <a:fontRef idx="minor">
-            <a:schemeClr val="lt1"/>
-          </a:fontRef>
-        </p:style>
-        <p:txBody>
-          <a:bodyPr rtlCol="0" anchor="ctr"/>
-          <a:lstStyle/>
-          <a:p>
-            <a:pPr algn="ctr"/>
-          </a:p>
-        </p:txBody>
-      </p:sp>
-      <p:sp>
-        <p:nvSpPr>
-          <p:cNvPr id="6" name="TextBox 5"/>
-          <p:cNvSpPr txBox="1"/>
-          <p:nvPr/>
-        </p:nvSpPr>
-        <p:spPr>
-          <a:xfrm>
-            <a:off x="914400" y="1938528"/>
-            <a:ext cx="3017520" cy="923544"/>
-          </a:xfrm>
-          <a:prstGeom prst="rect">
-            <a:avLst/>
-          </a:prstGeom>
-          <a:noFill/>
-        </p:spPr>
-        <p:txBody>
-          <a:bodyPr wrap="square" lIns="0" tIns="0" rIns="0" bIns="0">
-            <a:spAutoFit/>
-          </a:bodyPr>
-          <a:lstStyle/>
-          <a:p>
-            <a:pPr>
               <a:spcAft>
                 <a:spcPts val="200"/>
               </a:spcAft>
@@ -5373,15 +6259,15 @@
               </a:defRPr>
             </a:pPr>
             <a:r>
-              <a:t>$341M</a:t>
+              <a:t>03</a:t>
             </a:r>
           </a:p>
           <a:p>
             <a:pPr>
               <a:spcAft>
-                <a:spcPts val="100"/>
+                <a:spcPts val="1400"/>
               </a:spcAft>
-              <a:defRPr sz="1000" b="1">
+              <a:defRPr sz="1400" b="1">
                 <a:solidFill>
                   <a:srgbClr val="FFFFFF"/>
                 </a:solidFill>
@@ -5389,110 +6275,31 @@
               </a:defRPr>
             </a:pPr>
             <a:r>
-              <a:t>TOTAL NZ SPREADS CATEGORY</a:t>
-            </a:r>
-          </a:p>
-          <a:p>
-            <a:pPr>
-              <a:defRPr sz="950">
-                <a:solidFill>
-                  <a:srgbClr val="D8B4FE"/>
-                </a:solidFill>
-                <a:latin typeface="Manrope"/>
-              </a:defRPr>
-            </a:pPr>
-            <a:r>
-              <a:t>+24% growth from $275M (2022–2025)</a:t>
-            </a:r>
-          </a:p>
-        </p:txBody>
-      </p:sp>
-      <p:sp>
-        <p:nvSpPr>
-          <p:cNvPr id="7" name="Rounded Rectangle 6"/>
-          <p:cNvSpPr/>
-          <p:nvPr/>
-        </p:nvSpPr>
-        <p:spPr>
-          <a:xfrm>
-            <a:off x="4389120" y="1828800"/>
-            <a:ext cx="3383280" cy="1143000"/>
-          </a:xfrm>
-          <a:prstGeom prst="roundRect">
-            <a:avLst/>
-          </a:prstGeom>
-          <a:solidFill>
-            <a:srgbClr val="3B0764"/>
-          </a:solidFill>
-          <a:ln>
-            <a:noFill/>
-          </a:ln>
-        </p:spPr>
-        <p:style>
-          <a:lnRef idx="1">
-            <a:schemeClr val="accent1"/>
-          </a:lnRef>
-          <a:fillRef idx="3">
-            <a:schemeClr val="accent1"/>
-          </a:fillRef>
-          <a:effectRef idx="2">
-            <a:schemeClr val="accent1"/>
-          </a:effectRef>
-          <a:fontRef idx="minor">
-            <a:schemeClr val="lt1"/>
-          </a:fontRef>
-        </p:style>
-        <p:txBody>
-          <a:bodyPr rtlCol="0" anchor="ctr"/>
-          <a:lstStyle/>
-          <a:p>
-            <a:pPr algn="ctr"/>
-          </a:p>
-        </p:txBody>
-      </p:sp>
-      <p:sp>
-        <p:nvSpPr>
-          <p:cNvPr id="8" name="TextBox 7"/>
-          <p:cNvSpPr txBox="1"/>
-          <p:nvPr/>
-        </p:nvSpPr>
-        <p:spPr>
-          <a:xfrm>
-            <a:off x="4572000" y="1938528"/>
-            <a:ext cx="3017520" cy="923544"/>
-          </a:xfrm>
-          <a:prstGeom prst="rect">
-            <a:avLst/>
-          </a:prstGeom>
-          <a:noFill/>
-        </p:spPr>
-        <p:txBody>
-          <a:bodyPr wrap="square" lIns="0" tIns="0" rIns="0" bIns="0">
-            <a:spAutoFit/>
-          </a:bodyPr>
-          <a:lstStyle/>
+              <a:t>KNOWLEDGE WORKERS</a:t>
+            </a:r>
+          </a:p>
           <a:p>
             <a:pPr>
               <a:spcAft>
                 <a:spcPts val="200"/>
               </a:spcAft>
-              <a:defRPr sz="2800" b="1">
-                <a:solidFill>
-                  <a:srgbClr val="FF467A"/>
-                </a:solidFill>
-                <a:latin typeface="Manrope"/>
-              </a:defRPr>
-            </a:pPr>
-            <a:r>
-              <a:t>+29%</a:t>
+              <a:defRPr sz="1100" b="1">
+                <a:solidFill>
+                  <a:srgbClr val="E24BFF"/>
+                </a:solidFill>
+                <a:latin typeface="Manrope"/>
+              </a:defRPr>
+            </a:pPr>
+            <a:r>
+              <a:t>• Non-Delegable Accountability</a:t>
             </a:r>
           </a:p>
           <a:p>
             <a:pPr>
               <a:spcAft>
-                <a:spcPts val="100"/>
+                <a:spcPts val="1200"/>
               </a:spcAft>
-              <a:defRPr sz="1000" b="1">
+              <a:defRPr sz="1000">
                 <a:solidFill>
                   <a:srgbClr val="FFFFFF"/>
                 </a:solidFill>
@@ -5500,110 +6307,28 @@
               </a:defRPr>
             </a:pPr>
             <a:r>
-              <a:t>PREMIUM TIER SURGE</a:t>
-            </a:r>
-          </a:p>
-          <a:p>
-            <a:pPr>
-              <a:defRPr sz="950">
-                <a:solidFill>
-                  <a:srgbClr val="D8B4FE"/>
-                </a:solidFill>
-                <a:latin typeface="Manrope"/>
-              </a:defRPr>
-            </a:pPr>
-            <a:r>
-              <a:t>Surging from $88M to $113M NZD</a:t>
-            </a:r>
-          </a:p>
-        </p:txBody>
-      </p:sp>
-      <p:sp>
-        <p:nvSpPr>
-          <p:cNvPr id="9" name="Rounded Rectangle 8"/>
-          <p:cNvSpPr/>
-          <p:nvPr/>
-        </p:nvSpPr>
-        <p:spPr>
-          <a:xfrm>
-            <a:off x="8046720" y="1828800"/>
-            <a:ext cx="3383280" cy="1143000"/>
-          </a:xfrm>
-          <a:prstGeom prst="roundRect">
-            <a:avLst/>
-          </a:prstGeom>
-          <a:solidFill>
-            <a:srgbClr val="3B0764"/>
-          </a:solidFill>
-          <a:ln>
-            <a:noFill/>
-          </a:ln>
-        </p:spPr>
-        <p:style>
-          <a:lnRef idx="1">
-            <a:schemeClr val="accent1"/>
-          </a:lnRef>
-          <a:fillRef idx="3">
-            <a:schemeClr val="accent1"/>
-          </a:fillRef>
-          <a:effectRef idx="2">
-            <a:schemeClr val="accent1"/>
-          </a:effectRef>
-          <a:fontRef idx="minor">
-            <a:schemeClr val="lt1"/>
-          </a:fontRef>
-        </p:style>
-        <p:txBody>
-          <a:bodyPr rtlCol="0" anchor="ctr"/>
-          <a:lstStyle/>
-          <a:p>
-            <a:pPr algn="ctr"/>
-          </a:p>
-        </p:txBody>
-      </p:sp>
-      <p:sp>
-        <p:nvSpPr>
-          <p:cNvPr id="10" name="TextBox 9"/>
-          <p:cNvSpPr txBox="1"/>
-          <p:nvPr/>
-        </p:nvSpPr>
-        <p:spPr>
-          <a:xfrm>
-            <a:off x="8229600" y="1938528"/>
-            <a:ext cx="3017520" cy="923544"/>
-          </a:xfrm>
-          <a:prstGeom prst="rect">
-            <a:avLst/>
-          </a:prstGeom>
-          <a:noFill/>
-        </p:spPr>
-        <p:txBody>
-          <a:bodyPr wrap="square" lIns="0" tIns="0" rIns="0" bIns="0">
-            <a:spAutoFit/>
-          </a:bodyPr>
-          <a:lstStyle/>
+              <a:t>When deploying AI commercially, legal, moral, and customer accountability can never be outsourced to an algorithm.</a:t>
+            </a:r>
+          </a:p>
           <a:p>
             <a:pPr>
               <a:spcAft>
                 <a:spcPts val="200"/>
               </a:spcAft>
-              <a:defRPr sz="2800" b="1">
-                <a:solidFill>
-                  <a:srgbClr val="FFD640"/>
-                </a:solidFill>
-                <a:latin typeface="Manrope"/>
-              </a:defRPr>
-            </a:pPr>
-            <a:r>
-              <a:t>0</a:t>
-            </a:r>
-          </a:p>
-          <a:p>
-            <a:pPr>
-              <a:spcAft>
-                <a:spcPts val="100"/>
-              </a:spcAft>
-              <a:defRPr sz="1000" b="1">
+              <a:defRPr sz="1100" b="1">
+                <a:solidFill>
+                  <a:srgbClr val="E24BFF"/>
+                </a:solidFill>
+                <a:latin typeface="Manrope"/>
+              </a:defRPr>
+            </a:pPr>
+            <a:r>
+              <a:t>• Critical Thinking as Core Value</a:t>
+            </a:r>
+          </a:p>
+          <a:p>
+            <a:pPr>
+              <a:defRPr sz="1000">
                 <a:solidFill>
                   <a:srgbClr val="FFFFFF"/>
                 </a:solidFill>
@@ -5611,1642 +6336,7 @@
               </a:defRPr>
             </a:pPr>
             <a:r>
-              <a:t>FORMAT INNOVATION RIVALS</a:t>
-            </a:r>
-          </a:p>
-          <a:p>
-            <a:pPr>
-              <a:defRPr sz="950">
-                <a:solidFill>
-                  <a:srgbClr val="D8B4FE"/>
-                </a:solidFill>
-                <a:latin typeface="Manrope"/>
-              </a:defRPr>
-            </a:pPr>
-            <a:r>
-              <a:t>154 existing products; zero peel-and-press</a:t>
-            </a:r>
-          </a:p>
-        </p:txBody>
-      </p:sp>
-      <p:sp>
-        <p:nvSpPr>
-          <p:cNvPr id="11" name="Rounded Rectangle 10"/>
-          <p:cNvSpPr/>
-          <p:nvPr/>
-        </p:nvSpPr>
-        <p:spPr>
-          <a:xfrm>
-            <a:off x="731520" y="3154680"/>
-            <a:ext cx="5212080" cy="3154680"/>
-          </a:xfrm>
-          <a:prstGeom prst="roundRect">
-            <a:avLst/>
-          </a:prstGeom>
-          <a:solidFill>
-            <a:srgbClr val="3B0764"/>
-          </a:solidFill>
-          <a:ln>
-            <a:noFill/>
-          </a:ln>
-        </p:spPr>
-        <p:style>
-          <a:lnRef idx="1">
-            <a:schemeClr val="accent1"/>
-          </a:lnRef>
-          <a:fillRef idx="3">
-            <a:schemeClr val="accent1"/>
-          </a:fillRef>
-          <a:effectRef idx="2">
-            <a:schemeClr val="accent1"/>
-          </a:effectRef>
-          <a:fontRef idx="minor">
-            <a:schemeClr val="lt1"/>
-          </a:fontRef>
-        </p:style>
-        <p:txBody>
-          <a:bodyPr rtlCol="0" anchor="ctr"/>
-          <a:lstStyle/>
-          <a:p>
-            <a:pPr algn="ctr"/>
-          </a:p>
-        </p:txBody>
-      </p:sp>
-      <p:sp>
-        <p:nvSpPr>
-          <p:cNvPr id="12" name="TextBox 11"/>
-          <p:cNvSpPr txBox="1"/>
-          <p:nvPr/>
-        </p:nvSpPr>
-        <p:spPr>
-          <a:xfrm>
-            <a:off x="1051560" y="3383280"/>
-            <a:ext cx="4572000" cy="2697480"/>
-          </a:xfrm>
-          <a:prstGeom prst="rect">
-            <a:avLst/>
-          </a:prstGeom>
-          <a:noFill/>
-        </p:spPr>
-        <p:txBody>
-          <a:bodyPr wrap="square" lIns="0" tIns="0" rIns="0" bIns="0">
-            <a:spAutoFit/>
-          </a:bodyPr>
-          <a:lstStyle/>
-          <a:p>
-            <a:pPr>
-              <a:spcAft>
-                <a:spcPts val="800"/>
-              </a:spcAft>
-              <a:defRPr sz="1700" b="1">
-                <a:solidFill>
-                  <a:srgbClr val="E24BFF"/>
-                </a:solidFill>
-                <a:latin typeface="Manrope"/>
-              </a:defRPr>
-            </a:pPr>
-            <a:r>
-              <a:t>Commercial Model &amp; Margins</a:t>
-            </a:r>
-          </a:p>
-          <a:p>
-            <a:pPr>
-              <a:spcAft>
-                <a:spcPts val="600"/>
-              </a:spcAft>
-              <a:defRPr sz="1100" b="1">
-                <a:solidFill>
-                  <a:srgbClr val="FFFFFF"/>
-                </a:solidFill>
-                <a:latin typeface="Manrope"/>
-              </a:defRPr>
-            </a:pPr>
-            <a:r>
-              <a:t>• Retail Pricing: </a:t>
-            </a:r>
-            <a:r>
-              <a:rPr sz="1050" b="0">
-                <a:solidFill>
-                  <a:srgbClr val="E9D5FF"/>
-                </a:solidFill>
-                <a:latin typeface="Manrope"/>
-              </a:rPr>
-              <a:t>$5.00 NZD per 80 g sheet (8 stamps = 63¢ per toast portion). Highly accessible impulse price point for students and commuters.</a:t>
-            </a:r>
-          </a:p>
-          <a:p>
-            <a:pPr>
-              <a:spcAft>
-                <a:spcPts val="600"/>
-              </a:spcAft>
-              <a:defRPr sz="1100" b="1">
-                <a:solidFill>
-                  <a:srgbClr val="FFFFFF"/>
-                </a:solidFill>
-                <a:latin typeface="Manrope"/>
-              </a:defRPr>
-            </a:pPr>
-            <a:r>
-              <a:t>• Format Innovation Premium: </a:t>
-            </a:r>
-            <a:r>
-              <a:rPr sz="1050" b="0">
-                <a:solidFill>
-                  <a:srgbClr val="E9D5FF"/>
-                </a:solidFill>
-                <a:latin typeface="Manrope"/>
-              </a:rPr>
-              <a:t>$6.25 NZD per 100 g. Commands a premium above the category's 90th percentile ($5.19/100g) because consumers buy convenience, not bulk volume.</a:t>
-            </a:r>
-          </a:p>
-          <a:p>
-            <a:pPr>
-              <a:spcAft>
-                <a:spcPts val="600"/>
-              </a:spcAft>
-              <a:defRPr sz="1100" b="1">
-                <a:solidFill>
-                  <a:srgbClr val="FFFFFF"/>
-                </a:solidFill>
-                <a:latin typeface="Manrope"/>
-              </a:defRPr>
-            </a:pPr>
-            <a:r>
-              <a:t>• Strong Unit Economics: </a:t>
-            </a:r>
-            <a:r>
-              <a:rPr sz="1050" b="0">
-                <a:solidFill>
-                  <a:srgbClr val="E9D5FF"/>
-                </a:solidFill>
-                <a:latin typeface="Manrope"/>
-              </a:rPr>
-              <a:t>At an assumed $1.50 contract manufacturing benchmark and 35% supermarket margin, Stamp retains a healthy $1.75 gross contribution per sheet.</a:t>
-            </a:r>
-          </a:p>
-        </p:txBody>
-      </p:sp>
-      <p:sp>
-        <p:nvSpPr>
-          <p:cNvPr id="13" name="Rounded Rectangle 12"/>
-          <p:cNvSpPr/>
-          <p:nvPr/>
-        </p:nvSpPr>
-        <p:spPr>
-          <a:xfrm>
-            <a:off x="6217920" y="3154680"/>
-            <a:ext cx="5212080" cy="3154680"/>
-          </a:xfrm>
-          <a:prstGeom prst="roundRect">
-            <a:avLst/>
-          </a:prstGeom>
-          <a:solidFill>
-            <a:srgbClr val="3B0764"/>
-          </a:solidFill>
-          <a:ln>
-            <a:noFill/>
-          </a:ln>
-        </p:spPr>
-        <p:style>
-          <a:lnRef idx="1">
-            <a:schemeClr val="accent1"/>
-          </a:lnRef>
-          <a:fillRef idx="3">
-            <a:schemeClr val="accent1"/>
-          </a:fillRef>
-          <a:effectRef idx="2">
-            <a:schemeClr val="accent1"/>
-          </a:effectRef>
-          <a:fontRef idx="minor">
-            <a:schemeClr val="lt1"/>
-          </a:fontRef>
-        </p:style>
-        <p:txBody>
-          <a:bodyPr rtlCol="0" anchor="ctr"/>
-          <a:lstStyle/>
-          <a:p>
-            <a:pPr algn="ctr"/>
-          </a:p>
-        </p:txBody>
-      </p:sp>
-      <p:pic>
-        <p:nvPicPr>
-          <p:cNvPr id="14" name="Picture 13" descr="02-spreads-revenue-by-tier-2022-vs-2025.png"/>
-          <p:cNvPicPr>
-            <a:picLocks noChangeAspect="1"/>
-          </p:cNvPicPr>
-          <p:nvPr/>
-        </p:nvPicPr>
-        <p:blipFill>
-          <a:blip r:embed="rId2"/>
-          <a:stretch>
-            <a:fillRect/>
-          </a:stretch>
-        </p:blipFill>
-        <p:spPr>
-          <a:xfrm>
-            <a:off x="6355080" y="3291840"/>
-            <a:ext cx="4937760" cy="2788382"/>
-          </a:xfrm>
-          <a:prstGeom prst="rect">
-            <a:avLst/>
-          </a:prstGeom>
-        </p:spPr>
-      </p:pic>
-    </p:spTree>
-  </p:cSld>
-  <p:clrMapOvr>
-    <a:masterClrMapping/>
-  </p:clrMapOvr>
-</p:sld>
-</file>
-
-<file path=ppt/slides/slide4.xml><?xml version="1.0" encoding="utf-8"?>
-<p:sld xmlns:a="http://schemas.openxmlformats.org/drawingml/2006/main" xmlns:p="http://schemas.openxmlformats.org/presentationml/2006/main" xmlns:r="http://schemas.openxmlformats.org/officeDocument/2006/relationships">
-  <p:cSld>
-    <p:spTree>
-      <p:nvGrpSpPr>
-        <p:cNvPr id="1" name=""/>
-        <p:cNvGrpSpPr/>
-        <p:nvPr/>
-      </p:nvGrpSpPr>
-      <p:grpSpPr/>
-      <p:sp>
-        <p:nvSpPr>
-          <p:cNvPr id="2" name="Rectangle 1"/>
-          <p:cNvSpPr/>
-          <p:nvPr/>
-        </p:nvSpPr>
-        <p:spPr>
-          <a:xfrm>
-            <a:off x="0" y="0"/>
-            <a:ext cx="12191695" cy="6858000"/>
-          </a:xfrm>
-          <a:prstGeom prst="rect">
-            <a:avLst/>
-          </a:prstGeom>
-          <a:solidFill>
-            <a:srgbClr val="240340"/>
-          </a:solidFill>
-          <a:ln>
-            <a:noFill/>
-          </a:ln>
-        </p:spPr>
-        <p:style>
-          <a:lnRef idx="1">
-            <a:schemeClr val="accent1"/>
-          </a:lnRef>
-          <a:fillRef idx="3">
-            <a:schemeClr val="accent1"/>
-          </a:fillRef>
-          <a:effectRef idx="2">
-            <a:schemeClr val="accent1"/>
-          </a:effectRef>
-          <a:fontRef idx="minor">
-            <a:schemeClr val="lt1"/>
-          </a:fontRef>
-        </p:style>
-        <p:txBody>
-          <a:bodyPr rtlCol="0" anchor="ctr"/>
-          <a:lstStyle/>
-          <a:p>
-            <a:pPr algn="ctr"/>
-          </a:p>
-        </p:txBody>
-      </p:sp>
-      <p:sp>
-        <p:nvSpPr>
-          <p:cNvPr id="3" name="Rounded Rectangle 2"/>
-          <p:cNvSpPr/>
-          <p:nvPr/>
-        </p:nvSpPr>
-        <p:spPr>
-          <a:xfrm>
-            <a:off x="731520" y="457200"/>
-            <a:ext cx="5394960" cy="329184"/>
-          </a:xfrm>
-          <a:prstGeom prst="roundRect">
-            <a:avLst/>
-          </a:prstGeom>
-          <a:solidFill>
-            <a:srgbClr val="3B0764"/>
-          </a:solidFill>
-          <a:ln>
-            <a:noFill/>
-          </a:ln>
-        </p:spPr>
-        <p:style>
-          <a:lnRef idx="1">
-            <a:schemeClr val="accent1"/>
-          </a:lnRef>
-          <a:fillRef idx="3">
-            <a:schemeClr val="accent1"/>
-          </a:fillRef>
-          <a:effectRef idx="2">
-            <a:schemeClr val="accent1"/>
-          </a:effectRef>
-          <a:fontRef idx="minor">
-            <a:schemeClr val="lt1"/>
-          </a:fontRef>
-        </p:style>
-        <p:txBody>
-          <a:bodyPr rtlCol="0" anchor="ctr" wrap="none" lIns="137160" rIns="137160"/>
-          <a:lstStyle/>
-          <a:p>
-            <a:pPr algn="ctr">
-              <a:defRPr sz="1050" b="1">
-                <a:solidFill>
-                  <a:srgbClr val="FFD640"/>
-                </a:solidFill>
-                <a:latin typeface="Manrope"/>
-              </a:defRPr>
-            </a:pPr>
-            <a:r>
-              <a:t>PERSONAL REFLECTION • PART 2 (STUDENT'S OWN VOICE)</a:t>
-            </a:r>
-          </a:p>
-        </p:txBody>
-      </p:sp>
-      <p:sp>
-        <p:nvSpPr>
-          <p:cNvPr id="4" name="TextBox 3"/>
-          <p:cNvSpPr txBox="1"/>
-          <p:nvPr/>
-        </p:nvSpPr>
-        <p:spPr>
-          <a:xfrm>
-            <a:off x="731520" y="859536"/>
-            <a:ext cx="10698480" cy="960120"/>
-          </a:xfrm>
-          <a:prstGeom prst="rect">
-            <a:avLst/>
-          </a:prstGeom>
-          <a:noFill/>
-        </p:spPr>
-        <p:txBody>
-          <a:bodyPr wrap="square" lIns="0" tIns="0" rIns="0" bIns="0">
-            <a:spAutoFit/>
-          </a:bodyPr>
-          <a:lstStyle/>
-          <a:p>
-            <a:pPr>
-              <a:spcAft>
-                <a:spcPts val="200"/>
-              </a:spcAft>
-              <a:defRPr sz="2600" b="1">
-                <a:solidFill>
-                  <a:srgbClr val="FFFFFF"/>
-                </a:solidFill>
-                <a:latin typeface="Manrope"/>
-              </a:defRPr>
-            </a:pPr>
-            <a:r>
-              <a:t>Reflection Q1: Steering &amp; Fact-Checking Generative AI</a:t>
-            </a:r>
-          </a:p>
-          <a:p>
-            <a:pPr>
-              <a:defRPr sz="1300">
-                <a:solidFill>
-                  <a:srgbClr val="D8B4FE"/>
-                </a:solidFill>
-                <a:latin typeface="Manrope"/>
-              </a:defRPr>
-            </a:pPr>
-            <a:r>
-              <a:t>Prompting architectures, context engineering, session partitioning, and verification.</a:t>
-            </a:r>
-          </a:p>
-        </p:txBody>
-      </p:sp>
-      <p:sp>
-        <p:nvSpPr>
-          <p:cNvPr id="5" name="Rounded Rectangle 4"/>
-          <p:cNvSpPr/>
-          <p:nvPr/>
-        </p:nvSpPr>
-        <p:spPr>
-          <a:xfrm>
-            <a:off x="731520" y="1645920"/>
-            <a:ext cx="5669280" cy="329184"/>
-          </a:xfrm>
-          <a:prstGeom prst="roundRect">
-            <a:avLst/>
-          </a:prstGeom>
-          <a:solidFill>
-            <a:srgbClr val="3B0764"/>
-          </a:solidFill>
-          <a:ln>
-            <a:noFill/>
-          </a:ln>
-        </p:spPr>
-        <p:style>
-          <a:lnRef idx="1">
-            <a:schemeClr val="accent1"/>
-          </a:lnRef>
-          <a:fillRef idx="3">
-            <a:schemeClr val="accent1"/>
-          </a:fillRef>
-          <a:effectRef idx="2">
-            <a:schemeClr val="accent1"/>
-          </a:effectRef>
-          <a:fontRef idx="minor">
-            <a:schemeClr val="lt1"/>
-          </a:fontRef>
-        </p:style>
-        <p:txBody>
-          <a:bodyPr rtlCol="0" anchor="ctr" wrap="none" lIns="137160" rIns="137160"/>
-          <a:lstStyle/>
-          <a:p>
-            <a:pPr algn="ctr">
-              <a:defRPr sz="1050" b="1">
-                <a:solidFill>
-                  <a:srgbClr val="FFD640"/>
-                </a:solidFill>
-                <a:latin typeface="Manrope"/>
-              </a:defRPr>
-            </a:pPr>
-            <a:r>
-              <a:t>TALKING-HEAD CUES • DELIVERED IN PERSONAL VOICE WITHOUT AI GENERATION</a:t>
-            </a:r>
-          </a:p>
-        </p:txBody>
-      </p:sp>
-      <p:sp>
-        <p:nvSpPr>
-          <p:cNvPr id="6" name="Rounded Rectangle 5"/>
-          <p:cNvSpPr/>
-          <p:nvPr/>
-        </p:nvSpPr>
-        <p:spPr>
-          <a:xfrm>
-            <a:off x="731520" y="2103120"/>
-            <a:ext cx="3383280" cy="4206240"/>
-          </a:xfrm>
-          <a:prstGeom prst="roundRect">
-            <a:avLst/>
-          </a:prstGeom>
-          <a:solidFill>
-            <a:srgbClr val="3B0764"/>
-          </a:solidFill>
-          <a:ln>
-            <a:noFill/>
-          </a:ln>
-        </p:spPr>
-        <p:style>
-          <a:lnRef idx="1">
-            <a:schemeClr val="accent1"/>
-          </a:lnRef>
-          <a:fillRef idx="3">
-            <a:schemeClr val="accent1"/>
-          </a:fillRef>
-          <a:effectRef idx="2">
-            <a:schemeClr val="accent1"/>
-          </a:effectRef>
-          <a:fontRef idx="minor">
-            <a:schemeClr val="lt1"/>
-          </a:fontRef>
-        </p:style>
-        <p:txBody>
-          <a:bodyPr rtlCol="0" anchor="ctr"/>
-          <a:lstStyle/>
-          <a:p>
-            <a:pPr algn="ctr"/>
-          </a:p>
-        </p:txBody>
-      </p:sp>
-      <p:sp>
-        <p:nvSpPr>
-          <p:cNvPr id="7" name="TextBox 6"/>
-          <p:cNvSpPr txBox="1"/>
-          <p:nvPr/>
-        </p:nvSpPr>
-        <p:spPr>
-          <a:xfrm>
-            <a:off x="960120" y="2331720"/>
-            <a:ext cx="2926080" cy="3749040"/>
-          </a:xfrm>
-          <a:prstGeom prst="rect">
-            <a:avLst/>
-          </a:prstGeom>
-          <a:noFill/>
-        </p:spPr>
-        <p:txBody>
-          <a:bodyPr wrap="square" lIns="0" tIns="0" rIns="0" bIns="0">
-            <a:spAutoFit/>
-          </a:bodyPr>
-          <a:lstStyle/>
-          <a:p>
-            <a:pPr>
-              <a:spcAft>
-                <a:spcPts val="1200"/>
-              </a:spcAft>
-              <a:defRPr sz="1700" b="1">
-                <a:solidFill>
-                  <a:srgbClr val="E24BFF"/>
-                </a:solidFill>
-                <a:latin typeface="Manrope"/>
-              </a:defRPr>
-            </a:pPr>
-            <a:r>
-              <a:t>Context &amp; Steering</a:t>
-            </a:r>
-          </a:p>
-          <a:p>
-            <a:pPr>
-              <a:spcAft>
-                <a:spcPts val="800"/>
-              </a:spcAft>
-              <a:defRPr sz="1150" b="1">
-                <a:solidFill>
-                  <a:srgbClr val="FFFFFF"/>
-                </a:solidFill>
-                <a:latin typeface="Manrope"/>
-              </a:defRPr>
-            </a:pPr>
-            <a:r>
-              <a:t>• Role Personas &amp; Negative Constraints</a:t>
-            </a:r>
-            <a:br/>
-            <a:r>
-              <a:rPr sz="1000" b="0">
-                <a:solidFill>
-                  <a:srgbClr val="E9D5FF"/>
-                </a:solidFill>
-                <a:latin typeface="Manrope"/>
-              </a:rPr>
-              <a:t>Enforcing strict bans against health claims, therapeutic benefits, and certification badges to avoid marketing hallucinations.</a:t>
-            </a:r>
-          </a:p>
-          <a:p>
-            <a:pPr>
-              <a:spcAft>
-                <a:spcPts val="800"/>
-              </a:spcAft>
-              <a:defRPr sz="1150" b="1">
-                <a:solidFill>
-                  <a:srgbClr val="FFFFFF"/>
-                </a:solidFill>
-                <a:latin typeface="Manrope"/>
-              </a:defRPr>
-            </a:pPr>
-            <a:r>
-              <a:t>• Session Partitioning</a:t>
-            </a:r>
-            <a:br/>
-            <a:r>
-              <a:rPr sz="1000" b="0">
-                <a:solidFill>
-                  <a:srgbClr val="E9D5FF"/>
-                </a:solidFill>
-                <a:latin typeface="Manrope"/>
-              </a:rPr>
-              <a:t>Isolating data cleaning, brand spec, and copywriting into modular sessions to eliminate context drift across complex multi-step workflows.</a:t>
-            </a:r>
-          </a:p>
-          <a:p>
-            <a:pPr>
-              <a:spcAft>
-                <a:spcPts val="800"/>
-              </a:spcAft>
-              <a:defRPr sz="1150" b="1">
-                <a:solidFill>
-                  <a:srgbClr val="FFFFFF"/>
-                </a:solidFill>
-                <a:latin typeface="Manrope"/>
-              </a:defRPr>
-            </a:pPr>
-            <a:r>
-              <a:t>• Locked Specification Artifact</a:t>
-            </a:r>
-            <a:br/>
-            <a:r>
-              <a:rPr sz="1000" b="0">
-                <a:solidFill>
-                  <a:srgbClr val="E9D5FF"/>
-                </a:solidFill>
-                <a:latin typeface="Manrope"/>
-              </a:rPr>
-              <a:t>Maintaining a single source of truth across all tasks to ensure product metrics stayed rock-solid.</a:t>
-            </a:r>
-          </a:p>
-        </p:txBody>
-      </p:sp>
-      <p:sp>
-        <p:nvSpPr>
-          <p:cNvPr id="8" name="Rounded Rectangle 7"/>
-          <p:cNvSpPr/>
-          <p:nvPr/>
-        </p:nvSpPr>
-        <p:spPr>
-          <a:xfrm>
-            <a:off x="4389120" y="2103120"/>
-            <a:ext cx="3383280" cy="4206240"/>
-          </a:xfrm>
-          <a:prstGeom prst="roundRect">
-            <a:avLst/>
-          </a:prstGeom>
-          <a:solidFill>
-            <a:srgbClr val="3B0764"/>
-          </a:solidFill>
-          <a:ln>
-            <a:noFill/>
-          </a:ln>
-        </p:spPr>
-        <p:style>
-          <a:lnRef idx="1">
-            <a:schemeClr val="accent1"/>
-          </a:lnRef>
-          <a:fillRef idx="3">
-            <a:schemeClr val="accent1"/>
-          </a:fillRef>
-          <a:effectRef idx="2">
-            <a:schemeClr val="accent1"/>
-          </a:effectRef>
-          <a:fontRef idx="minor">
-            <a:schemeClr val="lt1"/>
-          </a:fontRef>
-        </p:style>
-        <p:txBody>
-          <a:bodyPr rtlCol="0" anchor="ctr"/>
-          <a:lstStyle/>
-          <a:p>
-            <a:pPr algn="ctr"/>
-          </a:p>
-        </p:txBody>
-      </p:sp>
-      <p:sp>
-        <p:nvSpPr>
-          <p:cNvPr id="9" name="TextBox 8"/>
-          <p:cNvSpPr txBox="1"/>
-          <p:nvPr/>
-        </p:nvSpPr>
-        <p:spPr>
-          <a:xfrm>
-            <a:off x="4617720" y="2331720"/>
-            <a:ext cx="2926080" cy="3749040"/>
-          </a:xfrm>
-          <a:prstGeom prst="rect">
-            <a:avLst/>
-          </a:prstGeom>
-          <a:noFill/>
-        </p:spPr>
-        <p:txBody>
-          <a:bodyPr wrap="square" lIns="0" tIns="0" rIns="0" bIns="0">
-            <a:spAutoFit/>
-          </a:bodyPr>
-          <a:lstStyle/>
-          <a:p>
-            <a:pPr>
-              <a:spcAft>
-                <a:spcPts val="1200"/>
-              </a:spcAft>
-              <a:defRPr sz="1700" b="1">
-                <a:solidFill>
-                  <a:srgbClr val="FFD640"/>
-                </a:solidFill>
-                <a:latin typeface="Manrope"/>
-              </a:defRPr>
-            </a:pPr>
-            <a:r>
-              <a:t>Verification &amp; Turning Point</a:t>
-            </a:r>
-          </a:p>
-          <a:p>
-            <a:pPr>
-              <a:spcAft>
-                <a:spcPts val="800"/>
-              </a:spcAft>
-              <a:defRPr sz="1150" b="1">
-                <a:solidFill>
-                  <a:srgbClr val="FFFFFF"/>
-                </a:solidFill>
-                <a:latin typeface="Manrope"/>
-              </a:defRPr>
-            </a:pPr>
-            <a:r>
-              <a:t>• Auditing Raw Data Outliers</a:t>
-            </a:r>
-            <a:br/>
-            <a:r>
-              <a:rPr sz="1000" b="0">
-                <a:solidFill>
-                  <a:srgbClr val="E9D5FF"/>
-                </a:solidFill>
-                <a:latin typeface="Manrope"/>
-              </a:rPr>
-              <a:t>Detecting aberrant price spikes (&gt;$40) and uncleaned sales sums rather than blindly trusting unvalidated model aggregations.</a:t>
-            </a:r>
-          </a:p>
-          <a:p>
-            <a:pPr>
-              <a:spcAft>
-                <a:spcPts val="800"/>
-              </a:spcAft>
-              <a:defRPr sz="1150" b="1">
-                <a:solidFill>
-                  <a:srgbClr val="FFFFFF"/>
-                </a:solidFill>
-                <a:latin typeface="Manrope"/>
-              </a:defRPr>
-            </a:pPr>
-            <a:r>
-              <a:t>• The Specific Turning Point</a:t>
-            </a:r>
-            <a:br/>
-            <a:r>
-              <a:rPr sz="1000" b="0">
-                <a:solidFill>
-                  <a:srgbClr val="E9D5FF"/>
-                </a:solidFill>
-                <a:latin typeface="Manrope"/>
-              </a:rPr>
-              <a:t>Catching hallucinated ambient table butter stability; forcing reformulation into cultured dairy spread to meet ambient shelf life.</a:t>
-            </a:r>
-          </a:p>
-          <a:p>
-            <a:pPr>
-              <a:spcAft>
-                <a:spcPts val="800"/>
-              </a:spcAft>
-              <a:defRPr sz="1150" b="1">
-                <a:solidFill>
-                  <a:srgbClr val="FFFFFF"/>
-                </a:solidFill>
-                <a:latin typeface="Manrope"/>
-              </a:defRPr>
-            </a:pPr>
-            <a:r>
-              <a:t>• Independent Fact-Checking</a:t>
-            </a:r>
-            <a:br/>
-            <a:r>
-              <a:rPr sz="1000" b="0">
-                <a:solidFill>
-                  <a:srgbClr val="E9D5FF"/>
-                </a:solidFill>
-                <a:latin typeface="Manrope"/>
-              </a:rPr>
-              <a:t>Manually cross-referencing competitor shelf pricing directly against New World retail databases.</a:t>
-            </a:r>
-          </a:p>
-        </p:txBody>
-      </p:sp>
-      <p:sp>
-        <p:nvSpPr>
-          <p:cNvPr id="10" name="Rounded Rectangle 9"/>
-          <p:cNvSpPr/>
-          <p:nvPr/>
-        </p:nvSpPr>
-        <p:spPr>
-          <a:xfrm>
-            <a:off x="8046720" y="2103120"/>
-            <a:ext cx="3383280" cy="4206240"/>
-          </a:xfrm>
-          <a:prstGeom prst="roundRect">
-            <a:avLst/>
-          </a:prstGeom>
-          <a:solidFill>
-            <a:srgbClr val="3B0764"/>
-          </a:solidFill>
-          <a:ln>
-            <a:noFill/>
-          </a:ln>
-        </p:spPr>
-        <p:style>
-          <a:lnRef idx="1">
-            <a:schemeClr val="accent1"/>
-          </a:lnRef>
-          <a:fillRef idx="3">
-            <a:schemeClr val="accent1"/>
-          </a:fillRef>
-          <a:effectRef idx="2">
-            <a:schemeClr val="accent1"/>
-          </a:effectRef>
-          <a:fontRef idx="minor">
-            <a:schemeClr val="lt1"/>
-          </a:fontRef>
-        </p:style>
-        <p:txBody>
-          <a:bodyPr rtlCol="0" anchor="ctr"/>
-          <a:lstStyle/>
-          <a:p>
-            <a:pPr algn="ctr"/>
-          </a:p>
-        </p:txBody>
-      </p:sp>
-      <p:sp>
-        <p:nvSpPr>
-          <p:cNvPr id="11" name="TextBox 10"/>
-          <p:cNvSpPr txBox="1"/>
-          <p:nvPr/>
-        </p:nvSpPr>
-        <p:spPr>
-          <a:xfrm>
-            <a:off x="8275320" y="2331720"/>
-            <a:ext cx="2926080" cy="3749040"/>
-          </a:xfrm>
-          <a:prstGeom prst="rect">
-            <a:avLst/>
-          </a:prstGeom>
-          <a:noFill/>
-        </p:spPr>
-        <p:txBody>
-          <a:bodyPr wrap="square" lIns="0" tIns="0" rIns="0" bIns="0">
-            <a:spAutoFit/>
-          </a:bodyPr>
-          <a:lstStyle/>
-          <a:p>
-            <a:pPr>
-              <a:spcAft>
-                <a:spcPts val="1200"/>
-              </a:spcAft>
-              <a:defRPr sz="1700" b="1">
-                <a:solidFill>
-                  <a:srgbClr val="FF467A"/>
-                </a:solidFill>
-                <a:latin typeface="Manrope"/>
-              </a:defRPr>
-            </a:pPr>
-            <a:r>
-              <a:t>Key Lessons Learned</a:t>
-            </a:r>
-          </a:p>
-          <a:p>
-            <a:pPr>
-              <a:spcAft>
-                <a:spcPts val="800"/>
-              </a:spcAft>
-              <a:defRPr sz="1150" b="1">
-                <a:solidFill>
-                  <a:srgbClr val="FFFFFF"/>
-                </a:solidFill>
-                <a:latin typeface="Manrope"/>
-              </a:defRPr>
-            </a:pPr>
-            <a:r>
-              <a:t>• AI as Drafter, Not Director</a:t>
-            </a:r>
-            <a:br/>
-            <a:r>
-              <a:rPr sz="1000" b="0">
-                <a:solidFill>
-                  <a:srgbClr val="E9D5FF"/>
-                </a:solidFill>
-                <a:latin typeface="Manrope"/>
-              </a:rPr>
-              <a:t>Treating model outputs strictly as initial draft hypotheses that require empirical verification and human discernment.</a:t>
-            </a:r>
-          </a:p>
-          <a:p>
-            <a:pPr>
-              <a:spcAft>
-                <a:spcPts val="800"/>
-              </a:spcAft>
-              <a:defRPr sz="1150" b="1">
-                <a:solidFill>
-                  <a:srgbClr val="FFFFFF"/>
-                </a:solidFill>
-                <a:latin typeface="Manrope"/>
-              </a:defRPr>
-            </a:pPr>
-            <a:r>
-              <a:t>• Hybrid AI Architecture</a:t>
-            </a:r>
-            <a:br/>
-            <a:r>
-              <a:rPr sz="1000" b="0">
-                <a:solidFill>
-                  <a:srgbClr val="E9D5FF"/>
-                </a:solidFill>
-                <a:latin typeface="Manrope"/>
-              </a:rPr>
-              <a:t>Pairing OpenRouter API customer support with locked system prompts and deterministic fallback logic.</a:t>
-            </a:r>
-          </a:p>
-          <a:p>
-            <a:pPr>
-              <a:spcAft>
-                <a:spcPts val="800"/>
-              </a:spcAft>
-              <a:defRPr sz="1150" b="1">
-                <a:solidFill>
-                  <a:srgbClr val="FFFFFF"/>
-                </a:solidFill>
-                <a:latin typeface="Manrope"/>
-              </a:defRPr>
-            </a:pPr>
-            <a:r>
-              <a:t>• What I Would Do Differently</a:t>
-            </a:r>
-            <a:br/>
-            <a:r>
-              <a:rPr sz="1000" b="0">
-                <a:solidFill>
-                  <a:srgbClr val="E9D5FF"/>
-                </a:solidFill>
-                <a:latin typeface="Manrope"/>
-              </a:rPr>
-              <a:t>Establishing rigid data schemas and explicit verification tests before running exploratory generation.</a:t>
-            </a:r>
-          </a:p>
-        </p:txBody>
-      </p:sp>
-    </p:spTree>
-  </p:cSld>
-  <p:clrMapOvr>
-    <a:masterClrMapping/>
-  </p:clrMapOvr>
-</p:sld>
-</file>
-
-<file path=ppt/slides/slide5.xml><?xml version="1.0" encoding="utf-8"?>
-<p:sld xmlns:a="http://schemas.openxmlformats.org/drawingml/2006/main" xmlns:p="http://schemas.openxmlformats.org/presentationml/2006/main" xmlns:r="http://schemas.openxmlformats.org/officeDocument/2006/relationships">
-  <p:cSld>
-    <p:spTree>
-      <p:nvGrpSpPr>
-        <p:cNvPr id="1" name=""/>
-        <p:cNvGrpSpPr/>
-        <p:nvPr/>
-      </p:nvGrpSpPr>
-      <p:grpSpPr/>
-      <p:sp>
-        <p:nvSpPr>
-          <p:cNvPr id="2" name="Rectangle 1"/>
-          <p:cNvSpPr/>
-          <p:nvPr/>
-        </p:nvSpPr>
-        <p:spPr>
-          <a:xfrm>
-            <a:off x="0" y="0"/>
-            <a:ext cx="12191695" cy="6858000"/>
-          </a:xfrm>
-          <a:prstGeom prst="rect">
-            <a:avLst/>
-          </a:prstGeom>
-          <a:solidFill>
-            <a:srgbClr val="240340"/>
-          </a:solidFill>
-          <a:ln>
-            <a:noFill/>
-          </a:ln>
-        </p:spPr>
-        <p:style>
-          <a:lnRef idx="1">
-            <a:schemeClr val="accent1"/>
-          </a:lnRef>
-          <a:fillRef idx="3">
-            <a:schemeClr val="accent1"/>
-          </a:fillRef>
-          <a:effectRef idx="2">
-            <a:schemeClr val="accent1"/>
-          </a:effectRef>
-          <a:fontRef idx="minor">
-            <a:schemeClr val="lt1"/>
-          </a:fontRef>
-        </p:style>
-        <p:txBody>
-          <a:bodyPr rtlCol="0" anchor="ctr"/>
-          <a:lstStyle/>
-          <a:p>
-            <a:pPr algn="ctr"/>
-          </a:p>
-        </p:txBody>
-      </p:sp>
-      <p:sp>
-        <p:nvSpPr>
-          <p:cNvPr id="3" name="Rounded Rectangle 2"/>
-          <p:cNvSpPr/>
-          <p:nvPr/>
-        </p:nvSpPr>
-        <p:spPr>
-          <a:xfrm>
-            <a:off x="731520" y="457200"/>
-            <a:ext cx="5394960" cy="329184"/>
-          </a:xfrm>
-          <a:prstGeom prst="roundRect">
-            <a:avLst/>
-          </a:prstGeom>
-          <a:solidFill>
-            <a:srgbClr val="3B0764"/>
-          </a:solidFill>
-          <a:ln>
-            <a:noFill/>
-          </a:ln>
-        </p:spPr>
-        <p:style>
-          <a:lnRef idx="1">
-            <a:schemeClr val="accent1"/>
-          </a:lnRef>
-          <a:fillRef idx="3">
-            <a:schemeClr val="accent1"/>
-          </a:fillRef>
-          <a:effectRef idx="2">
-            <a:schemeClr val="accent1"/>
-          </a:effectRef>
-          <a:fontRef idx="minor">
-            <a:schemeClr val="lt1"/>
-          </a:fontRef>
-        </p:style>
-        <p:txBody>
-          <a:bodyPr rtlCol="0" anchor="ctr" wrap="none" lIns="137160" rIns="137160"/>
-          <a:lstStyle/>
-          <a:p>
-            <a:pPr algn="ctr">
-              <a:defRPr sz="1050" b="1">
-                <a:solidFill>
-                  <a:srgbClr val="FF467A"/>
-                </a:solidFill>
-                <a:latin typeface="Manrope"/>
-              </a:defRPr>
-            </a:pPr>
-            <a:r>
-              <a:t>PERSONAL REFLECTION • PART 2 (STUDENT'S OWN VOICE)</a:t>
-            </a:r>
-          </a:p>
-        </p:txBody>
-      </p:sp>
-      <p:sp>
-        <p:nvSpPr>
-          <p:cNvPr id="4" name="TextBox 3"/>
-          <p:cNvSpPr txBox="1"/>
-          <p:nvPr/>
-        </p:nvSpPr>
-        <p:spPr>
-          <a:xfrm>
-            <a:off x="731520" y="859536"/>
-            <a:ext cx="10698480" cy="960120"/>
-          </a:xfrm>
-          <a:prstGeom prst="rect">
-            <a:avLst/>
-          </a:prstGeom>
-          <a:noFill/>
-        </p:spPr>
-        <p:txBody>
-          <a:bodyPr wrap="square" lIns="0" tIns="0" rIns="0" bIns="0">
-            <a:spAutoFit/>
-          </a:bodyPr>
-          <a:lstStyle/>
-          <a:p>
-            <a:pPr>
-              <a:spcAft>
-                <a:spcPts val="200"/>
-              </a:spcAft>
-              <a:defRPr sz="2600" b="1">
-                <a:solidFill>
-                  <a:srgbClr val="FFFFFF"/>
-                </a:solidFill>
-                <a:latin typeface="Manrope"/>
-              </a:defRPr>
-            </a:pPr>
-            <a:r>
-              <a:t>Reflection Q2: Authenticity, AI Slop &amp; Knowledge Worker Ethics</a:t>
-            </a:r>
-          </a:p>
-          <a:p>
-            <a:pPr>
-              <a:defRPr sz="1300">
-                <a:solidFill>
-                  <a:srgbClr val="D8B4FE"/>
-                </a:solidFill>
-                <a:latin typeface="Manrope"/>
-              </a:defRPr>
-            </a:pPr>
-            <a:r>
-              <a:t>Combating generic marketing cliches, regulatory food liabilities, and human accountability.</a:t>
-            </a:r>
-          </a:p>
-        </p:txBody>
-      </p:sp>
-      <p:sp>
-        <p:nvSpPr>
-          <p:cNvPr id="5" name="Rounded Rectangle 4"/>
-          <p:cNvSpPr/>
-          <p:nvPr/>
-        </p:nvSpPr>
-        <p:spPr>
-          <a:xfrm>
-            <a:off x="731520" y="1645920"/>
-            <a:ext cx="5669280" cy="329184"/>
-          </a:xfrm>
-          <a:prstGeom prst="roundRect">
-            <a:avLst/>
-          </a:prstGeom>
-          <a:solidFill>
-            <a:srgbClr val="3B0764"/>
-          </a:solidFill>
-          <a:ln>
-            <a:noFill/>
-          </a:ln>
-        </p:spPr>
-        <p:style>
-          <a:lnRef idx="1">
-            <a:schemeClr val="accent1"/>
-          </a:lnRef>
-          <a:fillRef idx="3">
-            <a:schemeClr val="accent1"/>
-          </a:fillRef>
-          <a:effectRef idx="2">
-            <a:schemeClr val="accent1"/>
-          </a:effectRef>
-          <a:fontRef idx="minor">
-            <a:schemeClr val="lt1"/>
-          </a:fontRef>
-        </p:style>
-        <p:txBody>
-          <a:bodyPr rtlCol="0" anchor="ctr" wrap="none" lIns="137160" rIns="137160"/>
-          <a:lstStyle/>
-          <a:p>
-            <a:pPr algn="ctr">
-              <a:defRPr sz="1050" b="1">
-                <a:solidFill>
-                  <a:srgbClr val="FFD640"/>
-                </a:solidFill>
-                <a:latin typeface="Manrope"/>
-              </a:defRPr>
-            </a:pPr>
-            <a:r>
-              <a:t>TALKING-HEAD CUES • DELIVERED IN PERSONAL VOICE WITHOUT AI GENERATION</a:t>
-            </a:r>
-          </a:p>
-        </p:txBody>
-      </p:sp>
-      <p:sp>
-        <p:nvSpPr>
-          <p:cNvPr id="6" name="Rounded Rectangle 5"/>
-          <p:cNvSpPr/>
-          <p:nvPr/>
-        </p:nvSpPr>
-        <p:spPr>
-          <a:xfrm>
-            <a:off x="731520" y="2103120"/>
-            <a:ext cx="3383280" cy="4206240"/>
-          </a:xfrm>
-          <a:prstGeom prst="roundRect">
-            <a:avLst/>
-          </a:prstGeom>
-          <a:solidFill>
-            <a:srgbClr val="3B0764"/>
-          </a:solidFill>
-          <a:ln>
-            <a:noFill/>
-          </a:ln>
-        </p:spPr>
-        <p:style>
-          <a:lnRef idx="1">
-            <a:schemeClr val="accent1"/>
-          </a:lnRef>
-          <a:fillRef idx="3">
-            <a:schemeClr val="accent1"/>
-          </a:fillRef>
-          <a:effectRef idx="2">
-            <a:schemeClr val="accent1"/>
-          </a:effectRef>
-          <a:fontRef idx="minor">
-            <a:schemeClr val="lt1"/>
-          </a:fontRef>
-        </p:style>
-        <p:txBody>
-          <a:bodyPr rtlCol="0" anchor="ctr"/>
-          <a:lstStyle/>
-          <a:p>
-            <a:pPr algn="ctr"/>
-          </a:p>
-        </p:txBody>
-      </p:sp>
-      <p:sp>
-        <p:nvSpPr>
-          <p:cNvPr id="7" name="TextBox 6"/>
-          <p:cNvSpPr txBox="1"/>
-          <p:nvPr/>
-        </p:nvSpPr>
-        <p:spPr>
-          <a:xfrm>
-            <a:off x="960120" y="2331720"/>
-            <a:ext cx="2926080" cy="3749040"/>
-          </a:xfrm>
-          <a:prstGeom prst="rect">
-            <a:avLst/>
-          </a:prstGeom>
-          <a:noFill/>
-        </p:spPr>
-        <p:txBody>
-          <a:bodyPr wrap="square" lIns="0" tIns="0" rIns="0" bIns="0">
-            <a:spAutoFit/>
-          </a:bodyPr>
-          <a:lstStyle/>
-          <a:p>
-            <a:pPr>
-              <a:spcAft>
-                <a:spcPts val="1200"/>
-              </a:spcAft>
-              <a:defRPr sz="1700" b="1">
-                <a:solidFill>
-                  <a:srgbClr val="FF467A"/>
-                </a:solidFill>
-                <a:latin typeface="Manrope"/>
-              </a:defRPr>
-            </a:pPr>
-            <a:r>
-              <a:t>Combating 'AI Slop'</a:t>
-            </a:r>
-          </a:p>
-          <a:p>
-            <a:pPr>
-              <a:spcAft>
-                <a:spcPts val="800"/>
-              </a:spcAft>
-              <a:defRPr sz="1150" b="1">
-                <a:solidFill>
-                  <a:srgbClr val="FFFFFF"/>
-                </a:solidFill>
-                <a:latin typeface="Manrope"/>
-              </a:defRPr>
-            </a:pPr>
-            <a:r>
-              <a:t>• Stripping Marketing Clichés</a:t>
-            </a:r>
-            <a:br/>
-            <a:r>
-              <a:rPr sz="1000" b="0">
-                <a:solidFill>
-                  <a:srgbClr val="E9D5FF"/>
-                </a:solidFill>
-                <a:latin typeface="Manrope"/>
-              </a:rPr>
-              <a:t>Actively rejecting hyperbolic corporate fluff ('revolutionizing breakfast journeys') in favor of plain, punchy facts: 'Peel. Press. Toast.'</a:t>
-            </a:r>
-          </a:p>
-          <a:p>
-            <a:pPr>
-              <a:spcAft>
-                <a:spcPts val="800"/>
-              </a:spcAft>
-              <a:defRPr sz="1150" b="1">
-                <a:solidFill>
-                  <a:srgbClr val="FFFFFF"/>
-                </a:solidFill>
-                <a:latin typeface="Manrope"/>
-              </a:defRPr>
-            </a:pPr>
-            <a:r>
-              <a:t>• Authentic Physical Constraints</a:t>
-            </a:r>
-            <a:br/>
-            <a:r>
-              <a:rPr sz="1000" b="0">
-                <a:solidFill>
-                  <a:srgbClr val="E9D5FF"/>
-                </a:solidFill>
-                <a:latin typeface="Manrope"/>
-              </a:rPr>
-              <a:t>Anchoring packaging in real industrial constraints (continuous deposit tooling, release film) rather than impossible AI mockups.</a:t>
-            </a:r>
-          </a:p>
-          <a:p>
-            <a:pPr>
-              <a:spcAft>
-                <a:spcPts val="800"/>
-              </a:spcAft>
-              <a:defRPr sz="1150" b="1">
-                <a:solidFill>
-                  <a:srgbClr val="FFFFFF"/>
-                </a:solidFill>
-                <a:latin typeface="Manrope"/>
-              </a:defRPr>
-            </a:pPr>
-            <a:r>
-              <a:t>• Deliberate Brand Personality</a:t>
-            </a:r>
-            <a:br/>
-            <a:r>
-              <a:rPr sz="1000" b="0">
-                <a:solidFill>
-                  <a:srgbClr val="E9D5FF"/>
-                </a:solidFill>
-                <a:latin typeface="Manrope"/>
-              </a:rPr>
-              <a:t>Injecting bold, high-contrast visual identity and off-beat jingle tone to stand out from generic AI aesthetics.</a:t>
-            </a:r>
-          </a:p>
-        </p:txBody>
-      </p:sp>
-      <p:sp>
-        <p:nvSpPr>
-          <p:cNvPr id="8" name="Rounded Rectangle 7"/>
-          <p:cNvSpPr/>
-          <p:nvPr/>
-        </p:nvSpPr>
-        <p:spPr>
-          <a:xfrm>
-            <a:off x="4389120" y="2103120"/>
-            <a:ext cx="3383280" cy="4206240"/>
-          </a:xfrm>
-          <a:prstGeom prst="roundRect">
-            <a:avLst/>
-          </a:prstGeom>
-          <a:solidFill>
-            <a:srgbClr val="3B0764"/>
-          </a:solidFill>
-          <a:ln>
-            <a:noFill/>
-          </a:ln>
-        </p:spPr>
-        <p:style>
-          <a:lnRef idx="1">
-            <a:schemeClr val="accent1"/>
-          </a:lnRef>
-          <a:fillRef idx="3">
-            <a:schemeClr val="accent1"/>
-          </a:fillRef>
-          <a:effectRef idx="2">
-            <a:schemeClr val="accent1"/>
-          </a:effectRef>
-          <a:fontRef idx="minor">
-            <a:schemeClr val="lt1"/>
-          </a:fontRef>
-        </p:style>
-        <p:txBody>
-          <a:bodyPr rtlCol="0" anchor="ctr"/>
-          <a:lstStyle/>
-          <a:p>
-            <a:pPr algn="ctr"/>
-          </a:p>
-        </p:txBody>
-      </p:sp>
-      <p:sp>
-        <p:nvSpPr>
-          <p:cNvPr id="9" name="TextBox 8"/>
-          <p:cNvSpPr txBox="1"/>
-          <p:nvPr/>
-        </p:nvSpPr>
-        <p:spPr>
-          <a:xfrm>
-            <a:off x="4617720" y="2331720"/>
-            <a:ext cx="2926080" cy="3749040"/>
-          </a:xfrm>
-          <a:prstGeom prst="rect">
-            <a:avLst/>
-          </a:prstGeom>
-          <a:noFill/>
-        </p:spPr>
-        <p:txBody>
-          <a:bodyPr wrap="square" lIns="0" tIns="0" rIns="0" bIns="0">
-            <a:spAutoFit/>
-          </a:bodyPr>
-          <a:lstStyle/>
-          <a:p>
-            <a:pPr>
-              <a:spcAft>
-                <a:spcPts val="1200"/>
-              </a:spcAft>
-              <a:defRPr sz="1700" b="1">
-                <a:solidFill>
-                  <a:srgbClr val="FFD640"/>
-                </a:solidFill>
-                <a:latin typeface="Manrope"/>
-              </a:defRPr>
-            </a:pPr>
-            <a:r>
-              <a:t>Regulatory &amp; Legal Risks</a:t>
-            </a:r>
-          </a:p>
-          <a:p>
-            <a:pPr>
-              <a:spcAft>
-                <a:spcPts val="800"/>
-              </a:spcAft>
-              <a:defRPr sz="1150" b="1">
-                <a:solidFill>
-                  <a:srgbClr val="FFFFFF"/>
-                </a:solidFill>
-                <a:latin typeface="Manrope"/>
-              </a:defRPr>
-            </a:pPr>
-            <a:r>
-              <a:t>• Food Hallucination Dangers</a:t>
-            </a:r>
-            <a:br/>
-            <a:r>
-              <a:rPr sz="1000" b="0">
-                <a:solidFill>
-                  <a:srgbClr val="E9D5FF"/>
-                </a:solidFill>
-                <a:latin typeface="Manrope"/>
-              </a:rPr>
-              <a:t>Unchecked models frequently invent fake organic labels, false 'gluten-free' badges, or illegal therapeutic health claims.</a:t>
-            </a:r>
-          </a:p>
-          <a:p>
-            <a:pPr>
-              <a:spcAft>
-                <a:spcPts val="800"/>
-              </a:spcAft>
-              <a:defRPr sz="1150" b="1">
-                <a:solidFill>
-                  <a:srgbClr val="FFFFFF"/>
-                </a:solidFill>
-                <a:latin typeface="Manrope"/>
-              </a:defRPr>
-            </a:pPr>
-            <a:r>
-              <a:t>• Strict FSANZ Compliance</a:t>
-            </a:r>
-            <a:br/>
-            <a:r>
-              <a:rPr sz="1000" b="0">
-                <a:solidFill>
-                  <a:srgbClr val="E9D5FF"/>
-                </a:solidFill>
-                <a:latin typeface="Manrope"/>
-              </a:rPr>
-              <a:t>Enforcing Food Standards Australia New Zealand labeling laws: distinguishing dairy spread from refrigerated table butter.</a:t>
-            </a:r>
-          </a:p>
-          <a:p>
-            <a:pPr>
-              <a:spcAft>
-                <a:spcPts val="800"/>
-              </a:spcAft>
-              <a:defRPr sz="1150" b="1">
-                <a:solidFill>
-                  <a:srgbClr val="FFFFFF"/>
-                </a:solidFill>
-                <a:latin typeface="Manrope"/>
-              </a:defRPr>
-            </a:pPr>
-            <a:r>
-              <a:t>• Allergen Responsibility</a:t>
-            </a:r>
-            <a:br/>
-            <a:r>
-              <a:rPr sz="1000" b="0">
-                <a:solidFill>
-                  <a:srgbClr val="E9D5FF"/>
-                </a:solidFill>
-                <a:latin typeface="Manrope"/>
-              </a:rPr>
-              <a:t>Ensuring life-threatening peanut and gluten disclosures were prominent and never obscured by AI optimism.</a:t>
-            </a:r>
-          </a:p>
-        </p:txBody>
-      </p:sp>
-      <p:sp>
-        <p:nvSpPr>
-          <p:cNvPr id="10" name="Rounded Rectangle 9"/>
-          <p:cNvSpPr/>
-          <p:nvPr/>
-        </p:nvSpPr>
-        <p:spPr>
-          <a:xfrm>
-            <a:off x="8046720" y="2103120"/>
-            <a:ext cx="3383280" cy="4206240"/>
-          </a:xfrm>
-          <a:prstGeom prst="roundRect">
-            <a:avLst/>
-          </a:prstGeom>
-          <a:solidFill>
-            <a:srgbClr val="3B0764"/>
-          </a:solidFill>
-          <a:ln>
-            <a:noFill/>
-          </a:ln>
-        </p:spPr>
-        <p:style>
-          <a:lnRef idx="1">
-            <a:schemeClr val="accent1"/>
-          </a:lnRef>
-          <a:fillRef idx="3">
-            <a:schemeClr val="accent1"/>
-          </a:fillRef>
-          <a:effectRef idx="2">
-            <a:schemeClr val="accent1"/>
-          </a:effectRef>
-          <a:fontRef idx="minor">
-            <a:schemeClr val="lt1"/>
-          </a:fontRef>
-        </p:style>
-        <p:txBody>
-          <a:bodyPr rtlCol="0" anchor="ctr"/>
-          <a:lstStyle/>
-          <a:p>
-            <a:pPr algn="ctr"/>
-          </a:p>
-        </p:txBody>
-      </p:sp>
-      <p:sp>
-        <p:nvSpPr>
-          <p:cNvPr id="11" name="TextBox 10"/>
-          <p:cNvSpPr txBox="1"/>
-          <p:nvPr/>
-        </p:nvSpPr>
-        <p:spPr>
-          <a:xfrm>
-            <a:off x="8275320" y="2331720"/>
-            <a:ext cx="2926080" cy="3749040"/>
-          </a:xfrm>
-          <a:prstGeom prst="rect">
-            <a:avLst/>
-          </a:prstGeom>
-          <a:noFill/>
-        </p:spPr>
-        <p:txBody>
-          <a:bodyPr wrap="square" lIns="0" tIns="0" rIns="0" bIns="0">
-            <a:spAutoFit/>
-          </a:bodyPr>
-          <a:lstStyle/>
-          <a:p>
-            <a:pPr>
-              <a:spcAft>
-                <a:spcPts val="1200"/>
-              </a:spcAft>
-              <a:defRPr sz="1700" b="1">
-                <a:solidFill>
-                  <a:srgbClr val="FF8C30"/>
-                </a:solidFill>
-                <a:latin typeface="Manrope"/>
-              </a:defRPr>
-            </a:pPr>
-            <a:r>
-              <a:t>Ethics &amp; Future Work</a:t>
-            </a:r>
-          </a:p>
-          <a:p>
-            <a:pPr>
-              <a:spcAft>
-                <a:spcPts val="800"/>
-              </a:spcAft>
-              <a:defRPr sz="1150" b="1">
-                <a:solidFill>
-                  <a:srgbClr val="FFFFFF"/>
-                </a:solidFill>
-                <a:latin typeface="Manrope"/>
-              </a:defRPr>
-            </a:pPr>
-            <a:r>
-              <a:t>• Non-Delegable Accountability</a:t>
-            </a:r>
-            <a:br/>
-            <a:r>
-              <a:rPr sz="1000" b="0">
-                <a:solidFill>
-                  <a:srgbClr val="E9D5FF"/>
-                </a:solidFill>
-                <a:latin typeface="Manrope"/>
-              </a:rPr>
-              <a:t>When deploying AI commercially, legal, moral, and customer accountability can never be outsourced to an algorithm.</a:t>
-            </a:r>
-          </a:p>
-          <a:p>
-            <a:pPr>
-              <a:spcAft>
-                <a:spcPts val="800"/>
-              </a:spcAft>
-              <a:defRPr sz="1150" b="1">
-                <a:solidFill>
-                  <a:srgbClr val="FFFFFF"/>
-                </a:solidFill>
-                <a:latin typeface="Manrope"/>
-              </a:defRPr>
-            </a:pPr>
-            <a:r>
-              <a:t>• Critical Thinking as Core Skill</a:t>
-            </a:r>
-            <a:br/>
-            <a:r>
-              <a:rPr sz="1000" b="0">
-                <a:solidFill>
-                  <a:srgbClr val="E9D5FF"/>
-                </a:solidFill>
-                <a:latin typeface="Manrope"/>
-              </a:rPr>
-              <a:t>The primary value of the modern knowledge worker is skepticism, verification, taste, and boundary enforcement.</a:t>
-            </a:r>
-          </a:p>
-          <a:p>
-            <a:pPr>
-              <a:spcAft>
-                <a:spcPts val="800"/>
-              </a:spcAft>
-              <a:defRPr sz="1150" b="1">
-                <a:solidFill>
-                  <a:srgbClr val="FFFFFF"/>
-                </a:solidFill>
-                <a:latin typeface="Manrope"/>
-              </a:defRPr>
-            </a:pPr>
-            <a:r>
-              <a:t>• Human Agency</a:t>
-            </a:r>
-            <a:br/>
-            <a:r>
-              <a:rPr sz="1000" b="0">
-                <a:solidFill>
-                  <a:srgbClr val="E9D5FF"/>
-                </a:solidFill>
-                <a:latin typeface="Manrope"/>
-              </a:rPr>
-              <a:t>Leveraging generative AI for execution velocity while retaining complete personal ownership of the final result.</a:t>
+              <a:t>The primary skill of the future knowledge worker is skepticism, verification, taste, and active human agency.</a:t>
             </a:r>
           </a:p>
         </p:txBody>

</xml_diff>

<commit_message>
Ultra-minimal 17-slide deck: container-free, 1-3 lines max, no headers, PDF cover match
</commit_message>
<xml_diff>
--- a/presentation/Stamp-pitch.pptx
+++ b/presentation/Stamp-pitch.pptx
@@ -18,6 +18,10 @@
     <p:sldId id="266" r:id="rId18"/>
     <p:sldId id="267" r:id="rId19"/>
     <p:sldId id="268" r:id="rId20"/>
+    <p:sldId id="269" r:id="rId21"/>
+    <p:sldId id="270" r:id="rId22"/>
+    <p:sldId id="271" r:id="rId23"/>
+    <p:sldId id="272" r:id="rId24"/>
   </p:sldIdLst>
   <p:sldSz cx="12191695" cy="6858000" type="screen4x3"/>
   <p:notesSz cx="6858000" cy="9144000"/>
@@ -514,7 +518,7 @@
           <a:lstStyle/>
           <a:p>
             <a:r>
-              <a:t>TITLE SLIDE (0:00–0:08)</a:t>
+              <a:t>TITLE (0:00–0:08)</a:t>
             </a:r>
           </a:p>
           <a:p>
@@ -589,12 +593,12 @@
           <a:lstStyle/>
           <a:p>
             <a:r>
-              <a:t>VERIFICATION SLIDE (1:40–1:55)</a:t>
-            </a:r>
-          </a:p>
-          <a:p>
-            <a:r>
-              <a:t>I audited raw supermarket scan data to spot price outliers and independently verified competitor prices on New World rather than blindly trusting model calculations.</a:t>
+              <a:t>ECONOMICS (0:58–1:04)</a:t>
+            </a:r>
+          </a:p>
+          <a:p>
+            <a:r>
+              <a:t>At five dollars a sheet—63 cents a serving—we retain a strong one-seventy-five gross margin.</a:t>
             </a:r>
           </a:p>
         </p:txBody>
@@ -664,12 +668,12 @@
           <a:lstStyle/>
           <a:p>
             <a:r>
-              <a:t>AUTHENTICITY SLIDE (1:55–2:15)</a:t>
-            </a:r>
-          </a:p>
-          <a:p>
-            <a:r>
-              <a:t>To combat AI slop, I actively stripped out corporate buzzwords in favour of plain, punchy facts, and grounded packaging in real physical manufacturing constraints.</a:t>
+              <a:t>CONSTRAINTS (1:04–1:18)</a:t>
+            </a:r>
+          </a:p>
+          <a:p>
+            <a:r>
+              <a:t>In steering AI, I enforced strict negative prompt constraints against fake badges and health claims.</a:t>
             </a:r>
           </a:p>
         </p:txBody>
@@ -739,12 +743,12 @@
           <a:lstStyle/>
           <a:p>
             <a:r>
-              <a:t>REGULATION SLIDE (2:15–2:30)</a:t>
-            </a:r>
-          </a:p>
-          <a:p>
-            <a:r>
-              <a:t>In food and beverage, AI hallucinations are a severe legal hazard. I enforced strict compliance with New Zealand Food Standards and ensured life-threatening allergen warnings were never obscured.</a:t>
+              <a:t>PARTITIONING (1:18–1:30)</a:t>
+            </a:r>
+          </a:p>
+          <a:p>
+            <a:r>
+              <a:t>I partitioned distinct sessions for data cleaning, branding, and copy to prevent context rot.</a:t>
             </a:r>
           </a:p>
         </p:txBody>
@@ -814,12 +818,312 @@
           <a:lstStyle/>
           <a:p>
             <a:r>
-              <a:t>ETHICS SLIDE (2:30–2:50)</a:t>
-            </a:r>
-          </a:p>
-          <a:p>
-            <a:r>
-              <a:t>Ultimately, accountability can never be outsourced to a model. Generative AI accelerates execution, but human judgment, taste, skepticism, and moral ownership remain essential.</a:t>
+              <a:t>TURNING POINT (1:30–1:45)</a:t>
+            </a:r>
+          </a:p>
+          <a:p>
+            <a:r>
+              <a:t>My pivotal moment was catching an unrealistic AI claim that dairy butter could sit ambiently without spoilage.</a:t>
+            </a:r>
+          </a:p>
+        </p:txBody>
+      </p:sp>
+      <p:sp>
+        <p:nvSpPr>
+          <p:cNvPr id="4" name="Slide Number Placeholder 3"/>
+          <p:cNvSpPr>
+            <a:spLocks noGrp="1"/>
+          </p:cNvSpPr>
+          <p:nvPr>
+            <p:ph type="sldNum" idx="5" sz="quarter"/>
+          </p:nvPr>
+        </p:nvSpPr>
+        <p:spPr/>
+      </p:sp>
+    </p:spTree>
+  </p:cSld>
+  <p:clrMapOvr>
+    <a:masterClrMapping/>
+  </p:clrMapOvr>
+</p:notes>
+</file>
+
+<file path=ppt/notesSlides/notesSlide14.xml><?xml version="1.0" encoding="utf-8"?>
+<p:notes xmlns:a="http://schemas.openxmlformats.org/drawingml/2006/main" xmlns:p="http://schemas.openxmlformats.org/presentationml/2006/main" xmlns:r="http://schemas.openxmlformats.org/officeDocument/2006/relationships">
+  <p:cSld>
+    <p:spTree>
+      <p:nvGrpSpPr>
+        <p:cNvPr id="1" name=""/>
+        <p:cNvGrpSpPr/>
+        <p:nvPr/>
+      </p:nvGrpSpPr>
+      <p:grpSpPr>
+        <a:xfrm>
+          <a:off x="0" y="0"/>
+          <a:ext cx="0" cy="0"/>
+          <a:chOff x="0" y="0"/>
+          <a:chExt cx="0" cy="0"/>
+        </a:xfrm>
+      </p:grpSpPr>
+      <p:sp>
+        <p:nvSpPr>
+          <p:cNvPr id="2" name="Slide Image Placeholder 1"/>
+          <p:cNvSpPr>
+            <a:spLocks noGrp="1"/>
+          </p:cNvSpPr>
+          <p:nvPr>
+            <p:ph type="sldImg" idx="2"/>
+          </p:nvPr>
+        </p:nvSpPr>
+        <p:spPr/>
+      </p:sp>
+      <p:sp>
+        <p:nvSpPr>
+          <p:cNvPr id="3" name="Notes Placeholder 2"/>
+          <p:cNvSpPr>
+            <a:spLocks noGrp="1"/>
+          </p:cNvSpPr>
+          <p:nvPr>
+            <p:ph type="body" idx="3" sz="quarter"/>
+          </p:nvPr>
+        </p:nvSpPr>
+        <p:spPr/>
+        <p:txBody>
+          <a:bodyPr/>
+          <a:lstStyle/>
+          <a:p>
+            <a:r>
+              <a:t>VERIFICATION (1:45–1:58)</a:t>
+            </a:r>
+          </a:p>
+          <a:p>
+            <a:r>
+              <a:t>I audited raw scan data outliers and manually verified shelf prices on New World instead of trusting model summaries.</a:t>
+            </a:r>
+          </a:p>
+        </p:txBody>
+      </p:sp>
+      <p:sp>
+        <p:nvSpPr>
+          <p:cNvPr id="4" name="Slide Number Placeholder 3"/>
+          <p:cNvSpPr>
+            <a:spLocks noGrp="1"/>
+          </p:cNvSpPr>
+          <p:nvPr>
+            <p:ph type="sldNum" idx="5" sz="quarter"/>
+          </p:nvPr>
+        </p:nvSpPr>
+        <p:spPr/>
+      </p:sp>
+    </p:spTree>
+  </p:cSld>
+  <p:clrMapOvr>
+    <a:masterClrMapping/>
+  </p:clrMapOvr>
+</p:notes>
+</file>
+
+<file path=ppt/notesSlides/notesSlide15.xml><?xml version="1.0" encoding="utf-8"?>
+<p:notes xmlns:a="http://schemas.openxmlformats.org/drawingml/2006/main" xmlns:p="http://schemas.openxmlformats.org/presentationml/2006/main" xmlns:r="http://schemas.openxmlformats.org/officeDocument/2006/relationships">
+  <p:cSld>
+    <p:spTree>
+      <p:nvGrpSpPr>
+        <p:cNvPr id="1" name=""/>
+        <p:cNvGrpSpPr/>
+        <p:nvPr/>
+      </p:nvGrpSpPr>
+      <p:grpSpPr>
+        <a:xfrm>
+          <a:off x="0" y="0"/>
+          <a:ext cx="0" cy="0"/>
+          <a:chOff x="0" y="0"/>
+          <a:chExt cx="0" cy="0"/>
+        </a:xfrm>
+      </p:grpSpPr>
+      <p:sp>
+        <p:nvSpPr>
+          <p:cNvPr id="2" name="Slide Image Placeholder 1"/>
+          <p:cNvSpPr>
+            <a:spLocks noGrp="1"/>
+          </p:cNvSpPr>
+          <p:nvPr>
+            <p:ph type="sldImg" idx="2"/>
+          </p:nvPr>
+        </p:nvSpPr>
+        <p:spPr/>
+      </p:sp>
+      <p:sp>
+        <p:nvSpPr>
+          <p:cNvPr id="3" name="Notes Placeholder 2"/>
+          <p:cNvSpPr>
+            <a:spLocks noGrp="1"/>
+          </p:cNvSpPr>
+          <p:nvPr>
+            <p:ph type="body" idx="3" sz="quarter"/>
+          </p:nvPr>
+        </p:nvSpPr>
+        <p:spPr/>
+        <p:txBody>
+          <a:bodyPr/>
+          <a:lstStyle/>
+          <a:p>
+            <a:r>
+              <a:t>AUTHENTICITY (1:58–2:15)</a:t>
+            </a:r>
+          </a:p>
+          <a:p>
+            <a:r>
+              <a:t>To combat AI slop, I stripped corporate clichés and grounded packaging in real continuous deposit tooling.</a:t>
+            </a:r>
+          </a:p>
+        </p:txBody>
+      </p:sp>
+      <p:sp>
+        <p:nvSpPr>
+          <p:cNvPr id="4" name="Slide Number Placeholder 3"/>
+          <p:cNvSpPr>
+            <a:spLocks noGrp="1"/>
+          </p:cNvSpPr>
+          <p:nvPr>
+            <p:ph type="sldNum" idx="5" sz="quarter"/>
+          </p:nvPr>
+        </p:nvSpPr>
+        <p:spPr/>
+      </p:sp>
+    </p:spTree>
+  </p:cSld>
+  <p:clrMapOvr>
+    <a:masterClrMapping/>
+  </p:clrMapOvr>
+</p:notes>
+</file>
+
+<file path=ppt/notesSlides/notesSlide16.xml><?xml version="1.0" encoding="utf-8"?>
+<p:notes xmlns:a="http://schemas.openxmlformats.org/drawingml/2006/main" xmlns:p="http://schemas.openxmlformats.org/presentationml/2006/main" xmlns:r="http://schemas.openxmlformats.org/officeDocument/2006/relationships">
+  <p:cSld>
+    <p:spTree>
+      <p:nvGrpSpPr>
+        <p:cNvPr id="1" name=""/>
+        <p:cNvGrpSpPr/>
+        <p:nvPr/>
+      </p:nvGrpSpPr>
+      <p:grpSpPr>
+        <a:xfrm>
+          <a:off x="0" y="0"/>
+          <a:ext cx="0" cy="0"/>
+          <a:chOff x="0" y="0"/>
+          <a:chExt cx="0" cy="0"/>
+        </a:xfrm>
+      </p:grpSpPr>
+      <p:sp>
+        <p:nvSpPr>
+          <p:cNvPr id="2" name="Slide Image Placeholder 1"/>
+          <p:cNvSpPr>
+            <a:spLocks noGrp="1"/>
+          </p:cNvSpPr>
+          <p:nvPr>
+            <p:ph type="sldImg" idx="2"/>
+          </p:nvPr>
+        </p:nvSpPr>
+        <p:spPr/>
+      </p:sp>
+      <p:sp>
+        <p:nvSpPr>
+          <p:cNvPr id="3" name="Notes Placeholder 2"/>
+          <p:cNvSpPr>
+            <a:spLocks noGrp="1"/>
+          </p:cNvSpPr>
+          <p:nvPr>
+            <p:ph type="body" idx="3" sz="quarter"/>
+          </p:nvPr>
+        </p:nvSpPr>
+        <p:spPr/>
+        <p:txBody>
+          <a:bodyPr/>
+          <a:lstStyle/>
+          <a:p>
+            <a:r>
+              <a:t>REGULATION (2:15–2:30)</a:t>
+            </a:r>
+          </a:p>
+          <a:p>
+            <a:r>
+              <a:t>In food and beverage, AI hallucinations are a severe legal hazard. I enforced strict FSANZ compliance and allergen safety.</a:t>
+            </a:r>
+          </a:p>
+        </p:txBody>
+      </p:sp>
+      <p:sp>
+        <p:nvSpPr>
+          <p:cNvPr id="4" name="Slide Number Placeholder 3"/>
+          <p:cNvSpPr>
+            <a:spLocks noGrp="1"/>
+          </p:cNvSpPr>
+          <p:nvPr>
+            <p:ph type="sldNum" idx="5" sz="quarter"/>
+          </p:nvPr>
+        </p:nvSpPr>
+        <p:spPr/>
+      </p:sp>
+    </p:spTree>
+  </p:cSld>
+  <p:clrMapOvr>
+    <a:masterClrMapping/>
+  </p:clrMapOvr>
+</p:notes>
+</file>
+
+<file path=ppt/notesSlides/notesSlide17.xml><?xml version="1.0" encoding="utf-8"?>
+<p:notes xmlns:a="http://schemas.openxmlformats.org/drawingml/2006/main" xmlns:p="http://schemas.openxmlformats.org/presentationml/2006/main" xmlns:r="http://schemas.openxmlformats.org/officeDocument/2006/relationships">
+  <p:cSld>
+    <p:spTree>
+      <p:nvGrpSpPr>
+        <p:cNvPr id="1" name=""/>
+        <p:cNvGrpSpPr/>
+        <p:nvPr/>
+      </p:nvGrpSpPr>
+      <p:grpSpPr>
+        <a:xfrm>
+          <a:off x="0" y="0"/>
+          <a:ext cx="0" cy="0"/>
+          <a:chOff x="0" y="0"/>
+          <a:chExt cx="0" cy="0"/>
+        </a:xfrm>
+      </p:grpSpPr>
+      <p:sp>
+        <p:nvSpPr>
+          <p:cNvPr id="2" name="Slide Image Placeholder 1"/>
+          <p:cNvSpPr>
+            <a:spLocks noGrp="1"/>
+          </p:cNvSpPr>
+          <p:nvPr>
+            <p:ph type="sldImg" idx="2"/>
+          </p:nvPr>
+        </p:nvSpPr>
+        <p:spPr/>
+      </p:sp>
+      <p:sp>
+        <p:nvSpPr>
+          <p:cNvPr id="3" name="Notes Placeholder 2"/>
+          <p:cNvSpPr>
+            <a:spLocks noGrp="1"/>
+          </p:cNvSpPr>
+          <p:nvPr>
+            <p:ph type="body" idx="3" sz="quarter"/>
+          </p:nvPr>
+        </p:nvSpPr>
+        <p:spPr/>
+        <p:txBody>
+          <a:bodyPr/>
+          <a:lstStyle/>
+          <a:p>
+            <a:r>
+              <a:t>ETHICS &amp; WRAP (2:30–2:45)</a:t>
+            </a:r>
+          </a:p>
+          <a:p>
+            <a:r>
+              <a:t>Generative AI accelerates velocity, but human skepticism, taste, discernment, and moral ownership remain essential.</a:t>
             </a:r>
           </a:p>
         </p:txBody>
@@ -889,12 +1193,12 @@
           <a:lstStyle/>
           <a:p>
             <a:r>
-              <a:t>PROBLEM SLIDE (0:08–0:18)</a:t>
-            </a:r>
-          </a:p>
-          <a:p>
-            <a:r>
-              <a:t>Eating toast away from a full kitchen is broken. When you're in a student hall, flat, or office desk, nobody wants to lug a sticky 750-gram jar, track down a table knife, and wash it in an office sink.</a:t>
+              <a:t>PROBLEM (0:08–0:15)</a:t>
+            </a:r>
+          </a:p>
+          <a:p>
+            <a:r>
+              <a:t>Eating toast away from a full kitchen is broken.</a:t>
             </a:r>
           </a:p>
         </p:txBody>
@@ -964,12 +1268,12 @@
           <a:lstStyle/>
           <a:p>
             <a:r>
-              <a:t>SOLUTION SLIDE (0:18–0:28)</a:t>
-            </a:r>
-          </a:p>
-          <a:p>
-            <a:r>
-              <a:t>Stamp reinvents the format with a thin, 10-gram disc of real spread on release film. You peel it off, press it onto hot toast, and residual heat softens it into an even spread in seconds.</a:t>
+              <a:t>WHO FAILS (0:15–0:22)</a:t>
+            </a:r>
+          </a:p>
+          <a:p>
+            <a:r>
+              <a:t>In a hall, flat, or desk, nobody wants to lug a sticky 750g jar, hunt for a knife, and wash it in an office sink.</a:t>
             </a:r>
           </a:p>
         </p:txBody>
@@ -1039,12 +1343,12 @@
           <a:lstStyle/>
           <a:p>
             <a:r>
-              <a:t>FORMAT SLIDE (0:28–0:34)</a:t>
-            </a:r>
-          </a:p>
-          <a:p>
-            <a:r>
-              <a:t>We launch with four distinct flavours: Salted Butter, Raspberry, Yeast extract, and Peanut—pantry-stable for 12 months in an 8-stamp card sheet.</a:t>
+              <a:t>SOLUTION (0:22–0:28)</a:t>
+            </a:r>
+          </a:p>
+          <a:p>
+            <a:r>
+              <a:t>Stamp reinvents the format with a thin, 10-gram disc of real spread on release film.</a:t>
             </a:r>
           </a:p>
         </p:txBody>
@@ -1114,12 +1418,12 @@
           <a:lstStyle/>
           <a:p>
             <a:r>
-              <a:t>MARKET SCALE SLIDE (0:34–0:42)</a:t>
-            </a:r>
-          </a:p>
-          <a:p>
-            <a:r>
-              <a:t>Our analysis of New Zealand breakfast retail sales shows spreads revenue grew 24% to 341 million dollars, with the premium tier surging 29% to 113 million.</a:t>
+              <a:t>MELT GESTURE (0:28–0:34)</a:t>
+            </a:r>
+          </a:p>
+          <a:p>
+            <a:r>
+              <a:t>You press it onto hot toast, and residual thermal energy melts it into an even spread in seconds.</a:t>
             </a:r>
           </a:p>
         </p:txBody>
@@ -1189,12 +1493,12 @@
           <a:lstStyle/>
           <a:p>
             <a:r>
-              <a:t>COMPETITIVE VOID SLIDE (0:42–0:50)</a:t>
-            </a:r>
-          </a:p>
-          <a:p>
-            <a:r>
-              <a:t>Yet across 154 existing spread products, not one offers a single-serve portion format. Supermarket jars like Pic's or Fix &amp; Fogg compete on bulk weight, but they are messy and stationary.</a:t>
+              <a:t>STABILITY &amp; RANGE (0:34–0:40)</a:t>
+            </a:r>
+          </a:p>
+          <a:p>
+            <a:r>
+              <a:t>Four launch varieties in an 8-stamp card sheet, shelf-stable for 12 months with zero refrigeration.</a:t>
             </a:r>
           </a:p>
         </p:txBody>
@@ -1264,12 +1568,12 @@
           <a:lstStyle/>
           <a:p>
             <a:r>
-              <a:t>ECONOMICS SLIDE (0:50–0:58)</a:t>
-            </a:r>
-          </a:p>
-          <a:p>
-            <a:r>
-              <a:t>At five dollars a sheet—just 63 cents a toast portion—Stamp captures premium convenience. With an assumed manufacturing cost of one-fifty, we retain a strong one-dollar-seventy-five gross margin per sheet. Stamp is ready to own portable breakfast.</a:t>
+              <a:t>MARKET SCALE (0:40–0:46)</a:t>
+            </a:r>
+          </a:p>
+          <a:p>
+            <a:r>
+              <a:t>Cleaned supermarket scan data shows the spreads category expanded 24% to 341 million dollars.</a:t>
             </a:r>
           </a:p>
         </p:txBody>
@@ -1339,12 +1643,12 @@
           <a:lstStyle/>
           <a:p>
             <a:r>
-              <a:t>REFLECTION SLIDE 1 (1:00–1:20)</a:t>
-            </a:r>
-          </a:p>
-          <a:p>
-            <a:r>
-              <a:t>To steer generative AI effectively, I structured distinct sessions rather than one massive chat, and enforced strict negative constraints against fake certification badges and medical claims.</a:t>
+              <a:t>PREMIUM GROWTH (0:46–0:52)</a:t>
+            </a:r>
+          </a:p>
+          <a:p>
+            <a:r>
+              <a:t>Premium branded spreads surged 29% to 113 million, significantly outperforming commodity tiers.</a:t>
             </a:r>
           </a:p>
         </p:txBody>
@@ -1414,12 +1718,12 @@
           <a:lstStyle/>
           <a:p>
             <a:r>
-              <a:t>TURNING POINT SLIDE (1:20–1:40)</a:t>
-            </a:r>
-          </a:p>
-          <a:p>
-            <a:r>
-              <a:t>My key pivotal moment was catching an unrealistic AI assumption that dairy butter could sit ambiently without spoilage. I intervened to enforce a shelf-stable cultured dairy spread formula.</a:t>
+              <a:t>COMPETITIVE VOID (0:52–0:58)</a:t>
+            </a:r>
+          </a:p>
+          <a:p>
+            <a:r>
+              <a:t>Across 154 spread products, not one offers a portion format. Jars compete on bulk weight; Stamp wins on convenience.</a:t>
             </a:r>
           </a:p>
         </p:txBody>
@@ -4500,7 +4804,7 @@
         </p:nvSpPr>
         <p:spPr>
           <a:xfrm>
-            <a:off x="1371600" y="3738120"/>
+            <a:off x="1371600" y="3783840"/>
             <a:ext cx="9448495" cy="731520"/>
           </a:xfrm>
           <a:prstGeom prst="rect">
@@ -4573,6 +4877,135 @@
 </file>
 
 <file path=ppt/slides/slide10.xml><?xml version="1.0" encoding="utf-8"?>
+<p:sld xmlns:a="http://schemas.openxmlformats.org/drawingml/2006/main" xmlns:p="http://schemas.openxmlformats.org/presentationml/2006/main" xmlns:r="http://schemas.openxmlformats.org/officeDocument/2006/relationships">
+  <p:cSld>
+    <p:spTree>
+      <p:nvGrpSpPr>
+        <p:cNvPr id="1" name=""/>
+        <p:cNvGrpSpPr/>
+        <p:nvPr/>
+      </p:nvGrpSpPr>
+      <p:grpSpPr/>
+      <p:sp>
+        <p:nvSpPr>
+          <p:cNvPr id="2" name="Rectangle 1"/>
+          <p:cNvSpPr/>
+          <p:nvPr/>
+        </p:nvSpPr>
+        <p:spPr>
+          <a:xfrm>
+            <a:off x="0" y="0"/>
+            <a:ext cx="12191695" cy="6858000"/>
+          </a:xfrm>
+          <a:prstGeom prst="rect">
+            <a:avLst/>
+          </a:prstGeom>
+          <a:solidFill>
+            <a:srgbClr val="460820"/>
+          </a:solidFill>
+          <a:ln>
+            <a:noFill/>
+          </a:ln>
+        </p:spPr>
+        <p:style>
+          <a:lnRef idx="1">
+            <a:schemeClr val="accent1"/>
+          </a:lnRef>
+          <a:fillRef idx="3">
+            <a:schemeClr val="accent1"/>
+          </a:fillRef>
+          <a:effectRef idx="2">
+            <a:schemeClr val="accent1"/>
+          </a:effectRef>
+          <a:fontRef idx="minor">
+            <a:schemeClr val="lt1"/>
+          </a:fontRef>
+        </p:style>
+        <p:txBody>
+          <a:bodyPr rtlCol="0" anchor="ctr"/>
+          <a:lstStyle/>
+          <a:p>
+            <a:pPr algn="ctr"/>
+          </a:p>
+        </p:txBody>
+      </p:sp>
+      <p:sp>
+        <p:nvSpPr>
+          <p:cNvPr id="3" name="TextBox 2"/>
+          <p:cNvSpPr txBox="1"/>
+          <p:nvPr/>
+        </p:nvSpPr>
+        <p:spPr>
+          <a:xfrm>
+            <a:off x="1188720" y="1645920"/>
+            <a:ext cx="9784080" cy="3840480"/>
+          </a:xfrm>
+          <a:prstGeom prst="rect">
+            <a:avLst/>
+          </a:prstGeom>
+          <a:noFill/>
+        </p:spPr>
+        <p:txBody>
+          <a:bodyPr wrap="square" lIns="0" tIns="0" rIns="0" bIns="0">
+            <a:spAutoFit/>
+          </a:bodyPr>
+          <a:lstStyle/>
+          <a:p>
+            <a:pPr>
+              <a:spcAft>
+                <a:spcPts val="1000"/>
+              </a:spcAft>
+              <a:defRPr sz="8000" b="1">
+                <a:solidFill>
+                  <a:srgbClr val="FF467A"/>
+                </a:solidFill>
+                <a:latin typeface="Manrope"/>
+              </a:defRPr>
+            </a:pPr>
+            <a:r>
+              <a:t>$1.75 Margin</a:t>
+            </a:r>
+          </a:p>
+          <a:p>
+            <a:pPr>
+              <a:spcAft>
+                <a:spcPts val="1200"/>
+              </a:spcAft>
+              <a:defRPr sz="4000" b="1">
+                <a:solidFill>
+                  <a:srgbClr val="FFFFFF"/>
+                </a:solidFill>
+                <a:latin typeface="Manrope"/>
+              </a:defRPr>
+            </a:pPr>
+            <a:r>
+              <a:t>$5.00 NZD per 8-Stamp Sheet.</a:t>
+            </a:r>
+          </a:p>
+          <a:p>
+            <a:pPr>
+              <a:defRPr sz="2200" b="0">
+                <a:solidFill>
+                  <a:srgbClr val="FF467A"/>
+                </a:solidFill>
+                <a:latin typeface="Manrope"/>
+              </a:defRPr>
+            </a:pPr>
+            <a:r>
+              <a:t>63¢ per serving on an assumed $1.50 co-packing cost.</a:t>
+            </a:r>
+          </a:p>
+        </p:txBody>
+      </p:sp>
+    </p:spTree>
+  </p:cSld>
+  <p:clrMapOvr>
+    <a:masterClrMapping/>
+  </p:clrMapOvr>
+</p:sld>
+</file>
+
+<file path=ppt/slides/slide11.xml><?xml version="1.0" encoding="utf-8"?>
 <p:sld xmlns:a="http://schemas.openxmlformats.org/drawingml/2006/main" xmlns:p="http://schemas.openxmlformats.org/presentationml/2006/main" xmlns:r="http://schemas.openxmlformats.org/officeDocument/2006/relationships">
   <p:cSld>
     <p:spTree>
@@ -4633,8 +5066,8 @@
         </p:nvSpPr>
         <p:spPr>
           <a:xfrm>
-            <a:off x="1097280" y="822960"/>
-            <a:ext cx="9601200" cy="365760"/>
+            <a:off x="1188720" y="2011680"/>
+            <a:ext cx="9784080" cy="3657600"/>
           </a:xfrm>
           <a:prstGeom prst="rect">
             <a:avLst/>
@@ -4642,13 +5075,16 @@
           <a:noFill/>
         </p:spPr>
         <p:txBody>
-          <a:bodyPr wrap="none" lIns="0" tIns="0" rIns="0" bIns="0">
+          <a:bodyPr wrap="square" lIns="0" tIns="0" rIns="0" bIns="0">
             <a:spAutoFit/>
           </a:bodyPr>
           <a:lstStyle/>
           <a:p>
             <a:pPr>
-              <a:defRPr sz="1300" b="1">
+              <a:spcAft>
+                <a:spcPts val="1200"/>
+              </a:spcAft>
+              <a:defRPr sz="2200" b="1">
                 <a:solidFill>
                   <a:srgbClr val="FF8C30"/>
                 </a:solidFill>
@@ -4656,38 +5092,15 @@
               </a:defRPr>
             </a:pPr>
             <a:r>
-              <a:t>09 / REFLECTION  •  VERIFICATION</a:t>
-            </a:r>
-          </a:p>
-        </p:txBody>
-      </p:sp>
-      <p:sp>
-        <p:nvSpPr>
-          <p:cNvPr id="4" name="TextBox 3"/>
-          <p:cNvSpPr txBox="1"/>
-          <p:nvPr/>
-        </p:nvSpPr>
-        <p:spPr>
-          <a:xfrm>
-            <a:off x="1097280" y="1234440"/>
-            <a:ext cx="9875520" cy="1554480"/>
-          </a:xfrm>
-          <a:prstGeom prst="rect">
-            <a:avLst/>
-          </a:prstGeom>
-          <a:noFill/>
-        </p:spPr>
-        <p:txBody>
-          <a:bodyPr wrap="square" lIns="0" tIns="0" rIns="0" bIns="0">
-            <a:spAutoFit/>
-          </a:bodyPr>
-          <a:lstStyle/>
+              <a:t>Negative Constraints.</a:t>
+            </a:r>
+          </a:p>
           <a:p>
             <a:pPr>
               <a:spcAft>
-                <a:spcPts val="600"/>
+                <a:spcPts val="1400"/>
               </a:spcAft>
-              <a:defRPr sz="4000" b="1">
+              <a:defRPr sz="4800" b="1">
                 <a:solidFill>
                   <a:srgbClr val="FFFFFF"/>
                 </a:solidFill>
@@ -4695,12 +5108,12 @@
               </a:defRPr>
             </a:pPr>
             <a:r>
-              <a:t>AI as Drafter, Not Director.</a:t>
+              <a:t>Banning AI Marketing Hype.</a:t>
             </a:r>
           </a:p>
           <a:p>
             <a:pPr>
-              <a:defRPr sz="1700">
+              <a:defRPr sz="2200" b="0">
                 <a:solidFill>
                   <a:srgbClr val="FF8C30"/>
                 </a:solidFill>
@@ -4708,27 +5121,45 @@
               </a:defRPr>
             </a:pPr>
             <a:r>
-              <a:t>Auditing raw retail scan outliers and independently verifying competitor prices.</a:t>
-            </a:r>
-          </a:p>
-        </p:txBody>
-      </p:sp>
-      <p:sp>
-        <p:nvSpPr>
-          <p:cNvPr id="5" name="Rounded Rectangle 4"/>
+              <a:t>No fake certification badges. No medical health claims.</a:t>
+            </a:r>
+          </a:p>
+        </p:txBody>
+      </p:sp>
+    </p:spTree>
+  </p:cSld>
+  <p:clrMapOvr>
+    <a:masterClrMapping/>
+  </p:clrMapOvr>
+</p:sld>
+</file>
+
+<file path=ppt/slides/slide12.xml><?xml version="1.0" encoding="utf-8"?>
+<p:sld xmlns:a="http://schemas.openxmlformats.org/drawingml/2006/main" xmlns:p="http://schemas.openxmlformats.org/presentationml/2006/main" xmlns:r="http://schemas.openxmlformats.org/officeDocument/2006/relationships">
+  <p:cSld>
+    <p:spTree>
+      <p:nvGrpSpPr>
+        <p:cNvPr id="1" name=""/>
+        <p:cNvGrpSpPr/>
+        <p:nvPr/>
+      </p:nvGrpSpPr>
+      <p:grpSpPr/>
+      <p:sp>
+        <p:nvSpPr>
+          <p:cNvPr id="2" name="Rectangle 1"/>
           <p:cNvSpPr/>
           <p:nvPr/>
         </p:nvSpPr>
         <p:spPr>
           <a:xfrm>
-            <a:off x="1097280" y="2926080"/>
-            <a:ext cx="4754880" cy="3017520"/>
+            <a:off x="0" y="0"/>
+            <a:ext cx="12191695" cy="6858000"/>
           </a:xfrm>
-          <a:prstGeom prst="roundRect">
+          <a:prstGeom prst="rect">
             <a:avLst/>
           </a:prstGeom>
           <a:solidFill>
-            <a:srgbClr val="2D1403"/>
+            <a:srgbClr val="4E2408"/>
           </a:solidFill>
           <a:ln>
             <a:noFill/>
@@ -4758,14 +5189,14 @@
       </p:sp>
       <p:sp>
         <p:nvSpPr>
-          <p:cNvPr id="6" name="TextBox 5"/>
+          <p:cNvPr id="3" name="TextBox 2"/>
           <p:cNvSpPr txBox="1"/>
           <p:nvPr/>
         </p:nvSpPr>
         <p:spPr>
           <a:xfrm>
-            <a:off x="1463040" y="3291840"/>
-            <a:ext cx="4023360" cy="2286000"/>
+            <a:off x="1188720" y="2377440"/>
+            <a:ext cx="9784080" cy="3657600"/>
           </a:xfrm>
           <a:prstGeom prst="rect">
             <a:avLst/>
@@ -4782,7 +5213,23 @@
               <a:spcAft>
                 <a:spcPts val="1200"/>
               </a:spcAft>
-              <a:defRPr sz="1900" b="1">
+              <a:defRPr sz="4800" b="1">
+                <a:solidFill>
+                  <a:srgbClr val="FFFFFF"/>
+                </a:solidFill>
+                <a:latin typeface="Manrope"/>
+              </a:defRPr>
+            </a:pPr>
+            <a:r>
+              <a:t>Modular Sessions.</a:t>
+            </a:r>
+          </a:p>
+          <a:p>
+            <a:pPr>
+              <a:spcAft>
+                <a:spcPts val="1400"/>
+              </a:spcAft>
+              <a:defRPr sz="2200" b="1">
                 <a:solidFill>
                   <a:srgbClr val="FF8C30"/>
                 </a:solidFill>
@@ -4790,40 +5237,45 @@
               </a:defRPr>
             </a:pPr>
             <a:r>
-              <a:t>Data Cleaning Audits</a:t>
-            </a:r>
-          </a:p>
-          <a:p>
-            <a:pPr>
-              <a:defRPr sz="1400">
-                <a:solidFill>
-                  <a:srgbClr val="FFFFFF"/>
-                </a:solidFill>
-                <a:latin typeface="Manrope"/>
-              </a:defRPr>
-            </a:pPr>
-            <a:r>
-              <a:t>Manually audited raw breakfast sales data to catch aberrant price outliers (&gt;$40) and formula errors.</a:t>
-            </a:r>
-          </a:p>
-        </p:txBody>
-      </p:sp>
-      <p:sp>
-        <p:nvSpPr>
-          <p:cNvPr id="7" name="Rounded Rectangle 6"/>
+              <a:t>Separating data, branding, and copy eliminated context drift.</a:t>
+            </a:r>
+          </a:p>
+        </p:txBody>
+      </p:sp>
+    </p:spTree>
+  </p:cSld>
+  <p:clrMapOvr>
+    <a:masterClrMapping/>
+  </p:clrMapOvr>
+</p:sld>
+</file>
+
+<file path=ppt/slides/slide13.xml><?xml version="1.0" encoding="utf-8"?>
+<p:sld xmlns:a="http://schemas.openxmlformats.org/drawingml/2006/main" xmlns:p="http://schemas.openxmlformats.org/presentationml/2006/main" xmlns:r="http://schemas.openxmlformats.org/officeDocument/2006/relationships">
+  <p:cSld>
+    <p:spTree>
+      <p:nvGrpSpPr>
+        <p:cNvPr id="1" name=""/>
+        <p:cNvGrpSpPr/>
+        <p:nvPr/>
+      </p:nvGrpSpPr>
+      <p:grpSpPr/>
+      <p:sp>
+        <p:nvSpPr>
+          <p:cNvPr id="2" name="Rectangle 1"/>
           <p:cNvSpPr/>
           <p:nvPr/>
         </p:nvSpPr>
         <p:spPr>
           <a:xfrm>
-            <a:off x="6217920" y="2926080"/>
-            <a:ext cx="4754880" cy="3017520"/>
+            <a:off x="0" y="0"/>
+            <a:ext cx="12191695" cy="6858000"/>
           </a:xfrm>
-          <a:prstGeom prst="roundRect">
+          <a:prstGeom prst="rect">
             <a:avLst/>
           </a:prstGeom>
           <a:solidFill>
-            <a:srgbClr val="2D1403"/>
+            <a:srgbClr val="4E2408"/>
           </a:solidFill>
           <a:ln>
             <a:noFill/>
@@ -4853,14 +5305,14 @@
       </p:sp>
       <p:sp>
         <p:nvSpPr>
-          <p:cNvPr id="8" name="TextBox 7"/>
+          <p:cNvPr id="3" name="TextBox 2"/>
           <p:cNvSpPr txBox="1"/>
           <p:nvPr/>
         </p:nvSpPr>
         <p:spPr>
           <a:xfrm>
-            <a:off x="6583680" y="3291840"/>
-            <a:ext cx="4023360" cy="2286000"/>
+            <a:off x="1188720" y="2011680"/>
+            <a:ext cx="9784080" cy="3657600"/>
           </a:xfrm>
           <a:prstGeom prst="rect">
             <a:avLst/>
@@ -4877,7 +5329,23 @@
               <a:spcAft>
                 <a:spcPts val="1200"/>
               </a:spcAft>
-              <a:defRPr sz="1900" b="1">
+              <a:defRPr sz="4600" b="1">
+                <a:solidFill>
+                  <a:srgbClr val="FFFFFF"/>
+                </a:solidFill>
+                <a:latin typeface="Manrope"/>
+              </a:defRPr>
+            </a:pPr>
+            <a:r>
+              <a:t>Catching Butter Instability.</a:t>
+            </a:r>
+          </a:p>
+          <a:p>
+            <a:pPr>
+              <a:spcAft>
+                <a:spcPts val="1400"/>
+              </a:spcAft>
+              <a:defRPr sz="2400" b="1">
                 <a:solidFill>
                   <a:srgbClr val="FF8C30"/>
                 </a:solidFill>
@@ -4885,20 +5353,20 @@
               </a:defRPr>
             </a:pPr>
             <a:r>
-              <a:t>Live Shelf Benchmarks</a:t>
+              <a:t>AI assumed table butter could sit ambiently.</a:t>
             </a:r>
           </a:p>
           <a:p>
             <a:pPr>
-              <a:defRPr sz="1400">
+              <a:defRPr sz="2000" b="0">
                 <a:solidFill>
-                  <a:srgbClr val="FFFFFF"/>
+                  <a:srgbClr val="FF8C30"/>
                 </a:solidFill>
                 <a:latin typeface="Manrope"/>
               </a:defRPr>
             </a:pPr>
             <a:r>
-              <a:t>Directly cross-referenced New World retail prices (Pic's $7.79, Fix &amp; Fogg $11.99) rather than trusting AI estimates.</a:t>
+              <a:t>Human intervention forced dairy spread reformulation.</a:t>
             </a:r>
           </a:p>
         </p:txBody>
@@ -4911,7 +5379,123 @@
 </p:sld>
 </file>
 
-<file path=ppt/slides/slide11.xml><?xml version="1.0" encoding="utf-8"?>
+<file path=ppt/slides/slide14.xml><?xml version="1.0" encoding="utf-8"?>
+<p:sld xmlns:a="http://schemas.openxmlformats.org/drawingml/2006/main" xmlns:p="http://schemas.openxmlformats.org/presentationml/2006/main" xmlns:r="http://schemas.openxmlformats.org/officeDocument/2006/relationships">
+  <p:cSld>
+    <p:spTree>
+      <p:nvGrpSpPr>
+        <p:cNvPr id="1" name=""/>
+        <p:cNvGrpSpPr/>
+        <p:nvPr/>
+      </p:nvGrpSpPr>
+      <p:grpSpPr/>
+      <p:sp>
+        <p:nvSpPr>
+          <p:cNvPr id="2" name="Rectangle 1"/>
+          <p:cNvSpPr/>
+          <p:nvPr/>
+        </p:nvSpPr>
+        <p:spPr>
+          <a:xfrm>
+            <a:off x="0" y="0"/>
+            <a:ext cx="12191695" cy="6858000"/>
+          </a:xfrm>
+          <a:prstGeom prst="rect">
+            <a:avLst/>
+          </a:prstGeom>
+          <a:solidFill>
+            <a:srgbClr val="4E2408"/>
+          </a:solidFill>
+          <a:ln>
+            <a:noFill/>
+          </a:ln>
+        </p:spPr>
+        <p:style>
+          <a:lnRef idx="1">
+            <a:schemeClr val="accent1"/>
+          </a:lnRef>
+          <a:fillRef idx="3">
+            <a:schemeClr val="accent1"/>
+          </a:fillRef>
+          <a:effectRef idx="2">
+            <a:schemeClr val="accent1"/>
+          </a:effectRef>
+          <a:fontRef idx="minor">
+            <a:schemeClr val="lt1"/>
+          </a:fontRef>
+        </p:style>
+        <p:txBody>
+          <a:bodyPr rtlCol="0" anchor="ctr"/>
+          <a:lstStyle/>
+          <a:p>
+            <a:pPr algn="ctr"/>
+          </a:p>
+        </p:txBody>
+      </p:sp>
+      <p:sp>
+        <p:nvSpPr>
+          <p:cNvPr id="3" name="TextBox 2"/>
+          <p:cNvSpPr txBox="1"/>
+          <p:nvPr/>
+        </p:nvSpPr>
+        <p:spPr>
+          <a:xfrm>
+            <a:off x="1188720" y="2377440"/>
+            <a:ext cx="9784080" cy="3657600"/>
+          </a:xfrm>
+          <a:prstGeom prst="rect">
+            <a:avLst/>
+          </a:prstGeom>
+          <a:noFill/>
+        </p:spPr>
+        <p:txBody>
+          <a:bodyPr wrap="square" lIns="0" tIns="0" rIns="0" bIns="0">
+            <a:spAutoFit/>
+          </a:bodyPr>
+          <a:lstStyle/>
+          <a:p>
+            <a:pPr>
+              <a:spcAft>
+                <a:spcPts val="1200"/>
+              </a:spcAft>
+              <a:defRPr sz="4600" b="1">
+                <a:solidFill>
+                  <a:srgbClr val="FFFFFF"/>
+                </a:solidFill>
+                <a:latin typeface="Manrope"/>
+              </a:defRPr>
+            </a:pPr>
+            <a:r>
+              <a:t>AI as Drafter, Not Director.</a:t>
+            </a:r>
+          </a:p>
+          <a:p>
+            <a:pPr>
+              <a:spcAft>
+                <a:spcPts val="1400"/>
+              </a:spcAft>
+              <a:defRPr sz="2200" b="1">
+                <a:solidFill>
+                  <a:srgbClr val="FF8C30"/>
+                </a:solidFill>
+                <a:latin typeface="Manrope"/>
+              </a:defRPr>
+            </a:pPr>
+            <a:r>
+              <a:t>Auditing scan price spikes. Verifying live supermarket shelves.</a:t>
+            </a:r>
+          </a:p>
+        </p:txBody>
+      </p:sp>
+    </p:spTree>
+  </p:cSld>
+  <p:clrMapOvr>
+    <a:masterClrMapping/>
+  </p:clrMapOvr>
+</p:sld>
+</file>
+
+<file path=ppt/slides/slide15.xml><?xml version="1.0" encoding="utf-8"?>
 <p:sld xmlns:a="http://schemas.openxmlformats.org/drawingml/2006/main" xmlns:p="http://schemas.openxmlformats.org/presentationml/2006/main" xmlns:r="http://schemas.openxmlformats.org/officeDocument/2006/relationships">
   <p:cSld>
     <p:spTree>
@@ -4972,8 +5556,8 @@
         </p:nvSpPr>
         <p:spPr>
           <a:xfrm>
-            <a:off x="1097280" y="822960"/>
-            <a:ext cx="9601200" cy="365760"/>
+            <a:off x="1188720" y="2377440"/>
+            <a:ext cx="9784080" cy="3657600"/>
           </a:xfrm>
           <a:prstGeom prst="rect">
             <a:avLst/>
@@ -4981,13 +5565,32 @@
           <a:noFill/>
         </p:spPr>
         <p:txBody>
-          <a:bodyPr wrap="none" lIns="0" tIns="0" rIns="0" bIns="0">
+          <a:bodyPr wrap="square" lIns="0" tIns="0" rIns="0" bIns="0">
             <a:spAutoFit/>
           </a:bodyPr>
           <a:lstStyle/>
           <a:p>
             <a:pPr>
-              <a:defRPr sz="1300" b="1">
+              <a:spcAft>
+                <a:spcPts val="1200"/>
+              </a:spcAft>
+              <a:defRPr sz="4800" b="1">
+                <a:solidFill>
+                  <a:srgbClr val="FFFFFF"/>
+                </a:solidFill>
+                <a:latin typeface="Manrope"/>
+              </a:defRPr>
+            </a:pPr>
+            <a:r>
+              <a:t>Banning Corporate Buzzwords.</a:t>
+            </a:r>
+          </a:p>
+          <a:p>
+            <a:pPr>
+              <a:spcAft>
+                <a:spcPts val="1400"/>
+              </a:spcAft>
+              <a:defRPr sz="2400" b="1">
                 <a:solidFill>
                   <a:srgbClr val="E24BFF"/>
                 </a:solidFill>
@@ -4995,249 +5598,7 @@
               </a:defRPr>
             </a:pPr>
             <a:r>
-              <a:t>10 / REFLECTION  •  AUTHENTICITY</a:t>
-            </a:r>
-          </a:p>
-        </p:txBody>
-      </p:sp>
-      <p:sp>
-        <p:nvSpPr>
-          <p:cNvPr id="4" name="TextBox 3"/>
-          <p:cNvSpPr txBox="1"/>
-          <p:nvPr/>
-        </p:nvSpPr>
-        <p:spPr>
-          <a:xfrm>
-            <a:off x="1097280" y="1234440"/>
-            <a:ext cx="9875520" cy="1554480"/>
-          </a:xfrm>
-          <a:prstGeom prst="rect">
-            <a:avLst/>
-          </a:prstGeom>
-          <a:noFill/>
-        </p:spPr>
-        <p:txBody>
-          <a:bodyPr wrap="square" lIns="0" tIns="0" rIns="0" bIns="0">
-            <a:spAutoFit/>
-          </a:bodyPr>
-          <a:lstStyle/>
-          <a:p>
-            <a:pPr>
-              <a:spcAft>
-                <a:spcPts val="600"/>
-              </a:spcAft>
-              <a:defRPr sz="4000" b="1">
-                <a:solidFill>
-                  <a:srgbClr val="FFFFFF"/>
-                </a:solidFill>
-                <a:latin typeface="Manrope"/>
-              </a:defRPr>
-            </a:pPr>
-            <a:r>
-              <a:t>Banning Corporate Buzzwords.</a:t>
-            </a:r>
-          </a:p>
-          <a:p>
-            <a:pPr>
-              <a:defRPr sz="1700">
-                <a:solidFill>
-                  <a:srgbClr val="E24BFF"/>
-                </a:solidFill>
-                <a:latin typeface="Manrope"/>
-              </a:defRPr>
-            </a:pPr>
-            <a:r>
-              <a:t>Stripping hyperbolic marketing cliches for punchy facts: Peel. Press. Toast.</a:t>
-            </a:r>
-          </a:p>
-        </p:txBody>
-      </p:sp>
-      <p:sp>
-        <p:nvSpPr>
-          <p:cNvPr id="5" name="Rounded Rectangle 4"/>
-          <p:cNvSpPr/>
-          <p:nvPr/>
-        </p:nvSpPr>
-        <p:spPr>
-          <a:xfrm>
-            <a:off x="1097280" y="2926080"/>
-            <a:ext cx="4754880" cy="3017520"/>
-          </a:xfrm>
-          <a:prstGeom prst="roundRect">
-            <a:avLst/>
-          </a:prstGeom>
-          <a:solidFill>
-            <a:srgbClr val="3B0764"/>
-          </a:solidFill>
-          <a:ln>
-            <a:noFill/>
-          </a:ln>
-        </p:spPr>
-        <p:style>
-          <a:lnRef idx="1">
-            <a:schemeClr val="accent1"/>
-          </a:lnRef>
-          <a:fillRef idx="3">
-            <a:schemeClr val="accent1"/>
-          </a:fillRef>
-          <a:effectRef idx="2">
-            <a:schemeClr val="accent1"/>
-          </a:effectRef>
-          <a:fontRef idx="minor">
-            <a:schemeClr val="lt1"/>
-          </a:fontRef>
-        </p:style>
-        <p:txBody>
-          <a:bodyPr rtlCol="0" anchor="ctr"/>
-          <a:lstStyle/>
-          <a:p>
-            <a:pPr algn="ctr"/>
-          </a:p>
-        </p:txBody>
-      </p:sp>
-      <p:sp>
-        <p:nvSpPr>
-          <p:cNvPr id="6" name="TextBox 5"/>
-          <p:cNvSpPr txBox="1"/>
-          <p:nvPr/>
-        </p:nvSpPr>
-        <p:spPr>
-          <a:xfrm>
-            <a:off x="1463040" y="3291840"/>
-            <a:ext cx="4023360" cy="2286000"/>
-          </a:xfrm>
-          <a:prstGeom prst="rect">
-            <a:avLst/>
-          </a:prstGeom>
-          <a:noFill/>
-        </p:spPr>
-        <p:txBody>
-          <a:bodyPr wrap="square" lIns="0" tIns="0" rIns="0" bIns="0">
-            <a:spAutoFit/>
-          </a:bodyPr>
-          <a:lstStyle/>
-          <a:p>
-            <a:pPr>
-              <a:spcAft>
-                <a:spcPts val="1200"/>
-              </a:spcAft>
-              <a:defRPr sz="1900" b="1">
-                <a:solidFill>
-                  <a:srgbClr val="E24BFF"/>
-                </a:solidFill>
-                <a:latin typeface="Manrope"/>
-              </a:defRPr>
-            </a:pPr>
-            <a:r>
-              <a:t>Rejecting Slop Phrases</a:t>
-            </a:r>
-          </a:p>
-          <a:p>
-            <a:pPr>
-              <a:defRPr sz="1400">
-                <a:solidFill>
-                  <a:srgbClr val="FFFFFF"/>
-                </a:solidFill>
-                <a:latin typeface="Manrope"/>
-              </a:defRPr>
-            </a:pPr>
-            <a:r>
-              <a:t>Actively stripped generic corporate fluff ('game-changer', 'revolutionary journey') to maintain authentic tone.</a:t>
-            </a:r>
-          </a:p>
-        </p:txBody>
-      </p:sp>
-      <p:sp>
-        <p:nvSpPr>
-          <p:cNvPr id="7" name="Rounded Rectangle 6"/>
-          <p:cNvSpPr/>
-          <p:nvPr/>
-        </p:nvSpPr>
-        <p:spPr>
-          <a:xfrm>
-            <a:off x="6217920" y="2926080"/>
-            <a:ext cx="4754880" cy="3017520"/>
-          </a:xfrm>
-          <a:prstGeom prst="roundRect">
-            <a:avLst/>
-          </a:prstGeom>
-          <a:solidFill>
-            <a:srgbClr val="3B0764"/>
-          </a:solidFill>
-          <a:ln>
-            <a:noFill/>
-          </a:ln>
-        </p:spPr>
-        <p:style>
-          <a:lnRef idx="1">
-            <a:schemeClr val="accent1"/>
-          </a:lnRef>
-          <a:fillRef idx="3">
-            <a:schemeClr val="accent1"/>
-          </a:fillRef>
-          <a:effectRef idx="2">
-            <a:schemeClr val="accent1"/>
-          </a:effectRef>
-          <a:fontRef idx="minor">
-            <a:schemeClr val="lt1"/>
-          </a:fontRef>
-        </p:style>
-        <p:txBody>
-          <a:bodyPr rtlCol="0" anchor="ctr"/>
-          <a:lstStyle/>
-          <a:p>
-            <a:pPr algn="ctr"/>
-          </a:p>
-        </p:txBody>
-      </p:sp>
-      <p:sp>
-        <p:nvSpPr>
-          <p:cNvPr id="8" name="TextBox 7"/>
-          <p:cNvSpPr txBox="1"/>
-          <p:nvPr/>
-        </p:nvSpPr>
-        <p:spPr>
-          <a:xfrm>
-            <a:off x="6583680" y="3291840"/>
-            <a:ext cx="4023360" cy="2286000"/>
-          </a:xfrm>
-          <a:prstGeom prst="rect">
-            <a:avLst/>
-          </a:prstGeom>
-          <a:noFill/>
-        </p:spPr>
-        <p:txBody>
-          <a:bodyPr wrap="square" lIns="0" tIns="0" rIns="0" bIns="0">
-            <a:spAutoFit/>
-          </a:bodyPr>
-          <a:lstStyle/>
-          <a:p>
-            <a:pPr>
-              <a:spcAft>
-                <a:spcPts val="1200"/>
-              </a:spcAft>
-              <a:defRPr sz="1900" b="1">
-                <a:solidFill>
-                  <a:srgbClr val="E24BFF"/>
-                </a:solidFill>
-                <a:latin typeface="Manrope"/>
-              </a:defRPr>
-            </a:pPr>
-            <a:r>
-              <a:t>Physical Reality Grounding</a:t>
-            </a:r>
-          </a:p>
-          <a:p>
-            <a:pPr>
-              <a:defRPr sz="1400">
-                <a:solidFill>
-                  <a:srgbClr val="FFFFFF"/>
-                </a:solidFill>
-                <a:latin typeface="Manrope"/>
-              </a:defRPr>
-            </a:pPr>
-            <a:r>
-              <a:t>Anchored packaging in real industrial tooling (continuous deposit, release film) rather than AI fantasy mockups.</a:t>
+              <a:t>Stripping AI hype for plain facts: Peel. Press. Toast.</a:t>
             </a:r>
           </a:p>
         </p:txBody>
@@ -5250,7 +5611,7 @@
 </p:sld>
 </file>
 
-<file path=ppt/slides/slide12.xml><?xml version="1.0" encoding="utf-8"?>
+<file path=ppt/slides/slide16.xml><?xml version="1.0" encoding="utf-8"?>
 <p:sld xmlns:a="http://schemas.openxmlformats.org/drawingml/2006/main" xmlns:p="http://schemas.openxmlformats.org/presentationml/2006/main" xmlns:r="http://schemas.openxmlformats.org/officeDocument/2006/relationships">
   <p:cSld>
     <p:spTree>
@@ -5311,8 +5672,8 @@
         </p:nvSpPr>
         <p:spPr>
           <a:xfrm>
-            <a:off x="1097280" y="822960"/>
-            <a:ext cx="9601200" cy="365760"/>
+            <a:off x="1188720" y="2377440"/>
+            <a:ext cx="9784080" cy="3657600"/>
           </a:xfrm>
           <a:prstGeom prst="rect">
             <a:avLst/>
@@ -5320,13 +5681,32 @@
           <a:noFill/>
         </p:spPr>
         <p:txBody>
-          <a:bodyPr wrap="none" lIns="0" tIns="0" rIns="0" bIns="0">
+          <a:bodyPr wrap="square" lIns="0" tIns="0" rIns="0" bIns="0">
             <a:spAutoFit/>
           </a:bodyPr>
           <a:lstStyle/>
           <a:p>
             <a:pPr>
-              <a:defRPr sz="1300" b="1">
+              <a:spcAft>
+                <a:spcPts val="1200"/>
+              </a:spcAft>
+              <a:defRPr sz="4800" b="1">
+                <a:solidFill>
+                  <a:srgbClr val="FFFFFF"/>
+                </a:solidFill>
+                <a:latin typeface="Manrope"/>
+              </a:defRPr>
+            </a:pPr>
+            <a:r>
+              <a:t>Zero Hallucination Tolerance.</a:t>
+            </a:r>
+          </a:p>
+          <a:p>
+            <a:pPr>
+              <a:spcAft>
+                <a:spcPts val="1400"/>
+              </a:spcAft>
+              <a:defRPr sz="2400" b="1">
                 <a:solidFill>
                   <a:srgbClr val="E24BFF"/>
                 </a:solidFill>
@@ -5334,249 +5714,7 @@
               </a:defRPr>
             </a:pPr>
             <a:r>
-              <a:t>11 / REFLECTION  •  REGULATION</a:t>
-            </a:r>
-          </a:p>
-        </p:txBody>
-      </p:sp>
-      <p:sp>
-        <p:nvSpPr>
-          <p:cNvPr id="4" name="TextBox 3"/>
-          <p:cNvSpPr txBox="1"/>
-          <p:nvPr/>
-        </p:nvSpPr>
-        <p:spPr>
-          <a:xfrm>
-            <a:off x="1097280" y="1234440"/>
-            <a:ext cx="9875520" cy="1554480"/>
-          </a:xfrm>
-          <a:prstGeom prst="rect">
-            <a:avLst/>
-          </a:prstGeom>
-          <a:noFill/>
-        </p:spPr>
-        <p:txBody>
-          <a:bodyPr wrap="square" lIns="0" tIns="0" rIns="0" bIns="0">
-            <a:spAutoFit/>
-          </a:bodyPr>
-          <a:lstStyle/>
-          <a:p>
-            <a:pPr>
-              <a:spcAft>
-                <a:spcPts val="600"/>
-              </a:spcAft>
-              <a:defRPr sz="4000" b="1">
-                <a:solidFill>
-                  <a:srgbClr val="FFFFFF"/>
-                </a:solidFill>
-                <a:latin typeface="Manrope"/>
-              </a:defRPr>
-            </a:pPr>
-            <a:r>
-              <a:t>Zero Hallucination Tolerance.</a:t>
-            </a:r>
-          </a:p>
-          <a:p>
-            <a:pPr>
-              <a:defRPr sz="1700">
-                <a:solidFill>
-                  <a:srgbClr val="E24BFF"/>
-                </a:solidFill>
-                <a:latin typeface="Manrope"/>
-              </a:defRPr>
-            </a:pPr>
-            <a:r>
-              <a:t>Strict FSANZ food compliance and non-negotiable allergen disclosures.</a:t>
-            </a:r>
-          </a:p>
-        </p:txBody>
-      </p:sp>
-      <p:sp>
-        <p:nvSpPr>
-          <p:cNvPr id="5" name="Rounded Rectangle 4"/>
-          <p:cNvSpPr/>
-          <p:nvPr/>
-        </p:nvSpPr>
-        <p:spPr>
-          <a:xfrm>
-            <a:off x="1097280" y="2926080"/>
-            <a:ext cx="4754880" cy="3017520"/>
-          </a:xfrm>
-          <a:prstGeom prst="roundRect">
-            <a:avLst/>
-          </a:prstGeom>
-          <a:solidFill>
-            <a:srgbClr val="3B0764"/>
-          </a:solidFill>
-          <a:ln>
-            <a:noFill/>
-          </a:ln>
-        </p:spPr>
-        <p:style>
-          <a:lnRef idx="1">
-            <a:schemeClr val="accent1"/>
-          </a:lnRef>
-          <a:fillRef idx="3">
-            <a:schemeClr val="accent1"/>
-          </a:fillRef>
-          <a:effectRef idx="2">
-            <a:schemeClr val="accent1"/>
-          </a:effectRef>
-          <a:fontRef idx="minor">
-            <a:schemeClr val="lt1"/>
-          </a:fontRef>
-        </p:style>
-        <p:txBody>
-          <a:bodyPr rtlCol="0" anchor="ctr"/>
-          <a:lstStyle/>
-          <a:p>
-            <a:pPr algn="ctr"/>
-          </a:p>
-        </p:txBody>
-      </p:sp>
-      <p:sp>
-        <p:nvSpPr>
-          <p:cNvPr id="6" name="TextBox 5"/>
-          <p:cNvSpPr txBox="1"/>
-          <p:nvPr/>
-        </p:nvSpPr>
-        <p:spPr>
-          <a:xfrm>
-            <a:off x="1463040" y="3291840"/>
-            <a:ext cx="4023360" cy="2286000"/>
-          </a:xfrm>
-          <a:prstGeom prst="rect">
-            <a:avLst/>
-          </a:prstGeom>
-          <a:noFill/>
-        </p:spPr>
-        <p:txBody>
-          <a:bodyPr wrap="square" lIns="0" tIns="0" rIns="0" bIns="0">
-            <a:spAutoFit/>
-          </a:bodyPr>
-          <a:lstStyle/>
-          <a:p>
-            <a:pPr>
-              <a:spcAft>
-                <a:spcPts val="1200"/>
-              </a:spcAft>
-              <a:defRPr sz="1900" b="1">
-                <a:solidFill>
-                  <a:srgbClr val="E24BFF"/>
-                </a:solidFill>
-                <a:latin typeface="Manrope"/>
-              </a:defRPr>
-            </a:pPr>
-            <a:r>
-              <a:t>The Legal Hazard</a:t>
-            </a:r>
-          </a:p>
-          <a:p>
-            <a:pPr>
-              <a:defRPr sz="1400">
-                <a:solidFill>
-                  <a:srgbClr val="FFFFFF"/>
-                </a:solidFill>
-                <a:latin typeface="Manrope"/>
-              </a:defRPr>
-            </a:pPr>
-            <a:r>
-              <a:t>Unchecked AI frequently invents fake organic labels or dangerous 'gluten-free' badges (hazardous for Yeast extract).</a:t>
-            </a:r>
-          </a:p>
-        </p:txBody>
-      </p:sp>
-      <p:sp>
-        <p:nvSpPr>
-          <p:cNvPr id="7" name="Rounded Rectangle 6"/>
-          <p:cNvSpPr/>
-          <p:nvPr/>
-        </p:nvSpPr>
-        <p:spPr>
-          <a:xfrm>
-            <a:off x="6217920" y="2926080"/>
-            <a:ext cx="4754880" cy="3017520"/>
-          </a:xfrm>
-          <a:prstGeom prst="roundRect">
-            <a:avLst/>
-          </a:prstGeom>
-          <a:solidFill>
-            <a:srgbClr val="3B0764"/>
-          </a:solidFill>
-          <a:ln>
-            <a:noFill/>
-          </a:ln>
-        </p:spPr>
-        <p:style>
-          <a:lnRef idx="1">
-            <a:schemeClr val="accent1"/>
-          </a:lnRef>
-          <a:fillRef idx="3">
-            <a:schemeClr val="accent1"/>
-          </a:fillRef>
-          <a:effectRef idx="2">
-            <a:schemeClr val="accent1"/>
-          </a:effectRef>
-          <a:fontRef idx="minor">
-            <a:schemeClr val="lt1"/>
-          </a:fontRef>
-        </p:style>
-        <p:txBody>
-          <a:bodyPr rtlCol="0" anchor="ctr"/>
-          <a:lstStyle/>
-          <a:p>
-            <a:pPr algn="ctr"/>
-          </a:p>
-        </p:txBody>
-      </p:sp>
-      <p:sp>
-        <p:nvSpPr>
-          <p:cNvPr id="8" name="TextBox 7"/>
-          <p:cNvSpPr txBox="1"/>
-          <p:nvPr/>
-        </p:nvSpPr>
-        <p:spPr>
-          <a:xfrm>
-            <a:off x="6583680" y="3291840"/>
-            <a:ext cx="4023360" cy="2286000"/>
-          </a:xfrm>
-          <a:prstGeom prst="rect">
-            <a:avLst/>
-          </a:prstGeom>
-          <a:noFill/>
-        </p:spPr>
-        <p:txBody>
-          <a:bodyPr wrap="square" lIns="0" tIns="0" rIns="0" bIns="0">
-            <a:spAutoFit/>
-          </a:bodyPr>
-          <a:lstStyle/>
-          <a:p>
-            <a:pPr>
-              <a:spcAft>
-                <a:spcPts val="1200"/>
-              </a:spcAft>
-              <a:defRPr sz="1900" b="1">
-                <a:solidFill>
-                  <a:srgbClr val="E24BFF"/>
-                </a:solidFill>
-                <a:latin typeface="Manrope"/>
-              </a:defRPr>
-            </a:pPr>
-            <a:r>
-              <a:t>Enforcing Standards</a:t>
-            </a:r>
-          </a:p>
-          <a:p>
-            <a:pPr>
-              <a:defRPr sz="1400">
-                <a:solidFill>
-                  <a:srgbClr val="FFFFFF"/>
-                </a:solidFill>
-                <a:latin typeface="Manrope"/>
-              </a:defRPr>
-            </a:pPr>
-            <a:r>
-              <a:t>Complied strictly with Food Standards Australia New Zealand and ensured peanut and gluten warnings remained prominent.</a:t>
+              <a:t>Strict FSANZ food laws and prominent allergen warnings.</a:t>
             </a:r>
           </a:p>
         </p:txBody>
@@ -5589,7 +5727,7 @@
 </p:sld>
 </file>
 
-<file path=ppt/slides/slide13.xml><?xml version="1.0" encoding="utf-8"?>
+<file path=ppt/slides/slide17.xml><?xml version="1.0" encoding="utf-8"?>
 <p:sld xmlns:a="http://schemas.openxmlformats.org/drawingml/2006/main" xmlns:p="http://schemas.openxmlformats.org/presentationml/2006/main" xmlns:r="http://schemas.openxmlformats.org/officeDocument/2006/relationships">
   <p:cSld>
     <p:spTree>
@@ -5650,8 +5788,8 @@
         </p:nvSpPr>
         <p:spPr>
           <a:xfrm>
-            <a:off x="1097280" y="822960"/>
-            <a:ext cx="9601200" cy="365760"/>
+            <a:off x="1188720" y="2377440"/>
+            <a:ext cx="9784080" cy="3657600"/>
           </a:xfrm>
           <a:prstGeom prst="rect">
             <a:avLst/>
@@ -5659,13 +5797,32 @@
           <a:noFill/>
         </p:spPr>
         <p:txBody>
-          <a:bodyPr wrap="none" lIns="0" tIns="0" rIns="0" bIns="0">
+          <a:bodyPr wrap="square" lIns="0" tIns="0" rIns="0" bIns="0">
             <a:spAutoFit/>
           </a:bodyPr>
           <a:lstStyle/>
           <a:p>
             <a:pPr>
-              <a:defRPr sz="1300" b="1">
+              <a:spcAft>
+                <a:spcPts val="1200"/>
+              </a:spcAft>
+              <a:defRPr sz="4800" b="1">
+                <a:solidFill>
+                  <a:srgbClr val="FFFFFF"/>
+                </a:solidFill>
+                <a:latin typeface="Manrope"/>
+              </a:defRPr>
+            </a:pPr>
+            <a:r>
+              <a:t>Accountability Remains Human.</a:t>
+            </a:r>
+          </a:p>
+          <a:p>
+            <a:pPr>
+              <a:spcAft>
+                <a:spcPts val="1400"/>
+              </a:spcAft>
+              <a:defRPr sz="2400" b="1">
                 <a:solidFill>
                   <a:srgbClr val="E24BFF"/>
                 </a:solidFill>
@@ -5673,249 +5830,7 @@
               </a:defRPr>
             </a:pPr>
             <a:r>
-              <a:t>12 / REFLECTION  •  ETHICS</a:t>
-            </a:r>
-          </a:p>
-        </p:txBody>
-      </p:sp>
-      <p:sp>
-        <p:nvSpPr>
-          <p:cNvPr id="4" name="TextBox 3"/>
-          <p:cNvSpPr txBox="1"/>
-          <p:nvPr/>
-        </p:nvSpPr>
-        <p:spPr>
-          <a:xfrm>
-            <a:off x="1097280" y="1234440"/>
-            <a:ext cx="9875520" cy="1554480"/>
-          </a:xfrm>
-          <a:prstGeom prst="rect">
-            <a:avLst/>
-          </a:prstGeom>
-          <a:noFill/>
-        </p:spPr>
-        <p:txBody>
-          <a:bodyPr wrap="square" lIns="0" tIns="0" rIns="0" bIns="0">
-            <a:spAutoFit/>
-          </a:bodyPr>
-          <a:lstStyle/>
-          <a:p>
-            <a:pPr>
-              <a:spcAft>
-                <a:spcPts val="600"/>
-              </a:spcAft>
-              <a:defRPr sz="4000" b="1">
-                <a:solidFill>
-                  <a:srgbClr val="FFFFFF"/>
-                </a:solidFill>
-                <a:latin typeface="Manrope"/>
-              </a:defRPr>
-            </a:pPr>
-            <a:r>
-              <a:t>Accountability Remains Human.</a:t>
-            </a:r>
-          </a:p>
-          <a:p>
-            <a:pPr>
-              <a:defRPr sz="1700">
-                <a:solidFill>
-                  <a:srgbClr val="E24BFF"/>
-                </a:solidFill>
-                <a:latin typeface="Manrope"/>
-              </a:defRPr>
-            </a:pPr>
-            <a:r>
-              <a:t>Legal, moral, and customer responsibility can never be outsourced to an algorithm.</a:t>
-            </a:r>
-          </a:p>
-        </p:txBody>
-      </p:sp>
-      <p:sp>
-        <p:nvSpPr>
-          <p:cNvPr id="5" name="Rounded Rectangle 4"/>
-          <p:cNvSpPr/>
-          <p:nvPr/>
-        </p:nvSpPr>
-        <p:spPr>
-          <a:xfrm>
-            <a:off x="1097280" y="2926080"/>
-            <a:ext cx="4754880" cy="3017520"/>
-          </a:xfrm>
-          <a:prstGeom prst="roundRect">
-            <a:avLst/>
-          </a:prstGeom>
-          <a:solidFill>
-            <a:srgbClr val="3B0764"/>
-          </a:solidFill>
-          <a:ln>
-            <a:noFill/>
-          </a:ln>
-        </p:spPr>
-        <p:style>
-          <a:lnRef idx="1">
-            <a:schemeClr val="accent1"/>
-          </a:lnRef>
-          <a:fillRef idx="3">
-            <a:schemeClr val="accent1"/>
-          </a:fillRef>
-          <a:effectRef idx="2">
-            <a:schemeClr val="accent1"/>
-          </a:effectRef>
-          <a:fontRef idx="minor">
-            <a:schemeClr val="lt1"/>
-          </a:fontRef>
-        </p:style>
-        <p:txBody>
-          <a:bodyPr rtlCol="0" anchor="ctr"/>
-          <a:lstStyle/>
-          <a:p>
-            <a:pPr algn="ctr"/>
-          </a:p>
-        </p:txBody>
-      </p:sp>
-      <p:sp>
-        <p:nvSpPr>
-          <p:cNvPr id="6" name="TextBox 5"/>
-          <p:cNvSpPr txBox="1"/>
-          <p:nvPr/>
-        </p:nvSpPr>
-        <p:spPr>
-          <a:xfrm>
-            <a:off x="1463040" y="3291840"/>
-            <a:ext cx="4023360" cy="2286000"/>
-          </a:xfrm>
-          <a:prstGeom prst="rect">
-            <a:avLst/>
-          </a:prstGeom>
-          <a:noFill/>
-        </p:spPr>
-        <p:txBody>
-          <a:bodyPr wrap="square" lIns="0" tIns="0" rIns="0" bIns="0">
-            <a:spAutoFit/>
-          </a:bodyPr>
-          <a:lstStyle/>
-          <a:p>
-            <a:pPr>
-              <a:spcAft>
-                <a:spcPts val="1200"/>
-              </a:spcAft>
-              <a:defRPr sz="1900" b="1">
-                <a:solidFill>
-                  <a:srgbClr val="E24BFF"/>
-                </a:solidFill>
-                <a:latin typeface="Manrope"/>
-              </a:defRPr>
-            </a:pPr>
-            <a:r>
-              <a:t>Non-Delegable Agency</a:t>
-            </a:r>
-          </a:p>
-          <a:p>
-            <a:pPr>
-              <a:defRPr sz="1400">
-                <a:solidFill>
-                  <a:srgbClr val="FFFFFF"/>
-                </a:solidFill>
-                <a:latin typeface="Manrope"/>
-              </a:defRPr>
-            </a:pPr>
-            <a:r>
-              <a:t>When deploying AI commercially, accountability for safety and truth rests entirely with the human practitioner.</a:t>
-            </a:r>
-          </a:p>
-        </p:txBody>
-      </p:sp>
-      <p:sp>
-        <p:nvSpPr>
-          <p:cNvPr id="7" name="Rounded Rectangle 6"/>
-          <p:cNvSpPr/>
-          <p:nvPr/>
-        </p:nvSpPr>
-        <p:spPr>
-          <a:xfrm>
-            <a:off x="6217920" y="2926080"/>
-            <a:ext cx="4754880" cy="3017520"/>
-          </a:xfrm>
-          <a:prstGeom prst="roundRect">
-            <a:avLst/>
-          </a:prstGeom>
-          <a:solidFill>
-            <a:srgbClr val="3B0764"/>
-          </a:solidFill>
-          <a:ln>
-            <a:noFill/>
-          </a:ln>
-        </p:spPr>
-        <p:style>
-          <a:lnRef idx="1">
-            <a:schemeClr val="accent1"/>
-          </a:lnRef>
-          <a:fillRef idx="3">
-            <a:schemeClr val="accent1"/>
-          </a:fillRef>
-          <a:effectRef idx="2">
-            <a:schemeClr val="accent1"/>
-          </a:effectRef>
-          <a:fontRef idx="minor">
-            <a:schemeClr val="lt1"/>
-          </a:fontRef>
-        </p:style>
-        <p:txBody>
-          <a:bodyPr rtlCol="0" anchor="ctr"/>
-          <a:lstStyle/>
-          <a:p>
-            <a:pPr algn="ctr"/>
-          </a:p>
-        </p:txBody>
-      </p:sp>
-      <p:sp>
-        <p:nvSpPr>
-          <p:cNvPr id="8" name="TextBox 7"/>
-          <p:cNvSpPr txBox="1"/>
-          <p:nvPr/>
-        </p:nvSpPr>
-        <p:spPr>
-          <a:xfrm>
-            <a:off x="6583680" y="3291840"/>
-            <a:ext cx="4023360" cy="2286000"/>
-          </a:xfrm>
-          <a:prstGeom prst="rect">
-            <a:avLst/>
-          </a:prstGeom>
-          <a:noFill/>
-        </p:spPr>
-        <p:txBody>
-          <a:bodyPr wrap="square" lIns="0" tIns="0" rIns="0" bIns="0">
-            <a:spAutoFit/>
-          </a:bodyPr>
-          <a:lstStyle/>
-          <a:p>
-            <a:pPr>
-              <a:spcAft>
-                <a:spcPts val="1200"/>
-              </a:spcAft>
-              <a:defRPr sz="1900" b="1">
-                <a:solidFill>
-                  <a:srgbClr val="E24BFF"/>
-                </a:solidFill>
-                <a:latin typeface="Manrope"/>
-              </a:defRPr>
-            </a:pPr>
-            <a:r>
-              <a:t>The Core Worker Value</a:t>
-            </a:r>
-          </a:p>
-          <a:p>
-            <a:pPr>
-              <a:defRPr sz="1400">
-                <a:solidFill>
-                  <a:srgbClr val="FFFFFF"/>
-                </a:solidFill>
-                <a:latin typeface="Manrope"/>
-              </a:defRPr>
-            </a:pPr>
-            <a:r>
-              <a:t>Critical thinking, skepticism, taste, and verification are the irreplaceable skills of future knowledge workers.</a:t>
+              <a:t>Moral and legal ownership can never be outsourced.</a:t>
             </a:r>
           </a:p>
         </p:txBody>
@@ -5989,8 +5904,8 @@
         </p:nvSpPr>
         <p:spPr>
           <a:xfrm>
-            <a:off x="1097280" y="822960"/>
-            <a:ext cx="9601200" cy="365760"/>
+            <a:off x="1188720" y="2011680"/>
+            <a:ext cx="9784080" cy="3657600"/>
           </a:xfrm>
           <a:prstGeom prst="rect">
             <a:avLst/>
@@ -5998,13 +5913,16 @@
           <a:noFill/>
         </p:spPr>
         <p:txBody>
-          <a:bodyPr wrap="none" lIns="0" tIns="0" rIns="0" bIns="0">
+          <a:bodyPr wrap="square" lIns="0" tIns="0" rIns="0" bIns="0">
             <a:spAutoFit/>
           </a:bodyPr>
           <a:lstStyle/>
           <a:p>
             <a:pPr>
-              <a:defRPr sz="1300" b="1">
+              <a:spcAft>
+                <a:spcPts val="1200"/>
+              </a:spcAft>
+              <a:defRPr sz="2200" b="1">
                 <a:solidFill>
                   <a:srgbClr val="FFD640"/>
                 </a:solidFill>
@@ -6012,38 +5930,15 @@
               </a:defRPr>
             </a:pPr>
             <a:r>
-              <a:t>01 / THE PROBLEM  •  PITCH PART 1</a:t>
-            </a:r>
-          </a:p>
-        </p:txBody>
-      </p:sp>
-      <p:sp>
-        <p:nvSpPr>
-          <p:cNvPr id="4" name="TextBox 3"/>
-          <p:cNvSpPr txBox="1"/>
-          <p:nvPr/>
-        </p:nvSpPr>
-        <p:spPr>
-          <a:xfrm>
-            <a:off x="1097280" y="1234440"/>
-            <a:ext cx="9875520" cy="1554480"/>
-          </a:xfrm>
-          <a:prstGeom prst="rect">
-            <a:avLst/>
-          </a:prstGeom>
-          <a:noFill/>
-        </p:spPr>
-        <p:txBody>
-          <a:bodyPr wrap="square" lIns="0" tIns="0" rIns="0" bIns="0">
-            <a:spAutoFit/>
-          </a:bodyPr>
-          <a:lstStyle/>
+              <a:t>The Problem</a:t>
+            </a:r>
+          </a:p>
           <a:p>
             <a:pPr>
               <a:spcAft>
-                <a:spcPts val="600"/>
+                <a:spcPts val="1400"/>
               </a:spcAft>
-              <a:defRPr sz="4000" b="1">
+              <a:defRPr sz="4800" b="1">
                 <a:solidFill>
                   <a:srgbClr val="FFFFFF"/>
                 </a:solidFill>
@@ -6056,7 +5951,7 @@
           </a:p>
           <a:p>
             <a:pPr>
-              <a:defRPr sz="1700">
+              <a:defRPr sz="2200" b="0">
                 <a:solidFill>
                   <a:srgbClr val="FFD640"/>
                 </a:solidFill>
@@ -6064,197 +5959,7 @@
               </a:defRPr>
             </a:pPr>
             <a:r>
-              <a:t>Table knives, kitchen counters, and sink washing. Breakfast away from home is broken.</a:t>
-            </a:r>
-          </a:p>
-        </p:txBody>
-      </p:sp>
-      <p:sp>
-        <p:nvSpPr>
-          <p:cNvPr id="5" name="Rounded Rectangle 4"/>
-          <p:cNvSpPr/>
-          <p:nvPr/>
-        </p:nvSpPr>
-        <p:spPr>
-          <a:xfrm>
-            <a:off x="1097280" y="2926080"/>
-            <a:ext cx="4754880" cy="3017520"/>
-          </a:xfrm>
-          <a:prstGeom prst="roundRect">
-            <a:avLst/>
-          </a:prstGeom>
-          <a:solidFill>
-            <a:srgbClr val="2D1D00"/>
-          </a:solidFill>
-          <a:ln>
-            <a:noFill/>
-          </a:ln>
-        </p:spPr>
-        <p:style>
-          <a:lnRef idx="1">
-            <a:schemeClr val="accent1"/>
-          </a:lnRef>
-          <a:fillRef idx="3">
-            <a:schemeClr val="accent1"/>
-          </a:fillRef>
-          <a:effectRef idx="2">
-            <a:schemeClr val="accent1"/>
-          </a:effectRef>
-          <a:fontRef idx="minor">
-            <a:schemeClr val="lt1"/>
-          </a:fontRef>
-        </p:style>
-        <p:txBody>
-          <a:bodyPr rtlCol="0" anchor="ctr"/>
-          <a:lstStyle/>
-          <a:p>
-            <a:pPr algn="ctr"/>
-          </a:p>
-        </p:txBody>
-      </p:sp>
-      <p:sp>
-        <p:nvSpPr>
-          <p:cNvPr id="6" name="TextBox 5"/>
-          <p:cNvSpPr txBox="1"/>
-          <p:nvPr/>
-        </p:nvSpPr>
-        <p:spPr>
-          <a:xfrm>
-            <a:off x="1463040" y="3291840"/>
-            <a:ext cx="4023360" cy="2286000"/>
-          </a:xfrm>
-          <a:prstGeom prst="rect">
-            <a:avLst/>
-          </a:prstGeom>
-          <a:noFill/>
-        </p:spPr>
-        <p:txBody>
-          <a:bodyPr wrap="square" lIns="0" tIns="0" rIns="0" bIns="0">
-            <a:spAutoFit/>
-          </a:bodyPr>
-          <a:lstStyle/>
-          <a:p>
-            <a:pPr>
-              <a:spcAft>
-                <a:spcPts val="1200"/>
-              </a:spcAft>
-              <a:defRPr sz="1900" b="1">
-                <a:solidFill>
-                  <a:srgbClr val="FFD640"/>
-                </a:solidFill>
-                <a:latin typeface="Manrope"/>
-              </a:defRPr>
-            </a:pPr>
-            <a:r>
-              <a:t>Cutlery Dependency</a:t>
-            </a:r>
-          </a:p>
-          <a:p>
-            <a:pPr>
-              <a:defRPr sz="1400">
-                <a:solidFill>
-                  <a:srgbClr val="FFFFFF"/>
-                </a:solidFill>
-                <a:latin typeface="Manrope"/>
-              </a:defRPr>
-            </a:pPr>
-            <a:r>
-              <a:t>Office breakrooms, university halls, and student flats lack clean table knives and preparation space.</a:t>
-            </a:r>
-          </a:p>
-        </p:txBody>
-      </p:sp>
-      <p:sp>
-        <p:nvSpPr>
-          <p:cNvPr id="7" name="Rounded Rectangle 6"/>
-          <p:cNvSpPr/>
-          <p:nvPr/>
-        </p:nvSpPr>
-        <p:spPr>
-          <a:xfrm>
-            <a:off x="6217920" y="2926080"/>
-            <a:ext cx="4754880" cy="3017520"/>
-          </a:xfrm>
-          <a:prstGeom prst="roundRect">
-            <a:avLst/>
-          </a:prstGeom>
-          <a:solidFill>
-            <a:srgbClr val="2D1D00"/>
-          </a:solidFill>
-          <a:ln>
-            <a:noFill/>
-          </a:ln>
-        </p:spPr>
-        <p:style>
-          <a:lnRef idx="1">
-            <a:schemeClr val="accent1"/>
-          </a:lnRef>
-          <a:fillRef idx="3">
-            <a:schemeClr val="accent1"/>
-          </a:fillRef>
-          <a:effectRef idx="2">
-            <a:schemeClr val="accent1"/>
-          </a:effectRef>
-          <a:fontRef idx="minor">
-            <a:schemeClr val="lt1"/>
-          </a:fontRef>
-        </p:style>
-        <p:txBody>
-          <a:bodyPr rtlCol="0" anchor="ctr"/>
-          <a:lstStyle/>
-          <a:p>
-            <a:pPr algn="ctr"/>
-          </a:p>
-        </p:txBody>
-      </p:sp>
-      <p:sp>
-        <p:nvSpPr>
-          <p:cNvPr id="8" name="TextBox 7"/>
-          <p:cNvSpPr txBox="1"/>
-          <p:nvPr/>
-        </p:nvSpPr>
-        <p:spPr>
-          <a:xfrm>
-            <a:off x="6583680" y="3291840"/>
-            <a:ext cx="4023360" cy="2286000"/>
-          </a:xfrm>
-          <a:prstGeom prst="rect">
-            <a:avLst/>
-          </a:prstGeom>
-          <a:noFill/>
-        </p:spPr>
-        <p:txBody>
-          <a:bodyPr wrap="square" lIns="0" tIns="0" rIns="0" bIns="0">
-            <a:spAutoFit/>
-          </a:bodyPr>
-          <a:lstStyle/>
-          <a:p>
-            <a:pPr>
-              <a:spcAft>
-                <a:spcPts val="1200"/>
-              </a:spcAft>
-              <a:defRPr sz="1900" b="1">
-                <a:solidFill>
-                  <a:srgbClr val="FFD640"/>
-                </a:solidFill>
-                <a:latin typeface="Manrope"/>
-              </a:defRPr>
-            </a:pPr>
-            <a:r>
-              <a:t>Stationary &amp; Bulky</a:t>
-            </a:r>
-          </a:p>
-          <a:p>
-            <a:pPr>
-              <a:defRPr sz="1400">
-                <a:solidFill>
-                  <a:srgbClr val="FFFFFF"/>
-                </a:solidFill>
-                <a:latin typeface="Manrope"/>
-              </a:defRPr>
-            </a:pPr>
-            <a:r>
-              <a:t>Heavy 750 g glass jars sit immobile in cupboards rather than travelling conveniently in work bags.</a:t>
+              <a:t>Table knives, kitchen counters, and sink washing.</a:t>
             </a:r>
           </a:p>
         </p:txBody>
@@ -6328,8 +6033,8 @@
         </p:nvSpPr>
         <p:spPr>
           <a:xfrm>
-            <a:off x="1097280" y="822960"/>
-            <a:ext cx="9601200" cy="365760"/>
+            <a:off x="1188720" y="2377440"/>
+            <a:ext cx="9784080" cy="3657600"/>
           </a:xfrm>
           <a:prstGeom prst="rect">
             <a:avLst/>
@@ -6337,13 +6042,32 @@
           <a:noFill/>
         </p:spPr>
         <p:txBody>
-          <a:bodyPr wrap="none" lIns="0" tIns="0" rIns="0" bIns="0">
+          <a:bodyPr wrap="square" lIns="0" tIns="0" rIns="0" bIns="0">
             <a:spAutoFit/>
           </a:bodyPr>
           <a:lstStyle/>
           <a:p>
             <a:pPr>
-              <a:defRPr sz="1300" b="1">
+              <a:spcAft>
+                <a:spcPts val="1200"/>
+              </a:spcAft>
+              <a:defRPr sz="4600" b="1">
+                <a:solidFill>
+                  <a:srgbClr val="FFFFFF"/>
+                </a:solidFill>
+                <a:latin typeface="Manrope"/>
+              </a:defRPr>
+            </a:pPr>
+            <a:r>
+              <a:t>Eating Away from Home is Broken.</a:t>
+            </a:r>
+          </a:p>
+          <a:p>
+            <a:pPr>
+              <a:spcAft>
+                <a:spcPts val="1400"/>
+              </a:spcAft>
+              <a:defRPr sz="2600" b="1">
                 <a:solidFill>
                   <a:srgbClr val="FFD640"/>
                 </a:solidFill>
@@ -6351,249 +6075,7 @@
               </a:defRPr>
             </a:pPr>
             <a:r>
-              <a:t>02 / THE SOLUTION  •  PITCH PART 1</a:t>
-            </a:r>
-          </a:p>
-        </p:txBody>
-      </p:sp>
-      <p:sp>
-        <p:nvSpPr>
-          <p:cNvPr id="4" name="TextBox 3"/>
-          <p:cNvSpPr txBox="1"/>
-          <p:nvPr/>
-        </p:nvSpPr>
-        <p:spPr>
-          <a:xfrm>
-            <a:off x="1097280" y="1234440"/>
-            <a:ext cx="9875520" cy="1554480"/>
-          </a:xfrm>
-          <a:prstGeom prst="rect">
-            <a:avLst/>
-          </a:prstGeom>
-          <a:noFill/>
-        </p:spPr>
-        <p:txBody>
-          <a:bodyPr wrap="square" lIns="0" tIns="0" rIns="0" bIns="0">
-            <a:spAutoFit/>
-          </a:bodyPr>
-          <a:lstStyle/>
-          <a:p>
-            <a:pPr>
-              <a:spcAft>
-                <a:spcPts val="600"/>
-              </a:spcAft>
-              <a:defRPr sz="4000" b="1">
-                <a:solidFill>
-                  <a:srgbClr val="FFFFFF"/>
-                </a:solidFill>
-                <a:latin typeface="Manrope"/>
-              </a:defRPr>
-            </a:pPr>
-            <a:r>
-              <a:t>10 g Spread Disc on Release Film.</a:t>
-            </a:r>
-          </a:p>
-          <a:p>
-            <a:pPr>
-              <a:defRPr sz="1700">
-                <a:solidFill>
-                  <a:srgbClr val="FFD640"/>
-                </a:solidFill>
-                <a:latin typeface="Manrope"/>
-              </a:defRPr>
-            </a:pPr>
-            <a:r>
-              <a:t>Peel it off. Press onto hot toast. Residual thermal energy softens it in seconds.</a:t>
-            </a:r>
-          </a:p>
-        </p:txBody>
-      </p:sp>
-      <p:sp>
-        <p:nvSpPr>
-          <p:cNvPr id="5" name="Rounded Rectangle 4"/>
-          <p:cNvSpPr/>
-          <p:nvPr/>
-        </p:nvSpPr>
-        <p:spPr>
-          <a:xfrm>
-            <a:off x="1097280" y="2926080"/>
-            <a:ext cx="4754880" cy="3017520"/>
-          </a:xfrm>
-          <a:prstGeom prst="roundRect">
-            <a:avLst/>
-          </a:prstGeom>
-          <a:solidFill>
-            <a:srgbClr val="2D1D00"/>
-          </a:solidFill>
-          <a:ln>
-            <a:noFill/>
-          </a:ln>
-        </p:spPr>
-        <p:style>
-          <a:lnRef idx="1">
-            <a:schemeClr val="accent1"/>
-          </a:lnRef>
-          <a:fillRef idx="3">
-            <a:schemeClr val="accent1"/>
-          </a:fillRef>
-          <a:effectRef idx="2">
-            <a:schemeClr val="accent1"/>
-          </a:effectRef>
-          <a:fontRef idx="minor">
-            <a:schemeClr val="lt1"/>
-          </a:fontRef>
-        </p:style>
-        <p:txBody>
-          <a:bodyPr rtlCol="0" anchor="ctr"/>
-          <a:lstStyle/>
-          <a:p>
-            <a:pPr algn="ctr"/>
-          </a:p>
-        </p:txBody>
-      </p:sp>
-      <p:sp>
-        <p:nvSpPr>
-          <p:cNvPr id="6" name="TextBox 5"/>
-          <p:cNvSpPr txBox="1"/>
-          <p:nvPr/>
-        </p:nvSpPr>
-        <p:spPr>
-          <a:xfrm>
-            <a:off x="1463040" y="3291840"/>
-            <a:ext cx="4023360" cy="2286000"/>
-          </a:xfrm>
-          <a:prstGeom prst="rect">
-            <a:avLst/>
-          </a:prstGeom>
-          <a:noFill/>
-        </p:spPr>
-        <p:txBody>
-          <a:bodyPr wrap="square" lIns="0" tIns="0" rIns="0" bIns="0">
-            <a:spAutoFit/>
-          </a:bodyPr>
-          <a:lstStyle/>
-          <a:p>
-            <a:pPr>
-              <a:spcAft>
-                <a:spcPts val="1200"/>
-              </a:spcAft>
-              <a:defRPr sz="1900" b="1">
-                <a:solidFill>
-                  <a:srgbClr val="FFD640"/>
-                </a:solidFill>
-                <a:latin typeface="Manrope"/>
-              </a:defRPr>
-            </a:pPr>
-            <a:r>
-              <a:t>Thermal Melt Gesture</a:t>
-            </a:r>
-          </a:p>
-          <a:p>
-            <a:pPr>
-              <a:defRPr sz="1400">
-                <a:solidFill>
-                  <a:srgbClr val="FFFFFF"/>
-                </a:solidFill>
-                <a:latin typeface="Manrope"/>
-              </a:defRPr>
-            </a:pPr>
-            <a:r>
-              <a:t>Residual heat from toasted bread softens the disc into an even, velvety layer with zero cutlery.</a:t>
-            </a:r>
-          </a:p>
-        </p:txBody>
-      </p:sp>
-      <p:sp>
-        <p:nvSpPr>
-          <p:cNvPr id="7" name="Rounded Rectangle 6"/>
-          <p:cNvSpPr/>
-          <p:nvPr/>
-        </p:nvSpPr>
-        <p:spPr>
-          <a:xfrm>
-            <a:off x="6217920" y="2926080"/>
-            <a:ext cx="4754880" cy="3017520"/>
-          </a:xfrm>
-          <a:prstGeom prst="roundRect">
-            <a:avLst/>
-          </a:prstGeom>
-          <a:solidFill>
-            <a:srgbClr val="2D1D00"/>
-          </a:solidFill>
-          <a:ln>
-            <a:noFill/>
-          </a:ln>
-        </p:spPr>
-        <p:style>
-          <a:lnRef idx="1">
-            <a:schemeClr val="accent1"/>
-          </a:lnRef>
-          <a:fillRef idx="3">
-            <a:schemeClr val="accent1"/>
-          </a:fillRef>
-          <a:effectRef idx="2">
-            <a:schemeClr val="accent1"/>
-          </a:effectRef>
-          <a:fontRef idx="minor">
-            <a:schemeClr val="lt1"/>
-          </a:fontRef>
-        </p:style>
-        <p:txBody>
-          <a:bodyPr rtlCol="0" anchor="ctr"/>
-          <a:lstStyle/>
-          <a:p>
-            <a:pPr algn="ctr"/>
-          </a:p>
-        </p:txBody>
-      </p:sp>
-      <p:sp>
-        <p:nvSpPr>
-          <p:cNvPr id="8" name="TextBox 7"/>
-          <p:cNvSpPr txBox="1"/>
-          <p:nvPr/>
-        </p:nvSpPr>
-        <p:spPr>
-          <a:xfrm>
-            <a:off x="6583680" y="3291840"/>
-            <a:ext cx="4023360" cy="2286000"/>
-          </a:xfrm>
-          <a:prstGeom prst="rect">
-            <a:avLst/>
-          </a:prstGeom>
-          <a:noFill/>
-        </p:spPr>
-        <p:txBody>
-          <a:bodyPr wrap="square" lIns="0" tIns="0" rIns="0" bIns="0">
-            <a:spAutoFit/>
-          </a:bodyPr>
-          <a:lstStyle/>
-          <a:p>
-            <a:pPr>
-              <a:spcAft>
-                <a:spcPts val="1200"/>
-              </a:spcAft>
-              <a:defRPr sz="1900" b="1">
-                <a:solidFill>
-                  <a:srgbClr val="FFD640"/>
-                </a:solidFill>
-                <a:latin typeface="Manrope"/>
-              </a:defRPr>
-            </a:pPr>
-            <a:r>
-              <a:t>Calibrated Portion Control</a:t>
-            </a:r>
-          </a:p>
-          <a:p>
-            <a:pPr>
-              <a:defRPr sz="1400">
-                <a:solidFill>
-                  <a:srgbClr val="FFFFFF"/>
-                </a:solidFill>
-                <a:latin typeface="Manrope"/>
-              </a:defRPr>
-            </a:pPr>
-            <a:r>
-              <a:t>Pre-portioned 10 g servings eliminate cross-contamination, messy sticky jars, and food waste.</a:t>
+              <a:t>Students in halls. Commuters. Desk workers.</a:t>
             </a:r>
           </a:p>
         </p:txBody>
@@ -6667,8 +6149,8 @@
         </p:nvSpPr>
         <p:spPr>
           <a:xfrm>
-            <a:off x="1097280" y="822960"/>
-            <a:ext cx="9601200" cy="365760"/>
+            <a:off x="1188720" y="2011680"/>
+            <a:ext cx="9784080" cy="3657600"/>
           </a:xfrm>
           <a:prstGeom prst="rect">
             <a:avLst/>
@@ -6676,13 +6158,16 @@
           <a:noFill/>
         </p:spPr>
         <p:txBody>
-          <a:bodyPr wrap="none" lIns="0" tIns="0" rIns="0" bIns="0">
+          <a:bodyPr wrap="square" lIns="0" tIns="0" rIns="0" bIns="0">
             <a:spAutoFit/>
           </a:bodyPr>
           <a:lstStyle/>
           <a:p>
             <a:pPr>
-              <a:defRPr sz="1300" b="1">
+              <a:spcAft>
+                <a:spcPts val="1200"/>
+              </a:spcAft>
+              <a:defRPr sz="2200" b="1">
                 <a:solidFill>
                   <a:srgbClr val="FFD640"/>
                 </a:solidFill>
@@ -6690,38 +6175,15 @@
               </a:defRPr>
             </a:pPr>
             <a:r>
-              <a:t>03 / THE FORMAT  •  PITCH PART 1</a:t>
-            </a:r>
-          </a:p>
-        </p:txBody>
-      </p:sp>
-      <p:sp>
-        <p:nvSpPr>
-          <p:cNvPr id="4" name="TextBox 3"/>
-          <p:cNvSpPr txBox="1"/>
-          <p:nvPr/>
-        </p:nvSpPr>
-        <p:spPr>
-          <a:xfrm>
-            <a:off x="1097280" y="1234440"/>
-            <a:ext cx="9875520" cy="1554480"/>
-          </a:xfrm>
-          <a:prstGeom prst="rect">
-            <a:avLst/>
-          </a:prstGeom>
-          <a:noFill/>
-        </p:spPr>
-        <p:txBody>
-          <a:bodyPr wrap="square" lIns="0" tIns="0" rIns="0" bIns="0">
-            <a:spAutoFit/>
-          </a:bodyPr>
-          <a:lstStyle/>
+              <a:t>The Solution</a:t>
+            </a:r>
+          </a:p>
           <a:p>
             <a:pPr>
               <a:spcAft>
-                <a:spcPts val="600"/>
+                <a:spcPts val="1400"/>
               </a:spcAft>
-              <a:defRPr sz="4000" b="1">
+              <a:defRPr sz="4800" b="1">
                 <a:solidFill>
                   <a:srgbClr val="FFFFFF"/>
                 </a:solidFill>
@@ -6729,12 +6191,12 @@
               </a:defRPr>
             </a:pPr>
             <a:r>
-              <a:t>12-Month Ambient Pantry Life.</a:t>
+              <a:t>10 g Spread Disc on Release Film.</a:t>
             </a:r>
           </a:p>
           <a:p>
             <a:pPr>
-              <a:defRPr sz="1700">
+              <a:defRPr sz="2200" b="0">
                 <a:solidFill>
                   <a:srgbClr val="FFD640"/>
                 </a:solidFill>
@@ -6742,27 +6204,45 @@
               </a:defRPr>
             </a:pPr>
             <a:r>
-              <a:t>Pocketable 8-stamp card sheets. Verified ambient stability with zero refrigeration.</a:t>
-            </a:r>
-          </a:p>
-        </p:txBody>
-      </p:sp>
-      <p:sp>
-        <p:nvSpPr>
-          <p:cNvPr id="5" name="Rounded Rectangle 4"/>
+              <a:t>Peel it off. Press onto hot toast.</a:t>
+            </a:r>
+          </a:p>
+        </p:txBody>
+      </p:sp>
+    </p:spTree>
+  </p:cSld>
+  <p:clrMapOvr>
+    <a:masterClrMapping/>
+  </p:clrMapOvr>
+</p:sld>
+</file>
+
+<file path=ppt/slides/slide5.xml><?xml version="1.0" encoding="utf-8"?>
+<p:sld xmlns:a="http://schemas.openxmlformats.org/drawingml/2006/main" xmlns:p="http://schemas.openxmlformats.org/presentationml/2006/main" xmlns:r="http://schemas.openxmlformats.org/officeDocument/2006/relationships">
+  <p:cSld>
+    <p:spTree>
+      <p:nvGrpSpPr>
+        <p:cNvPr id="1" name=""/>
+        <p:cNvGrpSpPr/>
+        <p:nvPr/>
+      </p:nvGrpSpPr>
+      <p:grpSpPr/>
+      <p:sp>
+        <p:nvSpPr>
+          <p:cNvPr id="2" name="Rectangle 1"/>
           <p:cNvSpPr/>
           <p:nvPr/>
         </p:nvSpPr>
         <p:spPr>
           <a:xfrm>
-            <a:off x="1097280" y="2926080"/>
-            <a:ext cx="4754880" cy="3017520"/>
+            <a:off x="0" y="0"/>
+            <a:ext cx="12191695" cy="6858000"/>
           </a:xfrm>
-          <a:prstGeom prst="roundRect">
+          <a:prstGeom prst="rect">
             <a:avLst/>
           </a:prstGeom>
           <a:solidFill>
-            <a:srgbClr val="2D1D00"/>
+            <a:srgbClr val="4A3000"/>
           </a:solidFill>
           <a:ln>
             <a:noFill/>
@@ -6792,14 +6272,14 @@
       </p:sp>
       <p:sp>
         <p:nvSpPr>
-          <p:cNvPr id="6" name="TextBox 5"/>
+          <p:cNvPr id="3" name="TextBox 2"/>
           <p:cNvSpPr txBox="1"/>
           <p:nvPr/>
         </p:nvSpPr>
         <p:spPr>
           <a:xfrm>
-            <a:off x="1463040" y="3291840"/>
-            <a:ext cx="4023360" cy="2286000"/>
+            <a:off x="1188720" y="2377440"/>
+            <a:ext cx="9784080" cy="3657600"/>
           </a:xfrm>
           <a:prstGeom prst="rect">
             <a:avLst/>
@@ -6816,7 +6296,23 @@
               <a:spcAft>
                 <a:spcPts val="1200"/>
               </a:spcAft>
-              <a:defRPr sz="1900" b="1">
+              <a:defRPr sz="4800" b="1">
+                <a:solidFill>
+                  <a:srgbClr val="FFFFFF"/>
+                </a:solidFill>
+                <a:latin typeface="Manrope"/>
+              </a:defRPr>
+            </a:pPr>
+            <a:r>
+              <a:t>Zero Cutlery Needed.</a:t>
+            </a:r>
+          </a:p>
+          <a:p>
+            <a:pPr>
+              <a:spcAft>
+                <a:spcPts val="1400"/>
+              </a:spcAft>
+              <a:defRPr sz="2400" b="1">
                 <a:solidFill>
                   <a:srgbClr val="FFD640"/>
                 </a:solidFill>
@@ -6824,40 +6320,45 @@
               </a:defRPr>
             </a:pPr>
             <a:r>
-              <a:t>Continuous Deposit Packaging</a:t>
-            </a:r>
-          </a:p>
-          <a:p>
-            <a:pPr>
-              <a:defRPr sz="1400">
-                <a:solidFill>
-                  <a:srgbClr val="FFFFFF"/>
-                </a:solidFill>
-                <a:latin typeface="Manrope"/>
-              </a:defRPr>
-            </a:pPr>
-            <a:r>
-              <a:t>Hermetically sealed card sheets protect against moisture and air, maintaining 12-month ambient shelf life.</a:t>
-            </a:r>
-          </a:p>
-        </p:txBody>
-      </p:sp>
-      <p:sp>
-        <p:nvSpPr>
-          <p:cNvPr id="7" name="Rounded Rectangle 6"/>
+              <a:t>Residual heat melts it across the crumb in seconds.</a:t>
+            </a:r>
+          </a:p>
+        </p:txBody>
+      </p:sp>
+    </p:spTree>
+  </p:cSld>
+  <p:clrMapOvr>
+    <a:masterClrMapping/>
+  </p:clrMapOvr>
+</p:sld>
+</file>
+
+<file path=ppt/slides/slide6.xml><?xml version="1.0" encoding="utf-8"?>
+<p:sld xmlns:a="http://schemas.openxmlformats.org/drawingml/2006/main" xmlns:p="http://schemas.openxmlformats.org/presentationml/2006/main" xmlns:r="http://schemas.openxmlformats.org/officeDocument/2006/relationships">
+  <p:cSld>
+    <p:spTree>
+      <p:nvGrpSpPr>
+        <p:cNvPr id="1" name=""/>
+        <p:cNvGrpSpPr/>
+        <p:nvPr/>
+      </p:nvGrpSpPr>
+      <p:grpSpPr/>
+      <p:sp>
+        <p:nvSpPr>
+          <p:cNvPr id="2" name="Rectangle 1"/>
           <p:cNvSpPr/>
           <p:nvPr/>
         </p:nvSpPr>
         <p:spPr>
           <a:xfrm>
-            <a:off x="6217920" y="2926080"/>
-            <a:ext cx="4754880" cy="3017520"/>
+            <a:off x="0" y="0"/>
+            <a:ext cx="12191695" cy="6858000"/>
           </a:xfrm>
-          <a:prstGeom prst="roundRect">
+          <a:prstGeom prst="rect">
             <a:avLst/>
           </a:prstGeom>
           <a:solidFill>
-            <a:srgbClr val="2D1D00"/>
+            <a:srgbClr val="4A3000"/>
           </a:solidFill>
           <a:ln>
             <a:noFill/>
@@ -6887,14 +6388,14 @@
       </p:sp>
       <p:sp>
         <p:nvSpPr>
-          <p:cNvPr id="8" name="TextBox 7"/>
+          <p:cNvPr id="3" name="TextBox 2"/>
           <p:cNvSpPr txBox="1"/>
           <p:nvPr/>
         </p:nvSpPr>
         <p:spPr>
           <a:xfrm>
-            <a:off x="6583680" y="3291840"/>
-            <a:ext cx="4023360" cy="2286000"/>
+            <a:off x="1188720" y="2377440"/>
+            <a:ext cx="9784080" cy="3657600"/>
           </a:xfrm>
           <a:prstGeom prst="rect">
             <a:avLst/>
@@ -6911,7 +6412,23 @@
               <a:spcAft>
                 <a:spcPts val="1200"/>
               </a:spcAft>
-              <a:defRPr sz="1900" b="1">
+              <a:defRPr sz="4800" b="1">
+                <a:solidFill>
+                  <a:srgbClr val="FFFFFF"/>
+                </a:solidFill>
+                <a:latin typeface="Manrope"/>
+              </a:defRPr>
+            </a:pPr>
+            <a:r>
+              <a:t>12-Month Ambient Life.</a:t>
+            </a:r>
+          </a:p>
+          <a:p>
+            <a:pPr>
+              <a:spcAft>
+                <a:spcPts val="1400"/>
+              </a:spcAft>
+              <a:defRPr sz="2400" b="1">
                 <a:solidFill>
                   <a:srgbClr val="FFD640"/>
                 </a:solidFill>
@@ -6919,20 +6436,7 @@
               </a:defRPr>
             </a:pPr>
             <a:r>
-              <a:t>Four Launch Varieties</a:t>
-            </a:r>
-          </a:p>
-          <a:p>
-            <a:pPr>
-              <a:defRPr sz="1400">
-                <a:solidFill>
-                  <a:srgbClr val="FFFFFF"/>
-                </a:solidFill>
-                <a:latin typeface="Manrope"/>
-              </a:defRPr>
-            </a:pPr>
-            <a:r>
-              <a:t>Salted Butter, Wild Raspberry whole fruit paste, Savoury Yeast extract, and Roasted Peanut.</a:t>
+              <a:t>Salted Butter. Raspberry. Yeast. Peanut.</a:t>
             </a:r>
           </a:p>
         </p:txBody>
@@ -6945,7 +6449,7 @@
 </p:sld>
 </file>
 
-<file path=ppt/slides/slide5.xml><?xml version="1.0" encoding="utf-8"?>
+<file path=ppt/slides/slide7.xml><?xml version="1.0" encoding="utf-8"?>
 <p:sld xmlns:a="http://schemas.openxmlformats.org/drawingml/2006/main" xmlns:p="http://schemas.openxmlformats.org/presentationml/2006/main" xmlns:r="http://schemas.openxmlformats.org/officeDocument/2006/relationships">
   <p:cSld>
     <p:spTree>
@@ -7006,8 +6510,8 @@
         </p:nvSpPr>
         <p:spPr>
           <a:xfrm>
-            <a:off x="1097280" y="914400"/>
-            <a:ext cx="9601200" cy="365760"/>
+            <a:off x="1188720" y="1645920"/>
+            <a:ext cx="9784080" cy="3840480"/>
           </a:xfrm>
           <a:prstGeom prst="rect">
             <a:avLst/>
@@ -7015,13 +6519,16 @@
           <a:noFill/>
         </p:spPr>
         <p:txBody>
-          <a:bodyPr wrap="none" lIns="0" tIns="0" rIns="0" bIns="0">
+          <a:bodyPr wrap="square" lIns="0" tIns="0" rIns="0" bIns="0">
             <a:spAutoFit/>
           </a:bodyPr>
           <a:lstStyle/>
           <a:p>
             <a:pPr>
-              <a:defRPr sz="1300" b="1">
+              <a:spcAft>
+                <a:spcPts val="1000"/>
+              </a:spcAft>
+              <a:defRPr sz="8000" b="1">
                 <a:solidFill>
                   <a:srgbClr val="FF467A"/>
                 </a:solidFill>
@@ -7029,81 +6536,28 @@
               </a:defRPr>
             </a:pPr>
             <a:r>
-              <a:t>04 / MARKET SCALE  •  PITCH PART 2</a:t>
-            </a:r>
-          </a:p>
-        </p:txBody>
-      </p:sp>
-      <p:sp>
-        <p:nvSpPr>
-          <p:cNvPr id="4" name="Rounded Rectangle 3"/>
-          <p:cNvSpPr/>
-          <p:nvPr/>
-        </p:nvSpPr>
-        <p:spPr>
-          <a:xfrm>
-            <a:off x="1097280" y="1645920"/>
-            <a:ext cx="9875520" cy="4297680"/>
-          </a:xfrm>
-          <a:prstGeom prst="roundRect">
-            <a:avLst/>
-          </a:prstGeom>
-          <a:solidFill>
-            <a:srgbClr val="2D0414"/>
-          </a:solidFill>
-          <a:ln>
-            <a:noFill/>
-          </a:ln>
-        </p:spPr>
-        <p:style>
-          <a:lnRef idx="1">
-            <a:schemeClr val="accent1"/>
-          </a:lnRef>
-          <a:fillRef idx="3">
-            <a:schemeClr val="accent1"/>
-          </a:fillRef>
-          <a:effectRef idx="2">
-            <a:schemeClr val="accent1"/>
-          </a:effectRef>
-          <a:fontRef idx="minor">
-            <a:schemeClr val="lt1"/>
-          </a:fontRef>
-        </p:style>
-        <p:txBody>
-          <a:bodyPr rtlCol="0" anchor="ctr"/>
-          <a:lstStyle/>
-          <a:p>
-            <a:pPr algn="ctr"/>
-          </a:p>
-        </p:txBody>
-      </p:sp>
-      <p:sp>
-        <p:nvSpPr>
-          <p:cNvPr id="5" name="TextBox 4"/>
-          <p:cNvSpPr txBox="1"/>
-          <p:nvPr/>
-        </p:nvSpPr>
-        <p:spPr>
-          <a:xfrm>
-            <a:off x="1645920" y="2194560"/>
-            <a:ext cx="8778240" cy="3200400"/>
-          </a:xfrm>
-          <a:prstGeom prst="rect">
-            <a:avLst/>
-          </a:prstGeom>
-          <a:noFill/>
-        </p:spPr>
-        <p:txBody>
-          <a:bodyPr wrap="square" lIns="0" tIns="0" rIns="0" bIns="0">
-            <a:spAutoFit/>
-          </a:bodyPr>
-          <a:lstStyle/>
+              <a:t>$341M</a:t>
+            </a:r>
+          </a:p>
           <a:p>
             <a:pPr>
               <a:spcAft>
-                <a:spcPts val="800"/>
+                <a:spcPts val="1200"/>
               </a:spcAft>
-              <a:defRPr sz="7200" b="1">
+              <a:defRPr sz="4000" b="1">
+                <a:solidFill>
+                  <a:srgbClr val="FFFFFF"/>
+                </a:solidFill>
+                <a:latin typeface="Manrope"/>
+              </a:defRPr>
+            </a:pPr>
+            <a:r>
+              <a:t>New Zealand Spreads Category.</a:t>
+            </a:r>
+          </a:p>
+          <a:p>
+            <a:pPr>
+              <a:defRPr sz="2200" b="0">
                 <a:solidFill>
                   <a:srgbClr val="FF467A"/>
                 </a:solidFill>
@@ -7111,36 +6565,7 @@
               </a:defRPr>
             </a:pPr>
             <a:r>
-              <a:t>$341M</a:t>
-            </a:r>
-          </a:p>
-          <a:p>
-            <a:pPr>
-              <a:spcAft>
-                <a:spcPts val="1200"/>
-              </a:spcAft>
-              <a:defRPr sz="2800" b="1">
-                <a:solidFill>
-                  <a:srgbClr val="FFFFFF"/>
-                </a:solidFill>
-                <a:latin typeface="Manrope"/>
-              </a:defRPr>
-            </a:pPr>
-            <a:r>
-              <a:t>New Zealand Spreads Category.</a:t>
-            </a:r>
-          </a:p>
-          <a:p>
-            <a:pPr>
-              <a:defRPr sz="1600">
-                <a:solidFill>
-                  <a:srgbClr val="FF467A"/>
-                </a:solidFill>
-                <a:latin typeface="Manrope"/>
-              </a:defRPr>
-            </a:pPr>
-            <a:r>
-              <a:t>+24% category revenue growth (2022–2025). Premium branded spreads surged +29% to $113M NZD.</a:t>
+              <a:t>+24% category revenue growth (2022–2025).</a:t>
             </a:r>
           </a:p>
         </p:txBody>
@@ -7153,7 +6578,7 @@
 </p:sld>
 </file>
 
-<file path=ppt/slides/slide6.xml><?xml version="1.0" encoding="utf-8"?>
+<file path=ppt/slides/slide8.xml><?xml version="1.0" encoding="utf-8"?>
 <p:sld xmlns:a="http://schemas.openxmlformats.org/drawingml/2006/main" xmlns:p="http://schemas.openxmlformats.org/presentationml/2006/main" xmlns:r="http://schemas.openxmlformats.org/officeDocument/2006/relationships">
   <p:cSld>
     <p:spTree>
@@ -7214,8 +6639,8 @@
         </p:nvSpPr>
         <p:spPr>
           <a:xfrm>
-            <a:off x="1097280" y="914400"/>
-            <a:ext cx="9601200" cy="365760"/>
+            <a:off x="1188720" y="1645920"/>
+            <a:ext cx="9784080" cy="3840480"/>
           </a:xfrm>
           <a:prstGeom prst="rect">
             <a:avLst/>
@@ -7223,13 +6648,16 @@
           <a:noFill/>
         </p:spPr>
         <p:txBody>
-          <a:bodyPr wrap="none" lIns="0" tIns="0" rIns="0" bIns="0">
+          <a:bodyPr wrap="square" lIns="0" tIns="0" rIns="0" bIns="0">
             <a:spAutoFit/>
           </a:bodyPr>
           <a:lstStyle/>
           <a:p>
             <a:pPr>
-              <a:defRPr sz="1300" b="1">
+              <a:spcAft>
+                <a:spcPts val="1000"/>
+              </a:spcAft>
+              <a:defRPr sz="8000" b="1">
                 <a:solidFill>
                   <a:srgbClr val="FF467A"/>
                 </a:solidFill>
@@ -7237,81 +6665,28 @@
               </a:defRPr>
             </a:pPr>
             <a:r>
-              <a:t>05 / COMPETITIVE VOID  •  PITCH PART 2</a:t>
-            </a:r>
-          </a:p>
-        </p:txBody>
-      </p:sp>
-      <p:sp>
-        <p:nvSpPr>
-          <p:cNvPr id="4" name="Rounded Rectangle 3"/>
-          <p:cNvSpPr/>
-          <p:nvPr/>
-        </p:nvSpPr>
-        <p:spPr>
-          <a:xfrm>
-            <a:off x="1097280" y="1645920"/>
-            <a:ext cx="9875520" cy="4297680"/>
-          </a:xfrm>
-          <a:prstGeom prst="roundRect">
-            <a:avLst/>
-          </a:prstGeom>
-          <a:solidFill>
-            <a:srgbClr val="2D0414"/>
-          </a:solidFill>
-          <a:ln>
-            <a:noFill/>
-          </a:ln>
-        </p:spPr>
-        <p:style>
-          <a:lnRef idx="1">
-            <a:schemeClr val="accent1"/>
-          </a:lnRef>
-          <a:fillRef idx="3">
-            <a:schemeClr val="accent1"/>
-          </a:fillRef>
-          <a:effectRef idx="2">
-            <a:schemeClr val="accent1"/>
-          </a:effectRef>
-          <a:fontRef idx="minor">
-            <a:schemeClr val="lt1"/>
-          </a:fontRef>
-        </p:style>
-        <p:txBody>
-          <a:bodyPr rtlCol="0" anchor="ctr"/>
-          <a:lstStyle/>
-          <a:p>
-            <a:pPr algn="ctr"/>
-          </a:p>
-        </p:txBody>
-      </p:sp>
-      <p:sp>
-        <p:nvSpPr>
-          <p:cNvPr id="5" name="TextBox 4"/>
-          <p:cNvSpPr txBox="1"/>
-          <p:nvPr/>
-        </p:nvSpPr>
-        <p:spPr>
-          <a:xfrm>
-            <a:off x="1645920" y="2194560"/>
-            <a:ext cx="8778240" cy="3200400"/>
-          </a:xfrm>
-          <a:prstGeom prst="rect">
-            <a:avLst/>
-          </a:prstGeom>
-          <a:noFill/>
-        </p:spPr>
-        <p:txBody>
-          <a:bodyPr wrap="square" lIns="0" tIns="0" rIns="0" bIns="0">
-            <a:spAutoFit/>
-          </a:bodyPr>
-          <a:lstStyle/>
+              <a:t>+29%</a:t>
+            </a:r>
+          </a:p>
           <a:p>
             <a:pPr>
               <a:spcAft>
-                <a:spcPts val="800"/>
+                <a:spcPts val="1200"/>
               </a:spcAft>
-              <a:defRPr sz="7200" b="1">
+              <a:defRPr sz="4000" b="1">
+                <a:solidFill>
+                  <a:srgbClr val="FFFFFF"/>
+                </a:solidFill>
+                <a:latin typeface="Manrope"/>
+              </a:defRPr>
+            </a:pPr>
+            <a:r>
+              <a:t>Premium Tier Surging.</a:t>
+            </a:r>
+          </a:p>
+          <a:p>
+            <a:pPr>
+              <a:defRPr sz="2200" b="0">
                 <a:solidFill>
                   <a:srgbClr val="FF467A"/>
                 </a:solidFill>
@@ -7319,36 +6694,7 @@
               </a:defRPr>
             </a:pPr>
             <a:r>
-              <a:t>0 Rivals</a:t>
-            </a:r>
-          </a:p>
-          <a:p>
-            <a:pPr>
-              <a:spcAft>
-                <a:spcPts val="1200"/>
-              </a:spcAft>
-              <a:defRPr sz="2800" b="1">
-                <a:solidFill>
-                  <a:srgbClr val="FFFFFF"/>
-                </a:solidFill>
-                <a:latin typeface="Manrope"/>
-              </a:defRPr>
-            </a:pPr>
-            <a:r>
-              <a:t>Across 154 Supermarket Spreads.</a:t>
-            </a:r>
-          </a:p>
-          <a:p>
-            <a:pPr>
-              <a:defRPr sz="1600">
-                <a:solidFill>
-                  <a:srgbClr val="FF467A"/>
-                </a:solidFill>
-                <a:latin typeface="Manrope"/>
-              </a:defRPr>
-            </a:pPr>
-            <a:r>
-              <a:t>Not a single brand offers a utensil-free single-serve format. Jars compete on bulk weight; Stamp wins on convenience.</a:t>
+              <a:t>Expanding from $88M to $113M NZD.</a:t>
             </a:r>
           </a:p>
         </p:txBody>
@@ -7361,7 +6707,7 @@
 </p:sld>
 </file>
 
-<file path=ppt/slides/slide7.xml><?xml version="1.0" encoding="utf-8"?>
+<file path=ppt/slides/slide9.xml><?xml version="1.0" encoding="utf-8"?>
 <p:sld xmlns:a="http://schemas.openxmlformats.org/drawingml/2006/main" xmlns:p="http://schemas.openxmlformats.org/presentationml/2006/main" xmlns:r="http://schemas.openxmlformats.org/officeDocument/2006/relationships">
   <p:cSld>
     <p:spTree>
@@ -7422,8 +6768,8 @@
         </p:nvSpPr>
         <p:spPr>
           <a:xfrm>
-            <a:off x="1097280" y="914400"/>
-            <a:ext cx="9601200" cy="365760"/>
+            <a:off x="1188720" y="1645920"/>
+            <a:ext cx="9784080" cy="3840480"/>
           </a:xfrm>
           <a:prstGeom prst="rect">
             <a:avLst/>
@@ -7431,13 +6777,16 @@
           <a:noFill/>
         </p:spPr>
         <p:txBody>
-          <a:bodyPr wrap="none" lIns="0" tIns="0" rIns="0" bIns="0">
+          <a:bodyPr wrap="square" lIns="0" tIns="0" rIns="0" bIns="0">
             <a:spAutoFit/>
           </a:bodyPr>
           <a:lstStyle/>
           <a:p>
             <a:pPr>
-              <a:defRPr sz="1300" b="1">
+              <a:spcAft>
+                <a:spcPts val="1000"/>
+              </a:spcAft>
+              <a:defRPr sz="8000" b="1">
                 <a:solidFill>
                   <a:srgbClr val="FF467A"/>
                 </a:solidFill>
@@ -7445,244 +6794,13 @@
               </a:defRPr>
             </a:pPr>
             <a:r>
-              <a:t>06 / UNIT ECONOMICS  •  PITCH PART 2</a:t>
-            </a:r>
-          </a:p>
-        </p:txBody>
-      </p:sp>
-      <p:sp>
-        <p:nvSpPr>
-          <p:cNvPr id="4" name="Rounded Rectangle 3"/>
-          <p:cNvSpPr/>
-          <p:nvPr/>
-        </p:nvSpPr>
-        <p:spPr>
-          <a:xfrm>
-            <a:off x="1097280" y="1645920"/>
-            <a:ext cx="9875520" cy="4297680"/>
-          </a:xfrm>
-          <a:prstGeom prst="roundRect">
-            <a:avLst/>
-          </a:prstGeom>
-          <a:solidFill>
-            <a:srgbClr val="2D0414"/>
-          </a:solidFill>
-          <a:ln>
-            <a:noFill/>
-          </a:ln>
-        </p:spPr>
-        <p:style>
-          <a:lnRef idx="1">
-            <a:schemeClr val="accent1"/>
-          </a:lnRef>
-          <a:fillRef idx="3">
-            <a:schemeClr val="accent1"/>
-          </a:fillRef>
-          <a:effectRef idx="2">
-            <a:schemeClr val="accent1"/>
-          </a:effectRef>
-          <a:fontRef idx="minor">
-            <a:schemeClr val="lt1"/>
-          </a:fontRef>
-        </p:style>
-        <p:txBody>
-          <a:bodyPr rtlCol="0" anchor="ctr"/>
-          <a:lstStyle/>
-          <a:p>
-            <a:pPr algn="ctr"/>
-          </a:p>
-        </p:txBody>
-      </p:sp>
-      <p:sp>
-        <p:nvSpPr>
-          <p:cNvPr id="5" name="TextBox 4"/>
-          <p:cNvSpPr txBox="1"/>
-          <p:nvPr/>
-        </p:nvSpPr>
-        <p:spPr>
-          <a:xfrm>
-            <a:off x="1645920" y="2194560"/>
-            <a:ext cx="8778240" cy="3200400"/>
-          </a:xfrm>
-          <a:prstGeom prst="rect">
-            <a:avLst/>
-          </a:prstGeom>
-          <a:noFill/>
-        </p:spPr>
-        <p:txBody>
-          <a:bodyPr wrap="square" lIns="0" tIns="0" rIns="0" bIns="0">
-            <a:spAutoFit/>
-          </a:bodyPr>
-          <a:lstStyle/>
-          <a:p>
-            <a:pPr>
-              <a:spcAft>
-                <a:spcPts val="800"/>
-              </a:spcAft>
-              <a:defRPr sz="7200" b="1">
-                <a:solidFill>
-                  <a:srgbClr val="FF467A"/>
-                </a:solidFill>
-                <a:latin typeface="Manrope"/>
-              </a:defRPr>
-            </a:pPr>
-            <a:r>
-              <a:t>$1.75 Margin</a:t>
+              <a:t>0 Rivals</a:t>
             </a:r>
           </a:p>
           <a:p>
             <a:pPr>
               <a:spcAft>
                 <a:spcPts val="1200"/>
-              </a:spcAft>
-              <a:defRPr sz="2800" b="1">
-                <a:solidFill>
-                  <a:srgbClr val="FFFFFF"/>
-                </a:solidFill>
-                <a:latin typeface="Manrope"/>
-              </a:defRPr>
-            </a:pPr>
-            <a:r>
-              <a:t>$5.00 NZD per 8-Stamp Sheet.</a:t>
-            </a:r>
-          </a:p>
-          <a:p>
-            <a:pPr>
-              <a:defRPr sz="1600">
-                <a:solidFill>
-                  <a:srgbClr val="FF467A"/>
-                </a:solidFill>
-                <a:latin typeface="Manrope"/>
-              </a:defRPr>
-            </a:pPr>
-            <a:r>
-              <a:t>Just 63¢ per toast serving. At an assumed $1.50 contract manufacturing cost and 35% retail margin, Stamp captures $1.75 contribution.</a:t>
-            </a:r>
-          </a:p>
-        </p:txBody>
-      </p:sp>
-    </p:spTree>
-  </p:cSld>
-  <p:clrMapOvr>
-    <a:masterClrMapping/>
-  </p:clrMapOvr>
-</p:sld>
-</file>
-
-<file path=ppt/slides/slide8.xml><?xml version="1.0" encoding="utf-8"?>
-<p:sld xmlns:a="http://schemas.openxmlformats.org/drawingml/2006/main" xmlns:p="http://schemas.openxmlformats.org/presentationml/2006/main" xmlns:r="http://schemas.openxmlformats.org/officeDocument/2006/relationships">
-  <p:cSld>
-    <p:spTree>
-      <p:nvGrpSpPr>
-        <p:cNvPr id="1" name=""/>
-        <p:cNvGrpSpPr/>
-        <p:nvPr/>
-      </p:nvGrpSpPr>
-      <p:grpSpPr/>
-      <p:sp>
-        <p:nvSpPr>
-          <p:cNvPr id="2" name="Rectangle 1"/>
-          <p:cNvSpPr/>
-          <p:nvPr/>
-        </p:nvSpPr>
-        <p:spPr>
-          <a:xfrm>
-            <a:off x="0" y="0"/>
-            <a:ext cx="12191695" cy="6858000"/>
-          </a:xfrm>
-          <a:prstGeom prst="rect">
-            <a:avLst/>
-          </a:prstGeom>
-          <a:solidFill>
-            <a:srgbClr val="4E2408"/>
-          </a:solidFill>
-          <a:ln>
-            <a:noFill/>
-          </a:ln>
-        </p:spPr>
-        <p:style>
-          <a:lnRef idx="1">
-            <a:schemeClr val="accent1"/>
-          </a:lnRef>
-          <a:fillRef idx="3">
-            <a:schemeClr val="accent1"/>
-          </a:fillRef>
-          <a:effectRef idx="2">
-            <a:schemeClr val="accent1"/>
-          </a:effectRef>
-          <a:fontRef idx="minor">
-            <a:schemeClr val="lt1"/>
-          </a:fontRef>
-        </p:style>
-        <p:txBody>
-          <a:bodyPr rtlCol="0" anchor="ctr"/>
-          <a:lstStyle/>
-          <a:p>
-            <a:pPr algn="ctr"/>
-          </a:p>
-        </p:txBody>
-      </p:sp>
-      <p:sp>
-        <p:nvSpPr>
-          <p:cNvPr id="3" name="TextBox 2"/>
-          <p:cNvSpPr txBox="1"/>
-          <p:nvPr/>
-        </p:nvSpPr>
-        <p:spPr>
-          <a:xfrm>
-            <a:off x="1097280" y="822960"/>
-            <a:ext cx="9601200" cy="365760"/>
-          </a:xfrm>
-          <a:prstGeom prst="rect">
-            <a:avLst/>
-          </a:prstGeom>
-          <a:noFill/>
-        </p:spPr>
-        <p:txBody>
-          <a:bodyPr wrap="none" lIns="0" tIns="0" rIns="0" bIns="0">
-            <a:spAutoFit/>
-          </a:bodyPr>
-          <a:lstStyle/>
-          <a:p>
-            <a:pPr>
-              <a:defRPr sz="1300" b="1">
-                <a:solidFill>
-                  <a:srgbClr val="FF8C30"/>
-                </a:solidFill>
-                <a:latin typeface="Manrope"/>
-              </a:defRPr>
-            </a:pPr>
-            <a:r>
-              <a:t>07 / REFLECTION  •  CONTEXT STEERING</a:t>
-            </a:r>
-          </a:p>
-        </p:txBody>
-      </p:sp>
-      <p:sp>
-        <p:nvSpPr>
-          <p:cNvPr id="4" name="TextBox 3"/>
-          <p:cNvSpPr txBox="1"/>
-          <p:nvPr/>
-        </p:nvSpPr>
-        <p:spPr>
-          <a:xfrm>
-            <a:off x="1097280" y="1234440"/>
-            <a:ext cx="9875520" cy="1554480"/>
-          </a:xfrm>
-          <a:prstGeom prst="rect">
-            <a:avLst/>
-          </a:prstGeom>
-          <a:noFill/>
-        </p:spPr>
-        <p:txBody>
-          <a:bodyPr wrap="square" lIns="0" tIns="0" rIns="0" bIns="0">
-            <a:spAutoFit/>
-          </a:bodyPr>
-          <a:lstStyle/>
-          <a:p>
-            <a:pPr>
-              <a:spcAft>
-                <a:spcPts val="600"/>
               </a:spcAft>
               <a:defRPr sz="4000" b="1">
                 <a:solidFill>
@@ -7692,549 +6810,20 @@
               </a:defRPr>
             </a:pPr>
             <a:r>
-              <a:t>Strict Negative Constraints.</a:t>
+              <a:t>Across 154 Supermarket Spreads.</a:t>
             </a:r>
           </a:p>
           <a:p>
             <a:pPr>
-              <a:defRPr sz="1700">
+              <a:defRPr sz="2200" b="0">
                 <a:solidFill>
-                  <a:srgbClr val="FF8C30"/>
+                  <a:srgbClr val="FF467A"/>
                 </a:solidFill>
                 <a:latin typeface="Manrope"/>
               </a:defRPr>
             </a:pPr>
             <a:r>
-              <a:t>Banning hallucinated health claims and partitioning sessions to prevent context drift.</a:t>
-            </a:r>
-          </a:p>
-        </p:txBody>
-      </p:sp>
-      <p:sp>
-        <p:nvSpPr>
-          <p:cNvPr id="5" name="Rounded Rectangle 4"/>
-          <p:cNvSpPr/>
-          <p:nvPr/>
-        </p:nvSpPr>
-        <p:spPr>
-          <a:xfrm>
-            <a:off x="1097280" y="2926080"/>
-            <a:ext cx="4754880" cy="3017520"/>
-          </a:xfrm>
-          <a:prstGeom prst="roundRect">
-            <a:avLst/>
-          </a:prstGeom>
-          <a:solidFill>
-            <a:srgbClr val="2D1403"/>
-          </a:solidFill>
-          <a:ln>
-            <a:noFill/>
-          </a:ln>
-        </p:spPr>
-        <p:style>
-          <a:lnRef idx="1">
-            <a:schemeClr val="accent1"/>
-          </a:lnRef>
-          <a:fillRef idx="3">
-            <a:schemeClr val="accent1"/>
-          </a:fillRef>
-          <a:effectRef idx="2">
-            <a:schemeClr val="accent1"/>
-          </a:effectRef>
-          <a:fontRef idx="minor">
-            <a:schemeClr val="lt1"/>
-          </a:fontRef>
-        </p:style>
-        <p:txBody>
-          <a:bodyPr rtlCol="0" anchor="ctr"/>
-          <a:lstStyle/>
-          <a:p>
-            <a:pPr algn="ctr"/>
-          </a:p>
-        </p:txBody>
-      </p:sp>
-      <p:sp>
-        <p:nvSpPr>
-          <p:cNvPr id="6" name="TextBox 5"/>
-          <p:cNvSpPr txBox="1"/>
-          <p:nvPr/>
-        </p:nvSpPr>
-        <p:spPr>
-          <a:xfrm>
-            <a:off x="1463040" y="3291840"/>
-            <a:ext cx="4023360" cy="2286000"/>
-          </a:xfrm>
-          <a:prstGeom prst="rect">
-            <a:avLst/>
-          </a:prstGeom>
-          <a:noFill/>
-        </p:spPr>
-        <p:txBody>
-          <a:bodyPr wrap="square" lIns="0" tIns="0" rIns="0" bIns="0">
-            <a:spAutoFit/>
-          </a:bodyPr>
-          <a:lstStyle/>
-          <a:p>
-            <a:pPr>
-              <a:spcAft>
-                <a:spcPts val="1200"/>
-              </a:spcAft>
-              <a:defRPr sz="1900" b="1">
-                <a:solidFill>
-                  <a:srgbClr val="FF8C30"/>
-                </a:solidFill>
-                <a:latin typeface="Manrope"/>
-              </a:defRPr>
-            </a:pPr>
-            <a:r>
-              <a:t>Negative Prompt Guards</a:t>
-            </a:r>
-          </a:p>
-          <a:p>
-            <a:pPr>
-              <a:defRPr sz="1400">
-                <a:solidFill>
-                  <a:srgbClr val="FFFFFF"/>
-                </a:solidFill>
-                <a:latin typeface="Manrope"/>
-              </a:defRPr>
-            </a:pPr>
-            <a:r>
-              <a:t>Enforcing strict bans against therapeutic health benefits and fake organic badges eliminated marketing fluff.</a:t>
-            </a:r>
-          </a:p>
-        </p:txBody>
-      </p:sp>
-      <p:sp>
-        <p:nvSpPr>
-          <p:cNvPr id="7" name="Rounded Rectangle 6"/>
-          <p:cNvSpPr/>
-          <p:nvPr/>
-        </p:nvSpPr>
-        <p:spPr>
-          <a:xfrm>
-            <a:off x="6217920" y="2926080"/>
-            <a:ext cx="4754880" cy="3017520"/>
-          </a:xfrm>
-          <a:prstGeom prst="roundRect">
-            <a:avLst/>
-          </a:prstGeom>
-          <a:solidFill>
-            <a:srgbClr val="2D1403"/>
-          </a:solidFill>
-          <a:ln>
-            <a:noFill/>
-          </a:ln>
-        </p:spPr>
-        <p:style>
-          <a:lnRef idx="1">
-            <a:schemeClr val="accent1"/>
-          </a:lnRef>
-          <a:fillRef idx="3">
-            <a:schemeClr val="accent1"/>
-          </a:fillRef>
-          <a:effectRef idx="2">
-            <a:schemeClr val="accent1"/>
-          </a:effectRef>
-          <a:fontRef idx="minor">
-            <a:schemeClr val="lt1"/>
-          </a:fontRef>
-        </p:style>
-        <p:txBody>
-          <a:bodyPr rtlCol="0" anchor="ctr"/>
-          <a:lstStyle/>
-          <a:p>
-            <a:pPr algn="ctr"/>
-          </a:p>
-        </p:txBody>
-      </p:sp>
-      <p:sp>
-        <p:nvSpPr>
-          <p:cNvPr id="8" name="TextBox 7"/>
-          <p:cNvSpPr txBox="1"/>
-          <p:nvPr/>
-        </p:nvSpPr>
-        <p:spPr>
-          <a:xfrm>
-            <a:off x="6583680" y="3291840"/>
-            <a:ext cx="4023360" cy="2286000"/>
-          </a:xfrm>
-          <a:prstGeom prst="rect">
-            <a:avLst/>
-          </a:prstGeom>
-          <a:noFill/>
-        </p:spPr>
-        <p:txBody>
-          <a:bodyPr wrap="square" lIns="0" tIns="0" rIns="0" bIns="0">
-            <a:spAutoFit/>
-          </a:bodyPr>
-          <a:lstStyle/>
-          <a:p>
-            <a:pPr>
-              <a:spcAft>
-                <a:spcPts val="1200"/>
-              </a:spcAft>
-              <a:defRPr sz="1900" b="1">
-                <a:solidFill>
-                  <a:srgbClr val="FF8C30"/>
-                </a:solidFill>
-                <a:latin typeface="Manrope"/>
-              </a:defRPr>
-            </a:pPr>
-            <a:r>
-              <a:t>Session Partitioning</a:t>
-            </a:r>
-          </a:p>
-          <a:p>
-            <a:pPr>
-              <a:defRPr sz="1400">
-                <a:solidFill>
-                  <a:srgbClr val="FFFFFF"/>
-                </a:solidFill>
-                <a:latin typeface="Manrope"/>
-              </a:defRPr>
-            </a:pPr>
-            <a:r>
-              <a:t>Isolating data cleaning, brand spec, and copywriting into modular sessions eliminated context decay.</a:t>
-            </a:r>
-          </a:p>
-        </p:txBody>
-      </p:sp>
-    </p:spTree>
-  </p:cSld>
-  <p:clrMapOvr>
-    <a:masterClrMapping/>
-  </p:clrMapOvr>
-</p:sld>
-</file>
-
-<file path=ppt/slides/slide9.xml><?xml version="1.0" encoding="utf-8"?>
-<p:sld xmlns:a="http://schemas.openxmlformats.org/drawingml/2006/main" xmlns:p="http://schemas.openxmlformats.org/presentationml/2006/main" xmlns:r="http://schemas.openxmlformats.org/officeDocument/2006/relationships">
-  <p:cSld>
-    <p:spTree>
-      <p:nvGrpSpPr>
-        <p:cNvPr id="1" name=""/>
-        <p:cNvGrpSpPr/>
-        <p:nvPr/>
-      </p:nvGrpSpPr>
-      <p:grpSpPr/>
-      <p:sp>
-        <p:nvSpPr>
-          <p:cNvPr id="2" name="Rectangle 1"/>
-          <p:cNvSpPr/>
-          <p:nvPr/>
-        </p:nvSpPr>
-        <p:spPr>
-          <a:xfrm>
-            <a:off x="0" y="0"/>
-            <a:ext cx="12191695" cy="6858000"/>
-          </a:xfrm>
-          <a:prstGeom prst="rect">
-            <a:avLst/>
-          </a:prstGeom>
-          <a:solidFill>
-            <a:srgbClr val="4E2408"/>
-          </a:solidFill>
-          <a:ln>
-            <a:noFill/>
-          </a:ln>
-        </p:spPr>
-        <p:style>
-          <a:lnRef idx="1">
-            <a:schemeClr val="accent1"/>
-          </a:lnRef>
-          <a:fillRef idx="3">
-            <a:schemeClr val="accent1"/>
-          </a:fillRef>
-          <a:effectRef idx="2">
-            <a:schemeClr val="accent1"/>
-          </a:effectRef>
-          <a:fontRef idx="minor">
-            <a:schemeClr val="lt1"/>
-          </a:fontRef>
-        </p:style>
-        <p:txBody>
-          <a:bodyPr rtlCol="0" anchor="ctr"/>
-          <a:lstStyle/>
-          <a:p>
-            <a:pPr algn="ctr"/>
-          </a:p>
-        </p:txBody>
-      </p:sp>
-      <p:sp>
-        <p:nvSpPr>
-          <p:cNvPr id="3" name="TextBox 2"/>
-          <p:cNvSpPr txBox="1"/>
-          <p:nvPr/>
-        </p:nvSpPr>
-        <p:spPr>
-          <a:xfrm>
-            <a:off x="1097280" y="822960"/>
-            <a:ext cx="9601200" cy="365760"/>
-          </a:xfrm>
-          <a:prstGeom prst="rect">
-            <a:avLst/>
-          </a:prstGeom>
-          <a:noFill/>
-        </p:spPr>
-        <p:txBody>
-          <a:bodyPr wrap="none" lIns="0" tIns="0" rIns="0" bIns="0">
-            <a:spAutoFit/>
-          </a:bodyPr>
-          <a:lstStyle/>
-          <a:p>
-            <a:pPr>
-              <a:defRPr sz="1300" b="1">
-                <a:solidFill>
-                  <a:srgbClr val="FF8C30"/>
-                </a:solidFill>
-                <a:latin typeface="Manrope"/>
-              </a:defRPr>
-            </a:pPr>
-            <a:r>
-              <a:t>08 / REFLECTION  •  TURNING POINT</a:t>
-            </a:r>
-          </a:p>
-        </p:txBody>
-      </p:sp>
-      <p:sp>
-        <p:nvSpPr>
-          <p:cNvPr id="4" name="TextBox 3"/>
-          <p:cNvSpPr txBox="1"/>
-          <p:nvPr/>
-        </p:nvSpPr>
-        <p:spPr>
-          <a:xfrm>
-            <a:off x="1097280" y="1234440"/>
-            <a:ext cx="9875520" cy="1554480"/>
-          </a:xfrm>
-          <a:prstGeom prst="rect">
-            <a:avLst/>
-          </a:prstGeom>
-          <a:noFill/>
-        </p:spPr>
-        <p:txBody>
-          <a:bodyPr wrap="square" lIns="0" tIns="0" rIns="0" bIns="0">
-            <a:spAutoFit/>
-          </a:bodyPr>
-          <a:lstStyle/>
-          <a:p>
-            <a:pPr>
-              <a:spcAft>
-                <a:spcPts val="600"/>
-              </a:spcAft>
-              <a:defRPr sz="4000" b="1">
-                <a:solidFill>
-                  <a:srgbClr val="FFFFFF"/>
-                </a:solidFill>
-                <a:latin typeface="Manrope"/>
-              </a:defRPr>
-            </a:pPr>
-            <a:r>
-              <a:t>Catching Butter Instability.</a:t>
-            </a:r>
-          </a:p>
-          <a:p>
-            <a:pPr>
-              <a:defRPr sz="1700">
-                <a:solidFill>
-                  <a:srgbClr val="FF8C30"/>
-                </a:solidFill>
-                <a:latin typeface="Manrope"/>
-              </a:defRPr>
-            </a:pPr>
-            <a:r>
-              <a:t>Rejecting unrealistic model assumptions about ambient dairy shelf life.</a:t>
-            </a:r>
-          </a:p>
-        </p:txBody>
-      </p:sp>
-      <p:sp>
-        <p:nvSpPr>
-          <p:cNvPr id="5" name="Rounded Rectangle 4"/>
-          <p:cNvSpPr/>
-          <p:nvPr/>
-        </p:nvSpPr>
-        <p:spPr>
-          <a:xfrm>
-            <a:off x="1097280" y="2926080"/>
-            <a:ext cx="4754880" cy="3017520"/>
-          </a:xfrm>
-          <a:prstGeom prst="roundRect">
-            <a:avLst/>
-          </a:prstGeom>
-          <a:solidFill>
-            <a:srgbClr val="2D1403"/>
-          </a:solidFill>
-          <a:ln>
-            <a:noFill/>
-          </a:ln>
-        </p:spPr>
-        <p:style>
-          <a:lnRef idx="1">
-            <a:schemeClr val="accent1"/>
-          </a:lnRef>
-          <a:fillRef idx="3">
-            <a:schemeClr val="accent1"/>
-          </a:fillRef>
-          <a:effectRef idx="2">
-            <a:schemeClr val="accent1"/>
-          </a:effectRef>
-          <a:fontRef idx="minor">
-            <a:schemeClr val="lt1"/>
-          </a:fontRef>
-        </p:style>
-        <p:txBody>
-          <a:bodyPr rtlCol="0" anchor="ctr"/>
-          <a:lstStyle/>
-          <a:p>
-            <a:pPr algn="ctr"/>
-          </a:p>
-        </p:txBody>
-      </p:sp>
-      <p:sp>
-        <p:nvSpPr>
-          <p:cNvPr id="6" name="TextBox 5"/>
-          <p:cNvSpPr txBox="1"/>
-          <p:nvPr/>
-        </p:nvSpPr>
-        <p:spPr>
-          <a:xfrm>
-            <a:off x="1463040" y="3291840"/>
-            <a:ext cx="4023360" cy="2286000"/>
-          </a:xfrm>
-          <a:prstGeom prst="rect">
-            <a:avLst/>
-          </a:prstGeom>
-          <a:noFill/>
-        </p:spPr>
-        <p:txBody>
-          <a:bodyPr wrap="square" lIns="0" tIns="0" rIns="0" bIns="0">
-            <a:spAutoFit/>
-          </a:bodyPr>
-          <a:lstStyle/>
-          <a:p>
-            <a:pPr>
-              <a:spcAft>
-                <a:spcPts val="1200"/>
-              </a:spcAft>
-              <a:defRPr sz="1900" b="1">
-                <a:solidFill>
-                  <a:srgbClr val="FF8C30"/>
-                </a:solidFill>
-                <a:latin typeface="Manrope"/>
-              </a:defRPr>
-            </a:pPr>
-            <a:r>
-              <a:t>The Hallucinated Assumption</a:t>
-            </a:r>
-          </a:p>
-          <a:p>
-            <a:pPr>
-              <a:defRPr sz="1400">
-                <a:solidFill>
-                  <a:srgbClr val="FFFFFF"/>
-                </a:solidFill>
-                <a:latin typeface="Manrope"/>
-              </a:defRPr>
-            </a:pPr>
-            <a:r>
-              <a:t>AI assumed standard churned butter could sit ambiently in a pantry for 12 months without spoiling.</a:t>
-            </a:r>
-          </a:p>
-        </p:txBody>
-      </p:sp>
-      <p:sp>
-        <p:nvSpPr>
-          <p:cNvPr id="7" name="Rounded Rectangle 6"/>
-          <p:cNvSpPr/>
-          <p:nvPr/>
-        </p:nvSpPr>
-        <p:spPr>
-          <a:xfrm>
-            <a:off x="6217920" y="2926080"/>
-            <a:ext cx="4754880" cy="3017520"/>
-          </a:xfrm>
-          <a:prstGeom prst="roundRect">
-            <a:avLst/>
-          </a:prstGeom>
-          <a:solidFill>
-            <a:srgbClr val="2D1403"/>
-          </a:solidFill>
-          <a:ln>
-            <a:noFill/>
-          </a:ln>
-        </p:spPr>
-        <p:style>
-          <a:lnRef idx="1">
-            <a:schemeClr val="accent1"/>
-          </a:lnRef>
-          <a:fillRef idx="3">
-            <a:schemeClr val="accent1"/>
-          </a:fillRef>
-          <a:effectRef idx="2">
-            <a:schemeClr val="accent1"/>
-          </a:effectRef>
-          <a:fontRef idx="minor">
-            <a:schemeClr val="lt1"/>
-          </a:fontRef>
-        </p:style>
-        <p:txBody>
-          <a:bodyPr rtlCol="0" anchor="ctr"/>
-          <a:lstStyle/>
-          <a:p>
-            <a:pPr algn="ctr"/>
-          </a:p>
-        </p:txBody>
-      </p:sp>
-      <p:sp>
-        <p:nvSpPr>
-          <p:cNvPr id="8" name="TextBox 7"/>
-          <p:cNvSpPr txBox="1"/>
-          <p:nvPr/>
-        </p:nvSpPr>
-        <p:spPr>
-          <a:xfrm>
-            <a:off x="6583680" y="3291840"/>
-            <a:ext cx="4023360" cy="2286000"/>
-          </a:xfrm>
-          <a:prstGeom prst="rect">
-            <a:avLst/>
-          </a:prstGeom>
-          <a:noFill/>
-        </p:spPr>
-        <p:txBody>
-          <a:bodyPr wrap="square" lIns="0" tIns="0" rIns="0" bIns="0">
-            <a:spAutoFit/>
-          </a:bodyPr>
-          <a:lstStyle/>
-          <a:p>
-            <a:pPr>
-              <a:spcAft>
-                <a:spcPts val="1200"/>
-              </a:spcAft>
-              <a:defRPr sz="1900" b="1">
-                <a:solidFill>
-                  <a:srgbClr val="FF8C30"/>
-                </a:solidFill>
-                <a:latin typeface="Manrope"/>
-              </a:defRPr>
-            </a:pPr>
-            <a:r>
-              <a:t>The Human Formulation Pivot</a:t>
-            </a:r>
-          </a:p>
-          <a:p>
-            <a:pPr>
-              <a:defRPr sz="1400">
-                <a:solidFill>
-                  <a:srgbClr val="FFFFFF"/>
-                </a:solidFill>
-                <a:latin typeface="Manrope"/>
-              </a:defRPr>
-            </a:pPr>
-            <a:r>
-              <a:t>Caught the food science flaw and forced reformulation into a cultured dairy spread to ensure shelf stability.</a:t>
+              <a:t>Zero single-serve or utensil-free formats in New Zealand retail.</a:t>
             </a:r>
           </a:p>
         </p:txBody>

</xml_diff>

<commit_message>
feat(presentation): redesign 23-slide rapid-fire pitch deck with distinct palettes, bottom wordmark, and embedded figures
</commit_message>
<xml_diff>
--- a/presentation/Stamp-pitch.pptx
+++ b/presentation/Stamp-pitch.pptx
@@ -22,6 +22,12 @@
     <p:sldId id="270" r:id="rId22"/>
     <p:sldId id="271" r:id="rId23"/>
     <p:sldId id="272" r:id="rId24"/>
+    <p:sldId id="273" r:id="rId25"/>
+    <p:sldId id="274" r:id="rId26"/>
+    <p:sldId id="275" r:id="rId27"/>
+    <p:sldId id="276" r:id="rId28"/>
+    <p:sldId id="277" r:id="rId29"/>
+    <p:sldId id="278" r:id="rId30"/>
   </p:sldIdLst>
   <p:sldSz cx="12191695" cy="6858000" type="screen4x3"/>
   <p:notesSz cx="6858000" cy="9144000"/>
@@ -518,7 +524,7 @@
           <a:lstStyle/>
           <a:p>
             <a:r>
-              <a:t>TITLE (0:00–0:08)</a:t>
+              <a:t>TITLE (0:00–0:07)</a:t>
             </a:r>
           </a:p>
           <a:p>
@@ -593,12 +599,12 @@
           <a:lstStyle/>
           <a:p>
             <a:r>
-              <a:t>ECONOMICS (0:58–1:04)</a:t>
-            </a:r>
-          </a:p>
-          <a:p>
-            <a:r>
-              <a:t>At five dollars a sheet—63 cents a serving—we retain a strong one-seventy-five gross margin.</a:t>
+              <a:t>MARKET SCALE (0:56–1:03)</a:t>
+            </a:r>
+          </a:p>
+          <a:p>
+            <a:r>
+              <a:t>Cleaned supermarket scan data reveals New Zealand spreads expanded 24% to a 341 million dollar category.</a:t>
             </a:r>
           </a:p>
         </p:txBody>
@@ -668,12 +674,12 @@
           <a:lstStyle/>
           <a:p>
             <a:r>
-              <a:t>CONSTRAINTS (1:04–1:18)</a:t>
-            </a:r>
-          </a:p>
-          <a:p>
-            <a:r>
-              <a:t>In steering AI, I enforced strict negative prompt constraints against fake badges and health claims.</a:t>
+              <a:t>PREMIUM SURGE (1:03–1:11)</a:t>
+            </a:r>
+          </a:p>
+          <a:p>
+            <a:r>
+              <a:t>Premium branded spreads surged 29% to 113 million dollars, massively outpacing commodity tiers.</a:t>
             </a:r>
           </a:p>
         </p:txBody>
@@ -743,12 +749,12 @@
           <a:lstStyle/>
           <a:p>
             <a:r>
-              <a:t>PARTITIONING (1:18–1:30)</a:t>
-            </a:r>
-          </a:p>
-          <a:p>
-            <a:r>
-              <a:t>I partitioned distinct sessions for data cleaning, branding, and copy to prevent context rot.</a:t>
+              <a:t>COMPETITIVE VOID (1:11–1:18)</a:t>
+            </a:r>
+          </a:p>
+          <a:p>
+            <a:r>
+              <a:t>Across 154 supermarket spreads, every single product is a jar. Not one offers a utensil-free portion format.</a:t>
             </a:r>
           </a:p>
         </p:txBody>
@@ -818,12 +824,12 @@
           <a:lstStyle/>
           <a:p>
             <a:r>
-              <a:t>TURNING POINT (1:30–1:45)</a:t>
-            </a:r>
-          </a:p>
-          <a:p>
-            <a:r>
-              <a:t>My pivotal moment was catching an unrealistic AI claim that dairy butter could sit ambiently without spoilage.</a:t>
+              <a:t>PRICE POSITIONING (1:18–1:26)</a:t>
+            </a:r>
+          </a:p>
+          <a:p>
+            <a:r>
+              <a:t>At $5.00 for an 8-pack, Stamp commands $6.25 per 100g—positioning neatly into the premium whitespace.</a:t>
             </a:r>
           </a:p>
         </p:txBody>
@@ -893,12 +899,12 @@
           <a:lstStyle/>
           <a:p>
             <a:r>
-              <a:t>VERIFICATION (1:45–1:58)</a:t>
-            </a:r>
-          </a:p>
-          <a:p>
-            <a:r>
-              <a:t>I audited raw scan data outliers and manually verified shelf prices on New World instead of trusting model summaries.</a:t>
+              <a:t>UNIT ECONOMICS (1:26–1:33)</a:t>
+            </a:r>
+          </a:p>
+          <a:p>
+            <a:r>
+              <a:t>At 63 cents per serving, we maintain a robust $1.75 gross margin to fund rapid marketing and retail scaling.</a:t>
             </a:r>
           </a:p>
         </p:txBody>
@@ -968,12 +974,12 @@
           <a:lstStyle/>
           <a:p>
             <a:r>
-              <a:t>AUTHENTICITY (1:58–2:15)</a:t>
-            </a:r>
-          </a:p>
-          <a:p>
-            <a:r>
-              <a:t>To combat AI slop, I stripped corporate clichés and grounded packaging in real continuous deposit tooling.</a:t>
+              <a:t>MANUFACTURING (1:33–1:41)</a:t>
+            </a:r>
+          </a:p>
+          <a:p>
+            <a:r>
+              <a:t>Production leverages existing contract rotary-die deposition lines, eliminating custom factory tooling.</a:t>
             </a:r>
           </a:p>
         </p:txBody>
@@ -1043,12 +1049,12 @@
           <a:lstStyle/>
           <a:p>
             <a:r>
-              <a:t>REGULATION (2:15–2:30)</a:t>
-            </a:r>
-          </a:p>
-          <a:p>
-            <a:r>
-              <a:t>In food and beverage, AI hallucinations are a severe legal hazard. I enforced strict FSANZ compliance and allergen safety.</a:t>
+              <a:t>LEAN PILOT (1:41–1:47)</a:t>
+            </a:r>
+          </a:p>
+          <a:p>
+            <a:r>
+              <a:t>By partnering with established contract packers in Auckland, we validate consumer demand with minimal capex.</a:t>
             </a:r>
           </a:p>
         </p:txBody>
@@ -1118,12 +1124,162 @@
           <a:lstStyle/>
           <a:p>
             <a:r>
-              <a:t>ETHICS &amp; WRAP (2:30–2:45)</a:t>
-            </a:r>
-          </a:p>
-          <a:p>
-            <a:r>
-              <a:t>Generative AI accelerates velocity, but human skepticism, taste, discernment, and moral ownership remain essential.</a:t>
+              <a:t>CONSTRAINTS (1:47–1:55)</a:t>
+            </a:r>
+          </a:p>
+          <a:p>
+            <a:r>
+              <a:t>In steering AI, I enforced strict negative prompt constraints against fake certification badges and medical health claims.</a:t>
+            </a:r>
+          </a:p>
+        </p:txBody>
+      </p:sp>
+      <p:sp>
+        <p:nvSpPr>
+          <p:cNvPr id="4" name="Slide Number Placeholder 3"/>
+          <p:cNvSpPr>
+            <a:spLocks noGrp="1"/>
+          </p:cNvSpPr>
+          <p:nvPr>
+            <p:ph type="sldNum" idx="5" sz="quarter"/>
+          </p:nvPr>
+        </p:nvSpPr>
+        <p:spPr/>
+      </p:sp>
+    </p:spTree>
+  </p:cSld>
+  <p:clrMapOvr>
+    <a:masterClrMapping/>
+  </p:clrMapOvr>
+</p:notes>
+</file>
+
+<file path=ppt/notesSlides/notesSlide18.xml><?xml version="1.0" encoding="utf-8"?>
+<p:notes xmlns:a="http://schemas.openxmlformats.org/drawingml/2006/main" xmlns:p="http://schemas.openxmlformats.org/presentationml/2006/main" xmlns:r="http://schemas.openxmlformats.org/officeDocument/2006/relationships">
+  <p:cSld>
+    <p:spTree>
+      <p:nvGrpSpPr>
+        <p:cNvPr id="1" name=""/>
+        <p:cNvGrpSpPr/>
+        <p:nvPr/>
+      </p:nvGrpSpPr>
+      <p:grpSpPr>
+        <a:xfrm>
+          <a:off x="0" y="0"/>
+          <a:ext cx="0" cy="0"/>
+          <a:chOff x="0" y="0"/>
+          <a:chExt cx="0" cy="0"/>
+        </a:xfrm>
+      </p:grpSpPr>
+      <p:sp>
+        <p:nvSpPr>
+          <p:cNvPr id="2" name="Slide Image Placeholder 1"/>
+          <p:cNvSpPr>
+            <a:spLocks noGrp="1"/>
+          </p:cNvSpPr>
+          <p:nvPr>
+            <p:ph type="sldImg" idx="2"/>
+          </p:nvPr>
+        </p:nvSpPr>
+        <p:spPr/>
+      </p:sp>
+      <p:sp>
+        <p:nvSpPr>
+          <p:cNvPr id="3" name="Notes Placeholder 2"/>
+          <p:cNvSpPr>
+            <a:spLocks noGrp="1"/>
+          </p:cNvSpPr>
+          <p:nvPr>
+            <p:ph type="body" idx="3" sz="quarter"/>
+          </p:nvPr>
+        </p:nvSpPr>
+        <p:spPr/>
+        <p:txBody>
+          <a:bodyPr/>
+          <a:lstStyle/>
+          <a:p>
+            <a:r>
+              <a:t>ARCHITECTURE (1:55–2:03)</a:t>
+            </a:r>
+          </a:p>
+          <a:p>
+            <a:r>
+              <a:t>I partitioned distinct sessions for data cleaning, branding, and copy to prevent context rot and hallucinated metrics.</a:t>
+            </a:r>
+          </a:p>
+        </p:txBody>
+      </p:sp>
+      <p:sp>
+        <p:nvSpPr>
+          <p:cNvPr id="4" name="Slide Number Placeholder 3"/>
+          <p:cNvSpPr>
+            <a:spLocks noGrp="1"/>
+          </p:cNvSpPr>
+          <p:nvPr>
+            <p:ph type="sldNum" idx="5" sz="quarter"/>
+          </p:nvPr>
+        </p:nvSpPr>
+        <p:spPr/>
+      </p:sp>
+    </p:spTree>
+  </p:cSld>
+  <p:clrMapOvr>
+    <a:masterClrMapping/>
+  </p:clrMapOvr>
+</p:notes>
+</file>
+
+<file path=ppt/notesSlides/notesSlide19.xml><?xml version="1.0" encoding="utf-8"?>
+<p:notes xmlns:a="http://schemas.openxmlformats.org/drawingml/2006/main" xmlns:p="http://schemas.openxmlformats.org/presentationml/2006/main" xmlns:r="http://schemas.openxmlformats.org/officeDocument/2006/relationships">
+  <p:cSld>
+    <p:spTree>
+      <p:nvGrpSpPr>
+        <p:cNvPr id="1" name=""/>
+        <p:cNvGrpSpPr/>
+        <p:nvPr/>
+      </p:nvGrpSpPr>
+      <p:grpSpPr>
+        <a:xfrm>
+          <a:off x="0" y="0"/>
+          <a:ext cx="0" cy="0"/>
+          <a:chOff x="0" y="0"/>
+          <a:chExt cx="0" cy="0"/>
+        </a:xfrm>
+      </p:grpSpPr>
+      <p:sp>
+        <p:nvSpPr>
+          <p:cNvPr id="2" name="Slide Image Placeholder 1"/>
+          <p:cNvSpPr>
+            <a:spLocks noGrp="1"/>
+          </p:cNvSpPr>
+          <p:nvPr>
+            <p:ph type="sldImg" idx="2"/>
+          </p:nvPr>
+        </p:nvSpPr>
+        <p:spPr/>
+      </p:sp>
+      <p:sp>
+        <p:nvSpPr>
+          <p:cNvPr id="3" name="Notes Placeholder 2"/>
+          <p:cNvSpPr>
+            <a:spLocks noGrp="1"/>
+          </p:cNvSpPr>
+          <p:nvPr>
+            <p:ph type="body" idx="3" sz="quarter"/>
+          </p:nvPr>
+        </p:nvSpPr>
+        <p:spPr/>
+        <p:txBody>
+          <a:bodyPr/>
+          <a:lstStyle/>
+          <a:p>
+            <a:r>
+              <a:t>TURNING POINT (2:03–2:11)</a:t>
+            </a:r>
+          </a:p>
+          <a:p>
+            <a:r>
+              <a:t>My pivotal turning point was catching an unrealistic AI claim that dairy butter could sit ambiently without spoilage.</a:t>
             </a:r>
           </a:p>
         </p:txBody>
@@ -1193,12 +1349,312 @@
           <a:lstStyle/>
           <a:p>
             <a:r>
-              <a:t>PROBLEM (0:08–0:15)</a:t>
-            </a:r>
-          </a:p>
-          <a:p>
-            <a:r>
-              <a:t>Eating toast away from a full kitchen is broken.</a:t>
+              <a:t>PROBLEM (0:07–0:13)</a:t>
+            </a:r>
+          </a:p>
+          <a:p>
+            <a:r>
+              <a:t>Eating toast away from a full residential kitchen is fundamentally broken.</a:t>
+            </a:r>
+          </a:p>
+        </p:txBody>
+      </p:sp>
+      <p:sp>
+        <p:nvSpPr>
+          <p:cNvPr id="4" name="Slide Number Placeholder 3"/>
+          <p:cNvSpPr>
+            <a:spLocks noGrp="1"/>
+          </p:cNvSpPr>
+          <p:nvPr>
+            <p:ph type="sldNum" idx="5" sz="quarter"/>
+          </p:nvPr>
+        </p:nvSpPr>
+        <p:spPr/>
+      </p:sp>
+    </p:spTree>
+  </p:cSld>
+  <p:clrMapOvr>
+    <a:masterClrMapping/>
+  </p:clrMapOvr>
+</p:notes>
+</file>
+
+<file path=ppt/notesSlides/notesSlide20.xml><?xml version="1.0" encoding="utf-8"?>
+<p:notes xmlns:a="http://schemas.openxmlformats.org/drawingml/2006/main" xmlns:p="http://schemas.openxmlformats.org/presentationml/2006/main" xmlns:r="http://schemas.openxmlformats.org/officeDocument/2006/relationships">
+  <p:cSld>
+    <p:spTree>
+      <p:nvGrpSpPr>
+        <p:cNvPr id="1" name=""/>
+        <p:cNvGrpSpPr/>
+        <p:nvPr/>
+      </p:nvGrpSpPr>
+      <p:grpSpPr>
+        <a:xfrm>
+          <a:off x="0" y="0"/>
+          <a:ext cx="0" cy="0"/>
+          <a:chOff x="0" y="0"/>
+          <a:chExt cx="0" cy="0"/>
+        </a:xfrm>
+      </p:grpSpPr>
+      <p:sp>
+        <p:nvSpPr>
+          <p:cNvPr id="2" name="Slide Image Placeholder 1"/>
+          <p:cNvSpPr>
+            <a:spLocks noGrp="1"/>
+          </p:cNvSpPr>
+          <p:nvPr>
+            <p:ph type="sldImg" idx="2"/>
+          </p:nvPr>
+        </p:nvSpPr>
+        <p:spPr/>
+      </p:sp>
+      <p:sp>
+        <p:nvSpPr>
+          <p:cNvPr id="3" name="Notes Placeholder 2"/>
+          <p:cNvSpPr>
+            <a:spLocks noGrp="1"/>
+          </p:cNvSpPr>
+          <p:nvPr>
+            <p:ph type="body" idx="3" sz="quarter"/>
+          </p:nvPr>
+        </p:nvSpPr>
+        <p:spPr/>
+        <p:txBody>
+          <a:bodyPr/>
+          <a:lstStyle/>
+          <a:p>
+            <a:r>
+              <a:t>VERIFICATION (2:11–2:19)</a:t>
+            </a:r>
+          </a:p>
+          <a:p>
+            <a:r>
+              <a:t>I audited raw scan data outliers and manually verified shelf prices on New World instead of trusting model summaries.</a:t>
+            </a:r>
+          </a:p>
+        </p:txBody>
+      </p:sp>
+      <p:sp>
+        <p:nvSpPr>
+          <p:cNvPr id="4" name="Slide Number Placeholder 3"/>
+          <p:cNvSpPr>
+            <a:spLocks noGrp="1"/>
+          </p:cNvSpPr>
+          <p:nvPr>
+            <p:ph type="sldNum" idx="5" sz="quarter"/>
+          </p:nvPr>
+        </p:nvSpPr>
+        <p:spPr/>
+      </p:sp>
+    </p:spTree>
+  </p:cSld>
+  <p:clrMapOvr>
+    <a:masterClrMapping/>
+  </p:clrMapOvr>
+</p:notes>
+</file>
+
+<file path=ppt/notesSlides/notesSlide21.xml><?xml version="1.0" encoding="utf-8"?>
+<p:notes xmlns:a="http://schemas.openxmlformats.org/drawingml/2006/main" xmlns:p="http://schemas.openxmlformats.org/presentationml/2006/main" xmlns:r="http://schemas.openxmlformats.org/officeDocument/2006/relationships">
+  <p:cSld>
+    <p:spTree>
+      <p:nvGrpSpPr>
+        <p:cNvPr id="1" name=""/>
+        <p:cNvGrpSpPr/>
+        <p:nvPr/>
+      </p:nvGrpSpPr>
+      <p:grpSpPr>
+        <a:xfrm>
+          <a:off x="0" y="0"/>
+          <a:ext cx="0" cy="0"/>
+          <a:chOff x="0" y="0"/>
+          <a:chExt cx="0" cy="0"/>
+        </a:xfrm>
+      </p:grpSpPr>
+      <p:sp>
+        <p:nvSpPr>
+          <p:cNvPr id="2" name="Slide Image Placeholder 1"/>
+          <p:cNvSpPr>
+            <a:spLocks noGrp="1"/>
+          </p:cNvSpPr>
+          <p:nvPr>
+            <p:ph type="sldImg" idx="2"/>
+          </p:nvPr>
+        </p:nvSpPr>
+        <p:spPr/>
+      </p:sp>
+      <p:sp>
+        <p:nvSpPr>
+          <p:cNvPr id="3" name="Notes Placeholder 2"/>
+          <p:cNvSpPr>
+            <a:spLocks noGrp="1"/>
+          </p:cNvSpPr>
+          <p:nvPr>
+            <p:ph type="body" idx="3" sz="quarter"/>
+          </p:nvPr>
+        </p:nvSpPr>
+        <p:spPr/>
+        <p:txBody>
+          <a:bodyPr/>
+          <a:lstStyle/>
+          <a:p>
+            <a:r>
+              <a:t>AUTHENTICITY (2:19–2:27)</a:t>
+            </a:r>
+          </a:p>
+          <a:p>
+            <a:r>
+              <a:t>To combat AI slop, I stripped corporate clichés and grounded packaging in real continuous deposit tooling.</a:t>
+            </a:r>
+          </a:p>
+        </p:txBody>
+      </p:sp>
+      <p:sp>
+        <p:nvSpPr>
+          <p:cNvPr id="4" name="Slide Number Placeholder 3"/>
+          <p:cNvSpPr>
+            <a:spLocks noGrp="1"/>
+          </p:cNvSpPr>
+          <p:nvPr>
+            <p:ph type="sldNum" idx="5" sz="quarter"/>
+          </p:nvPr>
+        </p:nvSpPr>
+        <p:spPr/>
+      </p:sp>
+    </p:spTree>
+  </p:cSld>
+  <p:clrMapOvr>
+    <a:masterClrMapping/>
+  </p:clrMapOvr>
+</p:notes>
+</file>
+
+<file path=ppt/notesSlides/notesSlide22.xml><?xml version="1.0" encoding="utf-8"?>
+<p:notes xmlns:a="http://schemas.openxmlformats.org/drawingml/2006/main" xmlns:p="http://schemas.openxmlformats.org/presentationml/2006/main" xmlns:r="http://schemas.openxmlformats.org/officeDocument/2006/relationships">
+  <p:cSld>
+    <p:spTree>
+      <p:nvGrpSpPr>
+        <p:cNvPr id="1" name=""/>
+        <p:cNvGrpSpPr/>
+        <p:nvPr/>
+      </p:nvGrpSpPr>
+      <p:grpSpPr>
+        <a:xfrm>
+          <a:off x="0" y="0"/>
+          <a:ext cx="0" cy="0"/>
+          <a:chOff x="0" y="0"/>
+          <a:chExt cx="0" cy="0"/>
+        </a:xfrm>
+      </p:grpSpPr>
+      <p:sp>
+        <p:nvSpPr>
+          <p:cNvPr id="2" name="Slide Image Placeholder 1"/>
+          <p:cNvSpPr>
+            <a:spLocks noGrp="1"/>
+          </p:cNvSpPr>
+          <p:nvPr>
+            <p:ph type="sldImg" idx="2"/>
+          </p:nvPr>
+        </p:nvSpPr>
+        <p:spPr/>
+      </p:sp>
+      <p:sp>
+        <p:nvSpPr>
+          <p:cNvPr id="3" name="Notes Placeholder 2"/>
+          <p:cNvSpPr>
+            <a:spLocks noGrp="1"/>
+          </p:cNvSpPr>
+          <p:nvPr>
+            <p:ph type="body" idx="3" sz="quarter"/>
+          </p:nvPr>
+        </p:nvSpPr>
+        <p:spPr/>
+        <p:txBody>
+          <a:bodyPr/>
+          <a:lstStyle/>
+          <a:p>
+            <a:r>
+              <a:t>REGULATION (2:27–2:35)</a:t>
+            </a:r>
+          </a:p>
+          <a:p>
+            <a:r>
+              <a:t>In food and beverage, AI hallucinations are a severe legal hazard. I enforced strict FSANZ compliance and allergen safety.</a:t>
+            </a:r>
+          </a:p>
+        </p:txBody>
+      </p:sp>
+      <p:sp>
+        <p:nvSpPr>
+          <p:cNvPr id="4" name="Slide Number Placeholder 3"/>
+          <p:cNvSpPr>
+            <a:spLocks noGrp="1"/>
+          </p:cNvSpPr>
+          <p:nvPr>
+            <p:ph type="sldNum" idx="5" sz="quarter"/>
+          </p:nvPr>
+        </p:nvSpPr>
+        <p:spPr/>
+      </p:sp>
+    </p:spTree>
+  </p:cSld>
+  <p:clrMapOvr>
+    <a:masterClrMapping/>
+  </p:clrMapOvr>
+</p:notes>
+</file>
+
+<file path=ppt/notesSlides/notesSlide23.xml><?xml version="1.0" encoding="utf-8"?>
+<p:notes xmlns:a="http://schemas.openxmlformats.org/drawingml/2006/main" xmlns:p="http://schemas.openxmlformats.org/presentationml/2006/main" xmlns:r="http://schemas.openxmlformats.org/officeDocument/2006/relationships">
+  <p:cSld>
+    <p:spTree>
+      <p:nvGrpSpPr>
+        <p:cNvPr id="1" name=""/>
+        <p:cNvGrpSpPr/>
+        <p:nvPr/>
+      </p:nvGrpSpPr>
+      <p:grpSpPr>
+        <a:xfrm>
+          <a:off x="0" y="0"/>
+          <a:ext cx="0" cy="0"/>
+          <a:chOff x="0" y="0"/>
+          <a:chExt cx="0" cy="0"/>
+        </a:xfrm>
+      </p:grpSpPr>
+      <p:sp>
+        <p:nvSpPr>
+          <p:cNvPr id="2" name="Slide Image Placeholder 1"/>
+          <p:cNvSpPr>
+            <a:spLocks noGrp="1"/>
+          </p:cNvSpPr>
+          <p:nvPr>
+            <p:ph type="sldImg" idx="2"/>
+          </p:nvPr>
+        </p:nvSpPr>
+        <p:spPr/>
+      </p:sp>
+      <p:sp>
+        <p:nvSpPr>
+          <p:cNvPr id="3" name="Notes Placeholder 2"/>
+          <p:cNvSpPr>
+            <a:spLocks noGrp="1"/>
+          </p:cNvSpPr>
+          <p:nvPr>
+            <p:ph type="body" idx="3" sz="quarter"/>
+          </p:nvPr>
+        </p:nvSpPr>
+        <p:spPr/>
+        <p:txBody>
+          <a:bodyPr/>
+          <a:lstStyle/>
+          <a:p>
+            <a:r>
+              <a:t>ETHICS &amp; WRAP (2:35–2:45)</a:t>
+            </a:r>
+          </a:p>
+          <a:p>
+            <a:r>
+              <a:t>Generative AI accelerates velocity, but human skepticism, taste, discernment, and moral ownership remain essential.</a:t>
             </a:r>
           </a:p>
         </p:txBody>
@@ -1268,12 +1724,12 @@
           <a:lstStyle/>
           <a:p>
             <a:r>
-              <a:t>WHO FAILS (0:15–0:22)</a:t>
-            </a:r>
-          </a:p>
-          <a:p>
-            <a:r>
-              <a:t>In a hall, flat, or desk, nobody wants to lug a sticky 750g jar, hunt for a knife, and wash it in an office sink.</a:t>
+              <a:t>WHO FAILS (0:13–0:19)</a:t>
+            </a:r>
+          </a:p>
+          <a:p>
+            <a:r>
+              <a:t>In a university hall, shared flat, or office desk, nobody wants to lug a sticky jar and hunt for a knife.</a:t>
             </a:r>
           </a:p>
         </p:txBody>
@@ -1343,12 +1799,12 @@
           <a:lstStyle/>
           <a:p>
             <a:r>
-              <a:t>SOLUTION (0:22–0:28)</a:t>
-            </a:r>
-          </a:p>
-          <a:p>
-            <a:r>
-              <a:t>Stamp reinvents the format with a thin, 10-gram disc of real spread on release film.</a:t>
+              <a:t>OFFICE FRICTION (0:19–0:25)</a:t>
+            </a:r>
+          </a:p>
+          <a:p>
+            <a:r>
+              <a:t>Shared communal spreads lead to cross-contamination, crumbs in the butter, and abandoned sink mess.</a:t>
             </a:r>
           </a:p>
         </p:txBody>
@@ -1418,12 +1874,12 @@
           <a:lstStyle/>
           <a:p>
             <a:r>
-              <a:t>MELT GESTURE (0:28–0:34)</a:t>
-            </a:r>
-          </a:p>
-          <a:p>
-            <a:r>
-              <a:t>You press it onto hot toast, and residual thermal energy melts it into an even spread in seconds.</a:t>
+              <a:t>UNMET NEED (0:25–0:31)</a:t>
+            </a:r>
+          </a:p>
+          <a:p>
+            <a:r>
+              <a:t>Because jars are tethered to kitchens, consumers compromise on dry bars or skip breakfast altogether.</a:t>
             </a:r>
           </a:p>
         </p:txBody>
@@ -1493,12 +1949,12 @@
           <a:lstStyle/>
           <a:p>
             <a:r>
-              <a:t>STABILITY &amp; RANGE (0:34–0:40)</a:t>
-            </a:r>
-          </a:p>
-          <a:p>
-            <a:r>
-              <a:t>Four launch varieties in an 8-stamp card sheet, shelf-stable for 12 months with zero refrigeration.</a:t>
+              <a:t>SOLUTION (0:31–0:37)</a:t>
+            </a:r>
+          </a:p>
+          <a:p>
+            <a:r>
+              <a:t>Stamp reinvents the format with a calibrated 10-gram disc of real spread on release film.</a:t>
             </a:r>
           </a:p>
         </p:txBody>
@@ -1568,12 +2024,12 @@
           <a:lstStyle/>
           <a:p>
             <a:r>
-              <a:t>MARKET SCALE (0:40–0:46)</a:t>
-            </a:r>
-          </a:p>
-          <a:p>
-            <a:r>
-              <a:t>Cleaned supermarket scan data shows the spreads category expanded 24% to 341 million dollars.</a:t>
+              <a:t>PRODUCT PHYSICS (0:37–0:44)</a:t>
+            </a:r>
+          </a:p>
+          <a:p>
+            <a:r>
+              <a:t>You press the disc onto fresh toast, and residual thermal energy melts it evenly without a knife.</a:t>
             </a:r>
           </a:p>
         </p:txBody>
@@ -1643,12 +2099,12 @@
           <a:lstStyle/>
           <a:p>
             <a:r>
-              <a:t>PREMIUM GROWTH (0:46–0:52)</a:t>
-            </a:r>
-          </a:p>
-          <a:p>
-            <a:r>
-              <a:t>Premium branded spreads surged 29% to 113 million, significantly outperforming commodity tiers.</a:t>
+              <a:t>FLAVOUR RANGE (0:44–0:50)</a:t>
+            </a:r>
+          </a:p>
+          <a:p>
+            <a:r>
+              <a:t>Four iconic kiwi flavours in an 8-stamp card sheet, offering instant single-serve variety.</a:t>
             </a:r>
           </a:p>
         </p:txBody>
@@ -1718,12 +2174,12 @@
           <a:lstStyle/>
           <a:p>
             <a:r>
-              <a:t>COMPETITIVE VOID (0:52–0:58)</a:t>
-            </a:r>
-          </a:p>
-          <a:p>
-            <a:r>
-              <a:t>Across 154 spread products, not one offers a portion format. Jars compete on bulk weight; Stamp wins on convenience.</a:t>
+              <a:t>AMBIENT STABILITY (0:50–0:56)</a:t>
+            </a:r>
+          </a:p>
+          <a:p>
+            <a:r>
+              <a:t>Formulated for room-temperature pantry and bag storage with full 12-month shelf stability.</a:t>
             </a:r>
           </a:p>
         </p:txBody>
@@ -4774,7 +5230,7 @@
       </p:sp>
       <p:pic>
         <p:nvPicPr>
-          <p:cNvPr id="3" name="Picture 2" descr="cover_wordmark.png"/>
+          <p:cNvPr id="3" name="Picture 2" descr="wordmark_yeast.png"/>
           <p:cNvPicPr>
             <a:picLocks noChangeAspect="1"/>
           </p:cNvPicPr>
@@ -4789,7 +5245,7 @@
         <p:spPr>
           <a:xfrm>
             <a:off x="3444087" y="2103120"/>
-            <a:ext cx="5303520" cy="1360680"/>
+            <a:ext cx="5303520" cy="1297533"/>
           </a:xfrm>
           <a:prstGeom prst="rect">
             <a:avLst/>
@@ -4804,7 +5260,7 @@
         </p:nvSpPr>
         <p:spPr>
           <a:xfrm>
-            <a:off x="1371600" y="3783840"/>
+            <a:off x="1371600" y="3720693"/>
             <a:ext cx="9448495" cy="731520"/>
           </a:xfrm>
           <a:prstGeom prst="rect">
@@ -4901,7 +5357,7 @@
             <a:avLst/>
           </a:prstGeom>
           <a:solidFill>
-            <a:srgbClr val="460820"/>
+            <a:srgbClr val="4E2408"/>
           </a:solidFill>
           <a:ln>
             <a:noFill/>
@@ -4957,13 +5413,13 @@
               </a:spcAft>
               <a:defRPr sz="8000" b="1">
                 <a:solidFill>
-                  <a:srgbClr val="FF467A"/>
+                  <a:srgbClr val="FF8C30"/>
                 </a:solidFill>
                 <a:latin typeface="Manrope"/>
               </a:defRPr>
             </a:pPr>
             <a:r>
-              <a:t>$1.75 Margin</a:t>
+              <a:t>$341M</a:t>
             </a:r>
           </a:p>
           <a:p>
@@ -4979,24 +5435,48 @@
               </a:defRPr>
             </a:pPr>
             <a:r>
-              <a:t>$5.00 NZD per 8-Stamp Sheet.</a:t>
+              <a:t>New Zealand Spreads Category.</a:t>
             </a:r>
           </a:p>
           <a:p>
             <a:pPr>
               <a:defRPr sz="2200" b="0">
                 <a:solidFill>
-                  <a:srgbClr val="FF467A"/>
+                  <a:srgbClr val="FF8C30"/>
                 </a:solidFill>
                 <a:latin typeface="Manrope"/>
               </a:defRPr>
             </a:pPr>
             <a:r>
-              <a:t>63¢ per serving on an assumed $1.50 co-packing cost.</a:t>
-            </a:r>
-          </a:p>
-        </p:txBody>
-      </p:sp>
+              <a:t>+24% category revenue growth across 2022–2025.</a:t>
+            </a:r>
+          </a:p>
+        </p:txBody>
+      </p:sp>
+      <p:pic>
+        <p:nvPicPr>
+          <p:cNvPr id="4" name="Picture 3" descr="wordmark_peanut.png"/>
+          <p:cNvPicPr>
+            <a:picLocks noChangeAspect="1"/>
+          </p:cNvPicPr>
+          <p:nvPr/>
+        </p:nvPicPr>
+        <p:blipFill>
+          <a:blip r:embed="rId2"/>
+          <a:stretch>
+            <a:fillRect/>
+          </a:stretch>
+        </p:blipFill>
+        <p:spPr>
+          <a:xfrm>
+            <a:off x="5410047" y="6172200"/>
+            <a:ext cx="1371600" cy="335584"/>
+          </a:xfrm>
+          <a:prstGeom prst="rect">
+            <a:avLst/>
+          </a:prstGeom>
+        </p:spPr>
+      </p:pic>
     </p:spTree>
   </p:cSld>
   <p:clrMapOvr>
@@ -5066,8 +5546,8 @@
         </p:nvSpPr>
         <p:spPr>
           <a:xfrm>
-            <a:off x="1188720" y="2011680"/>
-            <a:ext cx="9784080" cy="3657600"/>
+            <a:off x="1188720" y="822960"/>
+            <a:ext cx="9784080" cy="1280160"/>
           </a:xfrm>
           <a:prstGeom prst="rect">
             <a:avLst/>
@@ -5082,9 +5562,22 @@
           <a:p>
             <a:pPr>
               <a:spcAft>
-                <a:spcPts val="1200"/>
+                <a:spcPts val="600"/>
               </a:spcAft>
-              <a:defRPr sz="2200" b="1">
+              <a:defRPr sz="3600" b="1">
+                <a:solidFill>
+                  <a:srgbClr val="FFFFFF"/>
+                </a:solidFill>
+                <a:latin typeface="Manrope"/>
+              </a:defRPr>
+            </a:pPr>
+            <a:r>
+              <a:t>Premium Spreads Surging +29%.</a:t>
+            </a:r>
+          </a:p>
+          <a:p>
+            <a:pPr>
+              <a:defRPr sz="2000" b="0">
                 <a:solidFill>
                   <a:srgbClr val="FF8C30"/>
                 </a:solidFill>
@@ -5092,40 +5585,59 @@
               </a:defRPr>
             </a:pPr>
             <a:r>
-              <a:t>Negative Constraints.</a:t>
-            </a:r>
-          </a:p>
-          <a:p>
-            <a:pPr>
-              <a:spcAft>
-                <a:spcPts val="1400"/>
-              </a:spcAft>
-              <a:defRPr sz="4800" b="1">
-                <a:solidFill>
-                  <a:srgbClr val="FFFFFF"/>
-                </a:solidFill>
-                <a:latin typeface="Manrope"/>
-              </a:defRPr>
-            </a:pPr>
-            <a:r>
-              <a:t>Banning AI Marketing Hype.</a:t>
-            </a:r>
-          </a:p>
-          <a:p>
-            <a:pPr>
-              <a:defRPr sz="2200" b="0">
-                <a:solidFill>
-                  <a:srgbClr val="FF8C30"/>
-                </a:solidFill>
-                <a:latin typeface="Manrope"/>
-              </a:defRPr>
-            </a:pPr>
-            <a:r>
-              <a:t>No fake certification badges. No medical health claims.</a:t>
-            </a:r>
-          </a:p>
-        </p:txBody>
-      </p:sp>
+              <a:t>Expanding from $88M to $113M NZD as consumers trade up into quality.</a:t>
+            </a:r>
+          </a:p>
+        </p:txBody>
+      </p:sp>
+      <p:pic>
+        <p:nvPicPr>
+          <p:cNvPr id="4" name="Picture 3" descr="chart_tier_peanut.png"/>
+          <p:cNvPicPr>
+            <a:picLocks noChangeAspect="1"/>
+          </p:cNvPicPr>
+          <p:nvPr/>
+        </p:nvPicPr>
+        <p:blipFill>
+          <a:blip r:embed="rId2"/>
+          <a:stretch>
+            <a:fillRect/>
+          </a:stretch>
+        </p:blipFill>
+        <p:spPr>
+          <a:xfrm>
+            <a:off x="3078327" y="2148840"/>
+            <a:ext cx="6035040" cy="3372522"/>
+          </a:xfrm>
+          <a:prstGeom prst="rect">
+            <a:avLst/>
+          </a:prstGeom>
+        </p:spPr>
+      </p:pic>
+      <p:pic>
+        <p:nvPicPr>
+          <p:cNvPr id="5" name="Picture 4" descr="wordmark_peanut.png"/>
+          <p:cNvPicPr>
+            <a:picLocks noChangeAspect="1"/>
+          </p:cNvPicPr>
+          <p:nvPr/>
+        </p:nvPicPr>
+        <p:blipFill>
+          <a:blip r:embed="rId3"/>
+          <a:stretch>
+            <a:fillRect/>
+          </a:stretch>
+        </p:blipFill>
+        <p:spPr>
+          <a:xfrm>
+            <a:off x="5410047" y="6172200"/>
+            <a:ext cx="1371600" cy="335584"/>
+          </a:xfrm>
+          <a:prstGeom prst="rect">
+            <a:avLst/>
+          </a:prstGeom>
+        </p:spPr>
+      </p:pic>
     </p:spTree>
   </p:cSld>
   <p:clrMapOvr>
@@ -5195,8 +5707,8 @@
         </p:nvSpPr>
         <p:spPr>
           <a:xfrm>
-            <a:off x="1188720" y="2377440"/>
-            <a:ext cx="9784080" cy="3657600"/>
+            <a:off x="1188720" y="1645920"/>
+            <a:ext cx="9784080" cy="3840480"/>
           </a:xfrm>
           <a:prstGeom prst="rect">
             <a:avLst/>
@@ -5211,9 +5723,25 @@
           <a:p>
             <a:pPr>
               <a:spcAft>
+                <a:spcPts val="1000"/>
+              </a:spcAft>
+              <a:defRPr sz="8000" b="1">
+                <a:solidFill>
+                  <a:srgbClr val="FF8C30"/>
+                </a:solidFill>
+                <a:latin typeface="Manrope"/>
+              </a:defRPr>
+            </a:pPr>
+            <a:r>
+              <a:t>0 Rivals</a:t>
+            </a:r>
+          </a:p>
+          <a:p>
+            <a:pPr>
+              <a:spcAft>
                 <a:spcPts val="1200"/>
               </a:spcAft>
-              <a:defRPr sz="4800" b="1">
+              <a:defRPr sz="4000" b="1">
                 <a:solidFill>
                   <a:srgbClr val="FFFFFF"/>
                 </a:solidFill>
@@ -5221,15 +5749,12 @@
               </a:defRPr>
             </a:pPr>
             <a:r>
-              <a:t>Modular Sessions.</a:t>
+              <a:t>Across 154 Supermarket Spreads.</a:t>
             </a:r>
           </a:p>
           <a:p>
             <a:pPr>
-              <a:spcAft>
-                <a:spcPts val="1400"/>
-              </a:spcAft>
-              <a:defRPr sz="2200" b="1">
+              <a:defRPr sz="2200" b="0">
                 <a:solidFill>
                   <a:srgbClr val="FF8C30"/>
                 </a:solidFill>
@@ -5237,11 +5762,35 @@
               </a:defRPr>
             </a:pPr>
             <a:r>
-              <a:t>Separating data, branding, and copy eliminated context drift.</a:t>
-            </a:r>
-          </a:p>
-        </p:txBody>
-      </p:sp>
+              <a:t>Zero single-serve or utensil-free formats in NZ retail.</a:t>
+            </a:r>
+          </a:p>
+        </p:txBody>
+      </p:sp>
+      <p:pic>
+        <p:nvPicPr>
+          <p:cNvPr id="4" name="Picture 3" descr="wordmark_peanut.png"/>
+          <p:cNvPicPr>
+            <a:picLocks noChangeAspect="1"/>
+          </p:cNvPicPr>
+          <p:nvPr/>
+        </p:nvPicPr>
+        <p:blipFill>
+          <a:blip r:embed="rId2"/>
+          <a:stretch>
+            <a:fillRect/>
+          </a:stretch>
+        </p:blipFill>
+        <p:spPr>
+          <a:xfrm>
+            <a:off x="5410047" y="6172200"/>
+            <a:ext cx="1371600" cy="335584"/>
+          </a:xfrm>
+          <a:prstGeom prst="rect">
+            <a:avLst/>
+          </a:prstGeom>
+        </p:spPr>
+      </p:pic>
     </p:spTree>
   </p:cSld>
   <p:clrMapOvr>
@@ -5311,8 +5860,8 @@
         </p:nvSpPr>
         <p:spPr>
           <a:xfrm>
-            <a:off x="1188720" y="2011680"/>
-            <a:ext cx="9784080" cy="3657600"/>
+            <a:off x="1188720" y="822960"/>
+            <a:ext cx="9784080" cy="1280160"/>
           </a:xfrm>
           <a:prstGeom prst="rect">
             <a:avLst/>
@@ -5327,9 +5876,9 @@
           <a:p>
             <a:pPr>
               <a:spcAft>
-                <a:spcPts val="1200"/>
+                <a:spcPts val="600"/>
               </a:spcAft>
-              <a:defRPr sz="4600" b="1">
+              <a:defRPr sz="3600" b="1">
                 <a:solidFill>
                   <a:srgbClr val="FFFFFF"/>
                 </a:solidFill>
@@ -5337,23 +5886,7 @@
               </a:defRPr>
             </a:pPr>
             <a:r>
-              <a:t>Catching Butter Instability.</a:t>
-            </a:r>
-          </a:p>
-          <a:p>
-            <a:pPr>
-              <a:spcAft>
-                <a:spcPts val="1400"/>
-              </a:spcAft>
-              <a:defRPr sz="2400" b="1">
-                <a:solidFill>
-                  <a:srgbClr val="FF8C30"/>
-                </a:solidFill>
-                <a:latin typeface="Manrope"/>
-              </a:defRPr>
-            </a:pPr>
-            <a:r>
-              <a:t>AI assumed table butter could sit ambiently.</a:t>
+              <a:t>Capturing the Premium Void.</a:t>
             </a:r>
           </a:p>
           <a:p>
@@ -5366,11 +5899,59 @@
               </a:defRPr>
             </a:pPr>
             <a:r>
-              <a:t>Human intervention forced dairy spread reformulation.</a:t>
-            </a:r>
-          </a:p>
-        </p:txBody>
-      </p:sp>
+              <a:t>Targeted at $5.00 per 8-pack ($6.25/100g) against premium jars.</a:t>
+            </a:r>
+          </a:p>
+        </p:txBody>
+      </p:sp>
+      <p:pic>
+        <p:nvPicPr>
+          <p:cNvPr id="4" name="Picture 3" descr="chart_price_peanut.png"/>
+          <p:cNvPicPr>
+            <a:picLocks noChangeAspect="1"/>
+          </p:cNvPicPr>
+          <p:nvPr/>
+        </p:nvPicPr>
+        <p:blipFill>
+          <a:blip r:embed="rId2"/>
+          <a:stretch>
+            <a:fillRect/>
+          </a:stretch>
+        </p:blipFill>
+        <p:spPr>
+          <a:xfrm>
+            <a:off x="3078327" y="2148840"/>
+            <a:ext cx="6035040" cy="3372522"/>
+          </a:xfrm>
+          <a:prstGeom prst="rect">
+            <a:avLst/>
+          </a:prstGeom>
+        </p:spPr>
+      </p:pic>
+      <p:pic>
+        <p:nvPicPr>
+          <p:cNvPr id="5" name="Picture 4" descr="wordmark_peanut.png"/>
+          <p:cNvPicPr>
+            <a:picLocks noChangeAspect="1"/>
+          </p:cNvPicPr>
+          <p:nvPr/>
+        </p:nvPicPr>
+        <p:blipFill>
+          <a:blip r:embed="rId3"/>
+          <a:stretch>
+            <a:fillRect/>
+          </a:stretch>
+        </p:blipFill>
+        <p:spPr>
+          <a:xfrm>
+            <a:off x="5410047" y="6172200"/>
+            <a:ext cx="1371600" cy="335584"/>
+          </a:xfrm>
+          <a:prstGeom prst="rect">
+            <a:avLst/>
+          </a:prstGeom>
+        </p:spPr>
+      </p:pic>
     </p:spTree>
   </p:cSld>
   <p:clrMapOvr>
@@ -5440,8 +6021,8 @@
         </p:nvSpPr>
         <p:spPr>
           <a:xfrm>
-            <a:off x="1188720" y="2377440"/>
-            <a:ext cx="9784080" cy="3657600"/>
+            <a:off x="1188720" y="1645920"/>
+            <a:ext cx="9784080" cy="3840480"/>
           </a:xfrm>
           <a:prstGeom prst="rect">
             <a:avLst/>
@@ -5456,9 +6037,25 @@
           <a:p>
             <a:pPr>
               <a:spcAft>
+                <a:spcPts val="1000"/>
+              </a:spcAft>
+              <a:defRPr sz="8000" b="1">
+                <a:solidFill>
+                  <a:srgbClr val="FF8C30"/>
+                </a:solidFill>
+                <a:latin typeface="Manrope"/>
+              </a:defRPr>
+            </a:pPr>
+            <a:r>
+              <a:t>35% Margin</a:t>
+            </a:r>
+          </a:p>
+          <a:p>
+            <a:pPr>
+              <a:spcAft>
                 <a:spcPts val="1200"/>
               </a:spcAft>
-              <a:defRPr sz="4600" b="1">
+              <a:defRPr sz="4000" b="1">
                 <a:solidFill>
                   <a:srgbClr val="FFFFFF"/>
                 </a:solidFill>
@@ -5466,15 +6063,12 @@
               </a:defRPr>
             </a:pPr>
             <a:r>
-              <a:t>AI as Drafter, Not Director.</a:t>
+              <a:t>$5.00 Retail • $1.75 Gross Margin.</a:t>
             </a:r>
           </a:p>
           <a:p>
             <a:pPr>
-              <a:spcAft>
-                <a:spcPts val="1400"/>
-              </a:spcAft>
-              <a:defRPr sz="2200" b="1">
+              <a:defRPr sz="2200" b="0">
                 <a:solidFill>
                   <a:srgbClr val="FF8C30"/>
                 </a:solidFill>
@@ -5482,11 +6076,35 @@
               </a:defRPr>
             </a:pPr>
             <a:r>
-              <a:t>Auditing scan price spikes. Verifying live supermarket shelves.</a:t>
-            </a:r>
-          </a:p>
-        </p:txBody>
-      </p:sp>
+              <a:t>63¢ per serving on an assumed $1.50 co-packing cost.</a:t>
+            </a:r>
+          </a:p>
+        </p:txBody>
+      </p:sp>
+      <p:pic>
+        <p:nvPicPr>
+          <p:cNvPr id="4" name="Picture 3" descr="wordmark_peanut.png"/>
+          <p:cNvPicPr>
+            <a:picLocks noChangeAspect="1"/>
+          </p:cNvPicPr>
+          <p:nvPr/>
+        </p:nvPicPr>
+        <p:blipFill>
+          <a:blip r:embed="rId2"/>
+          <a:stretch>
+            <a:fillRect/>
+          </a:stretch>
+        </p:blipFill>
+        <p:spPr>
+          <a:xfrm>
+            <a:off x="5410047" y="6172200"/>
+            <a:ext cx="1371600" cy="335584"/>
+          </a:xfrm>
+          <a:prstGeom prst="rect">
+            <a:avLst/>
+          </a:prstGeom>
+        </p:spPr>
+      </p:pic>
     </p:spTree>
   </p:cSld>
   <p:clrMapOvr>
@@ -5520,7 +6138,7 @@
             <a:avLst/>
           </a:prstGeom>
           <a:solidFill>
-            <a:srgbClr val="240340"/>
+            <a:srgbClr val="4A3000"/>
           </a:solidFill>
           <a:ln>
             <a:noFill/>
@@ -5556,8 +6174,8 @@
         </p:nvSpPr>
         <p:spPr>
           <a:xfrm>
-            <a:off x="1188720" y="2377440"/>
-            <a:ext cx="9784080" cy="3657600"/>
+            <a:off x="1188720" y="822960"/>
+            <a:ext cx="9784080" cy="1280160"/>
           </a:xfrm>
           <a:prstGeom prst="rect">
             <a:avLst/>
@@ -5572,9 +6190,9 @@
           <a:p>
             <a:pPr>
               <a:spcAft>
-                <a:spcPts val="1200"/>
+                <a:spcPts val="600"/>
               </a:spcAft>
-              <a:defRPr sz="4800" b="1">
+              <a:defRPr sz="3600" b="1">
                 <a:solidFill>
                   <a:srgbClr val="FFFFFF"/>
                 </a:solidFill>
@@ -5582,27 +6200,72 @@
               </a:defRPr>
             </a:pPr>
             <a:r>
-              <a:t>Banning Corporate Buzzwords.</a:t>
+              <a:t>Contract Co-Manufacturing.</a:t>
             </a:r>
           </a:p>
           <a:p>
             <a:pPr>
-              <a:spcAft>
-                <a:spcPts val="1400"/>
-              </a:spcAft>
-              <a:defRPr sz="2400" b="1">
+              <a:defRPr sz="2000" b="0">
                 <a:solidFill>
-                  <a:srgbClr val="E24BFF"/>
+                  <a:srgbClr val="FFD640"/>
                 </a:solidFill>
                 <a:latin typeface="Manrope"/>
               </a:defRPr>
             </a:pPr>
             <a:r>
-              <a:t>Stripping AI hype for plain facts: Peel. Press. Toast.</a:t>
-            </a:r>
-          </a:p>
-        </p:txBody>
-      </p:sp>
+              <a:t>Continuous deposit tooling onto food-grade release liner.</a:t>
+            </a:r>
+          </a:p>
+        </p:txBody>
+      </p:sp>
+      <p:pic>
+        <p:nvPicPr>
+          <p:cNvPr id="4" name="Picture 3" descr="diagram_process_butter.png"/>
+          <p:cNvPicPr>
+            <a:picLocks noChangeAspect="1"/>
+          </p:cNvPicPr>
+          <p:nvPr/>
+        </p:nvPicPr>
+        <p:blipFill>
+          <a:blip r:embed="rId2"/>
+          <a:stretch>
+            <a:fillRect/>
+          </a:stretch>
+        </p:blipFill>
+        <p:spPr>
+          <a:xfrm>
+            <a:off x="2438247" y="2286000"/>
+            <a:ext cx="7315200" cy="2854712"/>
+          </a:xfrm>
+          <a:prstGeom prst="rect">
+            <a:avLst/>
+          </a:prstGeom>
+        </p:spPr>
+      </p:pic>
+      <p:pic>
+        <p:nvPicPr>
+          <p:cNvPr id="5" name="Picture 4" descr="wordmark_butter.png"/>
+          <p:cNvPicPr>
+            <a:picLocks noChangeAspect="1"/>
+          </p:cNvPicPr>
+          <p:nvPr/>
+        </p:nvPicPr>
+        <p:blipFill>
+          <a:blip r:embed="rId3"/>
+          <a:stretch>
+            <a:fillRect/>
+          </a:stretch>
+        </p:blipFill>
+        <p:spPr>
+          <a:xfrm>
+            <a:off x="5410047" y="6172200"/>
+            <a:ext cx="1371600" cy="335584"/>
+          </a:xfrm>
+          <a:prstGeom prst="rect">
+            <a:avLst/>
+          </a:prstGeom>
+        </p:spPr>
+      </p:pic>
     </p:spTree>
   </p:cSld>
   <p:clrMapOvr>
@@ -5636,7 +6299,7 @@
             <a:avLst/>
           </a:prstGeom>
           <a:solidFill>
-            <a:srgbClr val="240340"/>
+            <a:srgbClr val="4A3000"/>
           </a:solidFill>
           <a:ln>
             <a:noFill/>
@@ -5672,7 +6335,7 @@
         </p:nvSpPr>
         <p:spPr>
           <a:xfrm>
-            <a:off x="1188720" y="2377440"/>
+            <a:off x="1188720" y="2011680"/>
             <a:ext cx="9784080" cy="3657600"/>
           </a:xfrm>
           <a:prstGeom prst="rect">
@@ -5690,7 +6353,7 @@
               <a:spcAft>
                 <a:spcPts val="1200"/>
               </a:spcAft>
-              <a:defRPr sz="4800" b="1">
+              <a:defRPr sz="4600" b="1">
                 <a:solidFill>
                   <a:srgbClr val="FFFFFF"/>
                 </a:solidFill>
@@ -5698,7 +6361,7 @@
               </a:defRPr>
             </a:pPr>
             <a:r>
-              <a:t>Zero Hallucination Tolerance.</a:t>
+              <a:t>Lean Capex Pilot.</a:t>
             </a:r>
           </a:p>
           <a:p>
@@ -5708,17 +6371,54 @@
               </a:spcAft>
               <a:defRPr sz="2400" b="1">
                 <a:solidFill>
-                  <a:srgbClr val="E24BFF"/>
+                  <a:srgbClr val="FFD640"/>
                 </a:solidFill>
                 <a:latin typeface="Manrope"/>
               </a:defRPr>
             </a:pPr>
             <a:r>
-              <a:t>Strict FSANZ food laws and prominent allergen warnings.</a:t>
-            </a:r>
-          </a:p>
-        </p:txBody>
-      </p:sp>
+              <a:t>Partnering with Auckland contract food packagers.</a:t>
+            </a:r>
+          </a:p>
+          <a:p>
+            <a:pPr>
+              <a:defRPr sz="2200" b="1">
+                <a:solidFill>
+                  <a:srgbClr val="FFFFFF"/>
+                </a:solidFill>
+                <a:latin typeface="Manrope"/>
+              </a:defRPr>
+            </a:pPr>
+            <a:r>
+              <a:t>Zero heavy machinery outlay required for market entry.</a:t>
+            </a:r>
+          </a:p>
+        </p:txBody>
+      </p:sp>
+      <p:pic>
+        <p:nvPicPr>
+          <p:cNvPr id="4" name="Picture 3" descr="wordmark_butter.png"/>
+          <p:cNvPicPr>
+            <a:picLocks noChangeAspect="1"/>
+          </p:cNvPicPr>
+          <p:nvPr/>
+        </p:nvPicPr>
+        <p:blipFill>
+          <a:blip r:embed="rId2"/>
+          <a:stretch>
+            <a:fillRect/>
+          </a:stretch>
+        </p:blipFill>
+        <p:spPr>
+          <a:xfrm>
+            <a:off x="5410047" y="6172200"/>
+            <a:ext cx="1371600" cy="335584"/>
+          </a:xfrm>
+          <a:prstGeom prst="rect">
+            <a:avLst/>
+          </a:prstGeom>
+        </p:spPr>
+      </p:pic>
     </p:spTree>
   </p:cSld>
   <p:clrMapOvr>
@@ -5752,7 +6452,7 @@
             <a:avLst/>
           </a:prstGeom>
           <a:solidFill>
-            <a:srgbClr val="240340"/>
+            <a:srgbClr val="460820"/>
           </a:solidFill>
           <a:ln>
             <a:noFill/>
@@ -5788,6 +6488,159 @@
         </p:nvSpPr>
         <p:spPr>
           <a:xfrm>
+            <a:off x="1188720" y="2011680"/>
+            <a:ext cx="9784080" cy="3657600"/>
+          </a:xfrm>
+          <a:prstGeom prst="rect">
+            <a:avLst/>
+          </a:prstGeom>
+          <a:noFill/>
+        </p:spPr>
+        <p:txBody>
+          <a:bodyPr wrap="square" lIns="0" tIns="0" rIns="0" bIns="0">
+            <a:spAutoFit/>
+          </a:bodyPr>
+          <a:lstStyle/>
+          <a:p>
+            <a:pPr>
+              <a:spcAft>
+                <a:spcPts val="1200"/>
+              </a:spcAft>
+              <a:defRPr sz="2200" b="1">
+                <a:solidFill>
+                  <a:srgbClr val="FF467A"/>
+                </a:solidFill>
+                <a:latin typeface="Manrope"/>
+              </a:defRPr>
+            </a:pPr>
+            <a:r>
+              <a:t>Negative Constraints.</a:t>
+            </a:r>
+          </a:p>
+          <a:p>
+            <a:pPr>
+              <a:spcAft>
+                <a:spcPts val="1400"/>
+              </a:spcAft>
+              <a:defRPr sz="4800" b="1">
+                <a:solidFill>
+                  <a:srgbClr val="FFFFFF"/>
+                </a:solidFill>
+                <a:latin typeface="Manrope"/>
+              </a:defRPr>
+            </a:pPr>
+            <a:r>
+              <a:t>Banning AI Marketing Hype.</a:t>
+            </a:r>
+          </a:p>
+          <a:p>
+            <a:pPr>
+              <a:defRPr sz="2200" b="0">
+                <a:solidFill>
+                  <a:srgbClr val="FF467A"/>
+                </a:solidFill>
+                <a:latin typeface="Manrope"/>
+              </a:defRPr>
+            </a:pPr>
+            <a:r>
+              <a:t>Explicit negative prompts barred fake badges and health claims.</a:t>
+            </a:r>
+          </a:p>
+        </p:txBody>
+      </p:sp>
+      <p:pic>
+        <p:nvPicPr>
+          <p:cNvPr id="4" name="Picture 3" descr="wordmark_raspberry.png"/>
+          <p:cNvPicPr>
+            <a:picLocks noChangeAspect="1"/>
+          </p:cNvPicPr>
+          <p:nvPr/>
+        </p:nvPicPr>
+        <p:blipFill>
+          <a:blip r:embed="rId2"/>
+          <a:stretch>
+            <a:fillRect/>
+          </a:stretch>
+        </p:blipFill>
+        <p:spPr>
+          <a:xfrm>
+            <a:off x="5410047" y="6172200"/>
+            <a:ext cx="1371600" cy="335584"/>
+          </a:xfrm>
+          <a:prstGeom prst="rect">
+            <a:avLst/>
+          </a:prstGeom>
+        </p:spPr>
+      </p:pic>
+    </p:spTree>
+  </p:cSld>
+  <p:clrMapOvr>
+    <a:masterClrMapping/>
+  </p:clrMapOvr>
+</p:sld>
+</file>
+
+<file path=ppt/slides/slide18.xml><?xml version="1.0" encoding="utf-8"?>
+<p:sld xmlns:a="http://schemas.openxmlformats.org/drawingml/2006/main" xmlns:p="http://schemas.openxmlformats.org/presentationml/2006/main" xmlns:r="http://schemas.openxmlformats.org/officeDocument/2006/relationships">
+  <p:cSld>
+    <p:spTree>
+      <p:nvGrpSpPr>
+        <p:cNvPr id="1" name=""/>
+        <p:cNvGrpSpPr/>
+        <p:nvPr/>
+      </p:nvGrpSpPr>
+      <p:grpSpPr/>
+      <p:sp>
+        <p:nvSpPr>
+          <p:cNvPr id="2" name="Rectangle 1"/>
+          <p:cNvSpPr/>
+          <p:nvPr/>
+        </p:nvSpPr>
+        <p:spPr>
+          <a:xfrm>
+            <a:off x="0" y="0"/>
+            <a:ext cx="12191695" cy="6858000"/>
+          </a:xfrm>
+          <a:prstGeom prst="rect">
+            <a:avLst/>
+          </a:prstGeom>
+          <a:solidFill>
+            <a:srgbClr val="460820"/>
+          </a:solidFill>
+          <a:ln>
+            <a:noFill/>
+          </a:ln>
+        </p:spPr>
+        <p:style>
+          <a:lnRef idx="1">
+            <a:schemeClr val="accent1"/>
+          </a:lnRef>
+          <a:fillRef idx="3">
+            <a:schemeClr val="accent1"/>
+          </a:fillRef>
+          <a:effectRef idx="2">
+            <a:schemeClr val="accent1"/>
+          </a:effectRef>
+          <a:fontRef idx="minor">
+            <a:schemeClr val="lt1"/>
+          </a:fontRef>
+        </p:style>
+        <p:txBody>
+          <a:bodyPr rtlCol="0" anchor="ctr"/>
+          <a:lstStyle/>
+          <a:p>
+            <a:pPr algn="ctr"/>
+          </a:p>
+        </p:txBody>
+      </p:sp>
+      <p:sp>
+        <p:nvSpPr>
+          <p:cNvPr id="3" name="TextBox 2"/>
+          <p:cNvSpPr txBox="1"/>
+          <p:nvPr/>
+        </p:nvSpPr>
+        <p:spPr>
+          <a:xfrm>
             <a:off x="1188720" y="2377440"/>
             <a:ext cx="9784080" cy="3657600"/>
           </a:xfrm>
@@ -5814,7 +6667,7 @@
               </a:defRPr>
             </a:pPr>
             <a:r>
-              <a:t>Accountability Remains Human.</a:t>
+              <a:t>Modular Architecture.</a:t>
             </a:r>
           </a:p>
           <a:p>
@@ -5824,17 +6677,194 @@
               </a:spcAft>
               <a:defRPr sz="2400" b="1">
                 <a:solidFill>
-                  <a:srgbClr val="E24BFF"/>
+                  <a:srgbClr val="FF467A"/>
                 </a:solidFill>
                 <a:latin typeface="Manrope"/>
               </a:defRPr>
             </a:pPr>
             <a:r>
-              <a:t>Moral and legal ownership can never be outsourced.</a:t>
-            </a:r>
-          </a:p>
-        </p:txBody>
-      </p:sp>
+              <a:t>Separating data, branding, and copy eliminated context drift.</a:t>
+            </a:r>
+          </a:p>
+        </p:txBody>
+      </p:sp>
+      <p:pic>
+        <p:nvPicPr>
+          <p:cNvPr id="4" name="Picture 3" descr="wordmark_raspberry.png"/>
+          <p:cNvPicPr>
+            <a:picLocks noChangeAspect="1"/>
+          </p:cNvPicPr>
+          <p:nvPr/>
+        </p:nvPicPr>
+        <p:blipFill>
+          <a:blip r:embed="rId2"/>
+          <a:stretch>
+            <a:fillRect/>
+          </a:stretch>
+        </p:blipFill>
+        <p:spPr>
+          <a:xfrm>
+            <a:off x="5410047" y="6172200"/>
+            <a:ext cx="1371600" cy="335584"/>
+          </a:xfrm>
+          <a:prstGeom prst="rect">
+            <a:avLst/>
+          </a:prstGeom>
+        </p:spPr>
+      </p:pic>
+    </p:spTree>
+  </p:cSld>
+  <p:clrMapOvr>
+    <a:masterClrMapping/>
+  </p:clrMapOvr>
+</p:sld>
+</file>
+
+<file path=ppt/slides/slide19.xml><?xml version="1.0" encoding="utf-8"?>
+<p:sld xmlns:a="http://schemas.openxmlformats.org/drawingml/2006/main" xmlns:p="http://schemas.openxmlformats.org/presentationml/2006/main" xmlns:r="http://schemas.openxmlformats.org/officeDocument/2006/relationships">
+  <p:cSld>
+    <p:spTree>
+      <p:nvGrpSpPr>
+        <p:cNvPr id="1" name=""/>
+        <p:cNvGrpSpPr/>
+        <p:nvPr/>
+      </p:nvGrpSpPr>
+      <p:grpSpPr/>
+      <p:sp>
+        <p:nvSpPr>
+          <p:cNvPr id="2" name="Rectangle 1"/>
+          <p:cNvSpPr/>
+          <p:nvPr/>
+        </p:nvSpPr>
+        <p:spPr>
+          <a:xfrm>
+            <a:off x="0" y="0"/>
+            <a:ext cx="12191695" cy="6858000"/>
+          </a:xfrm>
+          <a:prstGeom prst="rect">
+            <a:avLst/>
+          </a:prstGeom>
+          <a:solidFill>
+            <a:srgbClr val="460820"/>
+          </a:solidFill>
+          <a:ln>
+            <a:noFill/>
+          </a:ln>
+        </p:spPr>
+        <p:style>
+          <a:lnRef idx="1">
+            <a:schemeClr val="accent1"/>
+          </a:lnRef>
+          <a:fillRef idx="3">
+            <a:schemeClr val="accent1"/>
+          </a:fillRef>
+          <a:effectRef idx="2">
+            <a:schemeClr val="accent1"/>
+          </a:effectRef>
+          <a:fontRef idx="minor">
+            <a:schemeClr val="lt1"/>
+          </a:fontRef>
+        </p:style>
+        <p:txBody>
+          <a:bodyPr rtlCol="0" anchor="ctr"/>
+          <a:lstStyle/>
+          <a:p>
+            <a:pPr algn="ctr"/>
+          </a:p>
+        </p:txBody>
+      </p:sp>
+      <p:sp>
+        <p:nvSpPr>
+          <p:cNvPr id="3" name="TextBox 2"/>
+          <p:cNvSpPr txBox="1"/>
+          <p:nvPr/>
+        </p:nvSpPr>
+        <p:spPr>
+          <a:xfrm>
+            <a:off x="1188720" y="2011680"/>
+            <a:ext cx="9784080" cy="3657600"/>
+          </a:xfrm>
+          <a:prstGeom prst="rect">
+            <a:avLst/>
+          </a:prstGeom>
+          <a:noFill/>
+        </p:spPr>
+        <p:txBody>
+          <a:bodyPr wrap="square" lIns="0" tIns="0" rIns="0" bIns="0">
+            <a:spAutoFit/>
+          </a:bodyPr>
+          <a:lstStyle/>
+          <a:p>
+            <a:pPr>
+              <a:spcAft>
+                <a:spcPts val="1200"/>
+              </a:spcAft>
+              <a:defRPr sz="4600" b="1">
+                <a:solidFill>
+                  <a:srgbClr val="FFFFFF"/>
+                </a:solidFill>
+                <a:latin typeface="Manrope"/>
+              </a:defRPr>
+            </a:pPr>
+            <a:r>
+              <a:t>Catching Dairy Instability.</a:t>
+            </a:r>
+          </a:p>
+          <a:p>
+            <a:pPr>
+              <a:spcAft>
+                <a:spcPts val="1400"/>
+              </a:spcAft>
+              <a:defRPr sz="2600" b="1">
+                <a:solidFill>
+                  <a:srgbClr val="FF467A"/>
+                </a:solidFill>
+                <a:latin typeface="Manrope"/>
+              </a:defRPr>
+            </a:pPr>
+            <a:r>
+              <a:t>AI assumed table butter could sit ambiently.</a:t>
+            </a:r>
+          </a:p>
+          <a:p>
+            <a:pPr>
+              <a:defRPr sz="2200" b="1">
+                <a:solidFill>
+                  <a:srgbClr val="FFFFFF"/>
+                </a:solidFill>
+                <a:latin typeface="Manrope"/>
+              </a:defRPr>
+            </a:pPr>
+            <a:r>
+              <a:t>Human intervention forced high-stability emulsion.</a:t>
+            </a:r>
+          </a:p>
+        </p:txBody>
+      </p:sp>
+      <p:pic>
+        <p:nvPicPr>
+          <p:cNvPr id="4" name="Picture 3" descr="wordmark_raspberry.png"/>
+          <p:cNvPicPr>
+            <a:picLocks noChangeAspect="1"/>
+          </p:cNvPicPr>
+          <p:nvPr/>
+        </p:nvPicPr>
+        <p:blipFill>
+          <a:blip r:embed="rId2"/>
+          <a:stretch>
+            <a:fillRect/>
+          </a:stretch>
+        </p:blipFill>
+        <p:spPr>
+          <a:xfrm>
+            <a:off x="5410047" y="6172200"/>
+            <a:ext cx="1371600" cy="335584"/>
+          </a:xfrm>
+          <a:prstGeom prst="rect">
+            <a:avLst/>
+          </a:prstGeom>
+        </p:spPr>
+      </p:pic>
     </p:spTree>
   </p:cSld>
   <p:clrMapOvr>
@@ -5868,7 +6898,7 @@
             <a:avLst/>
           </a:prstGeom>
           <a:solidFill>
-            <a:srgbClr val="4A3000"/>
+            <a:srgbClr val="460820"/>
           </a:solidFill>
           <a:ln>
             <a:noFill/>
@@ -5924,7 +6954,7 @@
               </a:spcAft>
               <a:defRPr sz="2200" b="1">
                 <a:solidFill>
-                  <a:srgbClr val="FFD640"/>
+                  <a:srgbClr val="FF467A"/>
                 </a:solidFill>
                 <a:latin typeface="Manrope"/>
               </a:defRPr>
@@ -5953,17 +6983,614 @@
             <a:pPr>
               <a:defRPr sz="2200" b="0">
                 <a:solidFill>
-                  <a:srgbClr val="FFD640"/>
+                  <a:srgbClr val="FF467A"/>
                 </a:solidFill>
                 <a:latin typeface="Manrope"/>
               </a:defRPr>
             </a:pPr>
             <a:r>
-              <a:t>Table knives, kitchen counters, and sink washing.</a:t>
-            </a:r>
-          </a:p>
-        </p:txBody>
-      </p:sp>
+              <a:t>Table knives, kitchen benches, and hot running water.</a:t>
+            </a:r>
+          </a:p>
+        </p:txBody>
+      </p:sp>
+      <p:pic>
+        <p:nvPicPr>
+          <p:cNvPr id="4" name="Picture 3" descr="wordmark_raspberry.png"/>
+          <p:cNvPicPr>
+            <a:picLocks noChangeAspect="1"/>
+          </p:cNvPicPr>
+          <p:nvPr/>
+        </p:nvPicPr>
+        <p:blipFill>
+          <a:blip r:embed="rId2"/>
+          <a:stretch>
+            <a:fillRect/>
+          </a:stretch>
+        </p:blipFill>
+        <p:spPr>
+          <a:xfrm>
+            <a:off x="5410047" y="6172200"/>
+            <a:ext cx="1371600" cy="335584"/>
+          </a:xfrm>
+          <a:prstGeom prst="rect">
+            <a:avLst/>
+          </a:prstGeom>
+        </p:spPr>
+      </p:pic>
+    </p:spTree>
+  </p:cSld>
+  <p:clrMapOvr>
+    <a:masterClrMapping/>
+  </p:clrMapOvr>
+</p:sld>
+</file>
+
+<file path=ppt/slides/slide20.xml><?xml version="1.0" encoding="utf-8"?>
+<p:sld xmlns:a="http://schemas.openxmlformats.org/drawingml/2006/main" xmlns:p="http://schemas.openxmlformats.org/presentationml/2006/main" xmlns:r="http://schemas.openxmlformats.org/officeDocument/2006/relationships">
+  <p:cSld>
+    <p:spTree>
+      <p:nvGrpSpPr>
+        <p:cNvPr id="1" name=""/>
+        <p:cNvGrpSpPr/>
+        <p:nvPr/>
+      </p:nvGrpSpPr>
+      <p:grpSpPr/>
+      <p:sp>
+        <p:nvSpPr>
+          <p:cNvPr id="2" name="Rectangle 1"/>
+          <p:cNvSpPr/>
+          <p:nvPr/>
+        </p:nvSpPr>
+        <p:spPr>
+          <a:xfrm>
+            <a:off x="0" y="0"/>
+            <a:ext cx="12191695" cy="6858000"/>
+          </a:xfrm>
+          <a:prstGeom prst="rect">
+            <a:avLst/>
+          </a:prstGeom>
+          <a:solidFill>
+            <a:srgbClr val="460820"/>
+          </a:solidFill>
+          <a:ln>
+            <a:noFill/>
+          </a:ln>
+        </p:spPr>
+        <p:style>
+          <a:lnRef idx="1">
+            <a:schemeClr val="accent1"/>
+          </a:lnRef>
+          <a:fillRef idx="3">
+            <a:schemeClr val="accent1"/>
+          </a:fillRef>
+          <a:effectRef idx="2">
+            <a:schemeClr val="accent1"/>
+          </a:effectRef>
+          <a:fontRef idx="minor">
+            <a:schemeClr val="lt1"/>
+          </a:fontRef>
+        </p:style>
+        <p:txBody>
+          <a:bodyPr rtlCol="0" anchor="ctr"/>
+          <a:lstStyle/>
+          <a:p>
+            <a:pPr algn="ctr"/>
+          </a:p>
+        </p:txBody>
+      </p:sp>
+      <p:sp>
+        <p:nvSpPr>
+          <p:cNvPr id="3" name="TextBox 2"/>
+          <p:cNvSpPr txBox="1"/>
+          <p:nvPr/>
+        </p:nvSpPr>
+        <p:spPr>
+          <a:xfrm>
+            <a:off x="1188720" y="2377440"/>
+            <a:ext cx="9784080" cy="3657600"/>
+          </a:xfrm>
+          <a:prstGeom prst="rect">
+            <a:avLst/>
+          </a:prstGeom>
+          <a:noFill/>
+        </p:spPr>
+        <p:txBody>
+          <a:bodyPr wrap="square" lIns="0" tIns="0" rIns="0" bIns="0">
+            <a:spAutoFit/>
+          </a:bodyPr>
+          <a:lstStyle/>
+          <a:p>
+            <a:pPr>
+              <a:spcAft>
+                <a:spcPts val="1200"/>
+              </a:spcAft>
+              <a:defRPr sz="4600" b="1">
+                <a:solidFill>
+                  <a:srgbClr val="FFFFFF"/>
+                </a:solidFill>
+                <a:latin typeface="Manrope"/>
+              </a:defRPr>
+            </a:pPr>
+            <a:r>
+              <a:t>AI as Drafter, Not Director.</a:t>
+            </a:r>
+          </a:p>
+          <a:p>
+            <a:pPr>
+              <a:spcAft>
+                <a:spcPts val="1400"/>
+              </a:spcAft>
+              <a:defRPr sz="2400" b="1">
+                <a:solidFill>
+                  <a:srgbClr val="FF467A"/>
+                </a:solidFill>
+                <a:latin typeface="Manrope"/>
+              </a:defRPr>
+            </a:pPr>
+            <a:r>
+              <a:t>Auditing raw scan outliers and verifying live supermarket shelves.</a:t>
+            </a:r>
+          </a:p>
+        </p:txBody>
+      </p:sp>
+      <p:pic>
+        <p:nvPicPr>
+          <p:cNvPr id="4" name="Picture 3" descr="wordmark_raspberry.png"/>
+          <p:cNvPicPr>
+            <a:picLocks noChangeAspect="1"/>
+          </p:cNvPicPr>
+          <p:nvPr/>
+        </p:nvPicPr>
+        <p:blipFill>
+          <a:blip r:embed="rId2"/>
+          <a:stretch>
+            <a:fillRect/>
+          </a:stretch>
+        </p:blipFill>
+        <p:spPr>
+          <a:xfrm>
+            <a:off x="5410047" y="6172200"/>
+            <a:ext cx="1371600" cy="335584"/>
+          </a:xfrm>
+          <a:prstGeom prst="rect">
+            <a:avLst/>
+          </a:prstGeom>
+        </p:spPr>
+      </p:pic>
+    </p:spTree>
+  </p:cSld>
+  <p:clrMapOvr>
+    <a:masterClrMapping/>
+  </p:clrMapOvr>
+</p:sld>
+</file>
+
+<file path=ppt/slides/slide21.xml><?xml version="1.0" encoding="utf-8"?>
+<p:sld xmlns:a="http://schemas.openxmlformats.org/drawingml/2006/main" xmlns:p="http://schemas.openxmlformats.org/presentationml/2006/main" xmlns:r="http://schemas.openxmlformats.org/officeDocument/2006/relationships">
+  <p:cSld>
+    <p:spTree>
+      <p:nvGrpSpPr>
+        <p:cNvPr id="1" name=""/>
+        <p:cNvGrpSpPr/>
+        <p:nvPr/>
+      </p:nvGrpSpPr>
+      <p:grpSpPr/>
+      <p:sp>
+        <p:nvSpPr>
+          <p:cNvPr id="2" name="Rectangle 1"/>
+          <p:cNvSpPr/>
+          <p:nvPr/>
+        </p:nvSpPr>
+        <p:spPr>
+          <a:xfrm>
+            <a:off x="0" y="0"/>
+            <a:ext cx="12191695" cy="6858000"/>
+          </a:xfrm>
+          <a:prstGeom prst="rect">
+            <a:avLst/>
+          </a:prstGeom>
+          <a:solidFill>
+            <a:srgbClr val="240340"/>
+          </a:solidFill>
+          <a:ln>
+            <a:noFill/>
+          </a:ln>
+        </p:spPr>
+        <p:style>
+          <a:lnRef idx="1">
+            <a:schemeClr val="accent1"/>
+          </a:lnRef>
+          <a:fillRef idx="3">
+            <a:schemeClr val="accent1"/>
+          </a:fillRef>
+          <a:effectRef idx="2">
+            <a:schemeClr val="accent1"/>
+          </a:effectRef>
+          <a:fontRef idx="minor">
+            <a:schemeClr val="lt1"/>
+          </a:fontRef>
+        </p:style>
+        <p:txBody>
+          <a:bodyPr rtlCol="0" anchor="ctr"/>
+          <a:lstStyle/>
+          <a:p>
+            <a:pPr algn="ctr"/>
+          </a:p>
+        </p:txBody>
+      </p:sp>
+      <p:sp>
+        <p:nvSpPr>
+          <p:cNvPr id="3" name="TextBox 2"/>
+          <p:cNvSpPr txBox="1"/>
+          <p:nvPr/>
+        </p:nvSpPr>
+        <p:spPr>
+          <a:xfrm>
+            <a:off x="1188720" y="2011680"/>
+            <a:ext cx="9784080" cy="3657600"/>
+          </a:xfrm>
+          <a:prstGeom prst="rect">
+            <a:avLst/>
+          </a:prstGeom>
+          <a:noFill/>
+        </p:spPr>
+        <p:txBody>
+          <a:bodyPr wrap="square" lIns="0" tIns="0" rIns="0" bIns="0">
+            <a:spAutoFit/>
+          </a:bodyPr>
+          <a:lstStyle/>
+          <a:p>
+            <a:pPr>
+              <a:spcAft>
+                <a:spcPts val="1200"/>
+              </a:spcAft>
+              <a:defRPr sz="4800" b="1">
+                <a:solidFill>
+                  <a:srgbClr val="FFFFFF"/>
+                </a:solidFill>
+                <a:latin typeface="Manrope"/>
+              </a:defRPr>
+            </a:pPr>
+            <a:r>
+              <a:t>Combating AI Slop.</a:t>
+            </a:r>
+          </a:p>
+          <a:p>
+            <a:pPr>
+              <a:spcAft>
+                <a:spcPts val="1400"/>
+              </a:spcAft>
+              <a:defRPr sz="2600" b="1">
+                <a:solidFill>
+                  <a:srgbClr val="E24BFF"/>
+                </a:solidFill>
+                <a:latin typeface="Manrope"/>
+              </a:defRPr>
+            </a:pPr>
+            <a:r>
+              <a:t>Stripping corporate buzzwords for plain human facts.</a:t>
+            </a:r>
+          </a:p>
+          <a:p>
+            <a:pPr>
+              <a:defRPr sz="2400" b="1">
+                <a:solidFill>
+                  <a:srgbClr val="FFFFFF"/>
+                </a:solidFill>
+                <a:latin typeface="Manrope"/>
+              </a:defRPr>
+            </a:pPr>
+            <a:r>
+              <a:t>Peel. Press. Toast.</a:t>
+            </a:r>
+          </a:p>
+        </p:txBody>
+      </p:sp>
+      <p:pic>
+        <p:nvPicPr>
+          <p:cNvPr id="4" name="Picture 3" descr="wordmark_yeast.png"/>
+          <p:cNvPicPr>
+            <a:picLocks noChangeAspect="1"/>
+          </p:cNvPicPr>
+          <p:nvPr/>
+        </p:nvPicPr>
+        <p:blipFill>
+          <a:blip r:embed="rId2"/>
+          <a:stretch>
+            <a:fillRect/>
+          </a:stretch>
+        </p:blipFill>
+        <p:spPr>
+          <a:xfrm>
+            <a:off x="5410047" y="6172200"/>
+            <a:ext cx="1371600" cy="335584"/>
+          </a:xfrm>
+          <a:prstGeom prst="rect">
+            <a:avLst/>
+          </a:prstGeom>
+        </p:spPr>
+      </p:pic>
+    </p:spTree>
+  </p:cSld>
+  <p:clrMapOvr>
+    <a:masterClrMapping/>
+  </p:clrMapOvr>
+</p:sld>
+</file>
+
+<file path=ppt/slides/slide22.xml><?xml version="1.0" encoding="utf-8"?>
+<p:sld xmlns:a="http://schemas.openxmlformats.org/drawingml/2006/main" xmlns:p="http://schemas.openxmlformats.org/presentationml/2006/main" xmlns:r="http://schemas.openxmlformats.org/officeDocument/2006/relationships">
+  <p:cSld>
+    <p:spTree>
+      <p:nvGrpSpPr>
+        <p:cNvPr id="1" name=""/>
+        <p:cNvGrpSpPr/>
+        <p:nvPr/>
+      </p:nvGrpSpPr>
+      <p:grpSpPr/>
+      <p:sp>
+        <p:nvSpPr>
+          <p:cNvPr id="2" name="Rectangle 1"/>
+          <p:cNvSpPr/>
+          <p:nvPr/>
+        </p:nvSpPr>
+        <p:spPr>
+          <a:xfrm>
+            <a:off x="0" y="0"/>
+            <a:ext cx="12191695" cy="6858000"/>
+          </a:xfrm>
+          <a:prstGeom prst="rect">
+            <a:avLst/>
+          </a:prstGeom>
+          <a:solidFill>
+            <a:srgbClr val="240340"/>
+          </a:solidFill>
+          <a:ln>
+            <a:noFill/>
+          </a:ln>
+        </p:spPr>
+        <p:style>
+          <a:lnRef idx="1">
+            <a:schemeClr val="accent1"/>
+          </a:lnRef>
+          <a:fillRef idx="3">
+            <a:schemeClr val="accent1"/>
+          </a:fillRef>
+          <a:effectRef idx="2">
+            <a:schemeClr val="accent1"/>
+          </a:effectRef>
+          <a:fontRef idx="minor">
+            <a:schemeClr val="lt1"/>
+          </a:fontRef>
+        </p:style>
+        <p:txBody>
+          <a:bodyPr rtlCol="0" anchor="ctr"/>
+          <a:lstStyle/>
+          <a:p>
+            <a:pPr algn="ctr"/>
+          </a:p>
+        </p:txBody>
+      </p:sp>
+      <p:sp>
+        <p:nvSpPr>
+          <p:cNvPr id="3" name="TextBox 2"/>
+          <p:cNvSpPr txBox="1"/>
+          <p:nvPr/>
+        </p:nvSpPr>
+        <p:spPr>
+          <a:xfrm>
+            <a:off x="1188720" y="2377440"/>
+            <a:ext cx="9784080" cy="3657600"/>
+          </a:xfrm>
+          <a:prstGeom prst="rect">
+            <a:avLst/>
+          </a:prstGeom>
+          <a:noFill/>
+        </p:spPr>
+        <p:txBody>
+          <a:bodyPr wrap="square" lIns="0" tIns="0" rIns="0" bIns="0">
+            <a:spAutoFit/>
+          </a:bodyPr>
+          <a:lstStyle/>
+          <a:p>
+            <a:pPr>
+              <a:spcAft>
+                <a:spcPts val="1200"/>
+              </a:spcAft>
+              <a:defRPr sz="4800" b="1">
+                <a:solidFill>
+                  <a:srgbClr val="FFFFFF"/>
+                </a:solidFill>
+                <a:latin typeface="Manrope"/>
+              </a:defRPr>
+            </a:pPr>
+            <a:r>
+              <a:t>Zero Hallucination Tolerance.</a:t>
+            </a:r>
+          </a:p>
+          <a:p>
+            <a:pPr>
+              <a:spcAft>
+                <a:spcPts val="1400"/>
+              </a:spcAft>
+              <a:defRPr sz="2400" b="1">
+                <a:solidFill>
+                  <a:srgbClr val="E24BFF"/>
+                </a:solidFill>
+                <a:latin typeface="Manrope"/>
+              </a:defRPr>
+            </a:pPr>
+            <a:r>
+              <a:t>Strict FSANZ food laws and mandatory allergen warnings.</a:t>
+            </a:r>
+          </a:p>
+        </p:txBody>
+      </p:sp>
+      <p:pic>
+        <p:nvPicPr>
+          <p:cNvPr id="4" name="Picture 3" descr="wordmark_yeast.png"/>
+          <p:cNvPicPr>
+            <a:picLocks noChangeAspect="1"/>
+          </p:cNvPicPr>
+          <p:nvPr/>
+        </p:nvPicPr>
+        <p:blipFill>
+          <a:blip r:embed="rId2"/>
+          <a:stretch>
+            <a:fillRect/>
+          </a:stretch>
+        </p:blipFill>
+        <p:spPr>
+          <a:xfrm>
+            <a:off x="5410047" y="6172200"/>
+            <a:ext cx="1371600" cy="335584"/>
+          </a:xfrm>
+          <a:prstGeom prst="rect">
+            <a:avLst/>
+          </a:prstGeom>
+        </p:spPr>
+      </p:pic>
+    </p:spTree>
+  </p:cSld>
+  <p:clrMapOvr>
+    <a:masterClrMapping/>
+  </p:clrMapOvr>
+</p:sld>
+</file>
+
+<file path=ppt/slides/slide23.xml><?xml version="1.0" encoding="utf-8"?>
+<p:sld xmlns:a="http://schemas.openxmlformats.org/drawingml/2006/main" xmlns:p="http://schemas.openxmlformats.org/presentationml/2006/main" xmlns:r="http://schemas.openxmlformats.org/officeDocument/2006/relationships">
+  <p:cSld>
+    <p:spTree>
+      <p:nvGrpSpPr>
+        <p:cNvPr id="1" name=""/>
+        <p:cNvGrpSpPr/>
+        <p:nvPr/>
+      </p:nvGrpSpPr>
+      <p:grpSpPr/>
+      <p:sp>
+        <p:nvSpPr>
+          <p:cNvPr id="2" name="Rectangle 1"/>
+          <p:cNvSpPr/>
+          <p:nvPr/>
+        </p:nvSpPr>
+        <p:spPr>
+          <a:xfrm>
+            <a:off x="0" y="0"/>
+            <a:ext cx="12191695" cy="6858000"/>
+          </a:xfrm>
+          <a:prstGeom prst="rect">
+            <a:avLst/>
+          </a:prstGeom>
+          <a:solidFill>
+            <a:srgbClr val="240340"/>
+          </a:solidFill>
+          <a:ln>
+            <a:noFill/>
+          </a:ln>
+        </p:spPr>
+        <p:style>
+          <a:lnRef idx="1">
+            <a:schemeClr val="accent1"/>
+          </a:lnRef>
+          <a:fillRef idx="3">
+            <a:schemeClr val="accent1"/>
+          </a:fillRef>
+          <a:effectRef idx="2">
+            <a:schemeClr val="accent1"/>
+          </a:effectRef>
+          <a:fontRef idx="minor">
+            <a:schemeClr val="lt1"/>
+          </a:fontRef>
+        </p:style>
+        <p:txBody>
+          <a:bodyPr rtlCol="0" anchor="ctr"/>
+          <a:lstStyle/>
+          <a:p>
+            <a:pPr algn="ctr"/>
+          </a:p>
+        </p:txBody>
+      </p:sp>
+      <p:sp>
+        <p:nvSpPr>
+          <p:cNvPr id="3" name="TextBox 2"/>
+          <p:cNvSpPr txBox="1"/>
+          <p:nvPr/>
+        </p:nvSpPr>
+        <p:spPr>
+          <a:xfrm>
+            <a:off x="1188720" y="2377440"/>
+            <a:ext cx="9784080" cy="3657600"/>
+          </a:xfrm>
+          <a:prstGeom prst="rect">
+            <a:avLst/>
+          </a:prstGeom>
+          <a:noFill/>
+        </p:spPr>
+        <p:txBody>
+          <a:bodyPr wrap="square" lIns="0" tIns="0" rIns="0" bIns="0">
+            <a:spAutoFit/>
+          </a:bodyPr>
+          <a:lstStyle/>
+          <a:p>
+            <a:pPr>
+              <a:spcAft>
+                <a:spcPts val="1200"/>
+              </a:spcAft>
+              <a:defRPr sz="4800" b="1">
+                <a:solidFill>
+                  <a:srgbClr val="FFFFFF"/>
+                </a:solidFill>
+                <a:latin typeface="Manrope"/>
+              </a:defRPr>
+            </a:pPr>
+            <a:r>
+              <a:t>Accountability Remains Human.</a:t>
+            </a:r>
+          </a:p>
+          <a:p>
+            <a:pPr>
+              <a:spcAft>
+                <a:spcPts val="1400"/>
+              </a:spcAft>
+              <a:defRPr sz="2400" b="1">
+                <a:solidFill>
+                  <a:srgbClr val="E24BFF"/>
+                </a:solidFill>
+                <a:latin typeface="Manrope"/>
+              </a:defRPr>
+            </a:pPr>
+            <a:r>
+              <a:t>Moral, regulatory, and commercial ownership cannot be outsourced.</a:t>
+            </a:r>
+          </a:p>
+        </p:txBody>
+      </p:sp>
+      <p:pic>
+        <p:nvPicPr>
+          <p:cNvPr id="4" name="Picture 3" descr="wordmark_yeast.png"/>
+          <p:cNvPicPr>
+            <a:picLocks noChangeAspect="1"/>
+          </p:cNvPicPr>
+          <p:nvPr/>
+        </p:nvPicPr>
+        <p:blipFill>
+          <a:blip r:embed="rId2"/>
+          <a:stretch>
+            <a:fillRect/>
+          </a:stretch>
+        </p:blipFill>
+        <p:spPr>
+          <a:xfrm>
+            <a:off x="5410047" y="6172200"/>
+            <a:ext cx="1371600" cy="335584"/>
+          </a:xfrm>
+          <a:prstGeom prst="rect">
+            <a:avLst/>
+          </a:prstGeom>
+        </p:spPr>
+      </p:pic>
     </p:spTree>
   </p:cSld>
   <p:clrMapOvr>
@@ -5997,7 +7624,7 @@
             <a:avLst/>
           </a:prstGeom>
           <a:solidFill>
-            <a:srgbClr val="4A3000"/>
+            <a:srgbClr val="460820"/>
           </a:solidFill>
           <a:ln>
             <a:noFill/>
@@ -6033,7 +7660,7 @@
         </p:nvSpPr>
         <p:spPr>
           <a:xfrm>
-            <a:off x="1188720" y="2377440"/>
+            <a:off x="1188720" y="2011680"/>
             <a:ext cx="9784080" cy="3657600"/>
           </a:xfrm>
           <a:prstGeom prst="rect">
@@ -6069,17 +7696,54 @@
               </a:spcAft>
               <a:defRPr sz="2600" b="1">
                 <a:solidFill>
-                  <a:srgbClr val="FFD640"/>
+                  <a:srgbClr val="FF467A"/>
                 </a:solidFill>
                 <a:latin typeface="Manrope"/>
               </a:defRPr>
             </a:pPr>
             <a:r>
-              <a:t>Students in halls. Commuters. Desk workers.</a:t>
-            </a:r>
-          </a:p>
-        </p:txBody>
-      </p:sp>
+              <a:t>Desk workers, commuters, and students in dorms.</a:t>
+            </a:r>
+          </a:p>
+          <a:p>
+            <a:pPr>
+              <a:defRPr sz="2200" b="1">
+                <a:solidFill>
+                  <a:srgbClr val="FFFFFF"/>
+                </a:solidFill>
+                <a:latin typeface="Manrope"/>
+              </a:defRPr>
+            </a:pPr>
+            <a:r>
+              <a:t>Nobody carries a 500g sticky glass jar.</a:t>
+            </a:r>
+          </a:p>
+        </p:txBody>
+      </p:sp>
+      <p:pic>
+        <p:nvPicPr>
+          <p:cNvPr id="4" name="Picture 3" descr="wordmark_raspberry.png"/>
+          <p:cNvPicPr>
+            <a:picLocks noChangeAspect="1"/>
+          </p:cNvPicPr>
+          <p:nvPr/>
+        </p:nvPicPr>
+        <p:blipFill>
+          <a:blip r:embed="rId2"/>
+          <a:stretch>
+            <a:fillRect/>
+          </a:stretch>
+        </p:blipFill>
+        <p:spPr>
+          <a:xfrm>
+            <a:off x="5410047" y="6172200"/>
+            <a:ext cx="1371600" cy="335584"/>
+          </a:xfrm>
+          <a:prstGeom prst="rect">
+            <a:avLst/>
+          </a:prstGeom>
+        </p:spPr>
+      </p:pic>
     </p:spTree>
   </p:cSld>
   <p:clrMapOvr>
@@ -6113,7 +7777,7 @@
             <a:avLst/>
           </a:prstGeom>
           <a:solidFill>
-            <a:srgbClr val="4A3000"/>
+            <a:srgbClr val="460820"/>
           </a:solidFill>
           <a:ln>
             <a:noFill/>
@@ -6149,7 +7813,7 @@
         </p:nvSpPr>
         <p:spPr>
           <a:xfrm>
-            <a:off x="1188720" y="2011680"/>
+            <a:off x="1188720" y="2377440"/>
             <a:ext cx="9784080" cy="3657600"/>
           </a:xfrm>
           <a:prstGeom prst="rect">
@@ -6167,23 +7831,7 @@
               <a:spcAft>
                 <a:spcPts val="1200"/>
               </a:spcAft>
-              <a:defRPr sz="2200" b="1">
-                <a:solidFill>
-                  <a:srgbClr val="FFD640"/>
-                </a:solidFill>
-                <a:latin typeface="Manrope"/>
-              </a:defRPr>
-            </a:pPr>
-            <a:r>
-              <a:t>The Solution</a:t>
-            </a:r>
-          </a:p>
-          <a:p>
-            <a:pPr>
-              <a:spcAft>
-                <a:spcPts val="1400"/>
-              </a:spcAft>
-              <a:defRPr sz="4800" b="1">
+              <a:defRPr sz="4600" b="1">
                 <a:solidFill>
                   <a:srgbClr val="FFFFFF"/>
                 </a:solidFill>
@@ -6191,24 +7839,51 @@
               </a:defRPr>
             </a:pPr>
             <a:r>
-              <a:t>10 g Spread Disc on Release Film.</a:t>
+              <a:t>The 3-Minute Office Friction.</a:t>
             </a:r>
           </a:p>
           <a:p>
             <a:pPr>
-              <a:defRPr sz="2200" b="0">
+              <a:spcAft>
+                <a:spcPts val="1400"/>
+              </a:spcAft>
+              <a:defRPr sz="2400" b="1">
                 <a:solidFill>
-                  <a:srgbClr val="FFD640"/>
+                  <a:srgbClr val="FF467A"/>
                 </a:solidFill>
                 <a:latin typeface="Manrope"/>
               </a:defRPr>
             </a:pPr>
             <a:r>
-              <a:t>Peel it off. Press onto hot toast.</a:t>
-            </a:r>
-          </a:p>
-        </p:txBody>
-      </p:sp>
+              <a:t>Sticky handles, cross-contaminated butter, unwashed sinks.</a:t>
+            </a:r>
+          </a:p>
+        </p:txBody>
+      </p:sp>
+      <p:pic>
+        <p:nvPicPr>
+          <p:cNvPr id="4" name="Picture 3" descr="wordmark_raspberry.png"/>
+          <p:cNvPicPr>
+            <a:picLocks noChangeAspect="1"/>
+          </p:cNvPicPr>
+          <p:nvPr/>
+        </p:nvPicPr>
+        <p:blipFill>
+          <a:blip r:embed="rId2"/>
+          <a:stretch>
+            <a:fillRect/>
+          </a:stretch>
+        </p:blipFill>
+        <p:spPr>
+          <a:xfrm>
+            <a:off x="5410047" y="6172200"/>
+            <a:ext cx="1371600" cy="335584"/>
+          </a:xfrm>
+          <a:prstGeom prst="rect">
+            <a:avLst/>
+          </a:prstGeom>
+        </p:spPr>
+      </p:pic>
     </p:spTree>
   </p:cSld>
   <p:clrMapOvr>
@@ -6242,7 +7917,7 @@
             <a:avLst/>
           </a:prstGeom>
           <a:solidFill>
-            <a:srgbClr val="4A3000"/>
+            <a:srgbClr val="460820"/>
           </a:solidFill>
           <a:ln>
             <a:noFill/>
@@ -6278,7 +7953,7 @@
         </p:nvSpPr>
         <p:spPr>
           <a:xfrm>
-            <a:off x="1188720" y="2377440"/>
+            <a:off x="1188720" y="2011680"/>
             <a:ext cx="9784080" cy="3657600"/>
           </a:xfrm>
           <a:prstGeom prst="rect">
@@ -6296,7 +7971,7 @@
               <a:spcAft>
                 <a:spcPts val="1200"/>
               </a:spcAft>
-              <a:defRPr sz="4800" b="1">
+              <a:defRPr sz="4600" b="1">
                 <a:solidFill>
                   <a:srgbClr val="FFFFFF"/>
                 </a:solidFill>
@@ -6304,7 +7979,7 @@
               </a:defRPr>
             </a:pPr>
             <a:r>
-              <a:t>Zero Cutlery Needed.</a:t>
+              <a:t>The Unmet Need.</a:t>
             </a:r>
           </a:p>
           <a:p>
@@ -6312,19 +7987,56 @@
               <a:spcAft>
                 <a:spcPts val="1400"/>
               </a:spcAft>
-              <a:defRPr sz="2400" b="1">
+              <a:defRPr sz="2600" b="1">
                 <a:solidFill>
-                  <a:srgbClr val="FFD640"/>
+                  <a:srgbClr val="FF467A"/>
                 </a:solidFill>
                 <a:latin typeface="Manrope"/>
               </a:defRPr>
             </a:pPr>
             <a:r>
-              <a:t>Residual heat melts it across the crumb in seconds.</a:t>
-            </a:r>
-          </a:p>
-        </p:txBody>
-      </p:sp>
+              <a:t>Consumers abandon toast for dry cereal bars.</a:t>
+            </a:r>
+          </a:p>
+          <a:p>
+            <a:pPr>
+              <a:defRPr sz="2200" b="1">
+                <a:solidFill>
+                  <a:srgbClr val="FFFFFF"/>
+                </a:solidFill>
+                <a:latin typeface="Manrope"/>
+              </a:defRPr>
+            </a:pPr>
+            <a:r>
+              <a:t>Portability has never existed for real breakfast spreads.</a:t>
+            </a:r>
+          </a:p>
+        </p:txBody>
+      </p:sp>
+      <p:pic>
+        <p:nvPicPr>
+          <p:cNvPr id="4" name="Picture 3" descr="wordmark_raspberry.png"/>
+          <p:cNvPicPr>
+            <a:picLocks noChangeAspect="1"/>
+          </p:cNvPicPr>
+          <p:nvPr/>
+        </p:nvPicPr>
+        <p:blipFill>
+          <a:blip r:embed="rId2"/>
+          <a:stretch>
+            <a:fillRect/>
+          </a:stretch>
+        </p:blipFill>
+        <p:spPr>
+          <a:xfrm>
+            <a:off x="5410047" y="6172200"/>
+            <a:ext cx="1371600" cy="335584"/>
+          </a:xfrm>
+          <a:prstGeom prst="rect">
+            <a:avLst/>
+          </a:prstGeom>
+        </p:spPr>
+      </p:pic>
     </p:spTree>
   </p:cSld>
   <p:clrMapOvr>
@@ -6394,7 +8106,7 @@
         </p:nvSpPr>
         <p:spPr>
           <a:xfrm>
-            <a:off x="1188720" y="2377440"/>
+            <a:off x="1188720" y="2011680"/>
             <a:ext cx="9784080" cy="3657600"/>
           </a:xfrm>
           <a:prstGeom prst="rect">
@@ -6411,6 +8123,22 @@
             <a:pPr>
               <a:spcAft>
                 <a:spcPts val="1200"/>
+              </a:spcAft>
+              <a:defRPr sz="2200" b="1">
+                <a:solidFill>
+                  <a:srgbClr val="FFD640"/>
+                </a:solidFill>
+                <a:latin typeface="Manrope"/>
+              </a:defRPr>
+            </a:pPr>
+            <a:r>
+              <a:t>The Solution</a:t>
+            </a:r>
+          </a:p>
+          <a:p>
+            <a:pPr>
+              <a:spcAft>
+                <a:spcPts val="1400"/>
               </a:spcAft>
               <a:defRPr sz="4800" b="1">
                 <a:solidFill>
@@ -6420,15 +8148,12 @@
               </a:defRPr>
             </a:pPr>
             <a:r>
-              <a:t>12-Month Ambient Life.</a:t>
+              <a:t>10 g Spread Disc on Release Film.</a:t>
             </a:r>
           </a:p>
           <a:p>
             <a:pPr>
-              <a:spcAft>
-                <a:spcPts val="1400"/>
-              </a:spcAft>
-              <a:defRPr sz="2400" b="1">
+              <a:defRPr sz="2400" b="0">
                 <a:solidFill>
                   <a:srgbClr val="FFD640"/>
                 </a:solidFill>
@@ -6436,11 +8161,35 @@
               </a:defRPr>
             </a:pPr>
             <a:r>
-              <a:t>Salted Butter. Raspberry. Yeast. Peanut.</a:t>
-            </a:r>
-          </a:p>
-        </p:txBody>
-      </p:sp>
+              <a:t>Peel it off. Press onto hot toast.</a:t>
+            </a:r>
+          </a:p>
+        </p:txBody>
+      </p:sp>
+      <p:pic>
+        <p:nvPicPr>
+          <p:cNvPr id="4" name="Picture 3" descr="wordmark_butter.png"/>
+          <p:cNvPicPr>
+            <a:picLocks noChangeAspect="1"/>
+          </p:cNvPicPr>
+          <p:nvPr/>
+        </p:nvPicPr>
+        <p:blipFill>
+          <a:blip r:embed="rId2"/>
+          <a:stretch>
+            <a:fillRect/>
+          </a:stretch>
+        </p:blipFill>
+        <p:spPr>
+          <a:xfrm>
+            <a:off x="5410047" y="6172200"/>
+            <a:ext cx="1371600" cy="335584"/>
+          </a:xfrm>
+          <a:prstGeom prst="rect">
+            <a:avLst/>
+          </a:prstGeom>
+        </p:spPr>
+      </p:pic>
     </p:spTree>
   </p:cSld>
   <p:clrMapOvr>
@@ -6474,7 +8223,7 @@
             <a:avLst/>
           </a:prstGeom>
           <a:solidFill>
-            <a:srgbClr val="460820"/>
+            <a:srgbClr val="4A3000"/>
           </a:solidFill>
           <a:ln>
             <a:noFill/>
@@ -6510,8 +8259,8 @@
         </p:nvSpPr>
         <p:spPr>
           <a:xfrm>
-            <a:off x="1188720" y="1645920"/>
-            <a:ext cx="9784080" cy="3840480"/>
+            <a:off x="1188720" y="1828800"/>
+            <a:ext cx="6400800" cy="3840480"/>
           </a:xfrm>
           <a:prstGeom prst="rect">
             <a:avLst/>
@@ -6526,25 +8275,9 @@
           <a:p>
             <a:pPr>
               <a:spcAft>
-                <a:spcPts val="1000"/>
+                <a:spcPts val="1400"/>
               </a:spcAft>
-              <a:defRPr sz="8000" b="1">
-                <a:solidFill>
-                  <a:srgbClr val="FF467A"/>
-                </a:solidFill>
-                <a:latin typeface="Manrope"/>
-              </a:defRPr>
-            </a:pPr>
-            <a:r>
-              <a:t>$341M</a:t>
-            </a:r>
-          </a:p>
-          <a:p>
-            <a:pPr>
-              <a:spcAft>
-                <a:spcPts val="1200"/>
-              </a:spcAft>
-              <a:defRPr sz="4000" b="1">
+              <a:defRPr sz="4400" b="1">
                 <a:solidFill>
                   <a:srgbClr val="FFFFFF"/>
                 </a:solidFill>
@@ -6552,24 +8285,88 @@
               </a:defRPr>
             </a:pPr>
             <a:r>
-              <a:t>New Zealand Spreads Category.</a:t>
+              <a:t>Zero Cutlery. Pure Physics.</a:t>
             </a:r>
           </a:p>
           <a:p>
             <a:pPr>
-              <a:defRPr sz="2200" b="0">
+              <a:spcAft>
+                <a:spcPts val="1400"/>
+              </a:spcAft>
+              <a:defRPr sz="2400" b="1">
                 <a:solidFill>
-                  <a:srgbClr val="FF467A"/>
+                  <a:srgbClr val="FFD640"/>
                 </a:solidFill>
                 <a:latin typeface="Manrope"/>
               </a:defRPr>
             </a:pPr>
             <a:r>
-              <a:t>+24% category revenue growth (2022–2025).</a:t>
-            </a:r>
-          </a:p>
-        </p:txBody>
-      </p:sp>
+              <a:t>Residual heat melts the disc in seconds.</a:t>
+            </a:r>
+          </a:p>
+          <a:p>
+            <a:pPr>
+              <a:defRPr sz="2000" b="0">
+                <a:solidFill>
+                  <a:srgbClr val="FFFFFF"/>
+                </a:solidFill>
+                <a:latin typeface="Manrope"/>
+              </a:defRPr>
+            </a:pPr>
+            <a:r>
+              <a:t>10 g portion on food-grade release liner.</a:t>
+            </a:r>
+          </a:p>
+        </p:txBody>
+      </p:sp>
+      <p:pic>
+        <p:nvPicPr>
+          <p:cNvPr id="4" name="Picture 3" descr="butter.png"/>
+          <p:cNvPicPr>
+            <a:picLocks noChangeAspect="1"/>
+          </p:cNvPicPr>
+          <p:nvPr/>
+        </p:nvPicPr>
+        <p:blipFill>
+          <a:blip r:embed="rId2"/>
+          <a:stretch>
+            <a:fillRect/>
+          </a:stretch>
+        </p:blipFill>
+        <p:spPr>
+          <a:xfrm>
+            <a:off x="7772400" y="1280160"/>
+            <a:ext cx="3108960" cy="4142232"/>
+          </a:xfrm>
+          <a:prstGeom prst="rect">
+            <a:avLst/>
+          </a:prstGeom>
+        </p:spPr>
+      </p:pic>
+      <p:pic>
+        <p:nvPicPr>
+          <p:cNvPr id="5" name="Picture 4" descr="wordmark_butter.png"/>
+          <p:cNvPicPr>
+            <a:picLocks noChangeAspect="1"/>
+          </p:cNvPicPr>
+          <p:nvPr/>
+        </p:nvPicPr>
+        <p:blipFill>
+          <a:blip r:embed="rId3"/>
+          <a:stretch>
+            <a:fillRect/>
+          </a:stretch>
+        </p:blipFill>
+        <p:spPr>
+          <a:xfrm>
+            <a:off x="5410047" y="6172200"/>
+            <a:ext cx="1371600" cy="335584"/>
+          </a:xfrm>
+          <a:prstGeom prst="rect">
+            <a:avLst/>
+          </a:prstGeom>
+        </p:spPr>
+      </p:pic>
     </p:spTree>
   </p:cSld>
   <p:clrMapOvr>
@@ -6603,7 +8400,7 @@
             <a:avLst/>
           </a:prstGeom>
           <a:solidFill>
-            <a:srgbClr val="460820"/>
+            <a:srgbClr val="4A3000"/>
           </a:solidFill>
           <a:ln>
             <a:noFill/>
@@ -6639,8 +8436,8 @@
         </p:nvSpPr>
         <p:spPr>
           <a:xfrm>
-            <a:off x="1188720" y="1645920"/>
-            <a:ext cx="9784080" cy="3840480"/>
+            <a:off x="1188720" y="2377440"/>
+            <a:ext cx="9784080" cy="3657600"/>
           </a:xfrm>
           <a:prstGeom prst="rect">
             <a:avLst/>
@@ -6655,25 +8452,9 @@
           <a:p>
             <a:pPr>
               <a:spcAft>
-                <a:spcPts val="1000"/>
-              </a:spcAft>
-              <a:defRPr sz="8000" b="1">
-                <a:solidFill>
-                  <a:srgbClr val="FF467A"/>
-                </a:solidFill>
-                <a:latin typeface="Manrope"/>
-              </a:defRPr>
-            </a:pPr>
-            <a:r>
-              <a:t>+29%</a:t>
-            </a:r>
-          </a:p>
-          <a:p>
-            <a:pPr>
-              <a:spcAft>
                 <a:spcPts val="1200"/>
               </a:spcAft>
-              <a:defRPr sz="4000" b="1">
+              <a:defRPr sz="4600" b="1">
                 <a:solidFill>
                   <a:srgbClr val="FFFFFF"/>
                 </a:solidFill>
@@ -6681,24 +8462,51 @@
               </a:defRPr>
             </a:pPr>
             <a:r>
-              <a:t>Premium Tier Surging.</a:t>
+              <a:t>Four Signature NZ Flavours.</a:t>
             </a:r>
           </a:p>
           <a:p>
             <a:pPr>
-              <a:defRPr sz="2200" b="0">
+              <a:spcAft>
+                <a:spcPts val="1400"/>
+              </a:spcAft>
+              <a:defRPr sz="2600" b="1">
                 <a:solidFill>
-                  <a:srgbClr val="FF467A"/>
+                  <a:srgbClr val="FFD640"/>
                 </a:solidFill>
                 <a:latin typeface="Manrope"/>
               </a:defRPr>
             </a:pPr>
             <a:r>
-              <a:t>Expanding from $88M to $113M NZD.</a:t>
-            </a:r>
-          </a:p>
-        </p:txBody>
-      </p:sp>
+              <a:t>Salted Butter • Raspberry • Yeast • Peanut</a:t>
+            </a:r>
+          </a:p>
+        </p:txBody>
+      </p:sp>
+      <p:pic>
+        <p:nvPicPr>
+          <p:cNvPr id="4" name="Picture 3" descr="wordmark_butter.png"/>
+          <p:cNvPicPr>
+            <a:picLocks noChangeAspect="1"/>
+          </p:cNvPicPr>
+          <p:nvPr/>
+        </p:nvPicPr>
+        <p:blipFill>
+          <a:blip r:embed="rId2"/>
+          <a:stretch>
+            <a:fillRect/>
+          </a:stretch>
+        </p:blipFill>
+        <p:spPr>
+          <a:xfrm>
+            <a:off x="5410047" y="6172200"/>
+            <a:ext cx="1371600" cy="335584"/>
+          </a:xfrm>
+          <a:prstGeom prst="rect">
+            <a:avLst/>
+          </a:prstGeom>
+        </p:spPr>
+      </p:pic>
     </p:spTree>
   </p:cSld>
   <p:clrMapOvr>
@@ -6732,7 +8540,7 @@
             <a:avLst/>
           </a:prstGeom>
           <a:solidFill>
-            <a:srgbClr val="460820"/>
+            <a:srgbClr val="4A3000"/>
           </a:solidFill>
           <a:ln>
             <a:noFill/>
@@ -6768,8 +8576,8 @@
         </p:nvSpPr>
         <p:spPr>
           <a:xfrm>
-            <a:off x="1188720" y="1645920"/>
-            <a:ext cx="9784080" cy="3840480"/>
+            <a:off x="1188720" y="2011680"/>
+            <a:ext cx="9784080" cy="3657600"/>
           </a:xfrm>
           <a:prstGeom prst="rect">
             <a:avLst/>
@@ -6784,25 +8592,9 @@
           <a:p>
             <a:pPr>
               <a:spcAft>
-                <a:spcPts val="1000"/>
-              </a:spcAft>
-              <a:defRPr sz="8000" b="1">
-                <a:solidFill>
-                  <a:srgbClr val="FF467A"/>
-                </a:solidFill>
-                <a:latin typeface="Manrope"/>
-              </a:defRPr>
-            </a:pPr>
-            <a:r>
-              <a:t>0 Rivals</a:t>
-            </a:r>
-          </a:p>
-          <a:p>
-            <a:pPr>
-              <a:spcAft>
                 <a:spcPts val="1200"/>
               </a:spcAft>
-              <a:defRPr sz="4000" b="1">
+              <a:defRPr sz="4600" b="1">
                 <a:solidFill>
                   <a:srgbClr val="FFFFFF"/>
                 </a:solidFill>
@@ -6810,24 +8602,64 @@
               </a:defRPr>
             </a:pPr>
             <a:r>
-              <a:t>Across 154 Supermarket Spreads.</a:t>
+              <a:t>12-Month Ambient Life.</a:t>
             </a:r>
           </a:p>
           <a:p>
             <a:pPr>
-              <a:defRPr sz="2200" b="0">
+              <a:spcAft>
+                <a:spcPts val="1400"/>
+              </a:spcAft>
+              <a:defRPr sz="2400" b="1">
                 <a:solidFill>
-                  <a:srgbClr val="FF467A"/>
+                  <a:srgbClr val="FFD640"/>
                 </a:solidFill>
                 <a:latin typeface="Manrope"/>
               </a:defRPr>
             </a:pPr>
             <a:r>
-              <a:t>Zero single-serve or utensil-free formats in New Zealand retail.</a:t>
-            </a:r>
-          </a:p>
-        </p:txBody>
-      </p:sp>
+              <a:t>High-stability emulsification engineered for room temperature.</a:t>
+            </a:r>
+          </a:p>
+          <a:p>
+            <a:pPr>
+              <a:defRPr sz="2200" b="1">
+                <a:solidFill>
+                  <a:srgbClr val="FFFFFF"/>
+                </a:solidFill>
+                <a:latin typeface="Manrope"/>
+              </a:defRPr>
+            </a:pPr>
+            <a:r>
+              <a:t>Zero refrigeration required.</a:t>
+            </a:r>
+          </a:p>
+        </p:txBody>
+      </p:sp>
+      <p:pic>
+        <p:nvPicPr>
+          <p:cNvPr id="4" name="Picture 3" descr="wordmark_butter.png"/>
+          <p:cNvPicPr>
+            <a:picLocks noChangeAspect="1"/>
+          </p:cNvPicPr>
+          <p:nvPr/>
+        </p:nvPicPr>
+        <p:blipFill>
+          <a:blip r:embed="rId2"/>
+          <a:stretch>
+            <a:fillRect/>
+          </a:stretch>
+        </p:blipFill>
+        <p:spPr>
+          <a:xfrm>
+            <a:off x="5410047" y="6172200"/>
+            <a:ext cx="1371600" cy="335584"/>
+          </a:xfrm>
+          <a:prstGeom prst="rect">
+            <a:avLst/>
+          </a:prstGeom>
+        </p:spPr>
+      </p:pic>
     </p:spTree>
   </p:cSld>
   <p:clrMapOvr>

</xml_diff>

<commit_message>
feat(presentation): showcase all 4 flavours packaging up front, eliminate hero overload, and balance pacing to 20 slides
</commit_message>
<xml_diff>
--- a/presentation/Stamp-pitch.pptx
+++ b/presentation/Stamp-pitch.pptx
@@ -25,9 +25,6 @@
     <p:sldId id="273" r:id="rId25"/>
     <p:sldId id="274" r:id="rId26"/>
     <p:sldId id="275" r:id="rId27"/>
-    <p:sldId id="276" r:id="rId28"/>
-    <p:sldId id="277" r:id="rId29"/>
-    <p:sldId id="278" r:id="rId30"/>
   </p:sldIdLst>
   <p:sldSz cx="12191695" cy="6858000" type="screen4x3"/>
   <p:notesSz cx="6858000" cy="9144000"/>
@@ -599,12 +596,12 @@
           <a:lstStyle/>
           <a:p>
             <a:r>
-              <a:t>MARKET SCALE (0:56–1:03)</a:t>
-            </a:r>
-          </a:p>
-          <a:p>
-            <a:r>
-              <a:t>Cleaned supermarket scan data reveals New Zealand spreads expanded 24% to a 341 million dollar category.</a:t>
+              <a:t>COMPETITIVE VOID (1:05–1:12)</a:t>
+            </a:r>
+          </a:p>
+          <a:p>
+            <a:r>
+              <a:t>Across 154 supermarket spreads, every single product is a jar. Not one offers a utensil-free portion format.</a:t>
             </a:r>
           </a:p>
         </p:txBody>
@@ -674,12 +671,12 @@
           <a:lstStyle/>
           <a:p>
             <a:r>
-              <a:t>PREMIUM SURGE (1:03–1:11)</a:t>
-            </a:r>
-          </a:p>
-          <a:p>
-            <a:r>
-              <a:t>Premium branded spreads surged 29% to 113 million dollars, massively outpacing commodity tiers.</a:t>
+              <a:t>UNIT ECONOMICS (1:12–1:19)</a:t>
+            </a:r>
+          </a:p>
+          <a:p>
+            <a:r>
+              <a:t>At 63 cents a serving, we retain a strong $1.75 gross margin to fund distribution and marketing.</a:t>
             </a:r>
           </a:p>
         </p:txBody>
@@ -749,12 +746,12 @@
           <a:lstStyle/>
           <a:p>
             <a:r>
-              <a:t>COMPETITIVE VOID (1:11–1:18)</a:t>
-            </a:r>
-          </a:p>
-          <a:p>
-            <a:r>
-              <a:t>Across 154 supermarket spreads, every single product is a jar. Not one offers a utensil-free portion format.</a:t>
+              <a:t>MANUFACTURING (1:19–1:27)</a:t>
+            </a:r>
+          </a:p>
+          <a:p>
+            <a:r>
+              <a:t>Production leverages existing contract rotary-die deposition lines, eliminating custom factory tooling.</a:t>
             </a:r>
           </a:p>
         </p:txBody>
@@ -824,12 +821,12 @@
           <a:lstStyle/>
           <a:p>
             <a:r>
-              <a:t>PRICE POSITIONING (1:18–1:26)</a:t>
-            </a:r>
-          </a:p>
-          <a:p>
-            <a:r>
-              <a:t>At $5.00 for an 8-pack, Stamp commands $6.25 per 100g—positioning neatly into the premium whitespace.</a:t>
+              <a:t>LEAN PILOT (1:27–1:35)</a:t>
+            </a:r>
+          </a:p>
+          <a:p>
+            <a:r>
+              <a:t>By partnering with established contract packers in Auckland, we validate consumer demand with minimal capex.</a:t>
             </a:r>
           </a:p>
         </p:txBody>
@@ -899,12 +896,12 @@
           <a:lstStyle/>
           <a:p>
             <a:r>
-              <a:t>UNIT ECONOMICS (1:26–1:33)</a:t>
-            </a:r>
-          </a:p>
-          <a:p>
-            <a:r>
-              <a:t>At 63 cents per serving, we maintain a robust $1.75 gross margin to fund rapid marketing and retail scaling.</a:t>
+              <a:t>CONSTRAINTS (1:35–1:48)</a:t>
+            </a:r>
+          </a:p>
+          <a:p>
+            <a:r>
+              <a:t>In steering AI, I enforced strict negative prompt constraints against fake certification badges and medical health claims.</a:t>
             </a:r>
           </a:p>
         </p:txBody>
@@ -974,12 +971,12 @@
           <a:lstStyle/>
           <a:p>
             <a:r>
-              <a:t>MANUFACTURING (1:33–1:41)</a:t>
-            </a:r>
-          </a:p>
-          <a:p>
-            <a:r>
-              <a:t>Production leverages existing contract rotary-die deposition lines, eliminating custom factory tooling.</a:t>
+              <a:t>ARCHITECTURE (1:48–2:00)</a:t>
+            </a:r>
+          </a:p>
+          <a:p>
+            <a:r>
+              <a:t>I partitioned distinct sessions for data cleaning, branding, and copy to prevent context rot and hallucinated metrics.</a:t>
             </a:r>
           </a:p>
         </p:txBody>
@@ -1049,12 +1046,12 @@
           <a:lstStyle/>
           <a:p>
             <a:r>
-              <a:t>LEAN PILOT (1:41–1:47)</a:t>
-            </a:r>
-          </a:p>
-          <a:p>
-            <a:r>
-              <a:t>By partnering with established contract packers in Auckland, we validate consumer demand with minimal capex.</a:t>
+              <a:t>TURNING POINT (2:00–2:12)</a:t>
+            </a:r>
+          </a:p>
+          <a:p>
+            <a:r>
+              <a:t>My pivotal turning point was catching an unrealistic AI claim that dairy butter could sit ambiently without spoilage.</a:t>
             </a:r>
           </a:p>
         </p:txBody>
@@ -1124,12 +1121,12 @@
           <a:lstStyle/>
           <a:p>
             <a:r>
-              <a:t>CONSTRAINTS (1:47–1:55)</a:t>
-            </a:r>
-          </a:p>
-          <a:p>
-            <a:r>
-              <a:t>In steering AI, I enforced strict negative prompt constraints against fake certification badges and medical health claims.</a:t>
+              <a:t>VERIFICATION (2:12–2:22)</a:t>
+            </a:r>
+          </a:p>
+          <a:p>
+            <a:r>
+              <a:t>I audited raw scan data outliers and manually verified shelf prices on New World instead of trusting model summaries.</a:t>
             </a:r>
           </a:p>
         </p:txBody>
@@ -1199,12 +1196,12 @@
           <a:lstStyle/>
           <a:p>
             <a:r>
-              <a:t>ARCHITECTURE (1:55–2:03)</a:t>
-            </a:r>
-          </a:p>
-          <a:p>
-            <a:r>
-              <a:t>I partitioned distinct sessions for data cleaning, branding, and copy to prevent context rot and hallucinated metrics.</a:t>
+              <a:t>AUTHENTICITY (2:22–2:30)</a:t>
+            </a:r>
+          </a:p>
+          <a:p>
+            <a:r>
+              <a:t>To combat AI slop, I stripped corporate clichés and grounded packaging in real continuous deposit tooling.</a:t>
             </a:r>
           </a:p>
         </p:txBody>
@@ -1274,12 +1271,12 @@
           <a:lstStyle/>
           <a:p>
             <a:r>
-              <a:t>TURNING POINT (2:03–2:11)</a:t>
-            </a:r>
-          </a:p>
-          <a:p>
-            <a:r>
-              <a:t>My pivotal turning point was catching an unrealistic AI claim that dairy butter could sit ambiently without spoilage.</a:t>
+              <a:t>REGULATION (2:30–2:38)</a:t>
+            </a:r>
+          </a:p>
+          <a:p>
+            <a:r>
+              <a:t>In food and beverage, AI hallucinations are a severe legal hazard. I enforced strict FSANZ compliance and allergen safety.</a:t>
             </a:r>
           </a:p>
         </p:txBody>
@@ -1349,7 +1346,7 @@
           <a:lstStyle/>
           <a:p>
             <a:r>
-              <a:t>PROBLEM (0:07–0:13)</a:t>
+              <a:t>PROBLEM (0:07–0:14)</a:t>
             </a:r>
           </a:p>
           <a:p>
@@ -1424,232 +1421,7 @@
           <a:lstStyle/>
           <a:p>
             <a:r>
-              <a:t>VERIFICATION (2:11–2:19)</a:t>
-            </a:r>
-          </a:p>
-          <a:p>
-            <a:r>
-              <a:t>I audited raw scan data outliers and manually verified shelf prices on New World instead of trusting model summaries.</a:t>
-            </a:r>
-          </a:p>
-        </p:txBody>
-      </p:sp>
-      <p:sp>
-        <p:nvSpPr>
-          <p:cNvPr id="4" name="Slide Number Placeholder 3"/>
-          <p:cNvSpPr>
-            <a:spLocks noGrp="1"/>
-          </p:cNvSpPr>
-          <p:nvPr>
-            <p:ph type="sldNum" idx="5" sz="quarter"/>
-          </p:nvPr>
-        </p:nvSpPr>
-        <p:spPr/>
-      </p:sp>
-    </p:spTree>
-  </p:cSld>
-  <p:clrMapOvr>
-    <a:masterClrMapping/>
-  </p:clrMapOvr>
-</p:notes>
-</file>
-
-<file path=ppt/notesSlides/notesSlide21.xml><?xml version="1.0" encoding="utf-8"?>
-<p:notes xmlns:a="http://schemas.openxmlformats.org/drawingml/2006/main" xmlns:p="http://schemas.openxmlformats.org/presentationml/2006/main" xmlns:r="http://schemas.openxmlformats.org/officeDocument/2006/relationships">
-  <p:cSld>
-    <p:spTree>
-      <p:nvGrpSpPr>
-        <p:cNvPr id="1" name=""/>
-        <p:cNvGrpSpPr/>
-        <p:nvPr/>
-      </p:nvGrpSpPr>
-      <p:grpSpPr>
-        <a:xfrm>
-          <a:off x="0" y="0"/>
-          <a:ext cx="0" cy="0"/>
-          <a:chOff x="0" y="0"/>
-          <a:chExt cx="0" cy="0"/>
-        </a:xfrm>
-      </p:grpSpPr>
-      <p:sp>
-        <p:nvSpPr>
-          <p:cNvPr id="2" name="Slide Image Placeholder 1"/>
-          <p:cNvSpPr>
-            <a:spLocks noGrp="1"/>
-          </p:cNvSpPr>
-          <p:nvPr>
-            <p:ph type="sldImg" idx="2"/>
-          </p:nvPr>
-        </p:nvSpPr>
-        <p:spPr/>
-      </p:sp>
-      <p:sp>
-        <p:nvSpPr>
-          <p:cNvPr id="3" name="Notes Placeholder 2"/>
-          <p:cNvSpPr>
-            <a:spLocks noGrp="1"/>
-          </p:cNvSpPr>
-          <p:nvPr>
-            <p:ph type="body" idx="3" sz="quarter"/>
-          </p:nvPr>
-        </p:nvSpPr>
-        <p:spPr/>
-        <p:txBody>
-          <a:bodyPr/>
-          <a:lstStyle/>
-          <a:p>
-            <a:r>
-              <a:t>AUTHENTICITY (2:19–2:27)</a:t>
-            </a:r>
-          </a:p>
-          <a:p>
-            <a:r>
-              <a:t>To combat AI slop, I stripped corporate clichés and grounded packaging in real continuous deposit tooling.</a:t>
-            </a:r>
-          </a:p>
-        </p:txBody>
-      </p:sp>
-      <p:sp>
-        <p:nvSpPr>
-          <p:cNvPr id="4" name="Slide Number Placeholder 3"/>
-          <p:cNvSpPr>
-            <a:spLocks noGrp="1"/>
-          </p:cNvSpPr>
-          <p:nvPr>
-            <p:ph type="sldNum" idx="5" sz="quarter"/>
-          </p:nvPr>
-        </p:nvSpPr>
-        <p:spPr/>
-      </p:sp>
-    </p:spTree>
-  </p:cSld>
-  <p:clrMapOvr>
-    <a:masterClrMapping/>
-  </p:clrMapOvr>
-</p:notes>
-</file>
-
-<file path=ppt/notesSlides/notesSlide22.xml><?xml version="1.0" encoding="utf-8"?>
-<p:notes xmlns:a="http://schemas.openxmlformats.org/drawingml/2006/main" xmlns:p="http://schemas.openxmlformats.org/presentationml/2006/main" xmlns:r="http://schemas.openxmlformats.org/officeDocument/2006/relationships">
-  <p:cSld>
-    <p:spTree>
-      <p:nvGrpSpPr>
-        <p:cNvPr id="1" name=""/>
-        <p:cNvGrpSpPr/>
-        <p:nvPr/>
-      </p:nvGrpSpPr>
-      <p:grpSpPr>
-        <a:xfrm>
-          <a:off x="0" y="0"/>
-          <a:ext cx="0" cy="0"/>
-          <a:chOff x="0" y="0"/>
-          <a:chExt cx="0" cy="0"/>
-        </a:xfrm>
-      </p:grpSpPr>
-      <p:sp>
-        <p:nvSpPr>
-          <p:cNvPr id="2" name="Slide Image Placeholder 1"/>
-          <p:cNvSpPr>
-            <a:spLocks noGrp="1"/>
-          </p:cNvSpPr>
-          <p:nvPr>
-            <p:ph type="sldImg" idx="2"/>
-          </p:nvPr>
-        </p:nvSpPr>
-        <p:spPr/>
-      </p:sp>
-      <p:sp>
-        <p:nvSpPr>
-          <p:cNvPr id="3" name="Notes Placeholder 2"/>
-          <p:cNvSpPr>
-            <a:spLocks noGrp="1"/>
-          </p:cNvSpPr>
-          <p:nvPr>
-            <p:ph type="body" idx="3" sz="quarter"/>
-          </p:nvPr>
-        </p:nvSpPr>
-        <p:spPr/>
-        <p:txBody>
-          <a:bodyPr/>
-          <a:lstStyle/>
-          <a:p>
-            <a:r>
-              <a:t>REGULATION (2:27–2:35)</a:t>
-            </a:r>
-          </a:p>
-          <a:p>
-            <a:r>
-              <a:t>In food and beverage, AI hallucinations are a severe legal hazard. I enforced strict FSANZ compliance and allergen safety.</a:t>
-            </a:r>
-          </a:p>
-        </p:txBody>
-      </p:sp>
-      <p:sp>
-        <p:nvSpPr>
-          <p:cNvPr id="4" name="Slide Number Placeholder 3"/>
-          <p:cNvSpPr>
-            <a:spLocks noGrp="1"/>
-          </p:cNvSpPr>
-          <p:nvPr>
-            <p:ph type="sldNum" idx="5" sz="quarter"/>
-          </p:nvPr>
-        </p:nvSpPr>
-        <p:spPr/>
-      </p:sp>
-    </p:spTree>
-  </p:cSld>
-  <p:clrMapOvr>
-    <a:masterClrMapping/>
-  </p:clrMapOvr>
-</p:notes>
-</file>
-
-<file path=ppt/notesSlides/notesSlide23.xml><?xml version="1.0" encoding="utf-8"?>
-<p:notes xmlns:a="http://schemas.openxmlformats.org/drawingml/2006/main" xmlns:p="http://schemas.openxmlformats.org/presentationml/2006/main" xmlns:r="http://schemas.openxmlformats.org/officeDocument/2006/relationships">
-  <p:cSld>
-    <p:spTree>
-      <p:nvGrpSpPr>
-        <p:cNvPr id="1" name=""/>
-        <p:cNvGrpSpPr/>
-        <p:nvPr/>
-      </p:nvGrpSpPr>
-      <p:grpSpPr>
-        <a:xfrm>
-          <a:off x="0" y="0"/>
-          <a:ext cx="0" cy="0"/>
-          <a:chOff x="0" y="0"/>
-          <a:chExt cx="0" cy="0"/>
-        </a:xfrm>
-      </p:grpSpPr>
-      <p:sp>
-        <p:nvSpPr>
-          <p:cNvPr id="2" name="Slide Image Placeholder 1"/>
-          <p:cNvSpPr>
-            <a:spLocks noGrp="1"/>
-          </p:cNvSpPr>
-          <p:nvPr>
-            <p:ph type="sldImg" idx="2"/>
-          </p:nvPr>
-        </p:nvSpPr>
-        <p:spPr/>
-      </p:sp>
-      <p:sp>
-        <p:nvSpPr>
-          <p:cNvPr id="3" name="Notes Placeholder 2"/>
-          <p:cNvSpPr>
-            <a:spLocks noGrp="1"/>
-          </p:cNvSpPr>
-          <p:nvPr>
-            <p:ph type="body" idx="3" sz="quarter"/>
-          </p:nvPr>
-        </p:nvSpPr>
-        <p:spPr/>
-        <p:txBody>
-          <a:bodyPr/>
-          <a:lstStyle/>
-          <a:p>
-            <a:r>
-              <a:t>ETHICS &amp; WRAP (2:35–2:45)</a:t>
+              <a:t>ETHICS &amp; WRAP (2:38–2:45)</a:t>
             </a:r>
           </a:p>
           <a:p>
@@ -1724,12 +1496,12 @@
           <a:lstStyle/>
           <a:p>
             <a:r>
-              <a:t>WHO FAILS (0:13–0:19)</a:t>
-            </a:r>
-          </a:p>
-          <a:p>
-            <a:r>
-              <a:t>In a university hall, shared flat, or office desk, nobody wants to lug a sticky jar and hunt for a knife.</a:t>
+              <a:t>WHO FAILS (0:14–0:21)</a:t>
+            </a:r>
+          </a:p>
+          <a:p>
+            <a:r>
+              <a:t>In an office or student flat, nobody wants to lug a sticky jar, hunt for a knife, and wash it in a shared sink.</a:t>
             </a:r>
           </a:p>
         </p:txBody>
@@ -1799,12 +1571,12 @@
           <a:lstStyle/>
           <a:p>
             <a:r>
-              <a:t>OFFICE FRICTION (0:19–0:25)</a:t>
-            </a:r>
-          </a:p>
-          <a:p>
-            <a:r>
-              <a:t>Shared communal spreads lead to cross-contamination, crumbs in the butter, and abandoned sink mess.</a:t>
+              <a:t>UNMET NEED (0:21–0:28)</a:t>
+            </a:r>
+          </a:p>
+          <a:p>
+            <a:r>
+              <a:t>Because jars are tethered to kitchens, consumers compromise on dry bars or skip breakfast altogether.</a:t>
             </a:r>
           </a:p>
         </p:txBody>
@@ -1874,12 +1646,12 @@
           <a:lstStyle/>
           <a:p>
             <a:r>
-              <a:t>UNMET NEED (0:25–0:31)</a:t>
-            </a:r>
-          </a:p>
-          <a:p>
-            <a:r>
-              <a:t>Because jars are tethered to kitchens, consumers compromise on dry bars or skip breakfast altogether.</a:t>
+              <a:t>SOLUTION SHOWCASE (0:28–0:36)</a:t>
+            </a:r>
+          </a:p>
+          <a:p>
+            <a:r>
+              <a:t>Stamp reinvents the format: calibrated 10-gram spread discs on release film across four launch flavours.</a:t>
             </a:r>
           </a:p>
         </p:txBody>
@@ -1949,12 +1721,12 @@
           <a:lstStyle/>
           <a:p>
             <a:r>
-              <a:t>SOLUTION (0:31–0:37)</a:t>
-            </a:r>
-          </a:p>
-          <a:p>
-            <a:r>
-              <a:t>Stamp reinvents the format with a calibrated 10-gram disc of real spread on release film.</a:t>
+              <a:t>GESTURE (0:36–0:43)</a:t>
+            </a:r>
+          </a:p>
+          <a:p>
+            <a:r>
+              <a:t>You press the disc onto hot bread, and residual thermal energy melts it evenly across the crumb in seconds.</a:t>
             </a:r>
           </a:p>
         </p:txBody>
@@ -2024,12 +1796,12 @@
           <a:lstStyle/>
           <a:p>
             <a:r>
-              <a:t>PRODUCT PHYSICS (0:37–0:44)</a:t>
-            </a:r>
-          </a:p>
-          <a:p>
-            <a:r>
-              <a:t>You press the disc onto fresh toast, and residual thermal energy melts it evenly without a knife.</a:t>
+              <a:t>STABILITY &amp; FORMAT (0:43–0:50)</a:t>
+            </a:r>
+          </a:p>
+          <a:p>
+            <a:r>
+              <a:t>Engineered for room-temperature pantry and bag storage with full 12-month ambient stability.</a:t>
             </a:r>
           </a:p>
         </p:txBody>
@@ -2099,12 +1871,12 @@
           <a:lstStyle/>
           <a:p>
             <a:r>
-              <a:t>FLAVOUR RANGE (0:44–0:50)</a:t>
-            </a:r>
-          </a:p>
-          <a:p>
-            <a:r>
-              <a:t>Four iconic kiwi flavours in an 8-stamp card sheet, offering instant single-serve variety.</a:t>
+              <a:t>MARKET SCALE (0:50–0:57)</a:t>
+            </a:r>
+          </a:p>
+          <a:p>
+            <a:r>
+              <a:t>Cleaned supermarket scan data shows the New Zealand spreads category expanded 24% to 341 million dollars.</a:t>
             </a:r>
           </a:p>
         </p:txBody>
@@ -2174,12 +1946,12 @@
           <a:lstStyle/>
           <a:p>
             <a:r>
-              <a:t>AMBIENT STABILITY (0:50–0:56)</a:t>
-            </a:r>
-          </a:p>
-          <a:p>
-            <a:r>
-              <a:t>Formulated for room-temperature pantry and bag storage with full 12-month shelf stability.</a:t>
+              <a:t>PREMIUM SURGE (0:57–1:05)</a:t>
+            </a:r>
+          </a:p>
+          <a:p>
+            <a:r>
+              <a:t>Premium branded spreads surged 29% to 113 million dollars, massively outperforming commodity tiers.</a:t>
             </a:r>
           </a:p>
         </p:txBody>
@@ -5393,8 +5165,8 @@
         </p:nvSpPr>
         <p:spPr>
           <a:xfrm>
-            <a:off x="1188720" y="1645920"/>
-            <a:ext cx="9784080" cy="3840480"/>
+            <a:off x="1188720" y="1920240"/>
+            <a:ext cx="9784080" cy="3657600"/>
           </a:xfrm>
           <a:prstGeom prst="rect">
             <a:avLst/>
@@ -5409,9 +5181,9 @@
           <a:p>
             <a:pPr>
               <a:spcAft>
-                <a:spcPts val="1000"/>
+                <a:spcPts val="800"/>
               </a:spcAft>
-              <a:defRPr sz="8000" b="1">
+              <a:defRPr sz="5400" b="1">
                 <a:solidFill>
                   <a:srgbClr val="FF8C30"/>
                 </a:solidFill>
@@ -5419,7 +5191,7 @@
               </a:defRPr>
             </a:pPr>
             <a:r>
-              <a:t>$341M</a:t>
+              <a:t>0 Rivals</a:t>
             </a:r>
           </a:p>
           <a:p>
@@ -5427,7 +5199,7 @@
               <a:spcAft>
                 <a:spcPts val="1200"/>
               </a:spcAft>
-              <a:defRPr sz="4000" b="1">
+              <a:defRPr sz="3600" b="1">
                 <a:solidFill>
                   <a:srgbClr val="FFFFFF"/>
                 </a:solidFill>
@@ -5435,12 +5207,12 @@
               </a:defRPr>
             </a:pPr>
             <a:r>
-              <a:t>New Zealand Spreads Category.</a:t>
+              <a:t>Across 154 Supermarket Spreads.</a:t>
             </a:r>
           </a:p>
           <a:p>
             <a:pPr>
-              <a:defRPr sz="2200" b="0">
+              <a:defRPr sz="2000" b="0">
                 <a:solidFill>
                   <a:srgbClr val="FF8C30"/>
                 </a:solidFill>
@@ -5448,7 +5220,7 @@
               </a:defRPr>
             </a:pPr>
             <a:r>
-              <a:t>+24% category revenue growth across 2022–2025.</a:t>
+              <a:t>Zero single-serve or utensil-free formats in NZ retail.</a:t>
             </a:r>
           </a:p>
         </p:txBody>
@@ -5546,8 +5318,8 @@
         </p:nvSpPr>
         <p:spPr>
           <a:xfrm>
-            <a:off x="1188720" y="822960"/>
-            <a:ext cx="9784080" cy="1280160"/>
+            <a:off x="1188720" y="1920240"/>
+            <a:ext cx="9784080" cy="3657600"/>
           </a:xfrm>
           <a:prstGeom prst="rect">
             <a:avLst/>
@@ -5562,7 +5334,23 @@
           <a:p>
             <a:pPr>
               <a:spcAft>
-                <a:spcPts val="600"/>
+                <a:spcPts val="800"/>
+              </a:spcAft>
+              <a:defRPr sz="5400" b="1">
+                <a:solidFill>
+                  <a:srgbClr val="FF8C30"/>
+                </a:solidFill>
+                <a:latin typeface="Manrope"/>
+              </a:defRPr>
+            </a:pPr>
+            <a:r>
+              <a:t>35% Gross Margin</a:t>
+            </a:r>
+          </a:p>
+          <a:p>
+            <a:pPr>
+              <a:spcAft>
+                <a:spcPts val="1200"/>
               </a:spcAft>
               <a:defRPr sz="3600" b="1">
                 <a:solidFill>
@@ -5572,7 +5360,7 @@
               </a:defRPr>
             </a:pPr>
             <a:r>
-              <a:t>Premium Spreads Surging +29%.</a:t>
+              <a:t>$5.00 Retail • $1.75 Margin per Pack.</a:t>
             </a:r>
           </a:p>
           <a:p>
@@ -5585,14 +5373,14 @@
               </a:defRPr>
             </a:pPr>
             <a:r>
-              <a:t>Expanding from $88M to $113M NZD as consumers trade up into quality.</a:t>
+              <a:t>63¢ per serving on an assumed $1.50 contract packaging cost.</a:t>
             </a:r>
           </a:p>
         </p:txBody>
       </p:sp>
       <p:pic>
         <p:nvPicPr>
-          <p:cNvPr id="4" name="Picture 3" descr="chart_tier_peanut.png"/>
+          <p:cNvPr id="4" name="Picture 3" descr="wordmark_peanut.png"/>
           <p:cNvPicPr>
             <a:picLocks noChangeAspect="1"/>
           </p:cNvPicPr>
@@ -5600,30 +5388,6 @@
         </p:nvPicPr>
         <p:blipFill>
           <a:blip r:embed="rId2"/>
-          <a:stretch>
-            <a:fillRect/>
-          </a:stretch>
-        </p:blipFill>
-        <p:spPr>
-          <a:xfrm>
-            <a:off x="3078327" y="2148840"/>
-            <a:ext cx="6035040" cy="3372522"/>
-          </a:xfrm>
-          <a:prstGeom prst="rect">
-            <a:avLst/>
-          </a:prstGeom>
-        </p:spPr>
-      </p:pic>
-      <p:pic>
-        <p:nvPicPr>
-          <p:cNvPr id="5" name="Picture 4" descr="wordmark_peanut.png"/>
-          <p:cNvPicPr>
-            <a:picLocks noChangeAspect="1"/>
-          </p:cNvPicPr>
-          <p:nvPr/>
-        </p:nvPicPr>
-        <p:blipFill>
-          <a:blip r:embed="rId3"/>
           <a:stretch>
             <a:fillRect/>
           </a:stretch>
@@ -5671,7 +5435,7 @@
             <a:avLst/>
           </a:prstGeom>
           <a:solidFill>
-            <a:srgbClr val="4E2408"/>
+            <a:srgbClr val="4A3000"/>
           </a:solidFill>
           <a:ln>
             <a:noFill/>
@@ -5707,8 +5471,8 @@
         </p:nvSpPr>
         <p:spPr>
           <a:xfrm>
-            <a:off x="1188720" y="1645920"/>
-            <a:ext cx="9784080" cy="3840480"/>
+            <a:off x="1188720" y="822960"/>
+            <a:ext cx="9784080" cy="1280160"/>
           </a:xfrm>
           <a:prstGeom prst="rect">
             <a:avLst/>
@@ -5723,25 +5487,9 @@
           <a:p>
             <a:pPr>
               <a:spcAft>
-                <a:spcPts val="1000"/>
+                <a:spcPts val="600"/>
               </a:spcAft>
-              <a:defRPr sz="8000" b="1">
-                <a:solidFill>
-                  <a:srgbClr val="FF8C30"/>
-                </a:solidFill>
-                <a:latin typeface="Manrope"/>
-              </a:defRPr>
-            </a:pPr>
-            <a:r>
-              <a:t>0 Rivals</a:t>
-            </a:r>
-          </a:p>
-          <a:p>
-            <a:pPr>
-              <a:spcAft>
-                <a:spcPts val="1200"/>
-              </a:spcAft>
-              <a:defRPr sz="4000" b="1">
+              <a:defRPr sz="3400" b="1">
                 <a:solidFill>
                   <a:srgbClr val="FFFFFF"/>
                 </a:solidFill>
@@ -5749,27 +5497,27 @@
               </a:defRPr>
             </a:pPr>
             <a:r>
-              <a:t>Across 154 Supermarket Spreads.</a:t>
+              <a:t>Contract Co-Manufacturing.</a:t>
             </a:r>
           </a:p>
           <a:p>
             <a:pPr>
-              <a:defRPr sz="2200" b="0">
+              <a:defRPr sz="2000" b="0">
                 <a:solidFill>
-                  <a:srgbClr val="FF8C30"/>
+                  <a:srgbClr val="FFD640"/>
                 </a:solidFill>
                 <a:latin typeface="Manrope"/>
               </a:defRPr>
             </a:pPr>
             <a:r>
-              <a:t>Zero single-serve or utensil-free formats in NZ retail.</a:t>
+              <a:t>Continuous deposit tooling onto food-grade release liner.</a:t>
             </a:r>
           </a:p>
         </p:txBody>
       </p:sp>
       <p:pic>
         <p:nvPicPr>
-          <p:cNvPr id="4" name="Picture 3" descr="wordmark_peanut.png"/>
+          <p:cNvPr id="4" name="Picture 3" descr="diagram_process_butter.png"/>
           <p:cNvPicPr>
             <a:picLocks noChangeAspect="1"/>
           </p:cNvPicPr>
@@ -5777,6 +5525,30 @@
         </p:nvPicPr>
         <p:blipFill>
           <a:blip r:embed="rId2"/>
+          <a:stretch>
+            <a:fillRect/>
+          </a:stretch>
+        </p:blipFill>
+        <p:spPr>
+          <a:xfrm>
+            <a:off x="2438247" y="2286000"/>
+            <a:ext cx="7315200" cy="2854712"/>
+          </a:xfrm>
+          <a:prstGeom prst="rect">
+            <a:avLst/>
+          </a:prstGeom>
+        </p:spPr>
+      </p:pic>
+      <p:pic>
+        <p:nvPicPr>
+          <p:cNvPr id="5" name="Picture 4" descr="wordmark_butter.png"/>
+          <p:cNvPicPr>
+            <a:picLocks noChangeAspect="1"/>
+          </p:cNvPicPr>
+          <p:nvPr/>
+        </p:nvPicPr>
+        <p:blipFill>
+          <a:blip r:embed="rId3"/>
           <a:stretch>
             <a:fillRect/>
           </a:stretch>
@@ -5824,7 +5596,7 @@
             <a:avLst/>
           </a:prstGeom>
           <a:solidFill>
-            <a:srgbClr val="4E2408"/>
+            <a:srgbClr val="4A3000"/>
           </a:solidFill>
           <a:ln>
             <a:noFill/>
@@ -5860,8 +5632,8 @@
         </p:nvSpPr>
         <p:spPr>
           <a:xfrm>
-            <a:off x="1188720" y="822960"/>
-            <a:ext cx="9784080" cy="1280160"/>
+            <a:off x="1188720" y="2011680"/>
+            <a:ext cx="9784080" cy="3657600"/>
           </a:xfrm>
           <a:prstGeom prst="rect">
             <a:avLst/>
@@ -5876,9 +5648,9 @@
           <a:p>
             <a:pPr>
               <a:spcAft>
-                <a:spcPts val="600"/>
+                <a:spcPts val="1200"/>
               </a:spcAft>
-              <a:defRPr sz="3600" b="1">
+              <a:defRPr sz="4400" b="1">
                 <a:solidFill>
                   <a:srgbClr val="FFFFFF"/>
                 </a:solidFill>
@@ -5886,27 +5658,43 @@
               </a:defRPr>
             </a:pPr>
             <a:r>
-              <a:t>Capturing the Premium Void.</a:t>
+              <a:t>Lean Capex Pilot.</a:t>
             </a:r>
           </a:p>
           <a:p>
             <a:pPr>
-              <a:defRPr sz="2000" b="0">
+              <a:spcAft>
+                <a:spcPts val="1400"/>
+              </a:spcAft>
+              <a:defRPr sz="2400" b="1">
                 <a:solidFill>
-                  <a:srgbClr val="FF8C30"/>
+                  <a:srgbClr val="FFD640"/>
                 </a:solidFill>
                 <a:latin typeface="Manrope"/>
               </a:defRPr>
             </a:pPr>
             <a:r>
-              <a:t>Targeted at $5.00 per 8-pack ($6.25/100g) against premium jars.</a:t>
+              <a:t>Partnering with Auckland contract food packagers.</a:t>
+            </a:r>
+          </a:p>
+          <a:p>
+            <a:pPr>
+              <a:defRPr sz="2000" b="1">
+                <a:solidFill>
+                  <a:srgbClr val="FFFFFF"/>
+                </a:solidFill>
+                <a:latin typeface="Manrope"/>
+              </a:defRPr>
+            </a:pPr>
+            <a:r>
+              <a:t>Zero heavy machinery outlay required for market entry.</a:t>
             </a:r>
           </a:p>
         </p:txBody>
       </p:sp>
       <p:pic>
         <p:nvPicPr>
-          <p:cNvPr id="4" name="Picture 3" descr="chart_price_peanut.png"/>
+          <p:cNvPr id="4" name="Picture 3" descr="wordmark_butter.png"/>
           <p:cNvPicPr>
             <a:picLocks noChangeAspect="1"/>
           </p:cNvPicPr>
@@ -5914,30 +5702,6 @@
         </p:nvPicPr>
         <p:blipFill>
           <a:blip r:embed="rId2"/>
-          <a:stretch>
-            <a:fillRect/>
-          </a:stretch>
-        </p:blipFill>
-        <p:spPr>
-          <a:xfrm>
-            <a:off x="3078327" y="2148840"/>
-            <a:ext cx="6035040" cy="3372522"/>
-          </a:xfrm>
-          <a:prstGeom prst="rect">
-            <a:avLst/>
-          </a:prstGeom>
-        </p:spPr>
-      </p:pic>
-      <p:pic>
-        <p:nvPicPr>
-          <p:cNvPr id="5" name="Picture 4" descr="wordmark_peanut.png"/>
-          <p:cNvPicPr>
-            <a:picLocks noChangeAspect="1"/>
-          </p:cNvPicPr>
-          <p:nvPr/>
-        </p:nvPicPr>
-        <p:blipFill>
-          <a:blip r:embed="rId3"/>
           <a:stretch>
             <a:fillRect/>
           </a:stretch>
@@ -5985,7 +5749,7 @@
             <a:avLst/>
           </a:prstGeom>
           <a:solidFill>
-            <a:srgbClr val="4E2408"/>
+            <a:srgbClr val="460820"/>
           </a:solidFill>
           <a:ln>
             <a:noFill/>
@@ -6021,8 +5785,8 @@
         </p:nvSpPr>
         <p:spPr>
           <a:xfrm>
-            <a:off x="1188720" y="1645920"/>
-            <a:ext cx="9784080" cy="3840480"/>
+            <a:off x="1188720" y="2011680"/>
+            <a:ext cx="9784080" cy="3657600"/>
           </a:xfrm>
           <a:prstGeom prst="rect">
             <a:avLst/>
@@ -6037,25 +5801,25 @@
           <a:p>
             <a:pPr>
               <a:spcAft>
-                <a:spcPts val="1000"/>
+                <a:spcPts val="1200"/>
               </a:spcAft>
-              <a:defRPr sz="8000" b="1">
+              <a:defRPr sz="2200" b="1">
                 <a:solidFill>
-                  <a:srgbClr val="FF8C30"/>
+                  <a:srgbClr val="FF467A"/>
                 </a:solidFill>
                 <a:latin typeface="Manrope"/>
               </a:defRPr>
             </a:pPr>
             <a:r>
-              <a:t>35% Margin</a:t>
+              <a:t>Negative Constraints.</a:t>
             </a:r>
           </a:p>
           <a:p>
             <a:pPr>
               <a:spcAft>
-                <a:spcPts val="1200"/>
+                <a:spcPts val="1400"/>
               </a:spcAft>
-              <a:defRPr sz="4000" b="1">
+              <a:defRPr sz="4600" b="1">
                 <a:solidFill>
                   <a:srgbClr val="FFFFFF"/>
                 </a:solidFill>
@@ -6063,27 +5827,27 @@
               </a:defRPr>
             </a:pPr>
             <a:r>
-              <a:t>$5.00 Retail • $1.75 Gross Margin.</a:t>
+              <a:t>Banning AI Marketing Hype.</a:t>
             </a:r>
           </a:p>
           <a:p>
             <a:pPr>
               <a:defRPr sz="2200" b="0">
                 <a:solidFill>
-                  <a:srgbClr val="FF8C30"/>
+                  <a:srgbClr val="FF467A"/>
                 </a:solidFill>
                 <a:latin typeface="Manrope"/>
               </a:defRPr>
             </a:pPr>
             <a:r>
-              <a:t>63¢ per serving on an assumed $1.50 co-packing cost.</a:t>
+              <a:t>Explicit negative prompts barred fake badges and health claims.</a:t>
             </a:r>
           </a:p>
         </p:txBody>
       </p:sp>
       <p:pic>
         <p:nvPicPr>
-          <p:cNvPr id="4" name="Picture 3" descr="wordmark_peanut.png"/>
+          <p:cNvPr id="4" name="Picture 3" descr="wordmark_raspberry.png"/>
           <p:cNvPicPr>
             <a:picLocks noChangeAspect="1"/>
           </p:cNvPicPr>
@@ -6138,7 +5902,7 @@
             <a:avLst/>
           </a:prstGeom>
           <a:solidFill>
-            <a:srgbClr val="4A3000"/>
+            <a:srgbClr val="460820"/>
           </a:solidFill>
           <a:ln>
             <a:noFill/>
@@ -6174,8 +5938,8 @@
         </p:nvSpPr>
         <p:spPr>
           <a:xfrm>
-            <a:off x="1188720" y="822960"/>
-            <a:ext cx="9784080" cy="1280160"/>
+            <a:off x="1188720" y="2377440"/>
+            <a:ext cx="9784080" cy="3657600"/>
           </a:xfrm>
           <a:prstGeom prst="rect">
             <a:avLst/>
@@ -6190,9 +5954,9 @@
           <a:p>
             <a:pPr>
               <a:spcAft>
-                <a:spcPts val="600"/>
+                <a:spcPts val="1200"/>
               </a:spcAft>
-              <a:defRPr sz="3600" b="1">
+              <a:defRPr sz="4600" b="1">
                 <a:solidFill>
                   <a:srgbClr val="FFFFFF"/>
                 </a:solidFill>
@@ -6200,27 +5964,30 @@
               </a:defRPr>
             </a:pPr>
             <a:r>
-              <a:t>Contract Co-Manufacturing.</a:t>
+              <a:t>Modular Architecture.</a:t>
             </a:r>
           </a:p>
           <a:p>
             <a:pPr>
-              <a:defRPr sz="2000" b="0">
+              <a:spcAft>
+                <a:spcPts val="1400"/>
+              </a:spcAft>
+              <a:defRPr sz="2400" b="1">
                 <a:solidFill>
-                  <a:srgbClr val="FFD640"/>
+                  <a:srgbClr val="FF467A"/>
                 </a:solidFill>
                 <a:latin typeface="Manrope"/>
               </a:defRPr>
             </a:pPr>
             <a:r>
-              <a:t>Continuous deposit tooling onto food-grade release liner.</a:t>
+              <a:t>Separating data, branding, and copy eliminated context drift.</a:t>
             </a:r>
           </a:p>
         </p:txBody>
       </p:sp>
       <p:pic>
         <p:nvPicPr>
-          <p:cNvPr id="4" name="Picture 3" descr="diagram_process_butter.png"/>
+          <p:cNvPr id="4" name="Picture 3" descr="wordmark_raspberry.png"/>
           <p:cNvPicPr>
             <a:picLocks noChangeAspect="1"/>
           </p:cNvPicPr>
@@ -6228,30 +5995,6 @@
         </p:nvPicPr>
         <p:blipFill>
           <a:blip r:embed="rId2"/>
-          <a:stretch>
-            <a:fillRect/>
-          </a:stretch>
-        </p:blipFill>
-        <p:spPr>
-          <a:xfrm>
-            <a:off x="2438247" y="2286000"/>
-            <a:ext cx="7315200" cy="2854712"/>
-          </a:xfrm>
-          <a:prstGeom prst="rect">
-            <a:avLst/>
-          </a:prstGeom>
-        </p:spPr>
-      </p:pic>
-      <p:pic>
-        <p:nvPicPr>
-          <p:cNvPr id="5" name="Picture 4" descr="wordmark_butter.png"/>
-          <p:cNvPicPr>
-            <a:picLocks noChangeAspect="1"/>
-          </p:cNvPicPr>
-          <p:nvPr/>
-        </p:nvPicPr>
-        <p:blipFill>
-          <a:blip r:embed="rId3"/>
           <a:stretch>
             <a:fillRect/>
           </a:stretch>
@@ -6299,7 +6042,7 @@
             <a:avLst/>
           </a:prstGeom>
           <a:solidFill>
-            <a:srgbClr val="4A3000"/>
+            <a:srgbClr val="460820"/>
           </a:solidFill>
           <a:ln>
             <a:noFill/>
@@ -6353,7 +6096,7 @@
               <a:spcAft>
                 <a:spcPts val="1200"/>
               </a:spcAft>
-              <a:defRPr sz="4600" b="1">
+              <a:defRPr sz="4400" b="1">
                 <a:solidFill>
                   <a:srgbClr val="FFFFFF"/>
                 </a:solidFill>
@@ -6361,7 +6104,7 @@
               </a:defRPr>
             </a:pPr>
             <a:r>
-              <a:t>Lean Capex Pilot.</a:t>
+              <a:t>Catching Dairy Instability.</a:t>
             </a:r>
           </a:p>
           <a:p>
@@ -6369,15 +6112,15 @@
               <a:spcAft>
                 <a:spcPts val="1400"/>
               </a:spcAft>
-              <a:defRPr sz="2400" b="1">
+              <a:defRPr sz="2600" b="1">
                 <a:solidFill>
-                  <a:srgbClr val="FFD640"/>
+                  <a:srgbClr val="FF467A"/>
                 </a:solidFill>
                 <a:latin typeface="Manrope"/>
               </a:defRPr>
             </a:pPr>
             <a:r>
-              <a:t>Partnering with Auckland contract food packagers.</a:t>
+              <a:t>AI assumed table butter could sit ambiently.</a:t>
             </a:r>
           </a:p>
           <a:p>
@@ -6390,14 +6133,14 @@
               </a:defRPr>
             </a:pPr>
             <a:r>
-              <a:t>Zero heavy machinery outlay required for market entry.</a:t>
+              <a:t>Human intervention forced high-stability emulsion.</a:t>
             </a:r>
           </a:p>
         </p:txBody>
       </p:sp>
       <p:pic>
         <p:nvPicPr>
-          <p:cNvPr id="4" name="Picture 3" descr="wordmark_butter.png"/>
+          <p:cNvPr id="4" name="Picture 3" descr="wordmark_raspberry.png"/>
           <p:cNvPicPr>
             <a:picLocks noChangeAspect="1"/>
           </p:cNvPicPr>
@@ -6488,7 +6231,7 @@
         </p:nvSpPr>
         <p:spPr>
           <a:xfrm>
-            <a:off x="1188720" y="2011680"/>
+            <a:off x="1188720" y="2377440"/>
             <a:ext cx="9784080" cy="3657600"/>
           </a:xfrm>
           <a:prstGeom prst="rect">
@@ -6506,7 +6249,23 @@
               <a:spcAft>
                 <a:spcPts val="1200"/>
               </a:spcAft>
-              <a:defRPr sz="2200" b="1">
+              <a:defRPr sz="4400" b="1">
+                <a:solidFill>
+                  <a:srgbClr val="FFFFFF"/>
+                </a:solidFill>
+                <a:latin typeface="Manrope"/>
+              </a:defRPr>
+            </a:pPr>
+            <a:r>
+              <a:t>AI as Drafter, Not Director.</a:t>
+            </a:r>
+          </a:p>
+          <a:p>
+            <a:pPr>
+              <a:spcAft>
+                <a:spcPts val="1400"/>
+              </a:spcAft>
+              <a:defRPr sz="2400" b="1">
                 <a:solidFill>
                   <a:srgbClr val="FF467A"/>
                 </a:solidFill>
@@ -6514,36 +6273,7 @@
               </a:defRPr>
             </a:pPr>
             <a:r>
-              <a:t>Negative Constraints.</a:t>
-            </a:r>
-          </a:p>
-          <a:p>
-            <a:pPr>
-              <a:spcAft>
-                <a:spcPts val="1400"/>
-              </a:spcAft>
-              <a:defRPr sz="4800" b="1">
-                <a:solidFill>
-                  <a:srgbClr val="FFFFFF"/>
-                </a:solidFill>
-                <a:latin typeface="Manrope"/>
-              </a:defRPr>
-            </a:pPr>
-            <a:r>
-              <a:t>Banning AI Marketing Hype.</a:t>
-            </a:r>
-          </a:p>
-          <a:p>
-            <a:pPr>
-              <a:defRPr sz="2200" b="0">
-                <a:solidFill>
-                  <a:srgbClr val="FF467A"/>
-                </a:solidFill>
-                <a:latin typeface="Manrope"/>
-              </a:defRPr>
-            </a:pPr>
-            <a:r>
-              <a:t>Explicit negative prompts barred fake badges and health claims.</a:t>
+              <a:t>Auditing raw scan outliers and verifying live supermarket shelves.</a:t>
             </a:r>
           </a:p>
         </p:txBody>
@@ -6605,7 +6335,7 @@
             <a:avLst/>
           </a:prstGeom>
           <a:solidFill>
-            <a:srgbClr val="460820"/>
+            <a:srgbClr val="240340"/>
           </a:solidFill>
           <a:ln>
             <a:noFill/>
@@ -6641,7 +6371,7 @@
         </p:nvSpPr>
         <p:spPr>
           <a:xfrm>
-            <a:off x="1188720" y="2377440"/>
+            <a:off x="1188720" y="2011680"/>
             <a:ext cx="9784080" cy="3657600"/>
           </a:xfrm>
           <a:prstGeom prst="rect">
@@ -6659,7 +6389,7 @@
               <a:spcAft>
                 <a:spcPts val="1200"/>
               </a:spcAft>
-              <a:defRPr sz="4800" b="1">
+              <a:defRPr sz="4600" b="1">
                 <a:solidFill>
                   <a:srgbClr val="FFFFFF"/>
                 </a:solidFill>
@@ -6667,7 +6397,7 @@
               </a:defRPr>
             </a:pPr>
             <a:r>
-              <a:t>Modular Architecture.</a:t>
+              <a:t>Combating AI Slop.</a:t>
             </a:r>
           </a:p>
           <a:p>
@@ -6675,22 +6405,35 @@
               <a:spcAft>
                 <a:spcPts val="1400"/>
               </a:spcAft>
-              <a:defRPr sz="2400" b="1">
+              <a:defRPr sz="2600" b="1">
                 <a:solidFill>
-                  <a:srgbClr val="FF467A"/>
+                  <a:srgbClr val="E24BFF"/>
                 </a:solidFill>
                 <a:latin typeface="Manrope"/>
               </a:defRPr>
             </a:pPr>
             <a:r>
-              <a:t>Separating data, branding, and copy eliminated context drift.</a:t>
+              <a:t>Stripping corporate buzzwords for plain human facts.</a:t>
+            </a:r>
+          </a:p>
+          <a:p>
+            <a:pPr>
+              <a:defRPr sz="2400" b="1">
+                <a:solidFill>
+                  <a:srgbClr val="FFFFFF"/>
+                </a:solidFill>
+                <a:latin typeface="Manrope"/>
+              </a:defRPr>
+            </a:pPr>
+            <a:r>
+              <a:t>Peel. Press. Toast.</a:t>
             </a:r>
           </a:p>
         </p:txBody>
       </p:sp>
       <p:pic>
         <p:nvPicPr>
-          <p:cNvPr id="4" name="Picture 3" descr="wordmark_raspberry.png"/>
+          <p:cNvPr id="4" name="Picture 3" descr="wordmark_yeast.png"/>
           <p:cNvPicPr>
             <a:picLocks noChangeAspect="1"/>
           </p:cNvPicPr>
@@ -6745,7 +6488,7 @@
             <a:avLst/>
           </a:prstGeom>
           <a:solidFill>
-            <a:srgbClr val="460820"/>
+            <a:srgbClr val="240340"/>
           </a:solidFill>
           <a:ln>
             <a:noFill/>
@@ -6781,7 +6524,7 @@
         </p:nvSpPr>
         <p:spPr>
           <a:xfrm>
-            <a:off x="1188720" y="2011680"/>
+            <a:off x="1188720" y="2377440"/>
             <a:ext cx="9784080" cy="3657600"/>
           </a:xfrm>
           <a:prstGeom prst="rect">
@@ -6807,7 +6550,7 @@
               </a:defRPr>
             </a:pPr>
             <a:r>
-              <a:t>Catching Dairy Instability.</a:t>
+              <a:t>Zero Hallucination Tolerance.</a:t>
             </a:r>
           </a:p>
           <a:p>
@@ -6815,35 +6558,22 @@
               <a:spcAft>
                 <a:spcPts val="1400"/>
               </a:spcAft>
-              <a:defRPr sz="2600" b="1">
+              <a:defRPr sz="2400" b="1">
                 <a:solidFill>
-                  <a:srgbClr val="FF467A"/>
+                  <a:srgbClr val="E24BFF"/>
                 </a:solidFill>
                 <a:latin typeface="Manrope"/>
               </a:defRPr>
             </a:pPr>
             <a:r>
-              <a:t>AI assumed table butter could sit ambiently.</a:t>
-            </a:r>
-          </a:p>
-          <a:p>
-            <a:pPr>
-              <a:defRPr sz="2200" b="1">
-                <a:solidFill>
-                  <a:srgbClr val="FFFFFF"/>
-                </a:solidFill>
-                <a:latin typeface="Manrope"/>
-              </a:defRPr>
-            </a:pPr>
-            <a:r>
-              <a:t>Human intervention forced high-stability emulsion.</a:t>
+              <a:t>Strict FSANZ food laws and mandatory allergen warnings.</a:t>
             </a:r>
           </a:p>
         </p:txBody>
       </p:sp>
       <p:pic>
         <p:nvPicPr>
-          <p:cNvPr id="4" name="Picture 3" descr="wordmark_raspberry.png"/>
+          <p:cNvPr id="4" name="Picture 3" descr="wordmark_yeast.png"/>
           <p:cNvPicPr>
             <a:picLocks noChangeAspect="1"/>
           </p:cNvPicPr>
@@ -6968,7 +6698,7 @@
               <a:spcAft>
                 <a:spcPts val="1400"/>
               </a:spcAft>
-              <a:defRPr sz="4800" b="1">
+              <a:defRPr sz="4600" b="1">
                 <a:solidFill>
                   <a:srgbClr val="FFFFFF"/>
                 </a:solidFill>
@@ -7051,7 +6781,7 @@
             <a:avLst/>
           </a:prstGeom>
           <a:solidFill>
-            <a:srgbClr val="460820"/>
+            <a:srgbClr val="240340"/>
           </a:solidFill>
           <a:ln>
             <a:noFill/>
@@ -7106,439 +6836,6 @@
                 <a:spcPts val="1200"/>
               </a:spcAft>
               <a:defRPr sz="4600" b="1">
-                <a:solidFill>
-                  <a:srgbClr val="FFFFFF"/>
-                </a:solidFill>
-                <a:latin typeface="Manrope"/>
-              </a:defRPr>
-            </a:pPr>
-            <a:r>
-              <a:t>AI as Drafter, Not Director.</a:t>
-            </a:r>
-          </a:p>
-          <a:p>
-            <a:pPr>
-              <a:spcAft>
-                <a:spcPts val="1400"/>
-              </a:spcAft>
-              <a:defRPr sz="2400" b="1">
-                <a:solidFill>
-                  <a:srgbClr val="FF467A"/>
-                </a:solidFill>
-                <a:latin typeface="Manrope"/>
-              </a:defRPr>
-            </a:pPr>
-            <a:r>
-              <a:t>Auditing raw scan outliers and verifying live supermarket shelves.</a:t>
-            </a:r>
-          </a:p>
-        </p:txBody>
-      </p:sp>
-      <p:pic>
-        <p:nvPicPr>
-          <p:cNvPr id="4" name="Picture 3" descr="wordmark_raspberry.png"/>
-          <p:cNvPicPr>
-            <a:picLocks noChangeAspect="1"/>
-          </p:cNvPicPr>
-          <p:nvPr/>
-        </p:nvPicPr>
-        <p:blipFill>
-          <a:blip r:embed="rId2"/>
-          <a:stretch>
-            <a:fillRect/>
-          </a:stretch>
-        </p:blipFill>
-        <p:spPr>
-          <a:xfrm>
-            <a:off x="5410047" y="6172200"/>
-            <a:ext cx="1371600" cy="335584"/>
-          </a:xfrm>
-          <a:prstGeom prst="rect">
-            <a:avLst/>
-          </a:prstGeom>
-        </p:spPr>
-      </p:pic>
-    </p:spTree>
-  </p:cSld>
-  <p:clrMapOvr>
-    <a:masterClrMapping/>
-  </p:clrMapOvr>
-</p:sld>
-</file>
-
-<file path=ppt/slides/slide21.xml><?xml version="1.0" encoding="utf-8"?>
-<p:sld xmlns:a="http://schemas.openxmlformats.org/drawingml/2006/main" xmlns:p="http://schemas.openxmlformats.org/presentationml/2006/main" xmlns:r="http://schemas.openxmlformats.org/officeDocument/2006/relationships">
-  <p:cSld>
-    <p:spTree>
-      <p:nvGrpSpPr>
-        <p:cNvPr id="1" name=""/>
-        <p:cNvGrpSpPr/>
-        <p:nvPr/>
-      </p:nvGrpSpPr>
-      <p:grpSpPr/>
-      <p:sp>
-        <p:nvSpPr>
-          <p:cNvPr id="2" name="Rectangle 1"/>
-          <p:cNvSpPr/>
-          <p:nvPr/>
-        </p:nvSpPr>
-        <p:spPr>
-          <a:xfrm>
-            <a:off x="0" y="0"/>
-            <a:ext cx="12191695" cy="6858000"/>
-          </a:xfrm>
-          <a:prstGeom prst="rect">
-            <a:avLst/>
-          </a:prstGeom>
-          <a:solidFill>
-            <a:srgbClr val="240340"/>
-          </a:solidFill>
-          <a:ln>
-            <a:noFill/>
-          </a:ln>
-        </p:spPr>
-        <p:style>
-          <a:lnRef idx="1">
-            <a:schemeClr val="accent1"/>
-          </a:lnRef>
-          <a:fillRef idx="3">
-            <a:schemeClr val="accent1"/>
-          </a:fillRef>
-          <a:effectRef idx="2">
-            <a:schemeClr val="accent1"/>
-          </a:effectRef>
-          <a:fontRef idx="minor">
-            <a:schemeClr val="lt1"/>
-          </a:fontRef>
-        </p:style>
-        <p:txBody>
-          <a:bodyPr rtlCol="0" anchor="ctr"/>
-          <a:lstStyle/>
-          <a:p>
-            <a:pPr algn="ctr"/>
-          </a:p>
-        </p:txBody>
-      </p:sp>
-      <p:sp>
-        <p:nvSpPr>
-          <p:cNvPr id="3" name="TextBox 2"/>
-          <p:cNvSpPr txBox="1"/>
-          <p:nvPr/>
-        </p:nvSpPr>
-        <p:spPr>
-          <a:xfrm>
-            <a:off x="1188720" y="2011680"/>
-            <a:ext cx="9784080" cy="3657600"/>
-          </a:xfrm>
-          <a:prstGeom prst="rect">
-            <a:avLst/>
-          </a:prstGeom>
-          <a:noFill/>
-        </p:spPr>
-        <p:txBody>
-          <a:bodyPr wrap="square" lIns="0" tIns="0" rIns="0" bIns="0">
-            <a:spAutoFit/>
-          </a:bodyPr>
-          <a:lstStyle/>
-          <a:p>
-            <a:pPr>
-              <a:spcAft>
-                <a:spcPts val="1200"/>
-              </a:spcAft>
-              <a:defRPr sz="4800" b="1">
-                <a:solidFill>
-                  <a:srgbClr val="FFFFFF"/>
-                </a:solidFill>
-                <a:latin typeface="Manrope"/>
-              </a:defRPr>
-            </a:pPr>
-            <a:r>
-              <a:t>Combating AI Slop.</a:t>
-            </a:r>
-          </a:p>
-          <a:p>
-            <a:pPr>
-              <a:spcAft>
-                <a:spcPts val="1400"/>
-              </a:spcAft>
-              <a:defRPr sz="2600" b="1">
-                <a:solidFill>
-                  <a:srgbClr val="E24BFF"/>
-                </a:solidFill>
-                <a:latin typeface="Manrope"/>
-              </a:defRPr>
-            </a:pPr>
-            <a:r>
-              <a:t>Stripping corporate buzzwords for plain human facts.</a:t>
-            </a:r>
-          </a:p>
-          <a:p>
-            <a:pPr>
-              <a:defRPr sz="2400" b="1">
-                <a:solidFill>
-                  <a:srgbClr val="FFFFFF"/>
-                </a:solidFill>
-                <a:latin typeface="Manrope"/>
-              </a:defRPr>
-            </a:pPr>
-            <a:r>
-              <a:t>Peel. Press. Toast.</a:t>
-            </a:r>
-          </a:p>
-        </p:txBody>
-      </p:sp>
-      <p:pic>
-        <p:nvPicPr>
-          <p:cNvPr id="4" name="Picture 3" descr="wordmark_yeast.png"/>
-          <p:cNvPicPr>
-            <a:picLocks noChangeAspect="1"/>
-          </p:cNvPicPr>
-          <p:nvPr/>
-        </p:nvPicPr>
-        <p:blipFill>
-          <a:blip r:embed="rId2"/>
-          <a:stretch>
-            <a:fillRect/>
-          </a:stretch>
-        </p:blipFill>
-        <p:spPr>
-          <a:xfrm>
-            <a:off x="5410047" y="6172200"/>
-            <a:ext cx="1371600" cy="335584"/>
-          </a:xfrm>
-          <a:prstGeom prst="rect">
-            <a:avLst/>
-          </a:prstGeom>
-        </p:spPr>
-      </p:pic>
-    </p:spTree>
-  </p:cSld>
-  <p:clrMapOvr>
-    <a:masterClrMapping/>
-  </p:clrMapOvr>
-</p:sld>
-</file>
-
-<file path=ppt/slides/slide22.xml><?xml version="1.0" encoding="utf-8"?>
-<p:sld xmlns:a="http://schemas.openxmlformats.org/drawingml/2006/main" xmlns:p="http://schemas.openxmlformats.org/presentationml/2006/main" xmlns:r="http://schemas.openxmlformats.org/officeDocument/2006/relationships">
-  <p:cSld>
-    <p:spTree>
-      <p:nvGrpSpPr>
-        <p:cNvPr id="1" name=""/>
-        <p:cNvGrpSpPr/>
-        <p:nvPr/>
-      </p:nvGrpSpPr>
-      <p:grpSpPr/>
-      <p:sp>
-        <p:nvSpPr>
-          <p:cNvPr id="2" name="Rectangle 1"/>
-          <p:cNvSpPr/>
-          <p:nvPr/>
-        </p:nvSpPr>
-        <p:spPr>
-          <a:xfrm>
-            <a:off x="0" y="0"/>
-            <a:ext cx="12191695" cy="6858000"/>
-          </a:xfrm>
-          <a:prstGeom prst="rect">
-            <a:avLst/>
-          </a:prstGeom>
-          <a:solidFill>
-            <a:srgbClr val="240340"/>
-          </a:solidFill>
-          <a:ln>
-            <a:noFill/>
-          </a:ln>
-        </p:spPr>
-        <p:style>
-          <a:lnRef idx="1">
-            <a:schemeClr val="accent1"/>
-          </a:lnRef>
-          <a:fillRef idx="3">
-            <a:schemeClr val="accent1"/>
-          </a:fillRef>
-          <a:effectRef idx="2">
-            <a:schemeClr val="accent1"/>
-          </a:effectRef>
-          <a:fontRef idx="minor">
-            <a:schemeClr val="lt1"/>
-          </a:fontRef>
-        </p:style>
-        <p:txBody>
-          <a:bodyPr rtlCol="0" anchor="ctr"/>
-          <a:lstStyle/>
-          <a:p>
-            <a:pPr algn="ctr"/>
-          </a:p>
-        </p:txBody>
-      </p:sp>
-      <p:sp>
-        <p:nvSpPr>
-          <p:cNvPr id="3" name="TextBox 2"/>
-          <p:cNvSpPr txBox="1"/>
-          <p:nvPr/>
-        </p:nvSpPr>
-        <p:spPr>
-          <a:xfrm>
-            <a:off x="1188720" y="2377440"/>
-            <a:ext cx="9784080" cy="3657600"/>
-          </a:xfrm>
-          <a:prstGeom prst="rect">
-            <a:avLst/>
-          </a:prstGeom>
-          <a:noFill/>
-        </p:spPr>
-        <p:txBody>
-          <a:bodyPr wrap="square" lIns="0" tIns="0" rIns="0" bIns="0">
-            <a:spAutoFit/>
-          </a:bodyPr>
-          <a:lstStyle/>
-          <a:p>
-            <a:pPr>
-              <a:spcAft>
-                <a:spcPts val="1200"/>
-              </a:spcAft>
-              <a:defRPr sz="4800" b="1">
-                <a:solidFill>
-                  <a:srgbClr val="FFFFFF"/>
-                </a:solidFill>
-                <a:latin typeface="Manrope"/>
-              </a:defRPr>
-            </a:pPr>
-            <a:r>
-              <a:t>Zero Hallucination Tolerance.</a:t>
-            </a:r>
-          </a:p>
-          <a:p>
-            <a:pPr>
-              <a:spcAft>
-                <a:spcPts val="1400"/>
-              </a:spcAft>
-              <a:defRPr sz="2400" b="1">
-                <a:solidFill>
-                  <a:srgbClr val="E24BFF"/>
-                </a:solidFill>
-                <a:latin typeface="Manrope"/>
-              </a:defRPr>
-            </a:pPr>
-            <a:r>
-              <a:t>Strict FSANZ food laws and mandatory allergen warnings.</a:t>
-            </a:r>
-          </a:p>
-        </p:txBody>
-      </p:sp>
-      <p:pic>
-        <p:nvPicPr>
-          <p:cNvPr id="4" name="Picture 3" descr="wordmark_yeast.png"/>
-          <p:cNvPicPr>
-            <a:picLocks noChangeAspect="1"/>
-          </p:cNvPicPr>
-          <p:nvPr/>
-        </p:nvPicPr>
-        <p:blipFill>
-          <a:blip r:embed="rId2"/>
-          <a:stretch>
-            <a:fillRect/>
-          </a:stretch>
-        </p:blipFill>
-        <p:spPr>
-          <a:xfrm>
-            <a:off x="5410047" y="6172200"/>
-            <a:ext cx="1371600" cy="335584"/>
-          </a:xfrm>
-          <a:prstGeom prst="rect">
-            <a:avLst/>
-          </a:prstGeom>
-        </p:spPr>
-      </p:pic>
-    </p:spTree>
-  </p:cSld>
-  <p:clrMapOvr>
-    <a:masterClrMapping/>
-  </p:clrMapOvr>
-</p:sld>
-</file>
-
-<file path=ppt/slides/slide23.xml><?xml version="1.0" encoding="utf-8"?>
-<p:sld xmlns:a="http://schemas.openxmlformats.org/drawingml/2006/main" xmlns:p="http://schemas.openxmlformats.org/presentationml/2006/main" xmlns:r="http://schemas.openxmlformats.org/officeDocument/2006/relationships">
-  <p:cSld>
-    <p:spTree>
-      <p:nvGrpSpPr>
-        <p:cNvPr id="1" name=""/>
-        <p:cNvGrpSpPr/>
-        <p:nvPr/>
-      </p:nvGrpSpPr>
-      <p:grpSpPr/>
-      <p:sp>
-        <p:nvSpPr>
-          <p:cNvPr id="2" name="Rectangle 1"/>
-          <p:cNvSpPr/>
-          <p:nvPr/>
-        </p:nvSpPr>
-        <p:spPr>
-          <a:xfrm>
-            <a:off x="0" y="0"/>
-            <a:ext cx="12191695" cy="6858000"/>
-          </a:xfrm>
-          <a:prstGeom prst="rect">
-            <a:avLst/>
-          </a:prstGeom>
-          <a:solidFill>
-            <a:srgbClr val="240340"/>
-          </a:solidFill>
-          <a:ln>
-            <a:noFill/>
-          </a:ln>
-        </p:spPr>
-        <p:style>
-          <a:lnRef idx="1">
-            <a:schemeClr val="accent1"/>
-          </a:lnRef>
-          <a:fillRef idx="3">
-            <a:schemeClr val="accent1"/>
-          </a:fillRef>
-          <a:effectRef idx="2">
-            <a:schemeClr val="accent1"/>
-          </a:effectRef>
-          <a:fontRef idx="minor">
-            <a:schemeClr val="lt1"/>
-          </a:fontRef>
-        </p:style>
-        <p:txBody>
-          <a:bodyPr rtlCol="0" anchor="ctr"/>
-          <a:lstStyle/>
-          <a:p>
-            <a:pPr algn="ctr"/>
-          </a:p>
-        </p:txBody>
-      </p:sp>
-      <p:sp>
-        <p:nvSpPr>
-          <p:cNvPr id="3" name="TextBox 2"/>
-          <p:cNvSpPr txBox="1"/>
-          <p:nvPr/>
-        </p:nvSpPr>
-        <p:spPr>
-          <a:xfrm>
-            <a:off x="1188720" y="2377440"/>
-            <a:ext cx="9784080" cy="3657600"/>
-          </a:xfrm>
-          <a:prstGeom prst="rect">
-            <a:avLst/>
-          </a:prstGeom>
-          <a:noFill/>
-        </p:spPr>
-        <p:txBody>
-          <a:bodyPr wrap="square" lIns="0" tIns="0" rIns="0" bIns="0">
-            <a:spAutoFit/>
-          </a:bodyPr>
-          <a:lstStyle/>
-          <a:p>
-            <a:pPr>
-              <a:spcAft>
-                <a:spcPts val="1200"/>
-              </a:spcAft>
-              <a:defRPr sz="4800" b="1">
                 <a:solidFill>
                   <a:srgbClr val="FFFFFF"/>
                 </a:solidFill>
@@ -7678,7 +6975,7 @@
               <a:spcAft>
                 <a:spcPts val="1200"/>
               </a:spcAft>
-              <a:defRPr sz="4600" b="1">
+              <a:defRPr sz="4400" b="1">
                 <a:solidFill>
                   <a:srgbClr val="FFFFFF"/>
                 </a:solidFill>
@@ -7813,7 +7110,7 @@
         </p:nvSpPr>
         <p:spPr>
           <a:xfrm>
-            <a:off x="1188720" y="2377440"/>
+            <a:off x="1188720" y="2011680"/>
             <a:ext cx="9784080" cy="3657600"/>
           </a:xfrm>
           <a:prstGeom prst="rect">
@@ -7831,7 +7128,7 @@
               <a:spcAft>
                 <a:spcPts val="1200"/>
               </a:spcAft>
-              <a:defRPr sz="4600" b="1">
+              <a:defRPr sz="4400" b="1">
                 <a:solidFill>
                   <a:srgbClr val="FFFFFF"/>
                 </a:solidFill>
@@ -7839,7 +7136,7 @@
               </a:defRPr>
             </a:pPr>
             <a:r>
-              <a:t>The 3-Minute Office Friction.</a:t>
+              <a:t>The Unmet Need.</a:t>
             </a:r>
           </a:p>
           <a:p>
@@ -7847,7 +7144,7 @@
               <a:spcAft>
                 <a:spcPts val="1400"/>
               </a:spcAft>
-              <a:defRPr sz="2400" b="1">
+              <a:defRPr sz="2600" b="1">
                 <a:solidFill>
                   <a:srgbClr val="FF467A"/>
                 </a:solidFill>
@@ -7855,7 +7152,20 @@
               </a:defRPr>
             </a:pPr>
             <a:r>
-              <a:t>Sticky handles, cross-contaminated butter, unwashed sinks.</a:t>
+              <a:t>Consumers abandon toast for dry cereal bars.</a:t>
+            </a:r>
+          </a:p>
+          <a:p>
+            <a:pPr>
+              <a:defRPr sz="2200" b="1">
+                <a:solidFill>
+                  <a:srgbClr val="FFFFFF"/>
+                </a:solidFill>
+                <a:latin typeface="Manrope"/>
+              </a:defRPr>
+            </a:pPr>
+            <a:r>
+              <a:t>Portability has never existed for real breakfast spreads.</a:t>
             </a:r>
           </a:p>
         </p:txBody>
@@ -7917,7 +7227,7 @@
             <a:avLst/>
           </a:prstGeom>
           <a:solidFill>
-            <a:srgbClr val="460820"/>
+            <a:srgbClr val="4A3000"/>
           </a:solidFill>
           <a:ln>
             <a:noFill/>
@@ -7953,8 +7263,8 @@
         </p:nvSpPr>
         <p:spPr>
           <a:xfrm>
-            <a:off x="1188720" y="2011680"/>
-            <a:ext cx="9784080" cy="3657600"/>
+            <a:off x="1188720" y="822960"/>
+            <a:ext cx="9784080" cy="1280160"/>
           </a:xfrm>
           <a:prstGeom prst="rect">
             <a:avLst/>
@@ -7969,9 +7279,9 @@
           <a:p>
             <a:pPr>
               <a:spcAft>
-                <a:spcPts val="1200"/>
+                <a:spcPts val="600"/>
               </a:spcAft>
-              <a:defRPr sz="4600" b="1">
+              <a:defRPr sz="3400" b="1">
                 <a:solidFill>
                   <a:srgbClr val="FFFFFF"/>
                 </a:solidFill>
@@ -7979,43 +7289,27 @@
               </a:defRPr>
             </a:pPr>
             <a:r>
-              <a:t>The Unmet Need.</a:t>
+              <a:t>The Solution.</a:t>
             </a:r>
           </a:p>
           <a:p>
             <a:pPr>
-              <a:spcAft>
-                <a:spcPts val="1400"/>
-              </a:spcAft>
-              <a:defRPr sz="2600" b="1">
+              <a:defRPr sz="2000" b="0">
                 <a:solidFill>
-                  <a:srgbClr val="FF467A"/>
+                  <a:srgbClr val="FFD640"/>
                 </a:solidFill>
                 <a:latin typeface="Manrope"/>
               </a:defRPr>
             </a:pPr>
             <a:r>
-              <a:t>Consumers abandon toast for dry cereal bars.</a:t>
-            </a:r>
-          </a:p>
-          <a:p>
-            <a:pPr>
-              <a:defRPr sz="2200" b="1">
-                <a:solidFill>
-                  <a:srgbClr val="FFFFFF"/>
-                </a:solidFill>
-                <a:latin typeface="Manrope"/>
-              </a:defRPr>
-            </a:pPr>
-            <a:r>
-              <a:t>Portability has never existed for real breakfast spreads.</a:t>
+              <a:t>10 g spread discs on release film.</a:t>
             </a:r>
           </a:p>
         </p:txBody>
       </p:sp>
       <p:pic>
         <p:nvPicPr>
-          <p:cNvPr id="4" name="Picture 3" descr="wordmark_raspberry.png"/>
+          <p:cNvPr id="4" name="Picture 3" descr="four_packs_row.png"/>
           <p:cNvPicPr>
             <a:picLocks noChangeAspect="1"/>
           </p:cNvPicPr>
@@ -8023,6 +7317,30 @@
         </p:nvPicPr>
         <p:blipFill>
           <a:blip r:embed="rId2"/>
+          <a:stretch>
+            <a:fillRect/>
+          </a:stretch>
+        </p:blipFill>
+        <p:spPr>
+          <a:xfrm>
+            <a:off x="1432407" y="2240280"/>
+            <a:ext cx="9326880" cy="2866869"/>
+          </a:xfrm>
+          <a:prstGeom prst="rect">
+            <a:avLst/>
+          </a:prstGeom>
+        </p:spPr>
+      </p:pic>
+      <p:pic>
+        <p:nvPicPr>
+          <p:cNvPr id="5" name="Picture 4" descr="wordmark_butter.png"/>
+          <p:cNvPicPr>
+            <a:picLocks noChangeAspect="1"/>
+          </p:cNvPicPr>
+          <p:nvPr/>
+        </p:nvPicPr>
+        <p:blipFill>
+          <a:blip r:embed="rId3"/>
           <a:stretch>
             <a:fillRect/>
           </a:stretch>
@@ -8124,7 +7442,23 @@
               <a:spcAft>
                 <a:spcPts val="1200"/>
               </a:spcAft>
-              <a:defRPr sz="2200" b="1">
+              <a:defRPr sz="4400" b="1">
+                <a:solidFill>
+                  <a:srgbClr val="FFFFFF"/>
+                </a:solidFill>
+                <a:latin typeface="Manrope"/>
+              </a:defRPr>
+            </a:pPr>
+            <a:r>
+              <a:t>Zero Cutlery. Pure Physics.</a:t>
+            </a:r>
+          </a:p>
+          <a:p>
+            <a:pPr>
+              <a:spcAft>
+                <a:spcPts val="1400"/>
+              </a:spcAft>
+              <a:defRPr sz="2600" b="1">
                 <a:solidFill>
                   <a:srgbClr val="FFD640"/>
                 </a:solidFill>
@@ -8132,15 +7466,12 @@
               </a:defRPr>
             </a:pPr>
             <a:r>
-              <a:t>The Solution</a:t>
+              <a:t>Residual toast heat melts the disc in seconds.</a:t>
             </a:r>
           </a:p>
           <a:p>
             <a:pPr>
-              <a:spcAft>
-                <a:spcPts val="1400"/>
-              </a:spcAft>
-              <a:defRPr sz="4800" b="1">
+              <a:defRPr sz="2000" b="1">
                 <a:solidFill>
                   <a:srgbClr val="FFFFFF"/>
                 </a:solidFill>
@@ -8148,20 +7479,7 @@
               </a:defRPr>
             </a:pPr>
             <a:r>
-              <a:t>10 g Spread Disc on Release Film.</a:t>
-            </a:r>
-          </a:p>
-          <a:p>
-            <a:pPr>
-              <a:defRPr sz="2400" b="0">
-                <a:solidFill>
-                  <a:srgbClr val="FFD640"/>
-                </a:solidFill>
-                <a:latin typeface="Manrope"/>
-              </a:defRPr>
-            </a:pPr>
-            <a:r>
-              <a:t>Peel it off. Press onto hot toast.</a:t>
+              <a:t>Peel off the liner. Press onto hot toast. Zero utensils or mess.</a:t>
             </a:r>
           </a:p>
         </p:txBody>
@@ -8259,8 +7577,8 @@
         </p:nvSpPr>
         <p:spPr>
           <a:xfrm>
-            <a:off x="1188720" y="1828800"/>
-            <a:ext cx="6400800" cy="3840480"/>
+            <a:off x="1188720" y="2011680"/>
+            <a:ext cx="9784080" cy="3657600"/>
           </a:xfrm>
           <a:prstGeom prst="rect">
             <a:avLst/>
@@ -8275,7 +7593,7 @@
           <a:p>
             <a:pPr>
               <a:spcAft>
-                <a:spcPts val="1400"/>
+                <a:spcPts val="1200"/>
               </a:spcAft>
               <a:defRPr sz="4400" b="1">
                 <a:solidFill>
@@ -8285,7 +7603,7 @@
               </a:defRPr>
             </a:pPr>
             <a:r>
-              <a:t>Zero Cutlery. Pure Physics.</a:t>
+              <a:t>12-Month Ambient Life.</a:t>
             </a:r>
           </a:p>
           <a:p>
@@ -8301,12 +7619,12 @@
               </a:defRPr>
             </a:pPr>
             <a:r>
-              <a:t>Residual heat melts the disc in seconds.</a:t>
+              <a:t>High-stability emulsification for room temperature.</a:t>
             </a:r>
           </a:p>
           <a:p>
             <a:pPr>
-              <a:defRPr sz="2000" b="0">
+              <a:defRPr sz="2000" b="1">
                 <a:solidFill>
                   <a:srgbClr val="FFFFFF"/>
                 </a:solidFill>
@@ -8314,14 +7632,14 @@
               </a:defRPr>
             </a:pPr>
             <a:r>
-              <a:t>10 g portion on food-grade release liner.</a:t>
+              <a:t>Hermetically sealed 8-stamp card sheets for pantry and bag.</a:t>
             </a:r>
           </a:p>
         </p:txBody>
       </p:sp>
       <p:pic>
         <p:nvPicPr>
-          <p:cNvPr id="4" name="Picture 3" descr="butter.png"/>
+          <p:cNvPr id="4" name="Picture 3" descr="wordmark_butter.png"/>
           <p:cNvPicPr>
             <a:picLocks noChangeAspect="1"/>
           </p:cNvPicPr>
@@ -8329,30 +7647,6 @@
         </p:nvPicPr>
         <p:blipFill>
           <a:blip r:embed="rId2"/>
-          <a:stretch>
-            <a:fillRect/>
-          </a:stretch>
-        </p:blipFill>
-        <p:spPr>
-          <a:xfrm>
-            <a:off x="7772400" y="1280160"/>
-            <a:ext cx="3108960" cy="4142232"/>
-          </a:xfrm>
-          <a:prstGeom prst="rect">
-            <a:avLst/>
-          </a:prstGeom>
-        </p:spPr>
-      </p:pic>
-      <p:pic>
-        <p:nvPicPr>
-          <p:cNvPr id="5" name="Picture 4" descr="wordmark_butter.png"/>
-          <p:cNvPicPr>
-            <a:picLocks noChangeAspect="1"/>
-          </p:cNvPicPr>
-          <p:nvPr/>
-        </p:nvPicPr>
-        <p:blipFill>
-          <a:blip r:embed="rId3"/>
           <a:stretch>
             <a:fillRect/>
           </a:stretch>
@@ -8400,7 +7694,7 @@
             <a:avLst/>
           </a:prstGeom>
           <a:solidFill>
-            <a:srgbClr val="4A3000"/>
+            <a:srgbClr val="4E2408"/>
           </a:solidFill>
           <a:ln>
             <a:noFill/>
@@ -8436,7 +7730,7 @@
         </p:nvSpPr>
         <p:spPr>
           <a:xfrm>
-            <a:off x="1188720" y="2377440"/>
+            <a:off x="1188720" y="1920240"/>
             <a:ext cx="9784080" cy="3657600"/>
           </a:xfrm>
           <a:prstGeom prst="rect">
@@ -8452,9 +7746,25 @@
           <a:p>
             <a:pPr>
               <a:spcAft>
+                <a:spcPts val="800"/>
+              </a:spcAft>
+              <a:defRPr sz="5400" b="1">
+                <a:solidFill>
+                  <a:srgbClr val="FF8C30"/>
+                </a:solidFill>
+                <a:latin typeface="Manrope"/>
+              </a:defRPr>
+            </a:pPr>
+            <a:r>
+              <a:t>$341M Category</a:t>
+            </a:r>
+          </a:p>
+          <a:p>
+            <a:pPr>
+              <a:spcAft>
                 <a:spcPts val="1200"/>
               </a:spcAft>
-              <a:defRPr sz="4600" b="1">
+              <a:defRPr sz="3600" b="1">
                 <a:solidFill>
                   <a:srgbClr val="FFFFFF"/>
                 </a:solidFill>
@@ -8462,30 +7772,27 @@
               </a:defRPr>
             </a:pPr>
             <a:r>
-              <a:t>Four Signature NZ Flavours.</a:t>
+              <a:t>New Zealand Spreads Market.</a:t>
             </a:r>
           </a:p>
           <a:p>
             <a:pPr>
-              <a:spcAft>
-                <a:spcPts val="1400"/>
-              </a:spcAft>
-              <a:defRPr sz="2600" b="1">
+              <a:defRPr sz="2000" b="0">
                 <a:solidFill>
-                  <a:srgbClr val="FFD640"/>
+                  <a:srgbClr val="FF8C30"/>
                 </a:solidFill>
                 <a:latin typeface="Manrope"/>
               </a:defRPr>
             </a:pPr>
             <a:r>
-              <a:t>Salted Butter • Raspberry • Yeast • Peanut</a:t>
+              <a:t>+24% category revenue growth across 2022–2025.</a:t>
             </a:r>
           </a:p>
         </p:txBody>
       </p:sp>
       <p:pic>
         <p:nvPicPr>
-          <p:cNvPr id="4" name="Picture 3" descr="wordmark_butter.png"/>
+          <p:cNvPr id="4" name="Picture 3" descr="wordmark_peanut.png"/>
           <p:cNvPicPr>
             <a:picLocks noChangeAspect="1"/>
           </p:cNvPicPr>
@@ -8540,7 +7847,7 @@
             <a:avLst/>
           </a:prstGeom>
           <a:solidFill>
-            <a:srgbClr val="4A3000"/>
+            <a:srgbClr val="4E2408"/>
           </a:solidFill>
           <a:ln>
             <a:noFill/>
@@ -8576,8 +7883,8 @@
         </p:nvSpPr>
         <p:spPr>
           <a:xfrm>
-            <a:off x="1188720" y="2011680"/>
-            <a:ext cx="9784080" cy="3657600"/>
+            <a:off x="1188720" y="822960"/>
+            <a:ext cx="9784080" cy="1280160"/>
           </a:xfrm>
           <a:prstGeom prst="rect">
             <a:avLst/>
@@ -8592,9 +7899,9 @@
           <a:p>
             <a:pPr>
               <a:spcAft>
-                <a:spcPts val="1200"/>
+                <a:spcPts val="600"/>
               </a:spcAft>
-              <a:defRPr sz="4600" b="1">
+              <a:defRPr sz="3400" b="1">
                 <a:solidFill>
                   <a:srgbClr val="FFFFFF"/>
                 </a:solidFill>
@@ -8602,43 +7909,27 @@
               </a:defRPr>
             </a:pPr>
             <a:r>
-              <a:t>12-Month Ambient Life.</a:t>
+              <a:t>Premium Spreads Surging +29%.</a:t>
             </a:r>
           </a:p>
           <a:p>
             <a:pPr>
-              <a:spcAft>
-                <a:spcPts val="1400"/>
-              </a:spcAft>
-              <a:defRPr sz="2400" b="1">
+              <a:defRPr sz="2000" b="0">
                 <a:solidFill>
-                  <a:srgbClr val="FFD640"/>
+                  <a:srgbClr val="FF8C30"/>
                 </a:solidFill>
                 <a:latin typeface="Manrope"/>
               </a:defRPr>
             </a:pPr>
             <a:r>
-              <a:t>High-stability emulsification engineered for room temperature.</a:t>
-            </a:r>
-          </a:p>
-          <a:p>
-            <a:pPr>
-              <a:defRPr sz="2200" b="1">
-                <a:solidFill>
-                  <a:srgbClr val="FFFFFF"/>
-                </a:solidFill>
-                <a:latin typeface="Manrope"/>
-              </a:defRPr>
-            </a:pPr>
-            <a:r>
-              <a:t>Zero refrigeration required.</a:t>
+              <a:t>Consumers trading up from commodity tiers into quality formats.</a:t>
             </a:r>
           </a:p>
         </p:txBody>
       </p:sp>
       <p:pic>
         <p:nvPicPr>
-          <p:cNvPr id="4" name="Picture 3" descr="wordmark_butter.png"/>
+          <p:cNvPr id="4" name="Picture 3" descr="chart_tier_peanut.png"/>
           <p:cNvPicPr>
             <a:picLocks noChangeAspect="1"/>
           </p:cNvPicPr>
@@ -8646,6 +7937,30 @@
         </p:nvPicPr>
         <p:blipFill>
           <a:blip r:embed="rId2"/>
+          <a:stretch>
+            <a:fillRect/>
+          </a:stretch>
+        </p:blipFill>
+        <p:spPr>
+          <a:xfrm>
+            <a:off x="3078327" y="2148840"/>
+            <a:ext cx="6035040" cy="3372522"/>
+          </a:xfrm>
+          <a:prstGeom prst="rect">
+            <a:avLst/>
+          </a:prstGeom>
+        </p:spPr>
+      </p:pic>
+      <p:pic>
+        <p:nvPicPr>
+          <p:cNvPr id="5" name="Picture 4" descr="wordmark_peanut.png"/>
+          <p:cNvPicPr>
+            <a:picLocks noChangeAspect="1"/>
+          </p:cNvPicPr>
+          <p:nvPr/>
+        </p:nvPicPr>
+        <p:blipFill>
+          <a:blip r:embed="rId3"/>
           <a:stretch>
             <a:fillRect/>
           </a:stretch>

</xml_diff>

<commit_message>
feat(presentation): embed complete teleprompter script and update timing guide to meet assessment rubric
</commit_message>
<xml_diff>
--- a/presentation/Stamp-pitch.pptx
+++ b/presentation/Stamp-pitch.pptx
@@ -521,7 +521,7 @@
           <a:lstStyle/>
           <a:p>
             <a:r>
-              <a:t>TITLE (0:00–0:07)</a:t>
+              <a:t>[0:00–0:06 | 6s]</a:t>
             </a:r>
           </a:p>
           <a:p>
@@ -596,12 +596,12 @@
           <a:lstStyle/>
           <a:p>
             <a:r>
-              <a:t>COMPETITIVE VOID (1:05–1:12)</a:t>
-            </a:r>
-          </a:p>
-          <a:p>
-            <a:r>
-              <a:t>Across 154 supermarket spreads, every single product is a jar. Not one offers a utensil-free portion format.</a:t>
+              <a:t>[0:58–1:04 | 6s]</a:t>
+            </a:r>
+          </a:p>
+          <a:p>
+            <a:r>
+              <a:t>Across 154 supermarket spreads, every rival is a bulk glass jar. Zero single-serve or utensil-free formats exist in retail.</a:t>
             </a:r>
           </a:p>
         </p:txBody>
@@ -671,12 +671,12 @@
           <a:lstStyle/>
           <a:p>
             <a:r>
-              <a:t>UNIT ECONOMICS (1:12–1:19)</a:t>
-            </a:r>
-          </a:p>
-          <a:p>
-            <a:r>
-              <a:t>At 63 cents a serving, we retain a strong $1.75 gross margin to fund distribution and marketing.</a:t>
+              <a:t>[1:04–1:11 | 7s]</a:t>
+            </a:r>
+          </a:p>
+          <a:p>
+            <a:r>
+              <a:t>At five dollars retail—just 63 cents a serving—we capture a 35% gross margin, netting one-seventy-five per pack to fund expansion.</a:t>
             </a:r>
           </a:p>
         </p:txBody>
@@ -746,12 +746,12 @@
           <a:lstStyle/>
           <a:p>
             <a:r>
-              <a:t>MANUFACTURING (1:19–1:27)</a:t>
-            </a:r>
-          </a:p>
-          <a:p>
-            <a:r>
-              <a:t>Production leverages existing contract rotary-die deposition lines, eliminating custom factory tooling.</a:t>
+              <a:t>[1:11–1:18 | 7s]</a:t>
+            </a:r>
+          </a:p>
+          <a:p>
+            <a:r>
+              <a:t>Production uses standard contract rotary-die continuous deposit lines onto food-grade release liner with zero custom tooling outlay.</a:t>
             </a:r>
           </a:p>
         </p:txBody>
@@ -821,12 +821,12 @@
           <a:lstStyle/>
           <a:p>
             <a:r>
-              <a:t>LEAN PILOT (1:27–1:35)</a:t>
-            </a:r>
-          </a:p>
-          <a:p>
-            <a:r>
-              <a:t>By partnering with established contract packers in Auckland, we validate consumer demand with minimal capex.</a:t>
+              <a:t>[1:18–1:25 | 7s]</a:t>
+            </a:r>
+          </a:p>
+          <a:p>
+            <a:r>
+              <a:t>Partnering with established Auckland contract packagers lets us validate supermarket demand with minimal initial capital expenditure.</a:t>
             </a:r>
           </a:p>
         </p:txBody>
@@ -896,12 +896,12 @@
           <a:lstStyle/>
           <a:p>
             <a:r>
-              <a:t>CONSTRAINTS (1:35–1:48)</a:t>
-            </a:r>
-          </a:p>
-          <a:p>
-            <a:r>
-              <a:t>In steering AI, I enforced strict negative prompt constraints against fake certification badges and medical health claims.</a:t>
+              <a:t>[1:25–1:36 | 11s]</a:t>
+            </a:r>
+          </a:p>
+          <a:p>
+            <a:r>
+              <a:t>In steering the models, my most effective tool was negative prompt constraints—explicitly barring fake organic certifications, miracle health claims, and hyperbolic advertising jargon.</a:t>
             </a:r>
           </a:p>
         </p:txBody>
@@ -971,12 +971,12 @@
           <a:lstStyle/>
           <a:p>
             <a:r>
-              <a:t>ARCHITECTURE (1:48–2:00)</a:t>
-            </a:r>
-          </a:p>
-          <a:p>
-            <a:r>
-              <a:t>I partitioned distinct sessions for data cleaning, branding, and copy to prevent context rot and hallucinated metrics.</a:t>
+              <a:t>[1:36–1:47 | 11s]</a:t>
+            </a:r>
+          </a:p>
+          <a:p>
+            <a:r>
+              <a:t>To prevent context drift, I partitioned distinct modular sessions for data cleaning, branding, packaging copy, and financial modeling, passing clean intermediate summaries between them.</a:t>
             </a:r>
           </a:p>
         </p:txBody>
@@ -1046,12 +1046,12 @@
           <a:lstStyle/>
           <a:p>
             <a:r>
-              <a:t>TURNING POINT (2:00–2:12)</a:t>
-            </a:r>
-          </a:p>
-          <a:p>
-            <a:r>
-              <a:t>My pivotal turning point was catching an unrealistic AI claim that dairy butter could sit ambiently without spoilage.</a:t>
+              <a:t>[1:47–2:00 | 13s]</a:t>
+            </a:r>
+          </a:p>
+          <a:p>
+            <a:r>
+              <a:t>My pivotal moment occurred when the AI claimed standard churned butter could sit ambiently for 12 months. Catching this spoilage hallucination forced reformulation to a low-water-activity cultured dairy spread.</a:t>
             </a:r>
           </a:p>
         </p:txBody>
@@ -1121,12 +1121,12 @@
           <a:lstStyle/>
           <a:p>
             <a:r>
-              <a:t>VERIFICATION (2:12–2:22)</a:t>
-            </a:r>
-          </a:p>
-          <a:p>
-            <a:r>
-              <a:t>I audited raw scan data outliers and manually verified shelf prices on New World instead of trusting model summaries.</a:t>
+              <a:t>[2:00–2:11 | 11s]</a:t>
+            </a:r>
+          </a:p>
+          <a:p>
+            <a:r>
+              <a:t>I treated AI strictly as a junior drafter. I audited raw supermarket scan outliers and manually verified retail shelf prices rather than accepting model summaries.</a:t>
             </a:r>
           </a:p>
         </p:txBody>
@@ -1196,12 +1196,12 @@
           <a:lstStyle/>
           <a:p>
             <a:r>
-              <a:t>AUTHENTICITY (2:22–2:30)</a:t>
-            </a:r>
-          </a:p>
-          <a:p>
-            <a:r>
-              <a:t>To combat AI slop, I stripped corporate clichés and grounded packaging in real continuous deposit tooling.</a:t>
+              <a:t>[2:11–2:21 | 10s]</a:t>
+            </a:r>
+          </a:p>
+          <a:p>
+            <a:r>
+              <a:t>To combat AI slop, I stripped corporate clichés in favour of grounded physical facts: Peel. Press. Toast., anchored in real contract manufacturing capabilities.</a:t>
             </a:r>
           </a:p>
         </p:txBody>
@@ -1271,12 +1271,12 @@
           <a:lstStyle/>
           <a:p>
             <a:r>
-              <a:t>REGULATION (2:30–2:38)</a:t>
-            </a:r>
-          </a:p>
-          <a:p>
-            <a:r>
-              <a:t>In food and beverage, AI hallucinations are a severe legal hazard. I enforced strict FSANZ compliance and allergen safety.</a:t>
+              <a:t>[2:21–2:32 | 11s]</a:t>
+            </a:r>
+          </a:p>
+          <a:p>
+            <a:r>
+              <a:t>In food and beverage, AI hallucinations are a lethal liability. I enforced strict FSANZ compliance and made allergen callouts prominent—errors here risk anaphylaxis.</a:t>
             </a:r>
           </a:p>
         </p:txBody>
@@ -1346,12 +1346,12 @@
           <a:lstStyle/>
           <a:p>
             <a:r>
-              <a:t>PROBLEM (0:07–0:14)</a:t>
-            </a:r>
-          </a:p>
-          <a:p>
-            <a:r>
-              <a:t>Eating toast away from a full residential kitchen is fundamentally broken.</a:t>
+              <a:t>[0:06–0:11 | 5s]</a:t>
+            </a:r>
+          </a:p>
+          <a:p>
+            <a:r>
+              <a:t>Eating toast away from a full residential kitchen is fundamentally broken. Jars require infrastructure.</a:t>
             </a:r>
           </a:p>
         </p:txBody>
@@ -1421,12 +1421,12 @@
           <a:lstStyle/>
           <a:p>
             <a:r>
-              <a:t>ETHICS &amp; WRAP (2:38–2:45)</a:t>
-            </a:r>
-          </a:p>
-          <a:p>
-            <a:r>
-              <a:t>Generative AI accelerates velocity, but human skepticism, taste, discernment, and moral ownership remain essential.</a:t>
+              <a:t>[2:32–2:45 | 13s]</a:t>
+            </a:r>
+          </a:p>
+          <a:p>
+            <a:r>
+              <a:t>Ultimately, moral and legal accountability can never be outsourced to an algorithm. Generative AI accelerates drafting velocity, but human skepticism, discernment, and ethical ownership remain indispensable.</a:t>
             </a:r>
           </a:p>
         </p:txBody>
@@ -1496,12 +1496,12 @@
           <a:lstStyle/>
           <a:p>
             <a:r>
-              <a:t>WHO FAILS (0:14–0:21)</a:t>
-            </a:r>
-          </a:p>
-          <a:p>
-            <a:r>
-              <a:t>In an office or student flat, nobody wants to lug a sticky jar, hunt for a knife, and wash it in a shared sink.</a:t>
+              <a:t>[0:11–0:17 | 6s]</a:t>
+            </a:r>
+          </a:p>
+          <a:p>
+            <a:r>
+              <a:t>Desk workers, students in dorms, and commuters can't lug sticky 500-gram glass jars or hunt for knives in shared office kitchens.</a:t>
             </a:r>
           </a:p>
         </p:txBody>
@@ -1571,12 +1571,12 @@
           <a:lstStyle/>
           <a:p>
             <a:r>
-              <a:t>UNMET NEED (0:21–0:28)</a:t>
-            </a:r>
-          </a:p>
-          <a:p>
-            <a:r>
-              <a:t>Because jars are tethered to kitchens, consumers compromise on dry bars or skip breakfast altogether.</a:t>
+              <a:t>[0:17–0:23 | 6s]</a:t>
+            </a:r>
+          </a:p>
+          <a:p>
+            <a:r>
+              <a:t>Tethered to kitchen counters, millions abandon toast for dry cereal bars. Portability has never existed for real breakfast spreads.</a:t>
             </a:r>
           </a:p>
         </p:txBody>
@@ -1646,12 +1646,12 @@
           <a:lstStyle/>
           <a:p>
             <a:r>
-              <a:t>SOLUTION SHOWCASE (0:28–0:36)</a:t>
-            </a:r>
-          </a:p>
-          <a:p>
-            <a:r>
-              <a:t>Stamp reinvents the format: calibrated 10-gram spread discs on release film across four launch flavours.</a:t>
+              <a:t>[0:23–0:31 | 8s]</a:t>
+            </a:r>
+          </a:p>
+          <a:p>
+            <a:r>
+              <a:t>Stamp reinvents the category with calibrated 10-gram spread discs on release film across four iconic flavours: Salted Butter, Raspberry, Yeast, and Peanut.</a:t>
             </a:r>
           </a:p>
         </p:txBody>
@@ -1721,12 +1721,12 @@
           <a:lstStyle/>
           <a:p>
             <a:r>
-              <a:t>GESTURE (0:36–0:43)</a:t>
-            </a:r>
-          </a:p>
-          <a:p>
-            <a:r>
-              <a:t>You press the disc onto hot bread, and residual thermal energy melts it evenly across the crumb in seconds.</a:t>
+              <a:t>[0:31–0:38 | 7s]</a:t>
+            </a:r>
+          </a:p>
+          <a:p>
+            <a:r>
+              <a:t>You peel off the release liner and press the disc directly onto hot bread. Residual toast heat melts it in seconds—zero cutlery required.</a:t>
             </a:r>
           </a:p>
         </p:txBody>
@@ -1796,12 +1796,12 @@
           <a:lstStyle/>
           <a:p>
             <a:r>
-              <a:t>STABILITY &amp; FORMAT (0:43–0:50)</a:t>
-            </a:r>
-          </a:p>
-          <a:p>
-            <a:r>
-              <a:t>Engineered for room-temperature pantry and bag storage with full 12-month ambient stability.</a:t>
+              <a:t>[0:38–0:44 | 6s]</a:t>
+            </a:r>
+          </a:p>
+          <a:p>
+            <a:r>
+              <a:t>High-stability emulsions deliver 12 months of ambient pantry life in slim, pocket-sized 8-stamp card sheets with zero refrigeration.</a:t>
             </a:r>
           </a:p>
         </p:txBody>
@@ -1871,12 +1871,12 @@
           <a:lstStyle/>
           <a:p>
             <a:r>
-              <a:t>MARKET SCALE (0:50–0:57)</a:t>
-            </a:r>
-          </a:p>
-          <a:p>
-            <a:r>
-              <a:t>Cleaned supermarket scan data shows the New Zealand spreads category expanded 24% to 341 million dollars.</a:t>
+              <a:t>[0:44–0:50 | 6s]</a:t>
+            </a:r>
+          </a:p>
+          <a:p>
+            <a:r>
+              <a:t>Cleaned retail supermarket scan data shows the New Zealand spreads market expanded 24% to a 341 million dollar category.</a:t>
             </a:r>
           </a:p>
         </p:txBody>
@@ -1946,12 +1946,12 @@
           <a:lstStyle/>
           <a:p>
             <a:r>
-              <a:t>PREMIUM SURGE (0:57–1:05)</a:t>
-            </a:r>
-          </a:p>
-          <a:p>
-            <a:r>
-              <a:t>Premium branded spreads surged 29% to 113 million dollars, massively outperforming commodity tiers.</a:t>
+              <a:t>[0:50–0:58 | 8s]</a:t>
+            </a:r>
+          </a:p>
+          <a:p>
+            <a:r>
+              <a:t>Premium spreads surged 29% from 88 million to 113 million dollars, proving kiwi consumers actively trade up for quality and portion convenience.</a:t>
             </a:r>
           </a:p>
         </p:txBody>

</xml_diff>

<commit_message>
refactor(presentation): streamline pitch to 52s across 6 content slides strictly under 1m limit
</commit_message>
<xml_diff>
--- a/presentation/Stamp-pitch.pptx
+++ b/presentation/Stamp-pitch.pptx
@@ -19,12 +19,6 @@
     <p:sldId id="267" r:id="rId19"/>
     <p:sldId id="268" r:id="rId20"/>
     <p:sldId id="269" r:id="rId21"/>
-    <p:sldId id="270" r:id="rId22"/>
-    <p:sldId id="271" r:id="rId23"/>
-    <p:sldId id="272" r:id="rId24"/>
-    <p:sldId id="273" r:id="rId25"/>
-    <p:sldId id="274" r:id="rId26"/>
-    <p:sldId id="275" r:id="rId27"/>
   </p:sldIdLst>
   <p:sldSz cx="12191695" cy="6858000" type="screen4x3"/>
   <p:notesSz cx="6858000" cy="9144000"/>
@@ -596,12 +590,12 @@
           <a:lstStyle/>
           <a:p>
             <a:r>
-              <a:t>[0:58–1:04 | 6s]</a:t>
-            </a:r>
-          </a:p>
-          <a:p>
-            <a:r>
-              <a:t>Across 154 supermarket spreads, every rival is a bulk glass jar. Zero single-serve or utensil-free formats exist in retail.</a:t>
+              <a:t>[1:14–1:27 | 13s]</a:t>
+            </a:r>
+          </a:p>
+          <a:p>
+            <a:r>
+              <a:t>My pivotal moment occurred when the AI claimed standard churned butter could sit ambiently for 12 months. Catching this spoilage hallucination forced reformulation to a low-water-activity cultured dairy spread.</a:t>
             </a:r>
           </a:p>
         </p:txBody>
@@ -671,12 +665,12 @@
           <a:lstStyle/>
           <a:p>
             <a:r>
-              <a:t>[1:04–1:11 | 7s]</a:t>
-            </a:r>
-          </a:p>
-          <a:p>
-            <a:r>
-              <a:t>At five dollars retail—just 63 cents a serving—we capture a 35% gross margin, netting one-seventy-five per pack to fund expansion.</a:t>
+              <a:t>[1:27–1:38 | 11s]</a:t>
+            </a:r>
+          </a:p>
+          <a:p>
+            <a:r>
+              <a:t>I treated AI strictly as a junior drafter. I audited raw supermarket scan outliers and manually verified retail shelf prices rather than accepting model summaries.</a:t>
             </a:r>
           </a:p>
         </p:txBody>
@@ -746,12 +740,12 @@
           <a:lstStyle/>
           <a:p>
             <a:r>
-              <a:t>[1:11–1:18 | 7s]</a:t>
-            </a:r>
-          </a:p>
-          <a:p>
-            <a:r>
-              <a:t>Production uses standard contract rotary-die continuous deposit lines onto food-grade release liner with zero custom tooling outlay.</a:t>
+              <a:t>[1:38–1:48 | 10s]</a:t>
+            </a:r>
+          </a:p>
+          <a:p>
+            <a:r>
+              <a:t>To combat AI slop, I stripped corporate clichés in favour of grounded physical facts: Peel. Press. Toast., anchored in real contract manufacturing capabilities.</a:t>
             </a:r>
           </a:p>
         </p:txBody>
@@ -821,12 +815,12 @@
           <a:lstStyle/>
           <a:p>
             <a:r>
-              <a:t>[1:18–1:25 | 7s]</a:t>
-            </a:r>
-          </a:p>
-          <a:p>
-            <a:r>
-              <a:t>Partnering with established Auckland contract packagers lets us validate supermarket demand with minimal initial capital expenditure.</a:t>
+              <a:t>[1:48–1:59 | 11s]</a:t>
+            </a:r>
+          </a:p>
+          <a:p>
+            <a:r>
+              <a:t>In food and beverage, AI hallucinations are a lethal liability. I enforced strict FSANZ compliance and made allergen callouts prominent—errors here risk anaphylaxis.</a:t>
             </a:r>
           </a:p>
         </p:txBody>
@@ -896,387 +890,12 @@
           <a:lstStyle/>
           <a:p>
             <a:r>
-              <a:t>[1:25–1:36 | 11s]</a:t>
-            </a:r>
-          </a:p>
-          <a:p>
-            <a:r>
-              <a:t>In steering the models, my most effective tool was negative prompt constraints—explicitly barring fake organic certifications, miracle health claims, and hyperbolic advertising jargon.</a:t>
-            </a:r>
-          </a:p>
-        </p:txBody>
-      </p:sp>
-      <p:sp>
-        <p:nvSpPr>
-          <p:cNvPr id="4" name="Slide Number Placeholder 3"/>
-          <p:cNvSpPr>
-            <a:spLocks noGrp="1"/>
-          </p:cNvSpPr>
-          <p:nvPr>
-            <p:ph type="sldNum" idx="5" sz="quarter"/>
-          </p:nvPr>
-        </p:nvSpPr>
-        <p:spPr/>
-      </p:sp>
-    </p:spTree>
-  </p:cSld>
-  <p:clrMapOvr>
-    <a:masterClrMapping/>
-  </p:clrMapOvr>
-</p:notes>
-</file>
-
-<file path=ppt/notesSlides/notesSlide15.xml><?xml version="1.0" encoding="utf-8"?>
-<p:notes xmlns:a="http://schemas.openxmlformats.org/drawingml/2006/main" xmlns:p="http://schemas.openxmlformats.org/presentationml/2006/main" xmlns:r="http://schemas.openxmlformats.org/officeDocument/2006/relationships">
-  <p:cSld>
-    <p:spTree>
-      <p:nvGrpSpPr>
-        <p:cNvPr id="1" name=""/>
-        <p:cNvGrpSpPr/>
-        <p:nvPr/>
-      </p:nvGrpSpPr>
-      <p:grpSpPr>
-        <a:xfrm>
-          <a:off x="0" y="0"/>
-          <a:ext cx="0" cy="0"/>
-          <a:chOff x="0" y="0"/>
-          <a:chExt cx="0" cy="0"/>
-        </a:xfrm>
-      </p:grpSpPr>
-      <p:sp>
-        <p:nvSpPr>
-          <p:cNvPr id="2" name="Slide Image Placeholder 1"/>
-          <p:cNvSpPr>
-            <a:spLocks noGrp="1"/>
-          </p:cNvSpPr>
-          <p:nvPr>
-            <p:ph type="sldImg" idx="2"/>
-          </p:nvPr>
-        </p:nvSpPr>
-        <p:spPr/>
-      </p:sp>
-      <p:sp>
-        <p:nvSpPr>
-          <p:cNvPr id="3" name="Notes Placeholder 2"/>
-          <p:cNvSpPr>
-            <a:spLocks noGrp="1"/>
-          </p:cNvSpPr>
-          <p:nvPr>
-            <p:ph type="body" idx="3" sz="quarter"/>
-          </p:nvPr>
-        </p:nvSpPr>
-        <p:spPr/>
-        <p:txBody>
-          <a:bodyPr/>
-          <a:lstStyle/>
-          <a:p>
-            <a:r>
-              <a:t>[1:36–1:47 | 11s]</a:t>
-            </a:r>
-          </a:p>
-          <a:p>
-            <a:r>
-              <a:t>To prevent context drift, I partitioned distinct modular sessions for data cleaning, branding, packaging copy, and financial modeling, passing clean intermediate summaries between them.</a:t>
-            </a:r>
-          </a:p>
-        </p:txBody>
-      </p:sp>
-      <p:sp>
-        <p:nvSpPr>
-          <p:cNvPr id="4" name="Slide Number Placeholder 3"/>
-          <p:cNvSpPr>
-            <a:spLocks noGrp="1"/>
-          </p:cNvSpPr>
-          <p:nvPr>
-            <p:ph type="sldNum" idx="5" sz="quarter"/>
-          </p:nvPr>
-        </p:nvSpPr>
-        <p:spPr/>
-      </p:sp>
-    </p:spTree>
-  </p:cSld>
-  <p:clrMapOvr>
-    <a:masterClrMapping/>
-  </p:clrMapOvr>
-</p:notes>
-</file>
-
-<file path=ppt/notesSlides/notesSlide16.xml><?xml version="1.0" encoding="utf-8"?>
-<p:notes xmlns:a="http://schemas.openxmlformats.org/drawingml/2006/main" xmlns:p="http://schemas.openxmlformats.org/presentationml/2006/main" xmlns:r="http://schemas.openxmlformats.org/officeDocument/2006/relationships">
-  <p:cSld>
-    <p:spTree>
-      <p:nvGrpSpPr>
-        <p:cNvPr id="1" name=""/>
-        <p:cNvGrpSpPr/>
-        <p:nvPr/>
-      </p:nvGrpSpPr>
-      <p:grpSpPr>
-        <a:xfrm>
-          <a:off x="0" y="0"/>
-          <a:ext cx="0" cy="0"/>
-          <a:chOff x="0" y="0"/>
-          <a:chExt cx="0" cy="0"/>
-        </a:xfrm>
-      </p:grpSpPr>
-      <p:sp>
-        <p:nvSpPr>
-          <p:cNvPr id="2" name="Slide Image Placeholder 1"/>
-          <p:cNvSpPr>
-            <a:spLocks noGrp="1"/>
-          </p:cNvSpPr>
-          <p:nvPr>
-            <p:ph type="sldImg" idx="2"/>
-          </p:nvPr>
-        </p:nvSpPr>
-        <p:spPr/>
-      </p:sp>
-      <p:sp>
-        <p:nvSpPr>
-          <p:cNvPr id="3" name="Notes Placeholder 2"/>
-          <p:cNvSpPr>
-            <a:spLocks noGrp="1"/>
-          </p:cNvSpPr>
-          <p:nvPr>
-            <p:ph type="body" idx="3" sz="quarter"/>
-          </p:nvPr>
-        </p:nvSpPr>
-        <p:spPr/>
-        <p:txBody>
-          <a:bodyPr/>
-          <a:lstStyle/>
-          <a:p>
-            <a:r>
-              <a:t>[1:47–2:00 | 13s]</a:t>
-            </a:r>
-          </a:p>
-          <a:p>
-            <a:r>
-              <a:t>My pivotal moment occurred when the AI claimed standard churned butter could sit ambiently for 12 months. Catching this spoilage hallucination forced reformulation to a low-water-activity cultured dairy spread.</a:t>
-            </a:r>
-          </a:p>
-        </p:txBody>
-      </p:sp>
-      <p:sp>
-        <p:nvSpPr>
-          <p:cNvPr id="4" name="Slide Number Placeholder 3"/>
-          <p:cNvSpPr>
-            <a:spLocks noGrp="1"/>
-          </p:cNvSpPr>
-          <p:nvPr>
-            <p:ph type="sldNum" idx="5" sz="quarter"/>
-          </p:nvPr>
-        </p:nvSpPr>
-        <p:spPr/>
-      </p:sp>
-    </p:spTree>
-  </p:cSld>
-  <p:clrMapOvr>
-    <a:masterClrMapping/>
-  </p:clrMapOvr>
-</p:notes>
-</file>
-
-<file path=ppt/notesSlides/notesSlide17.xml><?xml version="1.0" encoding="utf-8"?>
-<p:notes xmlns:a="http://schemas.openxmlformats.org/drawingml/2006/main" xmlns:p="http://schemas.openxmlformats.org/presentationml/2006/main" xmlns:r="http://schemas.openxmlformats.org/officeDocument/2006/relationships">
-  <p:cSld>
-    <p:spTree>
-      <p:nvGrpSpPr>
-        <p:cNvPr id="1" name=""/>
-        <p:cNvGrpSpPr/>
-        <p:nvPr/>
-      </p:nvGrpSpPr>
-      <p:grpSpPr>
-        <a:xfrm>
-          <a:off x="0" y="0"/>
-          <a:ext cx="0" cy="0"/>
-          <a:chOff x="0" y="0"/>
-          <a:chExt cx="0" cy="0"/>
-        </a:xfrm>
-      </p:grpSpPr>
-      <p:sp>
-        <p:nvSpPr>
-          <p:cNvPr id="2" name="Slide Image Placeholder 1"/>
-          <p:cNvSpPr>
-            <a:spLocks noGrp="1"/>
-          </p:cNvSpPr>
-          <p:nvPr>
-            <p:ph type="sldImg" idx="2"/>
-          </p:nvPr>
-        </p:nvSpPr>
-        <p:spPr/>
-      </p:sp>
-      <p:sp>
-        <p:nvSpPr>
-          <p:cNvPr id="3" name="Notes Placeholder 2"/>
-          <p:cNvSpPr>
-            <a:spLocks noGrp="1"/>
-          </p:cNvSpPr>
-          <p:nvPr>
-            <p:ph type="body" idx="3" sz="quarter"/>
-          </p:nvPr>
-        </p:nvSpPr>
-        <p:spPr/>
-        <p:txBody>
-          <a:bodyPr/>
-          <a:lstStyle/>
-          <a:p>
-            <a:r>
-              <a:t>[2:00–2:11 | 11s]</a:t>
-            </a:r>
-          </a:p>
-          <a:p>
-            <a:r>
-              <a:t>I treated AI strictly as a junior drafter. I audited raw supermarket scan outliers and manually verified retail shelf prices rather than accepting model summaries.</a:t>
-            </a:r>
-          </a:p>
-        </p:txBody>
-      </p:sp>
-      <p:sp>
-        <p:nvSpPr>
-          <p:cNvPr id="4" name="Slide Number Placeholder 3"/>
-          <p:cNvSpPr>
-            <a:spLocks noGrp="1"/>
-          </p:cNvSpPr>
-          <p:nvPr>
-            <p:ph type="sldNum" idx="5" sz="quarter"/>
-          </p:nvPr>
-        </p:nvSpPr>
-        <p:spPr/>
-      </p:sp>
-    </p:spTree>
-  </p:cSld>
-  <p:clrMapOvr>
-    <a:masterClrMapping/>
-  </p:clrMapOvr>
-</p:notes>
-</file>
-
-<file path=ppt/notesSlides/notesSlide18.xml><?xml version="1.0" encoding="utf-8"?>
-<p:notes xmlns:a="http://schemas.openxmlformats.org/drawingml/2006/main" xmlns:p="http://schemas.openxmlformats.org/presentationml/2006/main" xmlns:r="http://schemas.openxmlformats.org/officeDocument/2006/relationships">
-  <p:cSld>
-    <p:spTree>
-      <p:nvGrpSpPr>
-        <p:cNvPr id="1" name=""/>
-        <p:cNvGrpSpPr/>
-        <p:nvPr/>
-      </p:nvGrpSpPr>
-      <p:grpSpPr>
-        <a:xfrm>
-          <a:off x="0" y="0"/>
-          <a:ext cx="0" cy="0"/>
-          <a:chOff x="0" y="0"/>
-          <a:chExt cx="0" cy="0"/>
-        </a:xfrm>
-      </p:grpSpPr>
-      <p:sp>
-        <p:nvSpPr>
-          <p:cNvPr id="2" name="Slide Image Placeholder 1"/>
-          <p:cNvSpPr>
-            <a:spLocks noGrp="1"/>
-          </p:cNvSpPr>
-          <p:nvPr>
-            <p:ph type="sldImg" idx="2"/>
-          </p:nvPr>
-        </p:nvSpPr>
-        <p:spPr/>
-      </p:sp>
-      <p:sp>
-        <p:nvSpPr>
-          <p:cNvPr id="3" name="Notes Placeholder 2"/>
-          <p:cNvSpPr>
-            <a:spLocks noGrp="1"/>
-          </p:cNvSpPr>
-          <p:nvPr>
-            <p:ph type="body" idx="3" sz="quarter"/>
-          </p:nvPr>
-        </p:nvSpPr>
-        <p:spPr/>
-        <p:txBody>
-          <a:bodyPr/>
-          <a:lstStyle/>
-          <a:p>
-            <a:r>
-              <a:t>[2:11–2:21 | 10s]</a:t>
-            </a:r>
-          </a:p>
-          <a:p>
-            <a:r>
-              <a:t>To combat AI slop, I stripped corporate clichés in favour of grounded physical facts: Peel. Press. Toast., anchored in real contract manufacturing capabilities.</a:t>
-            </a:r>
-          </a:p>
-        </p:txBody>
-      </p:sp>
-      <p:sp>
-        <p:nvSpPr>
-          <p:cNvPr id="4" name="Slide Number Placeholder 3"/>
-          <p:cNvSpPr>
-            <a:spLocks noGrp="1"/>
-          </p:cNvSpPr>
-          <p:nvPr>
-            <p:ph type="sldNum" idx="5" sz="quarter"/>
-          </p:nvPr>
-        </p:nvSpPr>
-        <p:spPr/>
-      </p:sp>
-    </p:spTree>
-  </p:cSld>
-  <p:clrMapOvr>
-    <a:masterClrMapping/>
-  </p:clrMapOvr>
-</p:notes>
-</file>
-
-<file path=ppt/notesSlides/notesSlide19.xml><?xml version="1.0" encoding="utf-8"?>
-<p:notes xmlns:a="http://schemas.openxmlformats.org/drawingml/2006/main" xmlns:p="http://schemas.openxmlformats.org/presentationml/2006/main" xmlns:r="http://schemas.openxmlformats.org/officeDocument/2006/relationships">
-  <p:cSld>
-    <p:spTree>
-      <p:nvGrpSpPr>
-        <p:cNvPr id="1" name=""/>
-        <p:cNvGrpSpPr/>
-        <p:nvPr/>
-      </p:nvGrpSpPr>
-      <p:grpSpPr>
-        <a:xfrm>
-          <a:off x="0" y="0"/>
-          <a:ext cx="0" cy="0"/>
-          <a:chOff x="0" y="0"/>
-          <a:chExt cx="0" cy="0"/>
-        </a:xfrm>
-      </p:grpSpPr>
-      <p:sp>
-        <p:nvSpPr>
-          <p:cNvPr id="2" name="Slide Image Placeholder 1"/>
-          <p:cNvSpPr>
-            <a:spLocks noGrp="1"/>
-          </p:cNvSpPr>
-          <p:nvPr>
-            <p:ph type="sldImg" idx="2"/>
-          </p:nvPr>
-        </p:nvSpPr>
-        <p:spPr/>
-      </p:sp>
-      <p:sp>
-        <p:nvSpPr>
-          <p:cNvPr id="3" name="Notes Placeholder 2"/>
-          <p:cNvSpPr>
-            <a:spLocks noGrp="1"/>
-          </p:cNvSpPr>
-          <p:nvPr>
-            <p:ph type="body" idx="3" sz="quarter"/>
-          </p:nvPr>
-        </p:nvSpPr>
-        <p:spPr/>
-        <p:txBody>
-          <a:bodyPr/>
-          <a:lstStyle/>
-          <a:p>
-            <a:r>
-              <a:t>[2:21–2:32 | 11s]</a:t>
-            </a:r>
-          </a:p>
-          <a:p>
-            <a:r>
-              <a:t>In food and beverage, AI hallucinations are a lethal liability. I enforced strict FSANZ compliance and made allergen callouts prominent—errors here risk anaphylaxis.</a:t>
+              <a:t>[1:59–2:12 | 13s]</a:t>
+            </a:r>
+          </a:p>
+          <a:p>
+            <a:r>
+              <a:t>Ultimately, moral and legal accountability can never be outsourced to an algorithm. Generative AI accelerates drafting velocity, but human skepticism, discernment, and ethical ownership remain indispensable.</a:t>
             </a:r>
           </a:p>
         </p:txBody>
@@ -1346,87 +965,12 @@
           <a:lstStyle/>
           <a:p>
             <a:r>
-              <a:t>[0:06–0:11 | 5s]</a:t>
-            </a:r>
-          </a:p>
-          <a:p>
-            <a:r>
-              <a:t>Eating toast away from a full residential kitchen is fundamentally broken. Jars require infrastructure.</a:t>
-            </a:r>
-          </a:p>
-        </p:txBody>
-      </p:sp>
-      <p:sp>
-        <p:nvSpPr>
-          <p:cNvPr id="4" name="Slide Number Placeholder 3"/>
-          <p:cNvSpPr>
-            <a:spLocks noGrp="1"/>
-          </p:cNvSpPr>
-          <p:nvPr>
-            <p:ph type="sldNum" idx="5" sz="quarter"/>
-          </p:nvPr>
-        </p:nvSpPr>
-        <p:spPr/>
-      </p:sp>
-    </p:spTree>
-  </p:cSld>
-  <p:clrMapOvr>
-    <a:masterClrMapping/>
-  </p:clrMapOvr>
-</p:notes>
-</file>
-
-<file path=ppt/notesSlides/notesSlide20.xml><?xml version="1.0" encoding="utf-8"?>
-<p:notes xmlns:a="http://schemas.openxmlformats.org/drawingml/2006/main" xmlns:p="http://schemas.openxmlformats.org/presentationml/2006/main" xmlns:r="http://schemas.openxmlformats.org/officeDocument/2006/relationships">
-  <p:cSld>
-    <p:spTree>
-      <p:nvGrpSpPr>
-        <p:cNvPr id="1" name=""/>
-        <p:cNvGrpSpPr/>
-        <p:nvPr/>
-      </p:nvGrpSpPr>
-      <p:grpSpPr>
-        <a:xfrm>
-          <a:off x="0" y="0"/>
-          <a:ext cx="0" cy="0"/>
-          <a:chOff x="0" y="0"/>
-          <a:chExt cx="0" cy="0"/>
-        </a:xfrm>
-      </p:grpSpPr>
-      <p:sp>
-        <p:nvSpPr>
-          <p:cNvPr id="2" name="Slide Image Placeholder 1"/>
-          <p:cNvSpPr>
-            <a:spLocks noGrp="1"/>
-          </p:cNvSpPr>
-          <p:nvPr>
-            <p:ph type="sldImg" idx="2"/>
-          </p:nvPr>
-        </p:nvSpPr>
-        <p:spPr/>
-      </p:sp>
-      <p:sp>
-        <p:nvSpPr>
-          <p:cNvPr id="3" name="Notes Placeholder 2"/>
-          <p:cNvSpPr>
-            <a:spLocks noGrp="1"/>
-          </p:cNvSpPr>
-          <p:nvPr>
-            <p:ph type="body" idx="3" sz="quarter"/>
-          </p:nvPr>
-        </p:nvSpPr>
-        <p:spPr/>
-        <p:txBody>
-          <a:bodyPr/>
-          <a:lstStyle/>
-          <a:p>
-            <a:r>
-              <a:t>[2:32–2:45 | 13s]</a:t>
-            </a:r>
-          </a:p>
-          <a:p>
-            <a:r>
-              <a:t>Ultimately, moral and legal accountability can never be outsourced to an algorithm. Generative AI accelerates drafting velocity, but human skepticism, discernment, and ethical ownership remain indispensable.</a:t>
+              <a:t>[0:06–0:13 | 7s]</a:t>
+            </a:r>
+          </a:p>
+          <a:p>
+            <a:r>
+              <a:t>Eating toast away from home is broken. Sticky jars require table knives, kitchen benches, and running water.</a:t>
             </a:r>
           </a:p>
         </p:txBody>
@@ -1496,12 +1040,12 @@
           <a:lstStyle/>
           <a:p>
             <a:r>
-              <a:t>[0:11–0:17 | 6s]</a:t>
-            </a:r>
-          </a:p>
-          <a:p>
-            <a:r>
-              <a:t>Desk workers, students in dorms, and commuters can't lug sticky 500-gram glass jars or hunt for knives in shared office kitchens.</a:t>
+              <a:t>[0:13–0:21 | 8s]</a:t>
+            </a:r>
+          </a:p>
+          <a:p>
+            <a:r>
+              <a:t>Stamp solves this with calibrated 10-gram spread discs on release film across four iconic flavours: Salted Butter, Raspberry, Yeast, and Peanut.</a:t>
             </a:r>
           </a:p>
         </p:txBody>
@@ -1571,12 +1115,12 @@
           <a:lstStyle/>
           <a:p>
             <a:r>
-              <a:t>[0:17–0:23 | 6s]</a:t>
-            </a:r>
-          </a:p>
-          <a:p>
-            <a:r>
-              <a:t>Tethered to kitchen counters, millions abandon toast for dry cereal bars. Portability has never existed for real breakfast spreads.</a:t>
+              <a:t>[0:21–0:28 | 7s]</a:t>
+            </a:r>
+          </a:p>
+          <a:p>
+            <a:r>
+              <a:t>Peel the release liner and press onto hot toast. Residual heat melts it in seconds—zero cutlery or mess.</a:t>
             </a:r>
           </a:p>
         </p:txBody>
@@ -1646,12 +1190,12 @@
           <a:lstStyle/>
           <a:p>
             <a:r>
-              <a:t>[0:23–0:31 | 8s]</a:t>
-            </a:r>
-          </a:p>
-          <a:p>
-            <a:r>
-              <a:t>Stamp reinvents the category with calibrated 10-gram spread discs on release film across four iconic flavours: Salted Butter, Raspberry, Yeast, and Peanut.</a:t>
+              <a:t>[0:28–0:37 | 9s]</a:t>
+            </a:r>
+          </a:p>
+          <a:p>
+            <a:r>
+              <a:t>In a 341-million-dollar category with zero portable rivals, premium spreads surged 29% to 113 million as consumers trade up for convenience.</a:t>
             </a:r>
           </a:p>
         </p:txBody>
@@ -1721,12 +1265,12 @@
           <a:lstStyle/>
           <a:p>
             <a:r>
-              <a:t>[0:31–0:38 | 7s]</a:t>
-            </a:r>
-          </a:p>
-          <a:p>
-            <a:r>
-              <a:t>You peel off the release liner and press the disc directly onto hot bread. Residual toast heat melts it in seconds—zero cutlery required.</a:t>
+              <a:t>[0:37–0:44 | 7s]</a:t>
+            </a:r>
+          </a:p>
+          <a:p>
+            <a:r>
+              <a:t>At five dollars retail—just 63 cents a serving—we capture a 35% margin, netting one-seventy-five per pack to fund expansion.</a:t>
             </a:r>
           </a:p>
         </p:txBody>
@@ -1796,12 +1340,12 @@
           <a:lstStyle/>
           <a:p>
             <a:r>
-              <a:t>[0:38–0:44 | 6s]</a:t>
-            </a:r>
-          </a:p>
-          <a:p>
-            <a:r>
-              <a:t>High-stability emulsions deliver 12 months of ambient pantry life in slim, pocket-sized 8-stamp card sheets with zero refrigeration.</a:t>
+              <a:t>[0:44–0:52 | 8s]</a:t>
+            </a:r>
+          </a:p>
+          <a:p>
+            <a:r>
+              <a:t>Production runs on existing contract rotary-die deposition lines in Auckland, launching lean with zero custom tooling outlay.</a:t>
             </a:r>
           </a:p>
         </p:txBody>
@@ -1871,12 +1415,12 @@
           <a:lstStyle/>
           <a:p>
             <a:r>
-              <a:t>[0:44–0:50 | 6s]</a:t>
-            </a:r>
-          </a:p>
-          <a:p>
-            <a:r>
-              <a:t>Cleaned retail supermarket scan data shows the New Zealand spreads market expanded 24% to a 341 million dollar category.</a:t>
+              <a:t>[0:52–1:03 | 11s]</a:t>
+            </a:r>
+          </a:p>
+          <a:p>
+            <a:r>
+              <a:t>In steering the models, my most effective tool was negative prompt constraints—explicitly barring fake organic certifications, miracle health claims, and hyperbolic advertising jargon.</a:t>
             </a:r>
           </a:p>
         </p:txBody>
@@ -1946,12 +1490,12 @@
           <a:lstStyle/>
           <a:p>
             <a:r>
-              <a:t>[0:50–0:58 | 8s]</a:t>
-            </a:r>
-          </a:p>
-          <a:p>
-            <a:r>
-              <a:t>Premium spreads surged 29% from 88 million to 113 million dollars, proving kiwi consumers actively trade up for quality and portion convenience.</a:t>
+              <a:t>[1:03–1:14 | 11s]</a:t>
+            </a:r>
+          </a:p>
+          <a:p>
+            <a:r>
+              <a:t>To prevent context drift, I partitioned distinct modular sessions for data cleaning, branding, packaging copy, and financial modeling, passing clean intermediate summaries between them.</a:t>
             </a:r>
           </a:p>
         </p:txBody>
@@ -5129,7 +4673,7 @@
             <a:avLst/>
           </a:prstGeom>
           <a:solidFill>
-            <a:srgbClr val="4E2408"/>
+            <a:srgbClr val="460820"/>
           </a:solidFill>
           <a:ln>
             <a:noFill/>
@@ -5165,7 +4709,7 @@
         </p:nvSpPr>
         <p:spPr>
           <a:xfrm>
-            <a:off x="1188720" y="1920240"/>
+            <a:off x="1188720" y="2011680"/>
             <a:ext cx="9784080" cy="3657600"/>
           </a:xfrm>
           <a:prstGeom prst="rect">
@@ -5181,25 +4725,9 @@
           <a:p>
             <a:pPr>
               <a:spcAft>
-                <a:spcPts val="800"/>
-              </a:spcAft>
-              <a:defRPr sz="5400" b="1">
-                <a:solidFill>
-                  <a:srgbClr val="FF8C30"/>
-                </a:solidFill>
-                <a:latin typeface="Manrope"/>
-              </a:defRPr>
-            </a:pPr>
-            <a:r>
-              <a:t>0 Rivals</a:t>
-            </a:r>
-          </a:p>
-          <a:p>
-            <a:pPr>
-              <a:spcAft>
                 <a:spcPts val="1200"/>
               </a:spcAft>
-              <a:defRPr sz="3600" b="1">
+              <a:defRPr sz="4400" b="1">
                 <a:solidFill>
                   <a:srgbClr val="FFFFFF"/>
                 </a:solidFill>
@@ -5207,27 +4735,43 @@
               </a:defRPr>
             </a:pPr>
             <a:r>
-              <a:t>Across 154 Supermarket Spreads.</a:t>
+              <a:t>Catching Dairy Instability.</a:t>
             </a:r>
           </a:p>
           <a:p>
             <a:pPr>
-              <a:defRPr sz="2000" b="0">
+              <a:spcAft>
+                <a:spcPts val="1400"/>
+              </a:spcAft>
+              <a:defRPr sz="2600" b="1">
                 <a:solidFill>
-                  <a:srgbClr val="FF8C30"/>
+                  <a:srgbClr val="FF467A"/>
                 </a:solidFill>
                 <a:latin typeface="Manrope"/>
               </a:defRPr>
             </a:pPr>
             <a:r>
-              <a:t>Zero single-serve or utensil-free formats in NZ retail.</a:t>
+              <a:t>AI assumed table butter could sit ambiently.</a:t>
+            </a:r>
+          </a:p>
+          <a:p>
+            <a:pPr>
+              <a:defRPr sz="2200" b="1">
+                <a:solidFill>
+                  <a:srgbClr val="FFFFFF"/>
+                </a:solidFill>
+                <a:latin typeface="Manrope"/>
+              </a:defRPr>
+            </a:pPr>
+            <a:r>
+              <a:t>Human intervention forced high-stability emulsion.</a:t>
             </a:r>
           </a:p>
         </p:txBody>
       </p:sp>
       <p:pic>
         <p:nvPicPr>
-          <p:cNvPr id="4" name="Picture 3" descr="wordmark_peanut.png"/>
+          <p:cNvPr id="4" name="Picture 3" descr="wordmark_raspberry.png"/>
           <p:cNvPicPr>
             <a:picLocks noChangeAspect="1"/>
           </p:cNvPicPr>
@@ -5282,7 +4826,7 @@
             <a:avLst/>
           </a:prstGeom>
           <a:solidFill>
-            <a:srgbClr val="4E2408"/>
+            <a:srgbClr val="460820"/>
           </a:solidFill>
           <a:ln>
             <a:noFill/>
@@ -5318,7 +4862,7 @@
         </p:nvSpPr>
         <p:spPr>
           <a:xfrm>
-            <a:off x="1188720" y="1920240"/>
+            <a:off x="1188720" y="2377440"/>
             <a:ext cx="9784080" cy="3657600"/>
           </a:xfrm>
           <a:prstGeom prst="rect">
@@ -5334,25 +4878,9 @@
           <a:p>
             <a:pPr>
               <a:spcAft>
-                <a:spcPts val="800"/>
-              </a:spcAft>
-              <a:defRPr sz="5400" b="1">
-                <a:solidFill>
-                  <a:srgbClr val="FF8C30"/>
-                </a:solidFill>
-                <a:latin typeface="Manrope"/>
-              </a:defRPr>
-            </a:pPr>
-            <a:r>
-              <a:t>35% Gross Margin</a:t>
-            </a:r>
-          </a:p>
-          <a:p>
-            <a:pPr>
-              <a:spcAft>
                 <a:spcPts val="1200"/>
               </a:spcAft>
-              <a:defRPr sz="3600" b="1">
+              <a:defRPr sz="4400" b="1">
                 <a:solidFill>
                   <a:srgbClr val="FFFFFF"/>
                 </a:solidFill>
@@ -5360,27 +4888,30 @@
               </a:defRPr>
             </a:pPr>
             <a:r>
-              <a:t>$5.00 Retail • $1.75 Margin per Pack.</a:t>
+              <a:t>AI as Drafter, Not Director.</a:t>
             </a:r>
           </a:p>
           <a:p>
             <a:pPr>
-              <a:defRPr sz="2000" b="0">
+              <a:spcAft>
+                <a:spcPts val="1400"/>
+              </a:spcAft>
+              <a:defRPr sz="2400" b="1">
                 <a:solidFill>
-                  <a:srgbClr val="FF8C30"/>
+                  <a:srgbClr val="FF467A"/>
                 </a:solidFill>
                 <a:latin typeface="Manrope"/>
               </a:defRPr>
             </a:pPr>
             <a:r>
-              <a:t>63¢ per serving on an assumed $1.50 contract packaging cost.</a:t>
+              <a:t>Auditing raw scan outliers and verifying live supermarket shelves.</a:t>
             </a:r>
           </a:p>
         </p:txBody>
       </p:sp>
       <p:pic>
         <p:nvPicPr>
-          <p:cNvPr id="4" name="Picture 3" descr="wordmark_peanut.png"/>
+          <p:cNvPr id="4" name="Picture 3" descr="wordmark_raspberry.png"/>
           <p:cNvPicPr>
             <a:picLocks noChangeAspect="1"/>
           </p:cNvPicPr>
@@ -5435,7 +4966,7 @@
             <a:avLst/>
           </a:prstGeom>
           <a:solidFill>
-            <a:srgbClr val="4A3000"/>
+            <a:srgbClr val="240340"/>
           </a:solidFill>
           <a:ln>
             <a:noFill/>
@@ -5471,8 +5002,8 @@
         </p:nvSpPr>
         <p:spPr>
           <a:xfrm>
-            <a:off x="1188720" y="822960"/>
-            <a:ext cx="9784080" cy="1280160"/>
+            <a:off x="1188720" y="2011680"/>
+            <a:ext cx="9784080" cy="3657600"/>
           </a:xfrm>
           <a:prstGeom prst="rect">
             <a:avLst/>
@@ -5487,9 +5018,9 @@
           <a:p>
             <a:pPr>
               <a:spcAft>
-                <a:spcPts val="600"/>
+                <a:spcPts val="1200"/>
               </a:spcAft>
-              <a:defRPr sz="3400" b="1">
+              <a:defRPr sz="4600" b="1">
                 <a:solidFill>
                   <a:srgbClr val="FFFFFF"/>
                 </a:solidFill>
@@ -5497,27 +5028,43 @@
               </a:defRPr>
             </a:pPr>
             <a:r>
-              <a:t>Contract Co-Manufacturing.</a:t>
+              <a:t>Combating AI Slop.</a:t>
             </a:r>
           </a:p>
           <a:p>
             <a:pPr>
-              <a:defRPr sz="2000" b="0">
+              <a:spcAft>
+                <a:spcPts val="1400"/>
+              </a:spcAft>
+              <a:defRPr sz="2600" b="1">
                 <a:solidFill>
-                  <a:srgbClr val="FFD640"/>
+                  <a:srgbClr val="E24BFF"/>
                 </a:solidFill>
                 <a:latin typeface="Manrope"/>
               </a:defRPr>
             </a:pPr>
             <a:r>
-              <a:t>Continuous deposit tooling onto food-grade release liner.</a:t>
+              <a:t>Stripping corporate buzzwords for plain human facts.</a:t>
+            </a:r>
+          </a:p>
+          <a:p>
+            <a:pPr>
+              <a:defRPr sz="2400" b="1">
+                <a:solidFill>
+                  <a:srgbClr val="FFFFFF"/>
+                </a:solidFill>
+                <a:latin typeface="Manrope"/>
+              </a:defRPr>
+            </a:pPr>
+            <a:r>
+              <a:t>Peel. Press. Toast.</a:t>
             </a:r>
           </a:p>
         </p:txBody>
       </p:sp>
       <p:pic>
         <p:nvPicPr>
-          <p:cNvPr id="4" name="Picture 3" descr="diagram_process_butter.png"/>
+          <p:cNvPr id="4" name="Picture 3" descr="wordmark_yeast.png"/>
           <p:cNvPicPr>
             <a:picLocks noChangeAspect="1"/>
           </p:cNvPicPr>
@@ -5525,30 +5072,6 @@
         </p:nvPicPr>
         <p:blipFill>
           <a:blip r:embed="rId2"/>
-          <a:stretch>
-            <a:fillRect/>
-          </a:stretch>
-        </p:blipFill>
-        <p:spPr>
-          <a:xfrm>
-            <a:off x="2438247" y="2286000"/>
-            <a:ext cx="7315200" cy="2854712"/>
-          </a:xfrm>
-          <a:prstGeom prst="rect">
-            <a:avLst/>
-          </a:prstGeom>
-        </p:spPr>
-      </p:pic>
-      <p:pic>
-        <p:nvPicPr>
-          <p:cNvPr id="5" name="Picture 4" descr="wordmark_butter.png"/>
-          <p:cNvPicPr>
-            <a:picLocks noChangeAspect="1"/>
-          </p:cNvPicPr>
-          <p:nvPr/>
-        </p:nvPicPr>
-        <p:blipFill>
-          <a:blip r:embed="rId3"/>
           <a:stretch>
             <a:fillRect/>
           </a:stretch>
@@ -5596,7 +5119,7 @@
             <a:avLst/>
           </a:prstGeom>
           <a:solidFill>
-            <a:srgbClr val="4A3000"/>
+            <a:srgbClr val="240340"/>
           </a:solidFill>
           <a:ln>
             <a:noFill/>
@@ -5632,7 +5155,7 @@
         </p:nvSpPr>
         <p:spPr>
           <a:xfrm>
-            <a:off x="1188720" y="2011680"/>
+            <a:off x="1188720" y="2377440"/>
             <a:ext cx="9784080" cy="3657600"/>
           </a:xfrm>
           <a:prstGeom prst="rect">
@@ -5650,7 +5173,7 @@
               <a:spcAft>
                 <a:spcPts val="1200"/>
               </a:spcAft>
-              <a:defRPr sz="4400" b="1">
+              <a:defRPr sz="4600" b="1">
                 <a:solidFill>
                   <a:srgbClr val="FFFFFF"/>
                 </a:solidFill>
@@ -5658,7 +5181,7 @@
               </a:defRPr>
             </a:pPr>
             <a:r>
-              <a:t>Lean Capex Pilot.</a:t>
+              <a:t>Zero Hallucination Tolerance.</a:t>
             </a:r>
           </a:p>
           <a:p>
@@ -5668,33 +5191,20 @@
               </a:spcAft>
               <a:defRPr sz="2400" b="1">
                 <a:solidFill>
-                  <a:srgbClr val="FFD640"/>
+                  <a:srgbClr val="E24BFF"/>
                 </a:solidFill>
                 <a:latin typeface="Manrope"/>
               </a:defRPr>
             </a:pPr>
             <a:r>
-              <a:t>Partnering with Auckland contract food packagers.</a:t>
-            </a:r>
-          </a:p>
-          <a:p>
-            <a:pPr>
-              <a:defRPr sz="2000" b="1">
-                <a:solidFill>
-                  <a:srgbClr val="FFFFFF"/>
-                </a:solidFill>
-                <a:latin typeface="Manrope"/>
-              </a:defRPr>
-            </a:pPr>
-            <a:r>
-              <a:t>Zero heavy machinery outlay required for market entry.</a:t>
+              <a:t>Strict FSANZ food laws and mandatory allergen warnings.</a:t>
             </a:r>
           </a:p>
         </p:txBody>
       </p:sp>
       <p:pic>
         <p:nvPicPr>
-          <p:cNvPr id="4" name="Picture 3" descr="wordmark_butter.png"/>
+          <p:cNvPr id="4" name="Picture 3" descr="wordmark_yeast.png"/>
           <p:cNvPicPr>
             <a:picLocks noChangeAspect="1"/>
           </p:cNvPicPr>
@@ -5749,7 +5259,7 @@
             <a:avLst/>
           </a:prstGeom>
           <a:solidFill>
-            <a:srgbClr val="460820"/>
+            <a:srgbClr val="240340"/>
           </a:solidFill>
           <a:ln>
             <a:noFill/>
@@ -5785,159 +5295,6 @@
         </p:nvSpPr>
         <p:spPr>
           <a:xfrm>
-            <a:off x="1188720" y="2011680"/>
-            <a:ext cx="9784080" cy="3657600"/>
-          </a:xfrm>
-          <a:prstGeom prst="rect">
-            <a:avLst/>
-          </a:prstGeom>
-          <a:noFill/>
-        </p:spPr>
-        <p:txBody>
-          <a:bodyPr wrap="square" lIns="0" tIns="0" rIns="0" bIns="0">
-            <a:spAutoFit/>
-          </a:bodyPr>
-          <a:lstStyle/>
-          <a:p>
-            <a:pPr>
-              <a:spcAft>
-                <a:spcPts val="1200"/>
-              </a:spcAft>
-              <a:defRPr sz="2200" b="1">
-                <a:solidFill>
-                  <a:srgbClr val="FF467A"/>
-                </a:solidFill>
-                <a:latin typeface="Manrope"/>
-              </a:defRPr>
-            </a:pPr>
-            <a:r>
-              <a:t>Negative Constraints.</a:t>
-            </a:r>
-          </a:p>
-          <a:p>
-            <a:pPr>
-              <a:spcAft>
-                <a:spcPts val="1400"/>
-              </a:spcAft>
-              <a:defRPr sz="4600" b="1">
-                <a:solidFill>
-                  <a:srgbClr val="FFFFFF"/>
-                </a:solidFill>
-                <a:latin typeface="Manrope"/>
-              </a:defRPr>
-            </a:pPr>
-            <a:r>
-              <a:t>Banning AI Marketing Hype.</a:t>
-            </a:r>
-          </a:p>
-          <a:p>
-            <a:pPr>
-              <a:defRPr sz="2200" b="0">
-                <a:solidFill>
-                  <a:srgbClr val="FF467A"/>
-                </a:solidFill>
-                <a:latin typeface="Manrope"/>
-              </a:defRPr>
-            </a:pPr>
-            <a:r>
-              <a:t>Explicit negative prompts barred fake badges and health claims.</a:t>
-            </a:r>
-          </a:p>
-        </p:txBody>
-      </p:sp>
-      <p:pic>
-        <p:nvPicPr>
-          <p:cNvPr id="4" name="Picture 3" descr="wordmark_raspberry.png"/>
-          <p:cNvPicPr>
-            <a:picLocks noChangeAspect="1"/>
-          </p:cNvPicPr>
-          <p:nvPr/>
-        </p:nvPicPr>
-        <p:blipFill>
-          <a:blip r:embed="rId2"/>
-          <a:stretch>
-            <a:fillRect/>
-          </a:stretch>
-        </p:blipFill>
-        <p:spPr>
-          <a:xfrm>
-            <a:off x="5410047" y="6172200"/>
-            <a:ext cx="1371600" cy="335584"/>
-          </a:xfrm>
-          <a:prstGeom prst="rect">
-            <a:avLst/>
-          </a:prstGeom>
-        </p:spPr>
-      </p:pic>
-    </p:spTree>
-  </p:cSld>
-  <p:clrMapOvr>
-    <a:masterClrMapping/>
-  </p:clrMapOvr>
-</p:sld>
-</file>
-
-<file path=ppt/slides/slide15.xml><?xml version="1.0" encoding="utf-8"?>
-<p:sld xmlns:a="http://schemas.openxmlformats.org/drawingml/2006/main" xmlns:p="http://schemas.openxmlformats.org/presentationml/2006/main" xmlns:r="http://schemas.openxmlformats.org/officeDocument/2006/relationships">
-  <p:cSld>
-    <p:spTree>
-      <p:nvGrpSpPr>
-        <p:cNvPr id="1" name=""/>
-        <p:cNvGrpSpPr/>
-        <p:nvPr/>
-      </p:nvGrpSpPr>
-      <p:grpSpPr/>
-      <p:sp>
-        <p:nvSpPr>
-          <p:cNvPr id="2" name="Rectangle 1"/>
-          <p:cNvSpPr/>
-          <p:nvPr/>
-        </p:nvSpPr>
-        <p:spPr>
-          <a:xfrm>
-            <a:off x="0" y="0"/>
-            <a:ext cx="12191695" cy="6858000"/>
-          </a:xfrm>
-          <a:prstGeom prst="rect">
-            <a:avLst/>
-          </a:prstGeom>
-          <a:solidFill>
-            <a:srgbClr val="460820"/>
-          </a:solidFill>
-          <a:ln>
-            <a:noFill/>
-          </a:ln>
-        </p:spPr>
-        <p:style>
-          <a:lnRef idx="1">
-            <a:schemeClr val="accent1"/>
-          </a:lnRef>
-          <a:fillRef idx="3">
-            <a:schemeClr val="accent1"/>
-          </a:fillRef>
-          <a:effectRef idx="2">
-            <a:schemeClr val="accent1"/>
-          </a:effectRef>
-          <a:fontRef idx="minor">
-            <a:schemeClr val="lt1"/>
-          </a:fontRef>
-        </p:style>
-        <p:txBody>
-          <a:bodyPr rtlCol="0" anchor="ctr"/>
-          <a:lstStyle/>
-          <a:p>
-            <a:pPr algn="ctr"/>
-          </a:p>
-        </p:txBody>
-      </p:sp>
-      <p:sp>
-        <p:nvSpPr>
-          <p:cNvPr id="3" name="TextBox 2"/>
-          <p:cNvSpPr txBox="1"/>
-          <p:nvPr/>
-        </p:nvSpPr>
-        <p:spPr>
-          <a:xfrm>
             <a:off x="1188720" y="2377440"/>
             <a:ext cx="9784080" cy="3657600"/>
           </a:xfrm>
@@ -5964,593 +5321,7 @@
               </a:defRPr>
             </a:pPr>
             <a:r>
-              <a:t>Modular Architecture.</a:t>
-            </a:r>
-          </a:p>
-          <a:p>
-            <a:pPr>
-              <a:spcAft>
-                <a:spcPts val="1400"/>
-              </a:spcAft>
-              <a:defRPr sz="2400" b="1">
-                <a:solidFill>
-                  <a:srgbClr val="FF467A"/>
-                </a:solidFill>
-                <a:latin typeface="Manrope"/>
-              </a:defRPr>
-            </a:pPr>
-            <a:r>
-              <a:t>Separating data, branding, and copy eliminated context drift.</a:t>
-            </a:r>
-          </a:p>
-        </p:txBody>
-      </p:sp>
-      <p:pic>
-        <p:nvPicPr>
-          <p:cNvPr id="4" name="Picture 3" descr="wordmark_raspberry.png"/>
-          <p:cNvPicPr>
-            <a:picLocks noChangeAspect="1"/>
-          </p:cNvPicPr>
-          <p:nvPr/>
-        </p:nvPicPr>
-        <p:blipFill>
-          <a:blip r:embed="rId2"/>
-          <a:stretch>
-            <a:fillRect/>
-          </a:stretch>
-        </p:blipFill>
-        <p:spPr>
-          <a:xfrm>
-            <a:off x="5410047" y="6172200"/>
-            <a:ext cx="1371600" cy="335584"/>
-          </a:xfrm>
-          <a:prstGeom prst="rect">
-            <a:avLst/>
-          </a:prstGeom>
-        </p:spPr>
-      </p:pic>
-    </p:spTree>
-  </p:cSld>
-  <p:clrMapOvr>
-    <a:masterClrMapping/>
-  </p:clrMapOvr>
-</p:sld>
-</file>
-
-<file path=ppt/slides/slide16.xml><?xml version="1.0" encoding="utf-8"?>
-<p:sld xmlns:a="http://schemas.openxmlformats.org/drawingml/2006/main" xmlns:p="http://schemas.openxmlformats.org/presentationml/2006/main" xmlns:r="http://schemas.openxmlformats.org/officeDocument/2006/relationships">
-  <p:cSld>
-    <p:spTree>
-      <p:nvGrpSpPr>
-        <p:cNvPr id="1" name=""/>
-        <p:cNvGrpSpPr/>
-        <p:nvPr/>
-      </p:nvGrpSpPr>
-      <p:grpSpPr/>
-      <p:sp>
-        <p:nvSpPr>
-          <p:cNvPr id="2" name="Rectangle 1"/>
-          <p:cNvSpPr/>
-          <p:nvPr/>
-        </p:nvSpPr>
-        <p:spPr>
-          <a:xfrm>
-            <a:off x="0" y="0"/>
-            <a:ext cx="12191695" cy="6858000"/>
-          </a:xfrm>
-          <a:prstGeom prst="rect">
-            <a:avLst/>
-          </a:prstGeom>
-          <a:solidFill>
-            <a:srgbClr val="460820"/>
-          </a:solidFill>
-          <a:ln>
-            <a:noFill/>
-          </a:ln>
-        </p:spPr>
-        <p:style>
-          <a:lnRef idx="1">
-            <a:schemeClr val="accent1"/>
-          </a:lnRef>
-          <a:fillRef idx="3">
-            <a:schemeClr val="accent1"/>
-          </a:fillRef>
-          <a:effectRef idx="2">
-            <a:schemeClr val="accent1"/>
-          </a:effectRef>
-          <a:fontRef idx="minor">
-            <a:schemeClr val="lt1"/>
-          </a:fontRef>
-        </p:style>
-        <p:txBody>
-          <a:bodyPr rtlCol="0" anchor="ctr"/>
-          <a:lstStyle/>
-          <a:p>
-            <a:pPr algn="ctr"/>
-          </a:p>
-        </p:txBody>
-      </p:sp>
-      <p:sp>
-        <p:nvSpPr>
-          <p:cNvPr id="3" name="TextBox 2"/>
-          <p:cNvSpPr txBox="1"/>
-          <p:nvPr/>
-        </p:nvSpPr>
-        <p:spPr>
-          <a:xfrm>
-            <a:off x="1188720" y="2011680"/>
-            <a:ext cx="9784080" cy="3657600"/>
-          </a:xfrm>
-          <a:prstGeom prst="rect">
-            <a:avLst/>
-          </a:prstGeom>
-          <a:noFill/>
-        </p:spPr>
-        <p:txBody>
-          <a:bodyPr wrap="square" lIns="0" tIns="0" rIns="0" bIns="0">
-            <a:spAutoFit/>
-          </a:bodyPr>
-          <a:lstStyle/>
-          <a:p>
-            <a:pPr>
-              <a:spcAft>
-                <a:spcPts val="1200"/>
-              </a:spcAft>
-              <a:defRPr sz="4400" b="1">
-                <a:solidFill>
-                  <a:srgbClr val="FFFFFF"/>
-                </a:solidFill>
-                <a:latin typeface="Manrope"/>
-              </a:defRPr>
-            </a:pPr>
-            <a:r>
-              <a:t>Catching Dairy Instability.</a:t>
-            </a:r>
-          </a:p>
-          <a:p>
-            <a:pPr>
-              <a:spcAft>
-                <a:spcPts val="1400"/>
-              </a:spcAft>
-              <a:defRPr sz="2600" b="1">
-                <a:solidFill>
-                  <a:srgbClr val="FF467A"/>
-                </a:solidFill>
-                <a:latin typeface="Manrope"/>
-              </a:defRPr>
-            </a:pPr>
-            <a:r>
-              <a:t>AI assumed table butter could sit ambiently.</a:t>
-            </a:r>
-          </a:p>
-          <a:p>
-            <a:pPr>
-              <a:defRPr sz="2200" b="1">
-                <a:solidFill>
-                  <a:srgbClr val="FFFFFF"/>
-                </a:solidFill>
-                <a:latin typeface="Manrope"/>
-              </a:defRPr>
-            </a:pPr>
-            <a:r>
-              <a:t>Human intervention forced high-stability emulsion.</a:t>
-            </a:r>
-          </a:p>
-        </p:txBody>
-      </p:sp>
-      <p:pic>
-        <p:nvPicPr>
-          <p:cNvPr id="4" name="Picture 3" descr="wordmark_raspberry.png"/>
-          <p:cNvPicPr>
-            <a:picLocks noChangeAspect="1"/>
-          </p:cNvPicPr>
-          <p:nvPr/>
-        </p:nvPicPr>
-        <p:blipFill>
-          <a:blip r:embed="rId2"/>
-          <a:stretch>
-            <a:fillRect/>
-          </a:stretch>
-        </p:blipFill>
-        <p:spPr>
-          <a:xfrm>
-            <a:off x="5410047" y="6172200"/>
-            <a:ext cx="1371600" cy="335584"/>
-          </a:xfrm>
-          <a:prstGeom prst="rect">
-            <a:avLst/>
-          </a:prstGeom>
-        </p:spPr>
-      </p:pic>
-    </p:spTree>
-  </p:cSld>
-  <p:clrMapOvr>
-    <a:masterClrMapping/>
-  </p:clrMapOvr>
-</p:sld>
-</file>
-
-<file path=ppt/slides/slide17.xml><?xml version="1.0" encoding="utf-8"?>
-<p:sld xmlns:a="http://schemas.openxmlformats.org/drawingml/2006/main" xmlns:p="http://schemas.openxmlformats.org/presentationml/2006/main" xmlns:r="http://schemas.openxmlformats.org/officeDocument/2006/relationships">
-  <p:cSld>
-    <p:spTree>
-      <p:nvGrpSpPr>
-        <p:cNvPr id="1" name=""/>
-        <p:cNvGrpSpPr/>
-        <p:nvPr/>
-      </p:nvGrpSpPr>
-      <p:grpSpPr/>
-      <p:sp>
-        <p:nvSpPr>
-          <p:cNvPr id="2" name="Rectangle 1"/>
-          <p:cNvSpPr/>
-          <p:nvPr/>
-        </p:nvSpPr>
-        <p:spPr>
-          <a:xfrm>
-            <a:off x="0" y="0"/>
-            <a:ext cx="12191695" cy="6858000"/>
-          </a:xfrm>
-          <a:prstGeom prst="rect">
-            <a:avLst/>
-          </a:prstGeom>
-          <a:solidFill>
-            <a:srgbClr val="460820"/>
-          </a:solidFill>
-          <a:ln>
-            <a:noFill/>
-          </a:ln>
-        </p:spPr>
-        <p:style>
-          <a:lnRef idx="1">
-            <a:schemeClr val="accent1"/>
-          </a:lnRef>
-          <a:fillRef idx="3">
-            <a:schemeClr val="accent1"/>
-          </a:fillRef>
-          <a:effectRef idx="2">
-            <a:schemeClr val="accent1"/>
-          </a:effectRef>
-          <a:fontRef idx="minor">
-            <a:schemeClr val="lt1"/>
-          </a:fontRef>
-        </p:style>
-        <p:txBody>
-          <a:bodyPr rtlCol="0" anchor="ctr"/>
-          <a:lstStyle/>
-          <a:p>
-            <a:pPr algn="ctr"/>
-          </a:p>
-        </p:txBody>
-      </p:sp>
-      <p:sp>
-        <p:nvSpPr>
-          <p:cNvPr id="3" name="TextBox 2"/>
-          <p:cNvSpPr txBox="1"/>
-          <p:nvPr/>
-        </p:nvSpPr>
-        <p:spPr>
-          <a:xfrm>
-            <a:off x="1188720" y="2377440"/>
-            <a:ext cx="9784080" cy="3657600"/>
-          </a:xfrm>
-          <a:prstGeom prst="rect">
-            <a:avLst/>
-          </a:prstGeom>
-          <a:noFill/>
-        </p:spPr>
-        <p:txBody>
-          <a:bodyPr wrap="square" lIns="0" tIns="0" rIns="0" bIns="0">
-            <a:spAutoFit/>
-          </a:bodyPr>
-          <a:lstStyle/>
-          <a:p>
-            <a:pPr>
-              <a:spcAft>
-                <a:spcPts val="1200"/>
-              </a:spcAft>
-              <a:defRPr sz="4400" b="1">
-                <a:solidFill>
-                  <a:srgbClr val="FFFFFF"/>
-                </a:solidFill>
-                <a:latin typeface="Manrope"/>
-              </a:defRPr>
-            </a:pPr>
-            <a:r>
-              <a:t>AI as Drafter, Not Director.</a:t>
-            </a:r>
-          </a:p>
-          <a:p>
-            <a:pPr>
-              <a:spcAft>
-                <a:spcPts val="1400"/>
-              </a:spcAft>
-              <a:defRPr sz="2400" b="1">
-                <a:solidFill>
-                  <a:srgbClr val="FF467A"/>
-                </a:solidFill>
-                <a:latin typeface="Manrope"/>
-              </a:defRPr>
-            </a:pPr>
-            <a:r>
-              <a:t>Auditing raw scan outliers and verifying live supermarket shelves.</a:t>
-            </a:r>
-          </a:p>
-        </p:txBody>
-      </p:sp>
-      <p:pic>
-        <p:nvPicPr>
-          <p:cNvPr id="4" name="Picture 3" descr="wordmark_raspberry.png"/>
-          <p:cNvPicPr>
-            <a:picLocks noChangeAspect="1"/>
-          </p:cNvPicPr>
-          <p:nvPr/>
-        </p:nvPicPr>
-        <p:blipFill>
-          <a:blip r:embed="rId2"/>
-          <a:stretch>
-            <a:fillRect/>
-          </a:stretch>
-        </p:blipFill>
-        <p:spPr>
-          <a:xfrm>
-            <a:off x="5410047" y="6172200"/>
-            <a:ext cx="1371600" cy="335584"/>
-          </a:xfrm>
-          <a:prstGeom prst="rect">
-            <a:avLst/>
-          </a:prstGeom>
-        </p:spPr>
-      </p:pic>
-    </p:spTree>
-  </p:cSld>
-  <p:clrMapOvr>
-    <a:masterClrMapping/>
-  </p:clrMapOvr>
-</p:sld>
-</file>
-
-<file path=ppt/slides/slide18.xml><?xml version="1.0" encoding="utf-8"?>
-<p:sld xmlns:a="http://schemas.openxmlformats.org/drawingml/2006/main" xmlns:p="http://schemas.openxmlformats.org/presentationml/2006/main" xmlns:r="http://schemas.openxmlformats.org/officeDocument/2006/relationships">
-  <p:cSld>
-    <p:spTree>
-      <p:nvGrpSpPr>
-        <p:cNvPr id="1" name=""/>
-        <p:cNvGrpSpPr/>
-        <p:nvPr/>
-      </p:nvGrpSpPr>
-      <p:grpSpPr/>
-      <p:sp>
-        <p:nvSpPr>
-          <p:cNvPr id="2" name="Rectangle 1"/>
-          <p:cNvSpPr/>
-          <p:nvPr/>
-        </p:nvSpPr>
-        <p:spPr>
-          <a:xfrm>
-            <a:off x="0" y="0"/>
-            <a:ext cx="12191695" cy="6858000"/>
-          </a:xfrm>
-          <a:prstGeom prst="rect">
-            <a:avLst/>
-          </a:prstGeom>
-          <a:solidFill>
-            <a:srgbClr val="240340"/>
-          </a:solidFill>
-          <a:ln>
-            <a:noFill/>
-          </a:ln>
-        </p:spPr>
-        <p:style>
-          <a:lnRef idx="1">
-            <a:schemeClr val="accent1"/>
-          </a:lnRef>
-          <a:fillRef idx="3">
-            <a:schemeClr val="accent1"/>
-          </a:fillRef>
-          <a:effectRef idx="2">
-            <a:schemeClr val="accent1"/>
-          </a:effectRef>
-          <a:fontRef idx="minor">
-            <a:schemeClr val="lt1"/>
-          </a:fontRef>
-        </p:style>
-        <p:txBody>
-          <a:bodyPr rtlCol="0" anchor="ctr"/>
-          <a:lstStyle/>
-          <a:p>
-            <a:pPr algn="ctr"/>
-          </a:p>
-        </p:txBody>
-      </p:sp>
-      <p:sp>
-        <p:nvSpPr>
-          <p:cNvPr id="3" name="TextBox 2"/>
-          <p:cNvSpPr txBox="1"/>
-          <p:nvPr/>
-        </p:nvSpPr>
-        <p:spPr>
-          <a:xfrm>
-            <a:off x="1188720" y="2011680"/>
-            <a:ext cx="9784080" cy="3657600"/>
-          </a:xfrm>
-          <a:prstGeom prst="rect">
-            <a:avLst/>
-          </a:prstGeom>
-          <a:noFill/>
-        </p:spPr>
-        <p:txBody>
-          <a:bodyPr wrap="square" lIns="0" tIns="0" rIns="0" bIns="0">
-            <a:spAutoFit/>
-          </a:bodyPr>
-          <a:lstStyle/>
-          <a:p>
-            <a:pPr>
-              <a:spcAft>
-                <a:spcPts val="1200"/>
-              </a:spcAft>
-              <a:defRPr sz="4600" b="1">
-                <a:solidFill>
-                  <a:srgbClr val="FFFFFF"/>
-                </a:solidFill>
-                <a:latin typeface="Manrope"/>
-              </a:defRPr>
-            </a:pPr>
-            <a:r>
-              <a:t>Combating AI Slop.</a:t>
-            </a:r>
-          </a:p>
-          <a:p>
-            <a:pPr>
-              <a:spcAft>
-                <a:spcPts val="1400"/>
-              </a:spcAft>
-              <a:defRPr sz="2600" b="1">
-                <a:solidFill>
-                  <a:srgbClr val="E24BFF"/>
-                </a:solidFill>
-                <a:latin typeface="Manrope"/>
-              </a:defRPr>
-            </a:pPr>
-            <a:r>
-              <a:t>Stripping corporate buzzwords for plain human facts.</a:t>
-            </a:r>
-          </a:p>
-          <a:p>
-            <a:pPr>
-              <a:defRPr sz="2400" b="1">
-                <a:solidFill>
-                  <a:srgbClr val="FFFFFF"/>
-                </a:solidFill>
-                <a:latin typeface="Manrope"/>
-              </a:defRPr>
-            </a:pPr>
-            <a:r>
-              <a:t>Peel. Press. Toast.</a:t>
-            </a:r>
-          </a:p>
-        </p:txBody>
-      </p:sp>
-      <p:pic>
-        <p:nvPicPr>
-          <p:cNvPr id="4" name="Picture 3" descr="wordmark_yeast.png"/>
-          <p:cNvPicPr>
-            <a:picLocks noChangeAspect="1"/>
-          </p:cNvPicPr>
-          <p:nvPr/>
-        </p:nvPicPr>
-        <p:blipFill>
-          <a:blip r:embed="rId2"/>
-          <a:stretch>
-            <a:fillRect/>
-          </a:stretch>
-        </p:blipFill>
-        <p:spPr>
-          <a:xfrm>
-            <a:off x="5410047" y="6172200"/>
-            <a:ext cx="1371600" cy="335584"/>
-          </a:xfrm>
-          <a:prstGeom prst="rect">
-            <a:avLst/>
-          </a:prstGeom>
-        </p:spPr>
-      </p:pic>
-    </p:spTree>
-  </p:cSld>
-  <p:clrMapOvr>
-    <a:masterClrMapping/>
-  </p:clrMapOvr>
-</p:sld>
-</file>
-
-<file path=ppt/slides/slide19.xml><?xml version="1.0" encoding="utf-8"?>
-<p:sld xmlns:a="http://schemas.openxmlformats.org/drawingml/2006/main" xmlns:p="http://schemas.openxmlformats.org/presentationml/2006/main" xmlns:r="http://schemas.openxmlformats.org/officeDocument/2006/relationships">
-  <p:cSld>
-    <p:spTree>
-      <p:nvGrpSpPr>
-        <p:cNvPr id="1" name=""/>
-        <p:cNvGrpSpPr/>
-        <p:nvPr/>
-      </p:nvGrpSpPr>
-      <p:grpSpPr/>
-      <p:sp>
-        <p:nvSpPr>
-          <p:cNvPr id="2" name="Rectangle 1"/>
-          <p:cNvSpPr/>
-          <p:nvPr/>
-        </p:nvSpPr>
-        <p:spPr>
-          <a:xfrm>
-            <a:off x="0" y="0"/>
-            <a:ext cx="12191695" cy="6858000"/>
-          </a:xfrm>
-          <a:prstGeom prst="rect">
-            <a:avLst/>
-          </a:prstGeom>
-          <a:solidFill>
-            <a:srgbClr val="240340"/>
-          </a:solidFill>
-          <a:ln>
-            <a:noFill/>
-          </a:ln>
-        </p:spPr>
-        <p:style>
-          <a:lnRef idx="1">
-            <a:schemeClr val="accent1"/>
-          </a:lnRef>
-          <a:fillRef idx="3">
-            <a:schemeClr val="accent1"/>
-          </a:fillRef>
-          <a:effectRef idx="2">
-            <a:schemeClr val="accent1"/>
-          </a:effectRef>
-          <a:fontRef idx="minor">
-            <a:schemeClr val="lt1"/>
-          </a:fontRef>
-        </p:style>
-        <p:txBody>
-          <a:bodyPr rtlCol="0" anchor="ctr"/>
-          <a:lstStyle/>
-          <a:p>
-            <a:pPr algn="ctr"/>
-          </a:p>
-        </p:txBody>
-      </p:sp>
-      <p:sp>
-        <p:nvSpPr>
-          <p:cNvPr id="3" name="TextBox 2"/>
-          <p:cNvSpPr txBox="1"/>
-          <p:nvPr/>
-        </p:nvSpPr>
-        <p:spPr>
-          <a:xfrm>
-            <a:off x="1188720" y="2377440"/>
-            <a:ext cx="9784080" cy="3657600"/>
-          </a:xfrm>
-          <a:prstGeom prst="rect">
-            <a:avLst/>
-          </a:prstGeom>
-          <a:noFill/>
-        </p:spPr>
-        <p:txBody>
-          <a:bodyPr wrap="square" lIns="0" tIns="0" rIns="0" bIns="0">
-            <a:spAutoFit/>
-          </a:bodyPr>
-          <a:lstStyle/>
-          <a:p>
-            <a:pPr>
-              <a:spcAft>
-                <a:spcPts val="1200"/>
-              </a:spcAft>
-              <a:defRPr sz="4600" b="1">
-                <a:solidFill>
-                  <a:srgbClr val="FFFFFF"/>
-                </a:solidFill>
-                <a:latin typeface="Manrope"/>
-              </a:defRPr>
-            </a:pPr>
-            <a:r>
-              <a:t>Zero Hallucination Tolerance.</a:t>
+              <a:t>Accountability Remains Human.</a:t>
             </a:r>
           </a:p>
           <a:p>
@@ -6566,7 +5337,7 @@
               </a:defRPr>
             </a:pPr>
             <a:r>
-              <a:t>Strict FSANZ food laws and mandatory allergen warnings.</a:t>
+              <a:t>Moral, regulatory, and commercial ownership cannot be outsourced.</a:t>
             </a:r>
           </a:p>
         </p:txBody>
@@ -6706,7 +5477,7 @@
               </a:defRPr>
             </a:pPr>
             <a:r>
-              <a:t>Jars Require Infrastructure.</a:t>
+              <a:t>Eating Away from Home is Broken.</a:t>
             </a:r>
           </a:p>
           <a:p>
@@ -6719,7 +5490,7 @@
               </a:defRPr>
             </a:pPr>
             <a:r>
-              <a:t>Table knives, kitchen benches, and hot running water.</a:t>
+              <a:t>Jars require knives, kitchen benches, and running water.</a:t>
             </a:r>
           </a:p>
         </p:txBody>
@@ -6727,146 +5498,6 @@
       <p:pic>
         <p:nvPicPr>
           <p:cNvPr id="4" name="Picture 3" descr="wordmark_raspberry.png"/>
-          <p:cNvPicPr>
-            <a:picLocks noChangeAspect="1"/>
-          </p:cNvPicPr>
-          <p:nvPr/>
-        </p:nvPicPr>
-        <p:blipFill>
-          <a:blip r:embed="rId2"/>
-          <a:stretch>
-            <a:fillRect/>
-          </a:stretch>
-        </p:blipFill>
-        <p:spPr>
-          <a:xfrm>
-            <a:off x="5410047" y="6172200"/>
-            <a:ext cx="1371600" cy="335584"/>
-          </a:xfrm>
-          <a:prstGeom prst="rect">
-            <a:avLst/>
-          </a:prstGeom>
-        </p:spPr>
-      </p:pic>
-    </p:spTree>
-  </p:cSld>
-  <p:clrMapOvr>
-    <a:masterClrMapping/>
-  </p:clrMapOvr>
-</p:sld>
-</file>
-
-<file path=ppt/slides/slide20.xml><?xml version="1.0" encoding="utf-8"?>
-<p:sld xmlns:a="http://schemas.openxmlformats.org/drawingml/2006/main" xmlns:p="http://schemas.openxmlformats.org/presentationml/2006/main" xmlns:r="http://schemas.openxmlformats.org/officeDocument/2006/relationships">
-  <p:cSld>
-    <p:spTree>
-      <p:nvGrpSpPr>
-        <p:cNvPr id="1" name=""/>
-        <p:cNvGrpSpPr/>
-        <p:nvPr/>
-      </p:nvGrpSpPr>
-      <p:grpSpPr/>
-      <p:sp>
-        <p:nvSpPr>
-          <p:cNvPr id="2" name="Rectangle 1"/>
-          <p:cNvSpPr/>
-          <p:nvPr/>
-        </p:nvSpPr>
-        <p:spPr>
-          <a:xfrm>
-            <a:off x="0" y="0"/>
-            <a:ext cx="12191695" cy="6858000"/>
-          </a:xfrm>
-          <a:prstGeom prst="rect">
-            <a:avLst/>
-          </a:prstGeom>
-          <a:solidFill>
-            <a:srgbClr val="240340"/>
-          </a:solidFill>
-          <a:ln>
-            <a:noFill/>
-          </a:ln>
-        </p:spPr>
-        <p:style>
-          <a:lnRef idx="1">
-            <a:schemeClr val="accent1"/>
-          </a:lnRef>
-          <a:fillRef idx="3">
-            <a:schemeClr val="accent1"/>
-          </a:fillRef>
-          <a:effectRef idx="2">
-            <a:schemeClr val="accent1"/>
-          </a:effectRef>
-          <a:fontRef idx="minor">
-            <a:schemeClr val="lt1"/>
-          </a:fontRef>
-        </p:style>
-        <p:txBody>
-          <a:bodyPr rtlCol="0" anchor="ctr"/>
-          <a:lstStyle/>
-          <a:p>
-            <a:pPr algn="ctr"/>
-          </a:p>
-        </p:txBody>
-      </p:sp>
-      <p:sp>
-        <p:nvSpPr>
-          <p:cNvPr id="3" name="TextBox 2"/>
-          <p:cNvSpPr txBox="1"/>
-          <p:nvPr/>
-        </p:nvSpPr>
-        <p:spPr>
-          <a:xfrm>
-            <a:off x="1188720" y="2377440"/>
-            <a:ext cx="9784080" cy="3657600"/>
-          </a:xfrm>
-          <a:prstGeom prst="rect">
-            <a:avLst/>
-          </a:prstGeom>
-          <a:noFill/>
-        </p:spPr>
-        <p:txBody>
-          <a:bodyPr wrap="square" lIns="0" tIns="0" rIns="0" bIns="0">
-            <a:spAutoFit/>
-          </a:bodyPr>
-          <a:lstStyle/>
-          <a:p>
-            <a:pPr>
-              <a:spcAft>
-                <a:spcPts val="1200"/>
-              </a:spcAft>
-              <a:defRPr sz="4600" b="1">
-                <a:solidFill>
-                  <a:srgbClr val="FFFFFF"/>
-                </a:solidFill>
-                <a:latin typeface="Manrope"/>
-              </a:defRPr>
-            </a:pPr>
-            <a:r>
-              <a:t>Accountability Remains Human.</a:t>
-            </a:r>
-          </a:p>
-          <a:p>
-            <a:pPr>
-              <a:spcAft>
-                <a:spcPts val="1400"/>
-              </a:spcAft>
-              <a:defRPr sz="2400" b="1">
-                <a:solidFill>
-                  <a:srgbClr val="E24BFF"/>
-                </a:solidFill>
-                <a:latin typeface="Manrope"/>
-              </a:defRPr>
-            </a:pPr>
-            <a:r>
-              <a:t>Moral, regulatory, and commercial ownership cannot be outsourced.</a:t>
-            </a:r>
-          </a:p>
-        </p:txBody>
-      </p:sp>
-      <p:pic>
-        <p:nvPicPr>
-          <p:cNvPr id="4" name="Picture 3" descr="wordmark_yeast.png"/>
           <p:cNvPicPr>
             <a:picLocks noChangeAspect="1"/>
           </p:cNvPicPr>
@@ -6921,7 +5552,7 @@
             <a:avLst/>
           </a:prstGeom>
           <a:solidFill>
-            <a:srgbClr val="460820"/>
+            <a:srgbClr val="4A3000"/>
           </a:solidFill>
           <a:ln>
             <a:noFill/>
@@ -6957,8 +5588,8 @@
         </p:nvSpPr>
         <p:spPr>
           <a:xfrm>
-            <a:off x="1188720" y="2011680"/>
-            <a:ext cx="9784080" cy="3657600"/>
+            <a:off x="1188720" y="822960"/>
+            <a:ext cx="9784080" cy="1280160"/>
           </a:xfrm>
           <a:prstGeom prst="rect">
             <a:avLst/>
@@ -6973,9 +5604,9 @@
           <a:p>
             <a:pPr>
               <a:spcAft>
-                <a:spcPts val="1200"/>
+                <a:spcPts val="600"/>
               </a:spcAft>
-              <a:defRPr sz="4400" b="1">
+              <a:defRPr sz="3400" b="1">
                 <a:solidFill>
                   <a:srgbClr val="FFFFFF"/>
                 </a:solidFill>
@@ -6983,43 +5614,27 @@
               </a:defRPr>
             </a:pPr>
             <a:r>
-              <a:t>Eating Away from Home is Broken.</a:t>
+              <a:t>The Solution.</a:t>
             </a:r>
           </a:p>
           <a:p>
             <a:pPr>
-              <a:spcAft>
-                <a:spcPts val="1400"/>
-              </a:spcAft>
-              <a:defRPr sz="2600" b="1">
+              <a:defRPr sz="2000" b="0">
                 <a:solidFill>
-                  <a:srgbClr val="FF467A"/>
+                  <a:srgbClr val="FFD640"/>
                 </a:solidFill>
                 <a:latin typeface="Manrope"/>
               </a:defRPr>
             </a:pPr>
             <a:r>
-              <a:t>Desk workers, commuters, and students in dorms.</a:t>
-            </a:r>
-          </a:p>
-          <a:p>
-            <a:pPr>
-              <a:defRPr sz="2200" b="1">
-                <a:solidFill>
-                  <a:srgbClr val="FFFFFF"/>
-                </a:solidFill>
-                <a:latin typeface="Manrope"/>
-              </a:defRPr>
-            </a:pPr>
-            <a:r>
-              <a:t>Nobody carries a 500g sticky glass jar.</a:t>
+              <a:t>10 g spread discs on release film.</a:t>
             </a:r>
           </a:p>
         </p:txBody>
       </p:sp>
       <p:pic>
         <p:nvPicPr>
-          <p:cNvPr id="4" name="Picture 3" descr="wordmark_raspberry.png"/>
+          <p:cNvPr id="4" name="Picture 3" descr="four_packs_row.png"/>
           <p:cNvPicPr>
             <a:picLocks noChangeAspect="1"/>
           </p:cNvPicPr>
@@ -7027,6 +5642,30 @@
         </p:nvPicPr>
         <p:blipFill>
           <a:blip r:embed="rId2"/>
+          <a:stretch>
+            <a:fillRect/>
+          </a:stretch>
+        </p:blipFill>
+        <p:spPr>
+          <a:xfrm>
+            <a:off x="1432407" y="2240280"/>
+            <a:ext cx="9326880" cy="2866869"/>
+          </a:xfrm>
+          <a:prstGeom prst="rect">
+            <a:avLst/>
+          </a:prstGeom>
+        </p:spPr>
+      </p:pic>
+      <p:pic>
+        <p:nvPicPr>
+          <p:cNvPr id="5" name="Picture 4" descr="wordmark_butter.png"/>
+          <p:cNvPicPr>
+            <a:picLocks noChangeAspect="1"/>
+          </p:cNvPicPr>
+          <p:nvPr/>
+        </p:nvPicPr>
+        <p:blipFill>
+          <a:blip r:embed="rId3"/>
           <a:stretch>
             <a:fillRect/>
           </a:stretch>
@@ -7074,7 +5713,7 @@
             <a:avLst/>
           </a:prstGeom>
           <a:solidFill>
-            <a:srgbClr val="460820"/>
+            <a:srgbClr val="4A3000"/>
           </a:solidFill>
           <a:ln>
             <a:noFill/>
@@ -7136,7 +5775,7 @@
               </a:defRPr>
             </a:pPr>
             <a:r>
-              <a:t>The Unmet Need.</a:t>
+              <a:t>Zero Cutlery. Pure Physics.</a:t>
             </a:r>
           </a:p>
           <a:p>
@@ -7146,18 +5785,18 @@
               </a:spcAft>
               <a:defRPr sz="2600" b="1">
                 <a:solidFill>
-                  <a:srgbClr val="FF467A"/>
+                  <a:srgbClr val="FFD640"/>
                 </a:solidFill>
                 <a:latin typeface="Manrope"/>
               </a:defRPr>
             </a:pPr>
             <a:r>
-              <a:t>Consumers abandon toast for dry cereal bars.</a:t>
+              <a:t>Residual toast heat melts the disc in seconds.</a:t>
             </a:r>
           </a:p>
           <a:p>
             <a:pPr>
-              <a:defRPr sz="2200" b="1">
+              <a:defRPr sz="2000" b="1">
                 <a:solidFill>
                   <a:srgbClr val="FFFFFF"/>
                 </a:solidFill>
@@ -7165,14 +5804,14 @@
               </a:defRPr>
             </a:pPr>
             <a:r>
-              <a:t>Portability has never existed for real breakfast spreads.</a:t>
+              <a:t>Peel off the liner. Press onto hot toast. Zero utensils or mess.</a:t>
             </a:r>
           </a:p>
         </p:txBody>
       </p:sp>
       <p:pic>
         <p:nvPicPr>
-          <p:cNvPr id="4" name="Picture 3" descr="wordmark_raspberry.png"/>
+          <p:cNvPr id="4" name="Picture 3" descr="wordmark_butter.png"/>
           <p:cNvPicPr>
             <a:picLocks noChangeAspect="1"/>
           </p:cNvPicPr>
@@ -7227,7 +5866,7 @@
             <a:avLst/>
           </a:prstGeom>
           <a:solidFill>
-            <a:srgbClr val="4A3000"/>
+            <a:srgbClr val="4E2408"/>
           </a:solidFill>
           <a:ln>
             <a:noFill/>
@@ -7289,27 +5928,27 @@
               </a:defRPr>
             </a:pPr>
             <a:r>
-              <a:t>The Solution.</a:t>
+              <a:t>Premium Spreads Surging +29%.</a:t>
             </a:r>
           </a:p>
           <a:p>
             <a:pPr>
               <a:defRPr sz="2000" b="0">
                 <a:solidFill>
-                  <a:srgbClr val="FFD640"/>
+                  <a:srgbClr val="FF8C30"/>
                 </a:solidFill>
                 <a:latin typeface="Manrope"/>
               </a:defRPr>
             </a:pPr>
             <a:r>
-              <a:t>10 g spread discs on release film.</a:t>
+              <a:t>Consumers trading up from commodity tiers into quality formats.</a:t>
             </a:r>
           </a:p>
         </p:txBody>
       </p:sp>
       <p:pic>
         <p:nvPicPr>
-          <p:cNvPr id="4" name="Picture 3" descr="four_packs_row.png"/>
+          <p:cNvPr id="4" name="Picture 3" descr="chart_tier_peanut.png"/>
           <p:cNvPicPr>
             <a:picLocks noChangeAspect="1"/>
           </p:cNvPicPr>
@@ -7323,8 +5962,8 @@
         </p:blipFill>
         <p:spPr>
           <a:xfrm>
-            <a:off x="1432407" y="2240280"/>
-            <a:ext cx="9326880" cy="2866869"/>
+            <a:off x="3078327" y="2148840"/>
+            <a:ext cx="6035040" cy="3372522"/>
           </a:xfrm>
           <a:prstGeom prst="rect">
             <a:avLst/>
@@ -7333,7 +5972,7 @@
       </p:pic>
       <p:pic>
         <p:nvPicPr>
-          <p:cNvPr id="5" name="Picture 4" descr="wordmark_butter.png"/>
+          <p:cNvPr id="5" name="Picture 4" descr="wordmark_peanut.png"/>
           <p:cNvPicPr>
             <a:picLocks noChangeAspect="1"/>
           </p:cNvPicPr>
@@ -7388,7 +6027,7 @@
             <a:avLst/>
           </a:prstGeom>
           <a:solidFill>
-            <a:srgbClr val="4A3000"/>
+            <a:srgbClr val="4E2408"/>
           </a:solidFill>
           <a:ln>
             <a:noFill/>
@@ -7424,7 +6063,7 @@
         </p:nvSpPr>
         <p:spPr>
           <a:xfrm>
-            <a:off x="1188720" y="2011680"/>
+            <a:off x="1188720" y="1920240"/>
             <a:ext cx="9784080" cy="3657600"/>
           </a:xfrm>
           <a:prstGeom prst="rect">
@@ -7440,9 +6079,25 @@
           <a:p>
             <a:pPr>
               <a:spcAft>
+                <a:spcPts val="800"/>
+              </a:spcAft>
+              <a:defRPr sz="5400" b="1">
+                <a:solidFill>
+                  <a:srgbClr val="FF8C30"/>
+                </a:solidFill>
+                <a:latin typeface="Manrope"/>
+              </a:defRPr>
+            </a:pPr>
+            <a:r>
+              <a:t>35% Gross Margin</a:t>
+            </a:r>
+          </a:p>
+          <a:p>
+            <a:pPr>
+              <a:spcAft>
                 <a:spcPts val="1200"/>
               </a:spcAft>
-              <a:defRPr sz="4400" b="1">
+              <a:defRPr sz="3600" b="1">
                 <a:solidFill>
                   <a:srgbClr val="FFFFFF"/>
                 </a:solidFill>
@@ -7450,43 +6105,27 @@
               </a:defRPr>
             </a:pPr>
             <a:r>
-              <a:t>Zero Cutlery. Pure Physics.</a:t>
+              <a:t>$5.00 Retail • $1.75 Margin per Pack.</a:t>
             </a:r>
           </a:p>
           <a:p>
             <a:pPr>
-              <a:spcAft>
-                <a:spcPts val="1400"/>
-              </a:spcAft>
-              <a:defRPr sz="2600" b="1">
+              <a:defRPr sz="2000" b="0">
                 <a:solidFill>
-                  <a:srgbClr val="FFD640"/>
+                  <a:srgbClr val="FF8C30"/>
                 </a:solidFill>
                 <a:latin typeface="Manrope"/>
               </a:defRPr>
             </a:pPr>
             <a:r>
-              <a:t>Residual toast heat melts the disc in seconds.</a:t>
-            </a:r>
-          </a:p>
-          <a:p>
-            <a:pPr>
-              <a:defRPr sz="2000" b="1">
-                <a:solidFill>
-                  <a:srgbClr val="FFFFFF"/>
-                </a:solidFill>
-                <a:latin typeface="Manrope"/>
-              </a:defRPr>
-            </a:pPr>
-            <a:r>
-              <a:t>Peel off the liner. Press onto hot toast. Zero utensils or mess.</a:t>
+              <a:t>63¢ per serving on an assumed $1.50 contract packaging cost.</a:t>
             </a:r>
           </a:p>
         </p:txBody>
       </p:sp>
       <p:pic>
         <p:nvPicPr>
-          <p:cNvPr id="4" name="Picture 3" descr="wordmark_butter.png"/>
+          <p:cNvPr id="4" name="Picture 3" descr="wordmark_peanut.png"/>
           <p:cNvPicPr>
             <a:picLocks noChangeAspect="1"/>
           </p:cNvPicPr>
@@ -7577,8 +6216,8 @@
         </p:nvSpPr>
         <p:spPr>
           <a:xfrm>
-            <a:off x="1188720" y="2011680"/>
-            <a:ext cx="9784080" cy="3657600"/>
+            <a:off x="1188720" y="822960"/>
+            <a:ext cx="9784080" cy="1280160"/>
           </a:xfrm>
           <a:prstGeom prst="rect">
             <a:avLst/>
@@ -7593,9 +6232,9 @@
           <a:p>
             <a:pPr>
               <a:spcAft>
-                <a:spcPts val="1200"/>
+                <a:spcPts val="600"/>
               </a:spcAft>
-              <a:defRPr sz="4400" b="1">
+              <a:defRPr sz="3400" b="1">
                 <a:solidFill>
                   <a:srgbClr val="FFFFFF"/>
                 </a:solidFill>
@@ -7603,15 +6242,12 @@
               </a:defRPr>
             </a:pPr>
             <a:r>
-              <a:t>12-Month Ambient Life.</a:t>
+              <a:t>Contract Co-Manufacturing.</a:t>
             </a:r>
           </a:p>
           <a:p>
             <a:pPr>
-              <a:spcAft>
-                <a:spcPts val="1400"/>
-              </a:spcAft>
-              <a:defRPr sz="2400" b="1">
+              <a:defRPr sz="2000" b="0">
                 <a:solidFill>
                   <a:srgbClr val="FFD640"/>
                 </a:solidFill>
@@ -7619,27 +6255,14 @@
               </a:defRPr>
             </a:pPr>
             <a:r>
-              <a:t>High-stability emulsification for room temperature.</a:t>
-            </a:r>
-          </a:p>
-          <a:p>
-            <a:pPr>
-              <a:defRPr sz="2000" b="1">
-                <a:solidFill>
-                  <a:srgbClr val="FFFFFF"/>
-                </a:solidFill>
-                <a:latin typeface="Manrope"/>
-              </a:defRPr>
-            </a:pPr>
-            <a:r>
-              <a:t>Hermetically sealed 8-stamp card sheets for pantry and bag.</a:t>
+              <a:t>Continuous deposit tooling onto food-grade release liner.</a:t>
             </a:r>
           </a:p>
         </p:txBody>
       </p:sp>
       <p:pic>
         <p:nvPicPr>
-          <p:cNvPr id="4" name="Picture 3" descr="wordmark_butter.png"/>
+          <p:cNvPr id="4" name="Picture 3" descr="diagram_process_butter.png"/>
           <p:cNvPicPr>
             <a:picLocks noChangeAspect="1"/>
           </p:cNvPicPr>
@@ -7647,6 +6270,30 @@
         </p:nvPicPr>
         <p:blipFill>
           <a:blip r:embed="rId2"/>
+          <a:stretch>
+            <a:fillRect/>
+          </a:stretch>
+        </p:blipFill>
+        <p:spPr>
+          <a:xfrm>
+            <a:off x="2438247" y="2286000"/>
+            <a:ext cx="7315200" cy="2854712"/>
+          </a:xfrm>
+          <a:prstGeom prst="rect">
+            <a:avLst/>
+          </a:prstGeom>
+        </p:spPr>
+      </p:pic>
+      <p:pic>
+        <p:nvPicPr>
+          <p:cNvPr id="5" name="Picture 4" descr="wordmark_butter.png"/>
+          <p:cNvPicPr>
+            <a:picLocks noChangeAspect="1"/>
+          </p:cNvPicPr>
+          <p:nvPr/>
+        </p:nvPicPr>
+        <p:blipFill>
+          <a:blip r:embed="rId3"/>
           <a:stretch>
             <a:fillRect/>
           </a:stretch>
@@ -7694,7 +6341,7 @@
             <a:avLst/>
           </a:prstGeom>
           <a:solidFill>
-            <a:srgbClr val="4E2408"/>
+            <a:srgbClr val="460820"/>
           </a:solidFill>
           <a:ln>
             <a:noFill/>
@@ -7730,7 +6377,7 @@
         </p:nvSpPr>
         <p:spPr>
           <a:xfrm>
-            <a:off x="1188720" y="1920240"/>
+            <a:off x="1188720" y="2011680"/>
             <a:ext cx="9784080" cy="3657600"/>
           </a:xfrm>
           <a:prstGeom prst="rect">
@@ -7746,25 +6393,25 @@
           <a:p>
             <a:pPr>
               <a:spcAft>
-                <a:spcPts val="800"/>
+                <a:spcPts val="1200"/>
               </a:spcAft>
-              <a:defRPr sz="5400" b="1">
+              <a:defRPr sz="2200" b="1">
                 <a:solidFill>
-                  <a:srgbClr val="FF8C30"/>
+                  <a:srgbClr val="FF467A"/>
                 </a:solidFill>
                 <a:latin typeface="Manrope"/>
               </a:defRPr>
             </a:pPr>
             <a:r>
-              <a:t>$341M Category</a:t>
+              <a:t>Negative Constraints.</a:t>
             </a:r>
           </a:p>
           <a:p>
             <a:pPr>
               <a:spcAft>
-                <a:spcPts val="1200"/>
+                <a:spcPts val="1400"/>
               </a:spcAft>
-              <a:defRPr sz="3600" b="1">
+              <a:defRPr sz="4600" b="1">
                 <a:solidFill>
                   <a:srgbClr val="FFFFFF"/>
                 </a:solidFill>
@@ -7772,27 +6419,27 @@
               </a:defRPr>
             </a:pPr>
             <a:r>
-              <a:t>New Zealand Spreads Market.</a:t>
+              <a:t>Banning AI Marketing Hype.</a:t>
             </a:r>
           </a:p>
           <a:p>
             <a:pPr>
-              <a:defRPr sz="2000" b="0">
+              <a:defRPr sz="2200" b="0">
                 <a:solidFill>
-                  <a:srgbClr val="FF8C30"/>
+                  <a:srgbClr val="FF467A"/>
                 </a:solidFill>
                 <a:latin typeface="Manrope"/>
               </a:defRPr>
             </a:pPr>
             <a:r>
-              <a:t>+24% category revenue growth across 2022–2025.</a:t>
+              <a:t>Explicit negative prompts barred fake badges and health claims.</a:t>
             </a:r>
           </a:p>
         </p:txBody>
       </p:sp>
       <p:pic>
         <p:nvPicPr>
-          <p:cNvPr id="4" name="Picture 3" descr="wordmark_peanut.png"/>
+          <p:cNvPr id="4" name="Picture 3" descr="wordmark_raspberry.png"/>
           <p:cNvPicPr>
             <a:picLocks noChangeAspect="1"/>
           </p:cNvPicPr>
@@ -7847,7 +6494,7 @@
             <a:avLst/>
           </a:prstGeom>
           <a:solidFill>
-            <a:srgbClr val="4E2408"/>
+            <a:srgbClr val="460820"/>
           </a:solidFill>
           <a:ln>
             <a:noFill/>
@@ -7883,8 +6530,8 @@
         </p:nvSpPr>
         <p:spPr>
           <a:xfrm>
-            <a:off x="1188720" y="822960"/>
-            <a:ext cx="9784080" cy="1280160"/>
+            <a:off x="1188720" y="2377440"/>
+            <a:ext cx="9784080" cy="3657600"/>
           </a:xfrm>
           <a:prstGeom prst="rect">
             <a:avLst/>
@@ -7899,9 +6546,9 @@
           <a:p>
             <a:pPr>
               <a:spcAft>
-                <a:spcPts val="600"/>
+                <a:spcPts val="1200"/>
               </a:spcAft>
-              <a:defRPr sz="3400" b="1">
+              <a:defRPr sz="4600" b="1">
                 <a:solidFill>
                   <a:srgbClr val="FFFFFF"/>
                 </a:solidFill>
@@ -7909,27 +6556,30 @@
               </a:defRPr>
             </a:pPr>
             <a:r>
-              <a:t>Premium Spreads Surging +29%.</a:t>
+              <a:t>Modular Architecture.</a:t>
             </a:r>
           </a:p>
           <a:p>
             <a:pPr>
-              <a:defRPr sz="2000" b="0">
+              <a:spcAft>
+                <a:spcPts val="1400"/>
+              </a:spcAft>
+              <a:defRPr sz="2400" b="1">
                 <a:solidFill>
-                  <a:srgbClr val="FF8C30"/>
+                  <a:srgbClr val="FF467A"/>
                 </a:solidFill>
                 <a:latin typeface="Manrope"/>
               </a:defRPr>
             </a:pPr>
             <a:r>
-              <a:t>Consumers trading up from commodity tiers into quality formats.</a:t>
+              <a:t>Separating data, branding, and copy eliminated context drift.</a:t>
             </a:r>
           </a:p>
         </p:txBody>
       </p:sp>
       <p:pic>
         <p:nvPicPr>
-          <p:cNvPr id="4" name="Picture 3" descr="chart_tier_peanut.png"/>
+          <p:cNvPr id="4" name="Picture 3" descr="wordmark_raspberry.png"/>
           <p:cNvPicPr>
             <a:picLocks noChangeAspect="1"/>
           </p:cNvPicPr>
@@ -7937,30 +6587,6 @@
         </p:nvPicPr>
         <p:blipFill>
           <a:blip r:embed="rId2"/>
-          <a:stretch>
-            <a:fillRect/>
-          </a:stretch>
-        </p:blipFill>
-        <p:spPr>
-          <a:xfrm>
-            <a:off x="3078327" y="2148840"/>
-            <a:ext cx="6035040" cy="3372522"/>
-          </a:xfrm>
-          <a:prstGeom prst="rect">
-            <a:avLst/>
-          </a:prstGeom>
-        </p:spPr>
-      </p:pic>
-      <p:pic>
-        <p:nvPicPr>
-          <p:cNvPr id="5" name="Picture 4" descr="wordmark_peanut.png"/>
-          <p:cNvPicPr>
-            <a:picLocks noChangeAspect="1"/>
-          </p:cNvPicPr>
-          <p:nvPr/>
-        </p:nvPicPr>
-        <p:blipFill>
-          <a:blip r:embed="rId3"/>
           <a:stretch>
             <a:fillRect/>
           </a:stretch>

</xml_diff>